<commit_message>
Fix: Dezimalstellen bei Noten korrekt anzeigen
- API gibt Noten jetzt als TEXT zurück, um Rundungsprobleme zu vermeiden
- CAST(grade AS TEXT) statt CAST(grade AS REAL) in getGrades
- Duplikat-Eintrag für 'Hü - Geometrie' entfernt (falscher Eintrag mit 5.0)
- Korrekter Eintrag mit 4.7 wiederhergestellt
- Debug-Logs entfernt
- Client-Port auf 3001 geändert, Proxy auf 3003
- Alle Änderungen inkl. Datenbank committet
</commit_message>
<xml_diff>
--- a/J-M-Reihen/Mathe/Klasse 7/Kap.3 - Geometrische Abbildungen/#_Reihenplan.pptx
+++ b/J-M-Reihen/Mathe/Klasse 7/Kap.3 - Geometrische Abbildungen/#_Reihenplan.pptx
@@ -5,12 +5,21 @@
     <p:sldMasterId id="2147483648" r:id="rId1"/>
   </p:sldMasterIdLst>
   <p:notesMasterIdLst>
-    <p:notesMasterId r:id="rId5"/>
+    <p:notesMasterId r:id="rId14"/>
   </p:notesMasterIdLst>
   <p:sldIdLst>
     <p:sldId id="259" r:id="rId2"/>
-    <p:sldId id="257" r:id="rId3"/>
-    <p:sldId id="258" r:id="rId4"/>
+    <p:sldId id="262" r:id="rId3"/>
+    <p:sldId id="257" r:id="rId4"/>
+    <p:sldId id="258" r:id="rId5"/>
+    <p:sldId id="260" r:id="rId6"/>
+    <p:sldId id="265" r:id="rId7"/>
+    <p:sldId id="268" r:id="rId8"/>
+    <p:sldId id="270" r:id="rId9"/>
+    <p:sldId id="271" r:id="rId10"/>
+    <p:sldId id="273" r:id="rId11"/>
+    <p:sldId id="267" r:id="rId12"/>
+    <p:sldId id="261" r:id="rId13"/>
   </p:sldIdLst>
   <p:sldSz cx="12192000" cy="6858000"/>
   <p:notesSz cx="6858000" cy="9144000"/>
@@ -199,7 +208,7 @@
           <a:p>
             <a:fld id="{0A10E92E-5F19-834A-AA97-53FA2D660DCB}" type="datetimeFigureOut">
               <a:rPr lang="de-DE" smtClean="0"/>
-              <a:t>29.12.25</a:t>
+              <a:t>04.01.26</a:t>
             </a:fld>
             <a:endParaRPr lang="de-DE"/>
           </a:p>
@@ -531,7 +540,7 @@
           <a:p>
             <a:fld id="{5264360D-A3AE-044F-B6E9-FC0C70EEF33D}" type="slidenum">
               <a:rPr lang="de-DE" smtClean="0"/>
-              <a:t>2</a:t>
+              <a:t>3</a:t>
             </a:fld>
             <a:endParaRPr lang="de-DE"/>
           </a:p>
@@ -697,7 +706,7 @@
           <a:p>
             <a:fld id="{C72C0E08-E80E-9141-9781-077B3A888FD3}" type="datetimeFigureOut">
               <a:rPr lang="de-DE" smtClean="0"/>
-              <a:t>29.12.25</a:t>
+              <a:t>04.01.26</a:t>
             </a:fld>
             <a:endParaRPr lang="de-DE"/>
           </a:p>
@@ -895,7 +904,7 @@
           <a:p>
             <a:fld id="{C72C0E08-E80E-9141-9781-077B3A888FD3}" type="datetimeFigureOut">
               <a:rPr lang="de-DE" smtClean="0"/>
-              <a:t>29.12.25</a:t>
+              <a:t>04.01.26</a:t>
             </a:fld>
             <a:endParaRPr lang="de-DE"/>
           </a:p>
@@ -1103,7 +1112,7 @@
           <a:p>
             <a:fld id="{C72C0E08-E80E-9141-9781-077B3A888FD3}" type="datetimeFigureOut">
               <a:rPr lang="de-DE" smtClean="0"/>
-              <a:t>29.12.25</a:t>
+              <a:t>04.01.26</a:t>
             </a:fld>
             <a:endParaRPr lang="de-DE"/>
           </a:p>
@@ -1301,7 +1310,7 @@
           <a:p>
             <a:fld id="{C72C0E08-E80E-9141-9781-077B3A888FD3}" type="datetimeFigureOut">
               <a:rPr lang="de-DE" smtClean="0"/>
-              <a:t>29.12.25</a:t>
+              <a:t>04.01.26</a:t>
             </a:fld>
             <a:endParaRPr lang="de-DE"/>
           </a:p>
@@ -1576,7 +1585,7 @@
           <a:p>
             <a:fld id="{C72C0E08-E80E-9141-9781-077B3A888FD3}" type="datetimeFigureOut">
               <a:rPr lang="de-DE" smtClean="0"/>
-              <a:t>29.12.25</a:t>
+              <a:t>04.01.26</a:t>
             </a:fld>
             <a:endParaRPr lang="de-DE"/>
           </a:p>
@@ -1841,7 +1850,7 @@
           <a:p>
             <a:fld id="{C72C0E08-E80E-9141-9781-077B3A888FD3}" type="datetimeFigureOut">
               <a:rPr lang="de-DE" smtClean="0"/>
-              <a:t>29.12.25</a:t>
+              <a:t>04.01.26</a:t>
             </a:fld>
             <a:endParaRPr lang="de-DE"/>
           </a:p>
@@ -2253,7 +2262,7 @@
           <a:p>
             <a:fld id="{C72C0E08-E80E-9141-9781-077B3A888FD3}" type="datetimeFigureOut">
               <a:rPr lang="de-DE" smtClean="0"/>
-              <a:t>29.12.25</a:t>
+              <a:t>04.01.26</a:t>
             </a:fld>
             <a:endParaRPr lang="de-DE"/>
           </a:p>
@@ -2394,7 +2403,7 @@
           <a:p>
             <a:fld id="{C72C0E08-E80E-9141-9781-077B3A888FD3}" type="datetimeFigureOut">
               <a:rPr lang="de-DE" smtClean="0"/>
-              <a:t>29.12.25</a:t>
+              <a:t>04.01.26</a:t>
             </a:fld>
             <a:endParaRPr lang="de-DE"/>
           </a:p>
@@ -2507,7 +2516,7 @@
           <a:p>
             <a:fld id="{C72C0E08-E80E-9141-9781-077B3A888FD3}" type="datetimeFigureOut">
               <a:rPr lang="de-DE" smtClean="0"/>
-              <a:t>29.12.25</a:t>
+              <a:t>04.01.26</a:t>
             </a:fld>
             <a:endParaRPr lang="de-DE"/>
           </a:p>
@@ -2818,7 +2827,7 @@
           <a:p>
             <a:fld id="{C72C0E08-E80E-9141-9781-077B3A888FD3}" type="datetimeFigureOut">
               <a:rPr lang="de-DE" smtClean="0"/>
-              <a:t>29.12.25</a:t>
+              <a:t>04.01.26</a:t>
             </a:fld>
             <a:endParaRPr lang="de-DE"/>
           </a:p>
@@ -3106,7 +3115,7 @@
           <a:p>
             <a:fld id="{C72C0E08-E80E-9141-9781-077B3A888FD3}" type="datetimeFigureOut">
               <a:rPr lang="de-DE" smtClean="0"/>
-              <a:t>29.12.25</a:t>
+              <a:t>04.01.26</a:t>
             </a:fld>
             <a:endParaRPr lang="de-DE"/>
           </a:p>
@@ -3347,7 +3356,7 @@
           <a:p>
             <a:fld id="{C72C0E08-E80E-9141-9781-077B3A888FD3}" type="datetimeFigureOut">
               <a:rPr lang="de-DE" smtClean="0"/>
-              <a:t>29.12.25</a:t>
+              <a:t>04.01.26</a:t>
             </a:fld>
             <a:endParaRPr lang="de-DE"/>
           </a:p>
@@ -3914,7 +3923,43 @@
                   <a:srgbClr val="7030A0"/>
                 </a:solidFill>
               </a:rPr>
-              <a:t>HÜ</a:t>
+              <a:t>HÜ </a:t>
+            </a:r>
+            <a:r>
+              <a:rPr lang="de-DE" dirty="0"/>
+              <a:t>und Übungs- bzw. Knobelspiel</a:t>
+            </a:r>
+            <a:endParaRPr lang="de-DE" b="1" dirty="0">
+              <a:solidFill>
+                <a:srgbClr val="7030A0"/>
+              </a:solidFill>
+            </a:endParaRPr>
+          </a:p>
+          <a:p>
+            <a:pPr marL="0" indent="0">
+              <a:buNone/>
+            </a:pPr>
+            <a:endParaRPr lang="de-DE" dirty="0"/>
+          </a:p>
+          <a:p>
+            <a:pPr marL="0" indent="0">
+              <a:buNone/>
+            </a:pPr>
+            <a:endParaRPr lang="de-DE" dirty="0"/>
+          </a:p>
+          <a:p>
+            <a:pPr marL="0" indent="0">
+              <a:buNone/>
+            </a:pPr>
+            <a:endParaRPr lang="de-DE" dirty="0"/>
+          </a:p>
+          <a:p>
+            <a:pPr marL="0" indent="0">
+              <a:buNone/>
+            </a:pPr>
+            <a:r>
+              <a:rPr lang="de-DE" dirty="0"/>
+              <a:t>Arbeitsheft S.29 bis 37</a:t>
             </a:r>
           </a:p>
           <a:p>
@@ -3938,7 +3983,1240 @@
 </p:sld>
 </file>
 
+<file path=ppt/slides/slide10.xml><?xml version="1.0" encoding="utf-8"?>
+<p:sld xmlns:a="http://schemas.openxmlformats.org/drawingml/2006/main" xmlns:r="http://schemas.openxmlformats.org/officeDocument/2006/relationships" xmlns:p="http://schemas.openxmlformats.org/presentationml/2006/main">
+  <p:cSld>
+    <p:spTree>
+      <p:nvGrpSpPr>
+        <p:cNvPr id="1" name="">
+          <a:extLst>
+            <a:ext uri="{FF2B5EF4-FFF2-40B4-BE49-F238E27FC236}">
+              <a16:creationId xmlns:a16="http://schemas.microsoft.com/office/drawing/2014/main" id="{11C59FFA-CB53-2E41-B295-6995E33AED7C}"/>
+            </a:ext>
+          </a:extLst>
+        </p:cNvPr>
+        <p:cNvGrpSpPr/>
+        <p:nvPr/>
+      </p:nvGrpSpPr>
+      <p:grpSpPr>
+        <a:xfrm>
+          <a:off x="0" y="0"/>
+          <a:ext cx="0" cy="0"/>
+          <a:chOff x="0" y="0"/>
+          <a:chExt cx="0" cy="0"/>
+        </a:xfrm>
+      </p:grpSpPr>
+      <p:sp>
+        <p:nvSpPr>
+          <p:cNvPr id="3" name="Titel 1">
+            <a:extLst>
+              <a:ext uri="{FF2B5EF4-FFF2-40B4-BE49-F238E27FC236}">
+                <a16:creationId xmlns:a16="http://schemas.microsoft.com/office/drawing/2014/main" id="{E5C95B1E-543F-86D6-A505-7DAC962D4EE4}"/>
+              </a:ext>
+            </a:extLst>
+          </p:cNvPr>
+          <p:cNvSpPr txBox="1">
+            <a:spLocks/>
+          </p:cNvSpPr>
+          <p:nvPr/>
+        </p:nvSpPr>
+        <p:spPr>
+          <a:xfrm>
+            <a:off x="193623" y="425086"/>
+            <a:ext cx="11768528" cy="549275"/>
+          </a:xfrm>
+          <a:prstGeom prst="rect">
+            <a:avLst/>
+          </a:prstGeom>
+        </p:spPr>
+        <p:txBody>
+          <a:bodyPr>
+            <a:normAutofit fontScale="90000" lnSpcReduction="20000"/>
+          </a:bodyPr>
+          <a:lstStyle>
+            <a:lvl1pPr algn="l" defTabSz="914400" rtl="0" eaLnBrk="1" latinLnBrk="0" hangingPunct="1">
+              <a:lnSpc>
+                <a:spcPct val="90000"/>
+              </a:lnSpc>
+              <a:spcBef>
+                <a:spcPct val="0"/>
+              </a:spcBef>
+              <a:buNone/>
+              <a:defRPr sz="4400" kern="1200">
+                <a:solidFill>
+                  <a:schemeClr val="tx1"/>
+                </a:solidFill>
+                <a:latin typeface="+mj-lt"/>
+                <a:ea typeface="+mj-ea"/>
+                <a:cs typeface="+mj-cs"/>
+              </a:defRPr>
+            </a:lvl1pPr>
+          </a:lstStyle>
+          <a:p>
+            <a:pPr algn="ctr"/>
+            <a:r>
+              <a:rPr lang="de-DE" dirty="0">
+                <a:latin typeface="ADLaM Display" panose="02010000000000000000" pitchFamily="2" charset="77"/>
+                <a:ea typeface="ADLaM Display" panose="02010000000000000000" pitchFamily="2" charset="77"/>
+                <a:cs typeface="ADLaM Display" panose="02010000000000000000" pitchFamily="2" charset="77"/>
+              </a:rPr>
+              <a:t>Wiederholung: Achsenspiegelung</a:t>
+            </a:r>
+          </a:p>
+        </p:txBody>
+      </p:sp>
+      <p:sp>
+        <p:nvSpPr>
+          <p:cNvPr id="6" name="Abgerundetes Rechteck 5">
+            <a:extLst>
+              <a:ext uri="{FF2B5EF4-FFF2-40B4-BE49-F238E27FC236}">
+                <a16:creationId xmlns:a16="http://schemas.microsoft.com/office/drawing/2014/main" id="{21030813-6EB7-A10E-6DF4-C20A6368813F}"/>
+              </a:ext>
+            </a:extLst>
+          </p:cNvPr>
+          <p:cNvSpPr/>
+          <p:nvPr/>
+        </p:nvSpPr>
+        <p:spPr>
+          <a:xfrm>
+            <a:off x="193623" y="1240970"/>
+            <a:ext cx="11768527" cy="5382251"/>
+          </a:xfrm>
+          <a:prstGeom prst="roundRect">
+            <a:avLst/>
+          </a:prstGeom>
+        </p:spPr>
+        <p:style>
+          <a:lnRef idx="2">
+            <a:schemeClr val="accent3"/>
+          </a:lnRef>
+          <a:fillRef idx="1">
+            <a:schemeClr val="lt1"/>
+          </a:fillRef>
+          <a:effectRef idx="0">
+            <a:schemeClr val="accent3"/>
+          </a:effectRef>
+          <a:fontRef idx="minor">
+            <a:schemeClr val="dk1"/>
+          </a:fontRef>
+        </p:style>
+        <p:txBody>
+          <a:bodyPr rtlCol="0" anchor="ctr"/>
+          <a:lstStyle/>
+          <a:p>
+            <a:pPr algn="ctr"/>
+            <a:endParaRPr lang="de-DE" b="1" dirty="0"/>
+          </a:p>
+        </p:txBody>
+      </p:sp>
+      <p:sp>
+        <p:nvSpPr>
+          <p:cNvPr id="8" name="Inhaltsplatzhalter 2">
+            <a:extLst>
+              <a:ext uri="{FF2B5EF4-FFF2-40B4-BE49-F238E27FC236}">
+                <a16:creationId xmlns:a16="http://schemas.microsoft.com/office/drawing/2014/main" id="{51CD4DA6-533A-1C11-CF38-30C2128D053A}"/>
+              </a:ext>
+            </a:extLst>
+          </p:cNvPr>
+          <p:cNvSpPr txBox="1">
+            <a:spLocks/>
+          </p:cNvSpPr>
+          <p:nvPr/>
+        </p:nvSpPr>
+        <p:spPr>
+          <a:xfrm>
+            <a:off x="423472" y="1559658"/>
+            <a:ext cx="11327804" cy="4396299"/>
+          </a:xfrm>
+          <a:prstGeom prst="rect">
+            <a:avLst/>
+          </a:prstGeom>
+        </p:spPr>
+        <p:txBody>
+          <a:bodyPr/>
+          <a:lstStyle>
+            <a:lvl1pPr marL="228600" indent="-228600" algn="l" defTabSz="914400" rtl="0" eaLnBrk="1" latinLnBrk="0" hangingPunct="1">
+              <a:lnSpc>
+                <a:spcPct val="90000"/>
+              </a:lnSpc>
+              <a:spcBef>
+                <a:spcPts val="1000"/>
+              </a:spcBef>
+              <a:buFont typeface="Arial" panose="020B0604020202020204" pitchFamily="34" charset="0"/>
+              <a:buChar char="•"/>
+              <a:defRPr sz="2800" kern="1200">
+                <a:solidFill>
+                  <a:schemeClr val="tx1"/>
+                </a:solidFill>
+                <a:latin typeface="+mn-lt"/>
+                <a:ea typeface="+mn-ea"/>
+                <a:cs typeface="+mn-cs"/>
+              </a:defRPr>
+            </a:lvl1pPr>
+            <a:lvl2pPr marL="685800" indent="-228600" algn="l" defTabSz="914400" rtl="0" eaLnBrk="1" latinLnBrk="0" hangingPunct="1">
+              <a:lnSpc>
+                <a:spcPct val="90000"/>
+              </a:lnSpc>
+              <a:spcBef>
+                <a:spcPts val="500"/>
+              </a:spcBef>
+              <a:buFont typeface="Arial" panose="020B0604020202020204" pitchFamily="34" charset="0"/>
+              <a:buChar char="•"/>
+              <a:defRPr sz="2400" kern="1200">
+                <a:solidFill>
+                  <a:schemeClr val="tx1"/>
+                </a:solidFill>
+                <a:latin typeface="+mn-lt"/>
+                <a:ea typeface="+mn-ea"/>
+                <a:cs typeface="+mn-cs"/>
+              </a:defRPr>
+            </a:lvl2pPr>
+            <a:lvl3pPr marL="1143000" indent="-228600" algn="l" defTabSz="914400" rtl="0" eaLnBrk="1" latinLnBrk="0" hangingPunct="1">
+              <a:lnSpc>
+                <a:spcPct val="90000"/>
+              </a:lnSpc>
+              <a:spcBef>
+                <a:spcPts val="500"/>
+              </a:spcBef>
+              <a:buFont typeface="Arial" panose="020B0604020202020204" pitchFamily="34" charset="0"/>
+              <a:buChar char="•"/>
+              <a:defRPr sz="2000" kern="1200">
+                <a:solidFill>
+                  <a:schemeClr val="tx1"/>
+                </a:solidFill>
+                <a:latin typeface="+mn-lt"/>
+                <a:ea typeface="+mn-ea"/>
+                <a:cs typeface="+mn-cs"/>
+              </a:defRPr>
+            </a:lvl3pPr>
+            <a:lvl4pPr marL="1600200" indent="-228600" algn="l" defTabSz="914400" rtl="0" eaLnBrk="1" latinLnBrk="0" hangingPunct="1">
+              <a:lnSpc>
+                <a:spcPct val="90000"/>
+              </a:lnSpc>
+              <a:spcBef>
+                <a:spcPts val="500"/>
+              </a:spcBef>
+              <a:buFont typeface="Arial" panose="020B0604020202020204" pitchFamily="34" charset="0"/>
+              <a:buChar char="•"/>
+              <a:defRPr sz="1800" kern="1200">
+                <a:solidFill>
+                  <a:schemeClr val="tx1"/>
+                </a:solidFill>
+                <a:latin typeface="+mn-lt"/>
+                <a:ea typeface="+mn-ea"/>
+                <a:cs typeface="+mn-cs"/>
+              </a:defRPr>
+            </a:lvl4pPr>
+            <a:lvl5pPr marL="2057400" indent="-228600" algn="l" defTabSz="914400" rtl="0" eaLnBrk="1" latinLnBrk="0" hangingPunct="1">
+              <a:lnSpc>
+                <a:spcPct val="90000"/>
+              </a:lnSpc>
+              <a:spcBef>
+                <a:spcPts val="500"/>
+              </a:spcBef>
+              <a:buFont typeface="Arial" panose="020B0604020202020204" pitchFamily="34" charset="0"/>
+              <a:buChar char="•"/>
+              <a:defRPr sz="1800" kern="1200">
+                <a:solidFill>
+                  <a:schemeClr val="tx1"/>
+                </a:solidFill>
+                <a:latin typeface="+mn-lt"/>
+                <a:ea typeface="+mn-ea"/>
+                <a:cs typeface="+mn-cs"/>
+              </a:defRPr>
+            </a:lvl5pPr>
+            <a:lvl6pPr marL="2514600" indent="-228600" algn="l" defTabSz="914400" rtl="0" eaLnBrk="1" latinLnBrk="0" hangingPunct="1">
+              <a:lnSpc>
+                <a:spcPct val="90000"/>
+              </a:lnSpc>
+              <a:spcBef>
+                <a:spcPts val="500"/>
+              </a:spcBef>
+              <a:buFont typeface="Arial" panose="020B0604020202020204" pitchFamily="34" charset="0"/>
+              <a:buChar char="•"/>
+              <a:defRPr sz="1800" kern="1200">
+                <a:solidFill>
+                  <a:schemeClr val="tx1"/>
+                </a:solidFill>
+                <a:latin typeface="+mn-lt"/>
+                <a:ea typeface="+mn-ea"/>
+                <a:cs typeface="+mn-cs"/>
+              </a:defRPr>
+            </a:lvl6pPr>
+            <a:lvl7pPr marL="2971800" indent="-228600" algn="l" defTabSz="914400" rtl="0" eaLnBrk="1" latinLnBrk="0" hangingPunct="1">
+              <a:lnSpc>
+                <a:spcPct val="90000"/>
+              </a:lnSpc>
+              <a:spcBef>
+                <a:spcPts val="500"/>
+              </a:spcBef>
+              <a:buFont typeface="Arial" panose="020B0604020202020204" pitchFamily="34" charset="0"/>
+              <a:buChar char="•"/>
+              <a:defRPr sz="1800" kern="1200">
+                <a:solidFill>
+                  <a:schemeClr val="tx1"/>
+                </a:solidFill>
+                <a:latin typeface="+mn-lt"/>
+                <a:ea typeface="+mn-ea"/>
+                <a:cs typeface="+mn-cs"/>
+              </a:defRPr>
+            </a:lvl7pPr>
+            <a:lvl8pPr marL="3429000" indent="-228600" algn="l" defTabSz="914400" rtl="0" eaLnBrk="1" latinLnBrk="0" hangingPunct="1">
+              <a:lnSpc>
+                <a:spcPct val="90000"/>
+              </a:lnSpc>
+              <a:spcBef>
+                <a:spcPts val="500"/>
+              </a:spcBef>
+              <a:buFont typeface="Arial" panose="020B0604020202020204" pitchFamily="34" charset="0"/>
+              <a:buChar char="•"/>
+              <a:defRPr sz="1800" kern="1200">
+                <a:solidFill>
+                  <a:schemeClr val="tx1"/>
+                </a:solidFill>
+                <a:latin typeface="+mn-lt"/>
+                <a:ea typeface="+mn-ea"/>
+                <a:cs typeface="+mn-cs"/>
+              </a:defRPr>
+            </a:lvl8pPr>
+            <a:lvl9pPr marL="3886200" indent="-228600" algn="l" defTabSz="914400" rtl="0" eaLnBrk="1" latinLnBrk="0" hangingPunct="1">
+              <a:lnSpc>
+                <a:spcPct val="90000"/>
+              </a:lnSpc>
+              <a:spcBef>
+                <a:spcPts val="500"/>
+              </a:spcBef>
+              <a:buFont typeface="Arial" panose="020B0604020202020204" pitchFamily="34" charset="0"/>
+              <a:buChar char="•"/>
+              <a:defRPr sz="1800" kern="1200">
+                <a:solidFill>
+                  <a:schemeClr val="tx1"/>
+                </a:solidFill>
+                <a:latin typeface="+mn-lt"/>
+                <a:ea typeface="+mn-ea"/>
+                <a:cs typeface="+mn-cs"/>
+              </a:defRPr>
+            </a:lvl9pPr>
+          </a:lstStyle>
+          <a:p>
+            <a:pPr marL="0" indent="0" algn="just">
+              <a:buNone/>
+            </a:pPr>
+            <a:r>
+              <a:rPr lang="de-DE" b="1" dirty="0"/>
+              <a:t>Übungsaufgaben &amp; HA </a:t>
+            </a:r>
+          </a:p>
+          <a:p>
+            <a:pPr algn="just"/>
+            <a:r>
+              <a:rPr lang="de-DE" dirty="0"/>
+              <a:t>Buch S.97, Nr. 3</a:t>
+            </a:r>
+          </a:p>
+          <a:p>
+            <a:pPr algn="just"/>
+            <a:r>
+              <a:rPr lang="de-DE" dirty="0"/>
+              <a:t>Arbeitsheft S.30</a:t>
+            </a:r>
+          </a:p>
+          <a:p>
+            <a:pPr algn="just"/>
+            <a:r>
+              <a:rPr lang="de-DE" b="1" dirty="0"/>
+              <a:t>Bonus</a:t>
+            </a:r>
+            <a:r>
+              <a:rPr lang="de-DE" dirty="0"/>
+              <a:t>: Nr. 4</a:t>
+            </a:r>
+          </a:p>
+          <a:p>
+            <a:pPr algn="just"/>
+            <a:endParaRPr lang="de-DE" b="1" dirty="0"/>
+          </a:p>
+          <a:p>
+            <a:pPr algn="just"/>
+            <a:endParaRPr lang="de-DE" b="1" dirty="0"/>
+          </a:p>
+        </p:txBody>
+      </p:sp>
+      <p:pic>
+        <p:nvPicPr>
+          <p:cNvPr id="10" name="Grafik 9" descr="Ein Bild, das Text, Screenshot enthält.&#10;&#10;KI-generierte Inhalte können fehlerhaft sein.">
+            <a:extLst>
+              <a:ext uri="{FF2B5EF4-FFF2-40B4-BE49-F238E27FC236}">
+                <a16:creationId xmlns:a16="http://schemas.microsoft.com/office/drawing/2014/main" id="{5EEBACB8-7346-AD53-4754-4D335152D411}"/>
+              </a:ext>
+            </a:extLst>
+          </p:cNvPr>
+          <p:cNvPicPr>
+            <a:picLocks noChangeAspect="1"/>
+          </p:cNvPicPr>
+          <p:nvPr/>
+        </p:nvPicPr>
+        <p:blipFill>
+          <a:blip r:embed="rId2"/>
+          <a:stretch>
+            <a:fillRect/>
+          </a:stretch>
+        </p:blipFill>
+        <p:spPr>
+          <a:xfrm>
+            <a:off x="4796228" y="2010230"/>
+            <a:ext cx="6972300" cy="3606800"/>
+          </a:xfrm>
+          <a:prstGeom prst="rect">
+            <a:avLst/>
+          </a:prstGeom>
+        </p:spPr>
+      </p:pic>
+    </p:spTree>
+    <p:extLst>
+      <p:ext uri="{BB962C8B-B14F-4D97-AF65-F5344CB8AC3E}">
+        <p14:creationId xmlns:p14="http://schemas.microsoft.com/office/powerpoint/2010/main" val="3172547515"/>
+      </p:ext>
+    </p:extLst>
+  </p:cSld>
+  <p:clrMapOvr>
+    <a:masterClrMapping/>
+  </p:clrMapOvr>
+</p:sld>
+</file>
+
+<file path=ppt/slides/slide11.xml><?xml version="1.0" encoding="utf-8"?>
+<p:sld xmlns:a="http://schemas.openxmlformats.org/drawingml/2006/main" xmlns:r="http://schemas.openxmlformats.org/officeDocument/2006/relationships" xmlns:p="http://schemas.openxmlformats.org/presentationml/2006/main">
+  <p:cSld>
+    <p:spTree>
+      <p:nvGrpSpPr>
+        <p:cNvPr id="1" name="">
+          <a:extLst>
+            <a:ext uri="{FF2B5EF4-FFF2-40B4-BE49-F238E27FC236}">
+              <a16:creationId xmlns:a16="http://schemas.microsoft.com/office/drawing/2014/main" id="{D6F9E721-EB3B-BCB5-BE3B-CA6255C50FF9}"/>
+            </a:ext>
+          </a:extLst>
+        </p:cNvPr>
+        <p:cNvGrpSpPr/>
+        <p:nvPr/>
+      </p:nvGrpSpPr>
+      <p:grpSpPr>
+        <a:xfrm>
+          <a:off x="0" y="0"/>
+          <a:ext cx="0" cy="0"/>
+          <a:chOff x="0" y="0"/>
+          <a:chExt cx="0" cy="0"/>
+        </a:xfrm>
+      </p:grpSpPr>
+      <p:sp>
+        <p:nvSpPr>
+          <p:cNvPr id="3" name="Titel 1">
+            <a:extLst>
+              <a:ext uri="{FF2B5EF4-FFF2-40B4-BE49-F238E27FC236}">
+                <a16:creationId xmlns:a16="http://schemas.microsoft.com/office/drawing/2014/main" id="{68D2655B-9794-C641-BFA5-6367C8865A9C}"/>
+              </a:ext>
+            </a:extLst>
+          </p:cNvPr>
+          <p:cNvSpPr txBox="1">
+            <a:spLocks/>
+          </p:cNvSpPr>
+          <p:nvPr/>
+        </p:nvSpPr>
+        <p:spPr>
+          <a:xfrm>
+            <a:off x="193623" y="425086"/>
+            <a:ext cx="11768528" cy="549275"/>
+          </a:xfrm>
+          <a:prstGeom prst="rect">
+            <a:avLst/>
+          </a:prstGeom>
+        </p:spPr>
+        <p:txBody>
+          <a:bodyPr>
+            <a:normAutofit fontScale="90000" lnSpcReduction="20000"/>
+          </a:bodyPr>
+          <a:lstStyle>
+            <a:lvl1pPr algn="l" defTabSz="914400" rtl="0" eaLnBrk="1" latinLnBrk="0" hangingPunct="1">
+              <a:lnSpc>
+                <a:spcPct val="90000"/>
+              </a:lnSpc>
+              <a:spcBef>
+                <a:spcPct val="0"/>
+              </a:spcBef>
+              <a:buNone/>
+              <a:defRPr sz="4400" kern="1200">
+                <a:solidFill>
+                  <a:schemeClr val="tx1"/>
+                </a:solidFill>
+                <a:latin typeface="+mj-lt"/>
+                <a:ea typeface="+mj-ea"/>
+                <a:cs typeface="+mj-cs"/>
+              </a:defRPr>
+            </a:lvl1pPr>
+          </a:lstStyle>
+          <a:p>
+            <a:pPr algn="ctr"/>
+            <a:r>
+              <a:rPr lang="de-DE" dirty="0">
+                <a:latin typeface="ADLaM Display" panose="02010000000000000000" pitchFamily="2" charset="77"/>
+                <a:ea typeface="ADLaM Display" panose="02010000000000000000" pitchFamily="2" charset="77"/>
+                <a:cs typeface="ADLaM Display" panose="02010000000000000000" pitchFamily="2" charset="77"/>
+              </a:rPr>
+              <a:t>Wiederholung: Zirkel &amp; Punkspiegelung</a:t>
+            </a:r>
+          </a:p>
+        </p:txBody>
+      </p:sp>
+      <p:sp>
+        <p:nvSpPr>
+          <p:cNvPr id="2" name="Inhaltsplatzhalter 2">
+            <a:extLst>
+              <a:ext uri="{FF2B5EF4-FFF2-40B4-BE49-F238E27FC236}">
+                <a16:creationId xmlns:a16="http://schemas.microsoft.com/office/drawing/2014/main" id="{42FC0499-C856-06B5-5E9F-6DB0ABE3E14F}"/>
+              </a:ext>
+            </a:extLst>
+          </p:cNvPr>
+          <p:cNvSpPr txBox="1">
+            <a:spLocks/>
+          </p:cNvSpPr>
+          <p:nvPr/>
+        </p:nvSpPr>
+        <p:spPr>
+          <a:xfrm>
+            <a:off x="193623" y="5078627"/>
+            <a:ext cx="11768528" cy="1534168"/>
+          </a:xfrm>
+          <a:prstGeom prst="rect">
+            <a:avLst/>
+          </a:prstGeom>
+        </p:spPr>
+        <p:txBody>
+          <a:bodyPr/>
+          <a:lstStyle>
+            <a:lvl1pPr marL="228600" indent="-228600" algn="l" defTabSz="914400" rtl="0" eaLnBrk="1" latinLnBrk="0" hangingPunct="1">
+              <a:lnSpc>
+                <a:spcPct val="90000"/>
+              </a:lnSpc>
+              <a:spcBef>
+                <a:spcPts val="1000"/>
+              </a:spcBef>
+              <a:buFont typeface="Arial" panose="020B0604020202020204" pitchFamily="34" charset="0"/>
+              <a:buChar char="•"/>
+              <a:defRPr sz="2800" kern="1200">
+                <a:solidFill>
+                  <a:schemeClr val="tx1"/>
+                </a:solidFill>
+                <a:latin typeface="+mn-lt"/>
+                <a:ea typeface="+mn-ea"/>
+                <a:cs typeface="+mn-cs"/>
+              </a:defRPr>
+            </a:lvl1pPr>
+            <a:lvl2pPr marL="685800" indent="-228600" algn="l" defTabSz="914400" rtl="0" eaLnBrk="1" latinLnBrk="0" hangingPunct="1">
+              <a:lnSpc>
+                <a:spcPct val="90000"/>
+              </a:lnSpc>
+              <a:spcBef>
+                <a:spcPts val="500"/>
+              </a:spcBef>
+              <a:buFont typeface="Arial" panose="020B0604020202020204" pitchFamily="34" charset="0"/>
+              <a:buChar char="•"/>
+              <a:defRPr sz="2400" kern="1200">
+                <a:solidFill>
+                  <a:schemeClr val="tx1"/>
+                </a:solidFill>
+                <a:latin typeface="+mn-lt"/>
+                <a:ea typeface="+mn-ea"/>
+                <a:cs typeface="+mn-cs"/>
+              </a:defRPr>
+            </a:lvl2pPr>
+            <a:lvl3pPr marL="1143000" indent="-228600" algn="l" defTabSz="914400" rtl="0" eaLnBrk="1" latinLnBrk="0" hangingPunct="1">
+              <a:lnSpc>
+                <a:spcPct val="90000"/>
+              </a:lnSpc>
+              <a:spcBef>
+                <a:spcPts val="500"/>
+              </a:spcBef>
+              <a:buFont typeface="Arial" panose="020B0604020202020204" pitchFamily="34" charset="0"/>
+              <a:buChar char="•"/>
+              <a:defRPr sz="2000" kern="1200">
+                <a:solidFill>
+                  <a:schemeClr val="tx1"/>
+                </a:solidFill>
+                <a:latin typeface="+mn-lt"/>
+                <a:ea typeface="+mn-ea"/>
+                <a:cs typeface="+mn-cs"/>
+              </a:defRPr>
+            </a:lvl3pPr>
+            <a:lvl4pPr marL="1600200" indent="-228600" algn="l" defTabSz="914400" rtl="0" eaLnBrk="1" latinLnBrk="0" hangingPunct="1">
+              <a:lnSpc>
+                <a:spcPct val="90000"/>
+              </a:lnSpc>
+              <a:spcBef>
+                <a:spcPts val="500"/>
+              </a:spcBef>
+              <a:buFont typeface="Arial" panose="020B0604020202020204" pitchFamily="34" charset="0"/>
+              <a:buChar char="•"/>
+              <a:defRPr sz="1800" kern="1200">
+                <a:solidFill>
+                  <a:schemeClr val="tx1"/>
+                </a:solidFill>
+                <a:latin typeface="+mn-lt"/>
+                <a:ea typeface="+mn-ea"/>
+                <a:cs typeface="+mn-cs"/>
+              </a:defRPr>
+            </a:lvl4pPr>
+            <a:lvl5pPr marL="2057400" indent="-228600" algn="l" defTabSz="914400" rtl="0" eaLnBrk="1" latinLnBrk="0" hangingPunct="1">
+              <a:lnSpc>
+                <a:spcPct val="90000"/>
+              </a:lnSpc>
+              <a:spcBef>
+                <a:spcPts val="500"/>
+              </a:spcBef>
+              <a:buFont typeface="Arial" panose="020B0604020202020204" pitchFamily="34" charset="0"/>
+              <a:buChar char="•"/>
+              <a:defRPr sz="1800" kern="1200">
+                <a:solidFill>
+                  <a:schemeClr val="tx1"/>
+                </a:solidFill>
+                <a:latin typeface="+mn-lt"/>
+                <a:ea typeface="+mn-ea"/>
+                <a:cs typeface="+mn-cs"/>
+              </a:defRPr>
+            </a:lvl5pPr>
+            <a:lvl6pPr marL="2514600" indent="-228600" algn="l" defTabSz="914400" rtl="0" eaLnBrk="1" latinLnBrk="0" hangingPunct="1">
+              <a:lnSpc>
+                <a:spcPct val="90000"/>
+              </a:lnSpc>
+              <a:spcBef>
+                <a:spcPts val="500"/>
+              </a:spcBef>
+              <a:buFont typeface="Arial" panose="020B0604020202020204" pitchFamily="34" charset="0"/>
+              <a:buChar char="•"/>
+              <a:defRPr sz="1800" kern="1200">
+                <a:solidFill>
+                  <a:schemeClr val="tx1"/>
+                </a:solidFill>
+                <a:latin typeface="+mn-lt"/>
+                <a:ea typeface="+mn-ea"/>
+                <a:cs typeface="+mn-cs"/>
+              </a:defRPr>
+            </a:lvl6pPr>
+            <a:lvl7pPr marL="2971800" indent="-228600" algn="l" defTabSz="914400" rtl="0" eaLnBrk="1" latinLnBrk="0" hangingPunct="1">
+              <a:lnSpc>
+                <a:spcPct val="90000"/>
+              </a:lnSpc>
+              <a:spcBef>
+                <a:spcPts val="500"/>
+              </a:spcBef>
+              <a:buFont typeface="Arial" panose="020B0604020202020204" pitchFamily="34" charset="0"/>
+              <a:buChar char="•"/>
+              <a:defRPr sz="1800" kern="1200">
+                <a:solidFill>
+                  <a:schemeClr val="tx1"/>
+                </a:solidFill>
+                <a:latin typeface="+mn-lt"/>
+                <a:ea typeface="+mn-ea"/>
+                <a:cs typeface="+mn-cs"/>
+              </a:defRPr>
+            </a:lvl7pPr>
+            <a:lvl8pPr marL="3429000" indent="-228600" algn="l" defTabSz="914400" rtl="0" eaLnBrk="1" latinLnBrk="0" hangingPunct="1">
+              <a:lnSpc>
+                <a:spcPct val="90000"/>
+              </a:lnSpc>
+              <a:spcBef>
+                <a:spcPts val="500"/>
+              </a:spcBef>
+              <a:buFont typeface="Arial" panose="020B0604020202020204" pitchFamily="34" charset="0"/>
+              <a:buChar char="•"/>
+              <a:defRPr sz="1800" kern="1200">
+                <a:solidFill>
+                  <a:schemeClr val="tx1"/>
+                </a:solidFill>
+                <a:latin typeface="+mn-lt"/>
+                <a:ea typeface="+mn-ea"/>
+                <a:cs typeface="+mn-cs"/>
+              </a:defRPr>
+            </a:lvl8pPr>
+            <a:lvl9pPr marL="3886200" indent="-228600" algn="l" defTabSz="914400" rtl="0" eaLnBrk="1" latinLnBrk="0" hangingPunct="1">
+              <a:lnSpc>
+                <a:spcPct val="90000"/>
+              </a:lnSpc>
+              <a:spcBef>
+                <a:spcPts val="500"/>
+              </a:spcBef>
+              <a:buFont typeface="Arial" panose="020B0604020202020204" pitchFamily="34" charset="0"/>
+              <a:buChar char="•"/>
+              <a:defRPr sz="1800" kern="1200">
+                <a:solidFill>
+                  <a:schemeClr val="tx1"/>
+                </a:solidFill>
+                <a:latin typeface="+mn-lt"/>
+                <a:ea typeface="+mn-ea"/>
+                <a:cs typeface="+mn-cs"/>
+              </a:defRPr>
+            </a:lvl9pPr>
+          </a:lstStyle>
+          <a:p>
+            <a:pPr marL="0" indent="0">
+              <a:buNone/>
+            </a:pPr>
+            <a:r>
+              <a:rPr lang="de-DE" b="1" dirty="0"/>
+              <a:t>HA</a:t>
+            </a:r>
+            <a:r>
+              <a:rPr lang="de-DE" dirty="0"/>
+              <a:t> - Arbeitsheft</a:t>
+            </a:r>
+          </a:p>
+          <a:p>
+            <a:r>
+              <a:rPr lang="de-DE" dirty="0"/>
+              <a:t>S. 31 – Zirkel				-- WDH</a:t>
+            </a:r>
+          </a:p>
+          <a:p>
+            <a:r>
+              <a:rPr lang="de-DE" dirty="0"/>
+              <a:t>S. 32 – Punktspiegelung		-- WDH</a:t>
+            </a:r>
+          </a:p>
+          <a:p>
+            <a:pPr marL="0" indent="0">
+              <a:buNone/>
+            </a:pPr>
+            <a:endParaRPr lang="de-DE" dirty="0"/>
+          </a:p>
+        </p:txBody>
+      </p:sp>
+    </p:spTree>
+    <p:extLst>
+      <p:ext uri="{BB962C8B-B14F-4D97-AF65-F5344CB8AC3E}">
+        <p14:creationId xmlns:p14="http://schemas.microsoft.com/office/powerpoint/2010/main" val="3519360287"/>
+      </p:ext>
+    </p:extLst>
+  </p:cSld>
+  <p:clrMapOvr>
+    <a:masterClrMapping/>
+  </p:clrMapOvr>
+</p:sld>
+</file>
+
+<file path=ppt/slides/slide12.xml><?xml version="1.0" encoding="utf-8"?>
+<p:sld xmlns:a="http://schemas.openxmlformats.org/drawingml/2006/main" xmlns:r="http://schemas.openxmlformats.org/officeDocument/2006/relationships" xmlns:p="http://schemas.openxmlformats.org/presentationml/2006/main">
+  <p:cSld>
+    <p:spTree>
+      <p:nvGrpSpPr>
+        <p:cNvPr id="1" name="">
+          <a:extLst>
+            <a:ext uri="{FF2B5EF4-FFF2-40B4-BE49-F238E27FC236}">
+              <a16:creationId xmlns:a16="http://schemas.microsoft.com/office/drawing/2014/main" id="{9222C1B5-FD3F-140B-0240-6286CB108925}"/>
+            </a:ext>
+          </a:extLst>
+        </p:cNvPr>
+        <p:cNvGrpSpPr/>
+        <p:nvPr/>
+      </p:nvGrpSpPr>
+      <p:grpSpPr>
+        <a:xfrm>
+          <a:off x="0" y="0"/>
+          <a:ext cx="0" cy="0"/>
+          <a:chOff x="0" y="0"/>
+          <a:chExt cx="0" cy="0"/>
+        </a:xfrm>
+      </p:grpSpPr>
+      <p:sp>
+        <p:nvSpPr>
+          <p:cNvPr id="3" name="Titel 1">
+            <a:extLst>
+              <a:ext uri="{FF2B5EF4-FFF2-40B4-BE49-F238E27FC236}">
+                <a16:creationId xmlns:a16="http://schemas.microsoft.com/office/drawing/2014/main" id="{9EC30369-1B87-EE63-02B2-F5EE2C8932EA}"/>
+              </a:ext>
+            </a:extLst>
+          </p:cNvPr>
+          <p:cNvSpPr txBox="1">
+            <a:spLocks/>
+          </p:cNvSpPr>
+          <p:nvPr/>
+        </p:nvSpPr>
+        <p:spPr>
+          <a:xfrm>
+            <a:off x="193623" y="425086"/>
+            <a:ext cx="11768528" cy="549275"/>
+          </a:xfrm>
+          <a:prstGeom prst="rect">
+            <a:avLst/>
+          </a:prstGeom>
+        </p:spPr>
+        <p:txBody>
+          <a:bodyPr>
+            <a:normAutofit fontScale="90000" lnSpcReduction="20000"/>
+          </a:bodyPr>
+          <a:lstStyle>
+            <a:lvl1pPr algn="l" defTabSz="914400" rtl="0" eaLnBrk="1" latinLnBrk="0" hangingPunct="1">
+              <a:lnSpc>
+                <a:spcPct val="90000"/>
+              </a:lnSpc>
+              <a:spcBef>
+                <a:spcPct val="0"/>
+              </a:spcBef>
+              <a:buNone/>
+              <a:defRPr sz="4400" kern="1200">
+                <a:solidFill>
+                  <a:schemeClr val="tx1"/>
+                </a:solidFill>
+                <a:latin typeface="+mj-lt"/>
+                <a:ea typeface="+mj-ea"/>
+                <a:cs typeface="+mj-cs"/>
+              </a:defRPr>
+            </a:lvl1pPr>
+          </a:lstStyle>
+          <a:p>
+            <a:pPr algn="ctr"/>
+            <a:r>
+              <a:rPr lang="de-DE" dirty="0">
+                <a:latin typeface="ADLaM Display" panose="02010000000000000000" pitchFamily="2" charset="77"/>
+                <a:ea typeface="ADLaM Display" panose="02010000000000000000" pitchFamily="2" charset="77"/>
+                <a:cs typeface="ADLaM Display" panose="02010000000000000000" pitchFamily="2" charset="77"/>
+              </a:rPr>
+              <a:t>Grundbegriffe</a:t>
+            </a:r>
+          </a:p>
+        </p:txBody>
+      </p:sp>
+      <p:sp>
+        <p:nvSpPr>
+          <p:cNvPr id="2" name="Inhaltsplatzhalter 2">
+            <a:extLst>
+              <a:ext uri="{FF2B5EF4-FFF2-40B4-BE49-F238E27FC236}">
+                <a16:creationId xmlns:a16="http://schemas.microsoft.com/office/drawing/2014/main" id="{28678534-CDB9-14A7-825C-F99236BE0A48}"/>
+              </a:ext>
+            </a:extLst>
+          </p:cNvPr>
+          <p:cNvSpPr txBox="1">
+            <a:spLocks/>
+          </p:cNvSpPr>
+          <p:nvPr/>
+        </p:nvSpPr>
+        <p:spPr>
+          <a:xfrm>
+            <a:off x="193623" y="5577840"/>
+            <a:ext cx="11768528" cy="1034955"/>
+          </a:xfrm>
+          <a:prstGeom prst="rect">
+            <a:avLst/>
+          </a:prstGeom>
+        </p:spPr>
+        <p:txBody>
+          <a:bodyPr/>
+          <a:lstStyle>
+            <a:lvl1pPr marL="228600" indent="-228600" algn="l" defTabSz="914400" rtl="0" eaLnBrk="1" latinLnBrk="0" hangingPunct="1">
+              <a:lnSpc>
+                <a:spcPct val="90000"/>
+              </a:lnSpc>
+              <a:spcBef>
+                <a:spcPts val="1000"/>
+              </a:spcBef>
+              <a:buFont typeface="Arial" panose="020B0604020202020204" pitchFamily="34" charset="0"/>
+              <a:buChar char="•"/>
+              <a:defRPr sz="2800" kern="1200">
+                <a:solidFill>
+                  <a:schemeClr val="tx1"/>
+                </a:solidFill>
+                <a:latin typeface="+mn-lt"/>
+                <a:ea typeface="+mn-ea"/>
+                <a:cs typeface="+mn-cs"/>
+              </a:defRPr>
+            </a:lvl1pPr>
+            <a:lvl2pPr marL="685800" indent="-228600" algn="l" defTabSz="914400" rtl="0" eaLnBrk="1" latinLnBrk="0" hangingPunct="1">
+              <a:lnSpc>
+                <a:spcPct val="90000"/>
+              </a:lnSpc>
+              <a:spcBef>
+                <a:spcPts val="500"/>
+              </a:spcBef>
+              <a:buFont typeface="Arial" panose="020B0604020202020204" pitchFamily="34" charset="0"/>
+              <a:buChar char="•"/>
+              <a:defRPr sz="2400" kern="1200">
+                <a:solidFill>
+                  <a:schemeClr val="tx1"/>
+                </a:solidFill>
+                <a:latin typeface="+mn-lt"/>
+                <a:ea typeface="+mn-ea"/>
+                <a:cs typeface="+mn-cs"/>
+              </a:defRPr>
+            </a:lvl2pPr>
+            <a:lvl3pPr marL="1143000" indent="-228600" algn="l" defTabSz="914400" rtl="0" eaLnBrk="1" latinLnBrk="0" hangingPunct="1">
+              <a:lnSpc>
+                <a:spcPct val="90000"/>
+              </a:lnSpc>
+              <a:spcBef>
+                <a:spcPts val="500"/>
+              </a:spcBef>
+              <a:buFont typeface="Arial" panose="020B0604020202020204" pitchFamily="34" charset="0"/>
+              <a:buChar char="•"/>
+              <a:defRPr sz="2000" kern="1200">
+                <a:solidFill>
+                  <a:schemeClr val="tx1"/>
+                </a:solidFill>
+                <a:latin typeface="+mn-lt"/>
+                <a:ea typeface="+mn-ea"/>
+                <a:cs typeface="+mn-cs"/>
+              </a:defRPr>
+            </a:lvl3pPr>
+            <a:lvl4pPr marL="1600200" indent="-228600" algn="l" defTabSz="914400" rtl="0" eaLnBrk="1" latinLnBrk="0" hangingPunct="1">
+              <a:lnSpc>
+                <a:spcPct val="90000"/>
+              </a:lnSpc>
+              <a:spcBef>
+                <a:spcPts val="500"/>
+              </a:spcBef>
+              <a:buFont typeface="Arial" panose="020B0604020202020204" pitchFamily="34" charset="0"/>
+              <a:buChar char="•"/>
+              <a:defRPr sz="1800" kern="1200">
+                <a:solidFill>
+                  <a:schemeClr val="tx1"/>
+                </a:solidFill>
+                <a:latin typeface="+mn-lt"/>
+                <a:ea typeface="+mn-ea"/>
+                <a:cs typeface="+mn-cs"/>
+              </a:defRPr>
+            </a:lvl4pPr>
+            <a:lvl5pPr marL="2057400" indent="-228600" algn="l" defTabSz="914400" rtl="0" eaLnBrk="1" latinLnBrk="0" hangingPunct="1">
+              <a:lnSpc>
+                <a:spcPct val="90000"/>
+              </a:lnSpc>
+              <a:spcBef>
+                <a:spcPts val="500"/>
+              </a:spcBef>
+              <a:buFont typeface="Arial" panose="020B0604020202020204" pitchFamily="34" charset="0"/>
+              <a:buChar char="•"/>
+              <a:defRPr sz="1800" kern="1200">
+                <a:solidFill>
+                  <a:schemeClr val="tx1"/>
+                </a:solidFill>
+                <a:latin typeface="+mn-lt"/>
+                <a:ea typeface="+mn-ea"/>
+                <a:cs typeface="+mn-cs"/>
+              </a:defRPr>
+            </a:lvl5pPr>
+            <a:lvl6pPr marL="2514600" indent="-228600" algn="l" defTabSz="914400" rtl="0" eaLnBrk="1" latinLnBrk="0" hangingPunct="1">
+              <a:lnSpc>
+                <a:spcPct val="90000"/>
+              </a:lnSpc>
+              <a:spcBef>
+                <a:spcPts val="500"/>
+              </a:spcBef>
+              <a:buFont typeface="Arial" panose="020B0604020202020204" pitchFamily="34" charset="0"/>
+              <a:buChar char="•"/>
+              <a:defRPr sz="1800" kern="1200">
+                <a:solidFill>
+                  <a:schemeClr val="tx1"/>
+                </a:solidFill>
+                <a:latin typeface="+mn-lt"/>
+                <a:ea typeface="+mn-ea"/>
+                <a:cs typeface="+mn-cs"/>
+              </a:defRPr>
+            </a:lvl6pPr>
+            <a:lvl7pPr marL="2971800" indent="-228600" algn="l" defTabSz="914400" rtl="0" eaLnBrk="1" latinLnBrk="0" hangingPunct="1">
+              <a:lnSpc>
+                <a:spcPct val="90000"/>
+              </a:lnSpc>
+              <a:spcBef>
+                <a:spcPts val="500"/>
+              </a:spcBef>
+              <a:buFont typeface="Arial" panose="020B0604020202020204" pitchFamily="34" charset="0"/>
+              <a:buChar char="•"/>
+              <a:defRPr sz="1800" kern="1200">
+                <a:solidFill>
+                  <a:schemeClr val="tx1"/>
+                </a:solidFill>
+                <a:latin typeface="+mn-lt"/>
+                <a:ea typeface="+mn-ea"/>
+                <a:cs typeface="+mn-cs"/>
+              </a:defRPr>
+            </a:lvl7pPr>
+            <a:lvl8pPr marL="3429000" indent="-228600" algn="l" defTabSz="914400" rtl="0" eaLnBrk="1" latinLnBrk="0" hangingPunct="1">
+              <a:lnSpc>
+                <a:spcPct val="90000"/>
+              </a:lnSpc>
+              <a:spcBef>
+                <a:spcPts val="500"/>
+              </a:spcBef>
+              <a:buFont typeface="Arial" panose="020B0604020202020204" pitchFamily="34" charset="0"/>
+              <a:buChar char="•"/>
+              <a:defRPr sz="1800" kern="1200">
+                <a:solidFill>
+                  <a:schemeClr val="tx1"/>
+                </a:solidFill>
+                <a:latin typeface="+mn-lt"/>
+                <a:ea typeface="+mn-ea"/>
+                <a:cs typeface="+mn-cs"/>
+              </a:defRPr>
+            </a:lvl8pPr>
+            <a:lvl9pPr marL="3886200" indent="-228600" algn="l" defTabSz="914400" rtl="0" eaLnBrk="1" latinLnBrk="0" hangingPunct="1">
+              <a:lnSpc>
+                <a:spcPct val="90000"/>
+              </a:lnSpc>
+              <a:spcBef>
+                <a:spcPts val="500"/>
+              </a:spcBef>
+              <a:buFont typeface="Arial" panose="020B0604020202020204" pitchFamily="34" charset="0"/>
+              <a:buChar char="•"/>
+              <a:defRPr sz="1800" kern="1200">
+                <a:solidFill>
+                  <a:schemeClr val="tx1"/>
+                </a:solidFill>
+                <a:latin typeface="+mn-lt"/>
+                <a:ea typeface="+mn-ea"/>
+                <a:cs typeface="+mn-cs"/>
+              </a:defRPr>
+            </a:lvl9pPr>
+          </a:lstStyle>
+          <a:p>
+            <a:pPr marL="0" indent="0">
+              <a:buNone/>
+            </a:pPr>
+            <a:r>
+              <a:rPr lang="de-DE" b="1" dirty="0"/>
+              <a:t>HA - </a:t>
+            </a:r>
+            <a:r>
+              <a:rPr lang="de-DE" dirty="0"/>
+              <a:t>Arbeitsheft </a:t>
+            </a:r>
+          </a:p>
+          <a:p>
+            <a:r>
+              <a:rPr lang="de-DE" dirty="0"/>
+              <a:t>S. 33 bis 37 - Doppelspiegelung</a:t>
+            </a:r>
+          </a:p>
+        </p:txBody>
+      </p:sp>
+    </p:spTree>
+    <p:extLst>
+      <p:ext uri="{BB962C8B-B14F-4D97-AF65-F5344CB8AC3E}">
+        <p14:creationId xmlns:p14="http://schemas.microsoft.com/office/powerpoint/2010/main" val="2611820202"/>
+      </p:ext>
+    </p:extLst>
+  </p:cSld>
+  <p:clrMapOvr>
+    <a:masterClrMapping/>
+  </p:clrMapOvr>
+</p:sld>
+</file>
+
 <file path=ppt/slides/slide2.xml><?xml version="1.0" encoding="utf-8"?>
+<p:sld xmlns:a="http://schemas.openxmlformats.org/drawingml/2006/main" xmlns:r="http://schemas.openxmlformats.org/officeDocument/2006/relationships" xmlns:p="http://schemas.openxmlformats.org/presentationml/2006/main">
+  <p:cSld>
+    <p:spTree>
+      <p:nvGrpSpPr>
+        <p:cNvPr id="1" name="">
+          <a:extLst>
+            <a:ext uri="{FF2B5EF4-FFF2-40B4-BE49-F238E27FC236}">
+              <a16:creationId xmlns:a16="http://schemas.microsoft.com/office/drawing/2014/main" id="{53DF5F4C-102E-2FAA-E0F6-EAC29427C1C2}"/>
+            </a:ext>
+          </a:extLst>
+        </p:cNvPr>
+        <p:cNvGrpSpPr/>
+        <p:nvPr/>
+      </p:nvGrpSpPr>
+      <p:grpSpPr>
+        <a:xfrm>
+          <a:off x="0" y="0"/>
+          <a:ext cx="0" cy="0"/>
+          <a:chOff x="0" y="0"/>
+          <a:chExt cx="0" cy="0"/>
+        </a:xfrm>
+      </p:grpSpPr>
+      <p:sp>
+        <p:nvSpPr>
+          <p:cNvPr id="2" name="Titel 1">
+            <a:extLst>
+              <a:ext uri="{FF2B5EF4-FFF2-40B4-BE49-F238E27FC236}">
+                <a16:creationId xmlns:a16="http://schemas.microsoft.com/office/drawing/2014/main" id="{68DC2F80-0867-583C-AC58-8829AB16F9DD}"/>
+              </a:ext>
+            </a:extLst>
+          </p:cNvPr>
+          <p:cNvSpPr>
+            <a:spLocks noGrp="1"/>
+          </p:cNvSpPr>
+          <p:nvPr>
+            <p:ph type="title"/>
+          </p:nvPr>
+        </p:nvSpPr>
+        <p:spPr>
+          <a:xfrm>
+            <a:off x="193623" y="425086"/>
+            <a:ext cx="11768528" cy="549275"/>
+          </a:xfrm>
+        </p:spPr>
+        <p:txBody>
+          <a:bodyPr>
+            <a:normAutofit fontScale="90000"/>
+          </a:bodyPr>
+          <a:lstStyle/>
+          <a:p>
+            <a:pPr algn="ctr"/>
+            <a:r>
+              <a:rPr lang="de-DE" dirty="0">
+                <a:latin typeface="ADLaM Display" panose="02010000000000000000" pitchFamily="2" charset="77"/>
+                <a:ea typeface="ADLaM Display" panose="02010000000000000000" pitchFamily="2" charset="77"/>
+                <a:cs typeface="ADLaM Display" panose="02010000000000000000" pitchFamily="2" charset="77"/>
+              </a:rPr>
+              <a:t>Sitzordnung Computerraum</a:t>
+            </a:r>
+          </a:p>
+        </p:txBody>
+      </p:sp>
+      <p:sp>
+        <p:nvSpPr>
+          <p:cNvPr id="3" name="Inhaltsplatzhalter 2">
+            <a:extLst>
+              <a:ext uri="{FF2B5EF4-FFF2-40B4-BE49-F238E27FC236}">
+                <a16:creationId xmlns:a16="http://schemas.microsoft.com/office/drawing/2014/main" id="{FB5C29FB-88F6-4809-15BC-1B0316BD3AC4}"/>
+              </a:ext>
+            </a:extLst>
+          </p:cNvPr>
+          <p:cNvSpPr>
+            <a:spLocks noGrp="1"/>
+          </p:cNvSpPr>
+          <p:nvPr>
+            <p:ph sz="half" idx="1"/>
+          </p:nvPr>
+        </p:nvSpPr>
+        <p:spPr>
+          <a:xfrm>
+            <a:off x="193623" y="1497496"/>
+            <a:ext cx="11768528" cy="5115299"/>
+          </a:xfrm>
+        </p:spPr>
+        <p:txBody>
+          <a:bodyPr>
+            <a:normAutofit fontScale="92500" lnSpcReduction="20000"/>
+          </a:bodyPr>
+          <a:lstStyle/>
+          <a:p>
+            <a:pPr marL="0" indent="0" fontAlgn="ctr">
+              <a:buNone/>
+            </a:pPr>
+            <a:r>
+              <a:rPr lang="de-DE" dirty="0"/>
+              <a:t>Louisa					Marlene K.		 Adela</a:t>
+            </a:r>
+          </a:p>
+          <a:p>
+            <a:pPr marL="0" indent="0" fontAlgn="ctr">
+              <a:buNone/>
+            </a:pPr>
+            <a:r>
+              <a:rPr lang="de-DE" dirty="0"/>
+              <a:t>Julia		Marlene G.		 	Jasmin 		Friederike</a:t>
+            </a:r>
+          </a:p>
+          <a:p>
+            <a:pPr marL="0" indent="0" fontAlgn="ctr">
+              <a:buNone/>
+            </a:pPr>
+            <a:endParaRPr lang="de-DE" dirty="0"/>
+          </a:p>
+          <a:p>
+            <a:pPr marL="0" indent="0" fontAlgn="ctr">
+              <a:buNone/>
+            </a:pPr>
+            <a:r>
+              <a:rPr lang="de-DE" dirty="0"/>
+              <a:t>Jonas		Samuel			Dennis		Luise</a:t>
+            </a:r>
+          </a:p>
+          <a:p>
+            <a:pPr marL="0" indent="0" algn="just" fontAlgn="ctr">
+              <a:buNone/>
+            </a:pPr>
+            <a:r>
+              <a:rPr lang="de-DE" dirty="0"/>
+              <a:t>Kilian 		Jan				Vincent 		Hannah</a:t>
+            </a:r>
+          </a:p>
+          <a:p>
+            <a:pPr marL="0" indent="0" fontAlgn="ctr">
+              <a:buNone/>
+            </a:pPr>
+            <a:endParaRPr lang="de-DE" dirty="0"/>
+          </a:p>
+          <a:p>
+            <a:pPr marL="0" indent="0" fontAlgn="ctr">
+              <a:buNone/>
+            </a:pPr>
+            <a:endParaRPr lang="de-DE" dirty="0"/>
+          </a:p>
+          <a:p>
+            <a:pPr marL="0" indent="0" fontAlgn="ctr">
+              <a:buNone/>
+            </a:pPr>
+            <a:r>
+              <a:rPr lang="de-DE" dirty="0"/>
+              <a:t>Miró 		Freya				Felix			Niklas</a:t>
+            </a:r>
+          </a:p>
+          <a:p>
+            <a:pPr marL="0" indent="0" fontAlgn="ctr">
+              <a:buNone/>
+            </a:pPr>
+            <a:r>
+              <a:rPr lang="de-DE" dirty="0"/>
+              <a:t>Jonathan 	Josefine			</a:t>
+            </a:r>
+            <a:r>
+              <a:rPr lang="de-DE" dirty="0" err="1"/>
+              <a:t>Lennas</a:t>
+            </a:r>
+            <a:r>
+              <a:rPr lang="de-DE" dirty="0"/>
+              <a:t>		Nils</a:t>
+            </a:r>
+          </a:p>
+          <a:p>
+            <a:pPr marL="0" indent="0" fontAlgn="ctr">
+              <a:buNone/>
+            </a:pPr>
+            <a:endParaRPr lang="de-DE" dirty="0"/>
+          </a:p>
+          <a:p>
+            <a:pPr marL="0" indent="0" fontAlgn="ctr">
+              <a:buNone/>
+            </a:pPr>
+            <a:r>
+              <a:rPr lang="de-DE" dirty="0"/>
+              <a:t>Louis		Bruno				Fabio			Robin</a:t>
+            </a:r>
+          </a:p>
+          <a:p>
+            <a:pPr marL="0" indent="0" fontAlgn="ctr">
+              <a:buNone/>
+            </a:pPr>
+            <a:r>
+              <a:rPr lang="de-DE" dirty="0"/>
+              <a:t>Arthur 	Andreas			Jakob		 	Paul</a:t>
+            </a:r>
+          </a:p>
+        </p:txBody>
+      </p:sp>
+    </p:spTree>
+    <p:extLst>
+      <p:ext uri="{BB962C8B-B14F-4D97-AF65-F5344CB8AC3E}">
+        <p14:creationId xmlns:p14="http://schemas.microsoft.com/office/powerpoint/2010/main" val="3335560466"/>
+      </p:ext>
+    </p:extLst>
+  </p:cSld>
+  <p:clrMapOvr>
+    <a:masterClrMapping/>
+  </p:clrMapOvr>
+</p:sld>
+</file>
+
+<file path=ppt/slides/slide3.xml><?xml version="1.0" encoding="utf-8"?>
 <p:sld xmlns:a="http://schemas.openxmlformats.org/drawingml/2006/main" xmlns:r="http://schemas.openxmlformats.org/officeDocument/2006/relationships" xmlns:p="http://schemas.openxmlformats.org/presentationml/2006/main">
   <p:cSld>
     <p:spTree>
@@ -4060,7 +5338,7 @@
 </p:sld>
 </file>
 
-<file path=ppt/slides/slide3.xml><?xml version="1.0" encoding="utf-8"?>
+<file path=ppt/slides/slide4.xml><?xml version="1.0" encoding="utf-8"?>
 <p:sld xmlns:a="http://schemas.openxmlformats.org/drawingml/2006/main" xmlns:r="http://schemas.openxmlformats.org/officeDocument/2006/relationships" xmlns:p="http://schemas.openxmlformats.org/presentationml/2006/main">
   <p:cSld>
     <p:spTree>
@@ -4111,6 +5389,2497 @@
     <p:extLst>
       <p:ext uri="{BB962C8B-B14F-4D97-AF65-F5344CB8AC3E}">
         <p14:creationId xmlns:p14="http://schemas.microsoft.com/office/powerpoint/2010/main" val="3079377886"/>
+      </p:ext>
+    </p:extLst>
+  </p:cSld>
+  <p:clrMapOvr>
+    <a:masterClrMapping/>
+  </p:clrMapOvr>
+</p:sld>
+</file>
+
+<file path=ppt/slides/slide5.xml><?xml version="1.0" encoding="utf-8"?>
+<p:sld xmlns:a="http://schemas.openxmlformats.org/drawingml/2006/main" xmlns:r="http://schemas.openxmlformats.org/officeDocument/2006/relationships" xmlns:p="http://schemas.openxmlformats.org/presentationml/2006/main">
+  <p:cSld>
+    <p:spTree>
+      <p:nvGrpSpPr>
+        <p:cNvPr id="1" name=""/>
+        <p:cNvGrpSpPr/>
+        <p:nvPr/>
+      </p:nvGrpSpPr>
+      <p:grpSpPr>
+        <a:xfrm>
+          <a:off x="0" y="0"/>
+          <a:ext cx="0" cy="0"/>
+          <a:chOff x="0" y="0"/>
+          <a:chExt cx="0" cy="0"/>
+        </a:xfrm>
+      </p:grpSpPr>
+      <p:sp>
+        <p:nvSpPr>
+          <p:cNvPr id="3" name="Titel 1">
+            <a:extLst>
+              <a:ext uri="{FF2B5EF4-FFF2-40B4-BE49-F238E27FC236}">
+                <a16:creationId xmlns:a16="http://schemas.microsoft.com/office/drawing/2014/main" id="{BA140C9D-1408-E733-FF1E-44847D93BFFB}"/>
+              </a:ext>
+            </a:extLst>
+          </p:cNvPr>
+          <p:cNvSpPr txBox="1">
+            <a:spLocks/>
+          </p:cNvSpPr>
+          <p:nvPr/>
+        </p:nvSpPr>
+        <p:spPr>
+          <a:xfrm>
+            <a:off x="193623" y="425086"/>
+            <a:ext cx="11768528" cy="549275"/>
+          </a:xfrm>
+          <a:prstGeom prst="rect">
+            <a:avLst/>
+          </a:prstGeom>
+        </p:spPr>
+        <p:txBody>
+          <a:bodyPr>
+            <a:normAutofit fontScale="90000" lnSpcReduction="20000"/>
+          </a:bodyPr>
+          <a:lstStyle>
+            <a:lvl1pPr algn="l" defTabSz="914400" rtl="0" eaLnBrk="1" latinLnBrk="0" hangingPunct="1">
+              <a:lnSpc>
+                <a:spcPct val="90000"/>
+              </a:lnSpc>
+              <a:spcBef>
+                <a:spcPct val="0"/>
+              </a:spcBef>
+              <a:buNone/>
+              <a:defRPr sz="4400" kern="1200">
+                <a:solidFill>
+                  <a:schemeClr val="tx1"/>
+                </a:solidFill>
+                <a:latin typeface="+mj-lt"/>
+                <a:ea typeface="+mj-ea"/>
+                <a:cs typeface="+mj-cs"/>
+              </a:defRPr>
+            </a:lvl1pPr>
+          </a:lstStyle>
+          <a:p>
+            <a:pPr algn="ctr"/>
+            <a:r>
+              <a:rPr lang="de-DE" dirty="0">
+                <a:latin typeface="ADLaM Display" panose="02010000000000000000" pitchFamily="2" charset="77"/>
+                <a:ea typeface="ADLaM Display" panose="02010000000000000000" pitchFamily="2" charset="77"/>
+                <a:cs typeface="ADLaM Display" panose="02010000000000000000" pitchFamily="2" charset="77"/>
+              </a:rPr>
+              <a:t>Wiederholung: Achsenspiegelung</a:t>
+            </a:r>
+          </a:p>
+        </p:txBody>
+      </p:sp>
+      <p:sp>
+        <p:nvSpPr>
+          <p:cNvPr id="6" name="Abgerundetes Rechteck 5">
+            <a:extLst>
+              <a:ext uri="{FF2B5EF4-FFF2-40B4-BE49-F238E27FC236}">
+                <a16:creationId xmlns:a16="http://schemas.microsoft.com/office/drawing/2014/main" id="{584FD70A-0EC3-02CD-02E6-2F0482628609}"/>
+              </a:ext>
+            </a:extLst>
+          </p:cNvPr>
+          <p:cNvSpPr/>
+          <p:nvPr/>
+        </p:nvSpPr>
+        <p:spPr>
+          <a:xfrm>
+            <a:off x="193623" y="1240970"/>
+            <a:ext cx="11768527" cy="5382251"/>
+          </a:xfrm>
+          <a:prstGeom prst="roundRect">
+            <a:avLst/>
+          </a:prstGeom>
+        </p:spPr>
+        <p:style>
+          <a:lnRef idx="2">
+            <a:schemeClr val="accent3"/>
+          </a:lnRef>
+          <a:fillRef idx="1">
+            <a:schemeClr val="lt1"/>
+          </a:fillRef>
+          <a:effectRef idx="0">
+            <a:schemeClr val="accent3"/>
+          </a:effectRef>
+          <a:fontRef idx="minor">
+            <a:schemeClr val="dk1"/>
+          </a:fontRef>
+        </p:style>
+        <p:txBody>
+          <a:bodyPr rtlCol="0" anchor="ctr"/>
+          <a:lstStyle/>
+          <a:p>
+            <a:pPr algn="ctr"/>
+            <a:endParaRPr lang="de-DE"/>
+          </a:p>
+        </p:txBody>
+      </p:sp>
+      <p:sp>
+        <p:nvSpPr>
+          <p:cNvPr id="8" name="Inhaltsplatzhalter 2">
+            <a:extLst>
+              <a:ext uri="{FF2B5EF4-FFF2-40B4-BE49-F238E27FC236}">
+                <a16:creationId xmlns:a16="http://schemas.microsoft.com/office/drawing/2014/main" id="{D1B812B5-42BF-7EF8-4EF2-953E9E589C6F}"/>
+              </a:ext>
+            </a:extLst>
+          </p:cNvPr>
+          <p:cNvSpPr txBox="1">
+            <a:spLocks/>
+          </p:cNvSpPr>
+          <p:nvPr/>
+        </p:nvSpPr>
+        <p:spPr>
+          <a:xfrm>
+            <a:off x="423472" y="1559658"/>
+            <a:ext cx="11327804" cy="4396299"/>
+          </a:xfrm>
+          <a:prstGeom prst="rect">
+            <a:avLst/>
+          </a:prstGeom>
+        </p:spPr>
+        <p:txBody>
+          <a:bodyPr/>
+          <a:lstStyle>
+            <a:lvl1pPr marL="228600" indent="-228600" algn="l" defTabSz="914400" rtl="0" eaLnBrk="1" latinLnBrk="0" hangingPunct="1">
+              <a:lnSpc>
+                <a:spcPct val="90000"/>
+              </a:lnSpc>
+              <a:spcBef>
+                <a:spcPts val="1000"/>
+              </a:spcBef>
+              <a:buFont typeface="Arial" panose="020B0604020202020204" pitchFamily="34" charset="0"/>
+              <a:buChar char="•"/>
+              <a:defRPr sz="2800" kern="1200">
+                <a:solidFill>
+                  <a:schemeClr val="tx1"/>
+                </a:solidFill>
+                <a:latin typeface="+mn-lt"/>
+                <a:ea typeface="+mn-ea"/>
+                <a:cs typeface="+mn-cs"/>
+              </a:defRPr>
+            </a:lvl1pPr>
+            <a:lvl2pPr marL="685800" indent="-228600" algn="l" defTabSz="914400" rtl="0" eaLnBrk="1" latinLnBrk="0" hangingPunct="1">
+              <a:lnSpc>
+                <a:spcPct val="90000"/>
+              </a:lnSpc>
+              <a:spcBef>
+                <a:spcPts val="500"/>
+              </a:spcBef>
+              <a:buFont typeface="Arial" panose="020B0604020202020204" pitchFamily="34" charset="0"/>
+              <a:buChar char="•"/>
+              <a:defRPr sz="2400" kern="1200">
+                <a:solidFill>
+                  <a:schemeClr val="tx1"/>
+                </a:solidFill>
+                <a:latin typeface="+mn-lt"/>
+                <a:ea typeface="+mn-ea"/>
+                <a:cs typeface="+mn-cs"/>
+              </a:defRPr>
+            </a:lvl2pPr>
+            <a:lvl3pPr marL="1143000" indent="-228600" algn="l" defTabSz="914400" rtl="0" eaLnBrk="1" latinLnBrk="0" hangingPunct="1">
+              <a:lnSpc>
+                <a:spcPct val="90000"/>
+              </a:lnSpc>
+              <a:spcBef>
+                <a:spcPts val="500"/>
+              </a:spcBef>
+              <a:buFont typeface="Arial" panose="020B0604020202020204" pitchFamily="34" charset="0"/>
+              <a:buChar char="•"/>
+              <a:defRPr sz="2000" kern="1200">
+                <a:solidFill>
+                  <a:schemeClr val="tx1"/>
+                </a:solidFill>
+                <a:latin typeface="+mn-lt"/>
+                <a:ea typeface="+mn-ea"/>
+                <a:cs typeface="+mn-cs"/>
+              </a:defRPr>
+            </a:lvl3pPr>
+            <a:lvl4pPr marL="1600200" indent="-228600" algn="l" defTabSz="914400" rtl="0" eaLnBrk="1" latinLnBrk="0" hangingPunct="1">
+              <a:lnSpc>
+                <a:spcPct val="90000"/>
+              </a:lnSpc>
+              <a:spcBef>
+                <a:spcPts val="500"/>
+              </a:spcBef>
+              <a:buFont typeface="Arial" panose="020B0604020202020204" pitchFamily="34" charset="0"/>
+              <a:buChar char="•"/>
+              <a:defRPr sz="1800" kern="1200">
+                <a:solidFill>
+                  <a:schemeClr val="tx1"/>
+                </a:solidFill>
+                <a:latin typeface="+mn-lt"/>
+                <a:ea typeface="+mn-ea"/>
+                <a:cs typeface="+mn-cs"/>
+              </a:defRPr>
+            </a:lvl4pPr>
+            <a:lvl5pPr marL="2057400" indent="-228600" algn="l" defTabSz="914400" rtl="0" eaLnBrk="1" latinLnBrk="0" hangingPunct="1">
+              <a:lnSpc>
+                <a:spcPct val="90000"/>
+              </a:lnSpc>
+              <a:spcBef>
+                <a:spcPts val="500"/>
+              </a:spcBef>
+              <a:buFont typeface="Arial" panose="020B0604020202020204" pitchFamily="34" charset="0"/>
+              <a:buChar char="•"/>
+              <a:defRPr sz="1800" kern="1200">
+                <a:solidFill>
+                  <a:schemeClr val="tx1"/>
+                </a:solidFill>
+                <a:latin typeface="+mn-lt"/>
+                <a:ea typeface="+mn-ea"/>
+                <a:cs typeface="+mn-cs"/>
+              </a:defRPr>
+            </a:lvl5pPr>
+            <a:lvl6pPr marL="2514600" indent="-228600" algn="l" defTabSz="914400" rtl="0" eaLnBrk="1" latinLnBrk="0" hangingPunct="1">
+              <a:lnSpc>
+                <a:spcPct val="90000"/>
+              </a:lnSpc>
+              <a:spcBef>
+                <a:spcPts val="500"/>
+              </a:spcBef>
+              <a:buFont typeface="Arial" panose="020B0604020202020204" pitchFamily="34" charset="0"/>
+              <a:buChar char="•"/>
+              <a:defRPr sz="1800" kern="1200">
+                <a:solidFill>
+                  <a:schemeClr val="tx1"/>
+                </a:solidFill>
+                <a:latin typeface="+mn-lt"/>
+                <a:ea typeface="+mn-ea"/>
+                <a:cs typeface="+mn-cs"/>
+              </a:defRPr>
+            </a:lvl6pPr>
+            <a:lvl7pPr marL="2971800" indent="-228600" algn="l" defTabSz="914400" rtl="0" eaLnBrk="1" latinLnBrk="0" hangingPunct="1">
+              <a:lnSpc>
+                <a:spcPct val="90000"/>
+              </a:lnSpc>
+              <a:spcBef>
+                <a:spcPts val="500"/>
+              </a:spcBef>
+              <a:buFont typeface="Arial" panose="020B0604020202020204" pitchFamily="34" charset="0"/>
+              <a:buChar char="•"/>
+              <a:defRPr sz="1800" kern="1200">
+                <a:solidFill>
+                  <a:schemeClr val="tx1"/>
+                </a:solidFill>
+                <a:latin typeface="+mn-lt"/>
+                <a:ea typeface="+mn-ea"/>
+                <a:cs typeface="+mn-cs"/>
+              </a:defRPr>
+            </a:lvl7pPr>
+            <a:lvl8pPr marL="3429000" indent="-228600" algn="l" defTabSz="914400" rtl="0" eaLnBrk="1" latinLnBrk="0" hangingPunct="1">
+              <a:lnSpc>
+                <a:spcPct val="90000"/>
+              </a:lnSpc>
+              <a:spcBef>
+                <a:spcPts val="500"/>
+              </a:spcBef>
+              <a:buFont typeface="Arial" panose="020B0604020202020204" pitchFamily="34" charset="0"/>
+              <a:buChar char="•"/>
+              <a:defRPr sz="1800" kern="1200">
+                <a:solidFill>
+                  <a:schemeClr val="tx1"/>
+                </a:solidFill>
+                <a:latin typeface="+mn-lt"/>
+                <a:ea typeface="+mn-ea"/>
+                <a:cs typeface="+mn-cs"/>
+              </a:defRPr>
+            </a:lvl8pPr>
+            <a:lvl9pPr marL="3886200" indent="-228600" algn="l" defTabSz="914400" rtl="0" eaLnBrk="1" latinLnBrk="0" hangingPunct="1">
+              <a:lnSpc>
+                <a:spcPct val="90000"/>
+              </a:lnSpc>
+              <a:spcBef>
+                <a:spcPts val="500"/>
+              </a:spcBef>
+              <a:buFont typeface="Arial" panose="020B0604020202020204" pitchFamily="34" charset="0"/>
+              <a:buChar char="•"/>
+              <a:defRPr sz="1800" kern="1200">
+                <a:solidFill>
+                  <a:schemeClr val="tx1"/>
+                </a:solidFill>
+                <a:latin typeface="+mn-lt"/>
+                <a:ea typeface="+mn-ea"/>
+                <a:cs typeface="+mn-cs"/>
+              </a:defRPr>
+            </a:lvl9pPr>
+          </a:lstStyle>
+          <a:p>
+            <a:pPr marL="0" indent="0" algn="just">
+              <a:buNone/>
+            </a:pPr>
+            <a:r>
+              <a:rPr lang="de-DE" b="1" dirty="0"/>
+              <a:t>Aufgabe 1</a:t>
+            </a:r>
+          </a:p>
+          <a:p>
+            <a:pPr marL="0" indent="0" algn="just">
+              <a:buNone/>
+            </a:pPr>
+            <a:r>
+              <a:rPr lang="de-DE" dirty="0"/>
+              <a:t>Zeichne das Dreieck ABC mit den Eckpunkten A(2/3), B(8,5/1) und C(5/4) sowie die </a:t>
+            </a:r>
+            <a:r>
+              <a:rPr lang="de-DE" dirty="0" err="1"/>
+              <a:t>Berade</a:t>
+            </a:r>
+            <a:r>
+              <a:rPr lang="de-DE" dirty="0"/>
+              <a:t> CD durch die Punkte C und D(3/0). Spiegele dann das Dreieck ABC an der Geraden CD.</a:t>
+            </a:r>
+          </a:p>
+          <a:p>
+            <a:pPr marL="0" indent="0" algn="just">
+              <a:buNone/>
+            </a:pPr>
+            <a:endParaRPr lang="de-DE" dirty="0"/>
+          </a:p>
+          <a:p>
+            <a:pPr marL="0" indent="0" algn="just">
+              <a:buNone/>
+            </a:pPr>
+            <a:r>
+              <a:rPr lang="de-DE" b="1" dirty="0"/>
+              <a:t>Aufgabe 2</a:t>
+            </a:r>
+          </a:p>
+          <a:p>
+            <a:pPr marL="0" indent="0" algn="just">
+              <a:buNone/>
+            </a:pPr>
+            <a:r>
+              <a:rPr lang="de-DE" dirty="0"/>
+              <a:t>Schreibe einen Text der folgende Begriffe beinhaltet:</a:t>
+            </a:r>
+          </a:p>
+          <a:p>
+            <a:pPr marL="0" indent="0" algn="just">
+              <a:buNone/>
+            </a:pPr>
+            <a:r>
+              <a:rPr lang="de-DE" sz="2400" dirty="0">
+                <a:solidFill>
+                  <a:schemeClr val="tx2">
+                    <a:lumMod val="75000"/>
+                    <a:lumOff val="25000"/>
+                  </a:schemeClr>
+                </a:solidFill>
+                <a:latin typeface="Cavolini" panose="03000502040302020204" pitchFamily="66" charset="0"/>
+                <a:ea typeface="ADLaM Display" panose="02010000000000000000" pitchFamily="2" charset="77"/>
+                <a:cs typeface="Cavolini" panose="03000502040302020204" pitchFamily="66" charset="0"/>
+              </a:rPr>
+              <a:t>Originalpunkt, Spiegelachse, parallel, Abstand, Bildpunkt, P, verschiedene Seiten, denselben, P‘, Fixpunkt, Achsenspiegelung, Mittellinie, Geodreieck</a:t>
+            </a:r>
+          </a:p>
+        </p:txBody>
+      </p:sp>
+    </p:spTree>
+    <p:extLst>
+      <p:ext uri="{BB962C8B-B14F-4D97-AF65-F5344CB8AC3E}">
+        <p14:creationId xmlns:p14="http://schemas.microsoft.com/office/powerpoint/2010/main" val="3178181211"/>
+      </p:ext>
+    </p:extLst>
+  </p:cSld>
+  <p:clrMapOvr>
+    <a:masterClrMapping/>
+  </p:clrMapOvr>
+</p:sld>
+</file>
+
+<file path=ppt/slides/slide6.xml><?xml version="1.0" encoding="utf-8"?>
+<p:sld xmlns:a="http://schemas.openxmlformats.org/drawingml/2006/main" xmlns:r="http://schemas.openxmlformats.org/officeDocument/2006/relationships" xmlns:p="http://schemas.openxmlformats.org/presentationml/2006/main">
+  <p:cSld>
+    <p:spTree>
+      <p:nvGrpSpPr>
+        <p:cNvPr id="1" name="">
+          <a:extLst>
+            <a:ext uri="{FF2B5EF4-FFF2-40B4-BE49-F238E27FC236}">
+              <a16:creationId xmlns:a16="http://schemas.microsoft.com/office/drawing/2014/main" id="{9E9A4012-513C-1652-41DD-76A8CF12A7BB}"/>
+            </a:ext>
+          </a:extLst>
+        </p:cNvPr>
+        <p:cNvGrpSpPr/>
+        <p:nvPr/>
+      </p:nvGrpSpPr>
+      <p:grpSpPr>
+        <a:xfrm>
+          <a:off x="0" y="0"/>
+          <a:ext cx="0" cy="0"/>
+          <a:chOff x="0" y="0"/>
+          <a:chExt cx="0" cy="0"/>
+        </a:xfrm>
+      </p:grpSpPr>
+      <p:sp>
+        <p:nvSpPr>
+          <p:cNvPr id="3" name="Titel 1">
+            <a:extLst>
+              <a:ext uri="{FF2B5EF4-FFF2-40B4-BE49-F238E27FC236}">
+                <a16:creationId xmlns:a16="http://schemas.microsoft.com/office/drawing/2014/main" id="{DA84CAF6-1015-5B92-11EB-B7C4A9A15ABB}"/>
+              </a:ext>
+            </a:extLst>
+          </p:cNvPr>
+          <p:cNvSpPr txBox="1">
+            <a:spLocks/>
+          </p:cNvSpPr>
+          <p:nvPr/>
+        </p:nvSpPr>
+        <p:spPr>
+          <a:xfrm>
+            <a:off x="193623" y="425086"/>
+            <a:ext cx="11768528" cy="549275"/>
+          </a:xfrm>
+          <a:prstGeom prst="rect">
+            <a:avLst/>
+          </a:prstGeom>
+        </p:spPr>
+        <p:txBody>
+          <a:bodyPr>
+            <a:normAutofit fontScale="90000" lnSpcReduction="20000"/>
+          </a:bodyPr>
+          <a:lstStyle>
+            <a:lvl1pPr algn="l" defTabSz="914400" rtl="0" eaLnBrk="1" latinLnBrk="0" hangingPunct="1">
+              <a:lnSpc>
+                <a:spcPct val="90000"/>
+              </a:lnSpc>
+              <a:spcBef>
+                <a:spcPct val="0"/>
+              </a:spcBef>
+              <a:buNone/>
+              <a:defRPr sz="4400" kern="1200">
+                <a:solidFill>
+                  <a:schemeClr val="tx1"/>
+                </a:solidFill>
+                <a:latin typeface="+mj-lt"/>
+                <a:ea typeface="+mj-ea"/>
+                <a:cs typeface="+mj-cs"/>
+              </a:defRPr>
+            </a:lvl1pPr>
+          </a:lstStyle>
+          <a:p>
+            <a:pPr algn="ctr"/>
+            <a:r>
+              <a:rPr lang="de-DE" dirty="0">
+                <a:latin typeface="ADLaM Display" panose="02010000000000000000" pitchFamily="2" charset="77"/>
+                <a:ea typeface="ADLaM Display" panose="02010000000000000000" pitchFamily="2" charset="77"/>
+                <a:cs typeface="ADLaM Display" panose="02010000000000000000" pitchFamily="2" charset="77"/>
+              </a:rPr>
+              <a:t>Wiederholung: Achsenspiegelung</a:t>
+            </a:r>
+          </a:p>
+        </p:txBody>
+      </p:sp>
+      <p:sp>
+        <p:nvSpPr>
+          <p:cNvPr id="6" name="Abgerundetes Rechteck 5">
+            <a:extLst>
+              <a:ext uri="{FF2B5EF4-FFF2-40B4-BE49-F238E27FC236}">
+                <a16:creationId xmlns:a16="http://schemas.microsoft.com/office/drawing/2014/main" id="{E4979463-21F0-7B46-6790-38104BDD00F1}"/>
+              </a:ext>
+            </a:extLst>
+          </p:cNvPr>
+          <p:cNvSpPr/>
+          <p:nvPr/>
+        </p:nvSpPr>
+        <p:spPr>
+          <a:xfrm>
+            <a:off x="193623" y="1240970"/>
+            <a:ext cx="11768527" cy="5382251"/>
+          </a:xfrm>
+          <a:prstGeom prst="roundRect">
+            <a:avLst/>
+          </a:prstGeom>
+        </p:spPr>
+        <p:style>
+          <a:lnRef idx="2">
+            <a:schemeClr val="accent3"/>
+          </a:lnRef>
+          <a:fillRef idx="1">
+            <a:schemeClr val="lt1"/>
+          </a:fillRef>
+          <a:effectRef idx="0">
+            <a:schemeClr val="accent3"/>
+          </a:effectRef>
+          <a:fontRef idx="minor">
+            <a:schemeClr val="dk1"/>
+          </a:fontRef>
+        </p:style>
+        <p:txBody>
+          <a:bodyPr rtlCol="0" anchor="ctr"/>
+          <a:lstStyle/>
+          <a:p>
+            <a:pPr algn="ctr"/>
+            <a:endParaRPr lang="de-DE"/>
+          </a:p>
+        </p:txBody>
+      </p:sp>
+      <p:sp>
+        <p:nvSpPr>
+          <p:cNvPr id="8" name="Inhaltsplatzhalter 2">
+            <a:extLst>
+              <a:ext uri="{FF2B5EF4-FFF2-40B4-BE49-F238E27FC236}">
+                <a16:creationId xmlns:a16="http://schemas.microsoft.com/office/drawing/2014/main" id="{FDCFFAF8-DA45-C902-D19F-089239CD514F}"/>
+              </a:ext>
+            </a:extLst>
+          </p:cNvPr>
+          <p:cNvSpPr txBox="1">
+            <a:spLocks/>
+          </p:cNvSpPr>
+          <p:nvPr/>
+        </p:nvSpPr>
+        <p:spPr>
+          <a:xfrm>
+            <a:off x="423472" y="1559658"/>
+            <a:ext cx="11327804" cy="4396299"/>
+          </a:xfrm>
+          <a:prstGeom prst="rect">
+            <a:avLst/>
+          </a:prstGeom>
+        </p:spPr>
+        <p:txBody>
+          <a:bodyPr/>
+          <a:lstStyle>
+            <a:lvl1pPr marL="228600" indent="-228600" algn="l" defTabSz="914400" rtl="0" eaLnBrk="1" latinLnBrk="0" hangingPunct="1">
+              <a:lnSpc>
+                <a:spcPct val="90000"/>
+              </a:lnSpc>
+              <a:spcBef>
+                <a:spcPts val="1000"/>
+              </a:spcBef>
+              <a:buFont typeface="Arial" panose="020B0604020202020204" pitchFamily="34" charset="0"/>
+              <a:buChar char="•"/>
+              <a:defRPr sz="2800" kern="1200">
+                <a:solidFill>
+                  <a:schemeClr val="tx1"/>
+                </a:solidFill>
+                <a:latin typeface="+mn-lt"/>
+                <a:ea typeface="+mn-ea"/>
+                <a:cs typeface="+mn-cs"/>
+              </a:defRPr>
+            </a:lvl1pPr>
+            <a:lvl2pPr marL="685800" indent="-228600" algn="l" defTabSz="914400" rtl="0" eaLnBrk="1" latinLnBrk="0" hangingPunct="1">
+              <a:lnSpc>
+                <a:spcPct val="90000"/>
+              </a:lnSpc>
+              <a:spcBef>
+                <a:spcPts val="500"/>
+              </a:spcBef>
+              <a:buFont typeface="Arial" panose="020B0604020202020204" pitchFamily="34" charset="0"/>
+              <a:buChar char="•"/>
+              <a:defRPr sz="2400" kern="1200">
+                <a:solidFill>
+                  <a:schemeClr val="tx1"/>
+                </a:solidFill>
+                <a:latin typeface="+mn-lt"/>
+                <a:ea typeface="+mn-ea"/>
+                <a:cs typeface="+mn-cs"/>
+              </a:defRPr>
+            </a:lvl2pPr>
+            <a:lvl3pPr marL="1143000" indent="-228600" algn="l" defTabSz="914400" rtl="0" eaLnBrk="1" latinLnBrk="0" hangingPunct="1">
+              <a:lnSpc>
+                <a:spcPct val="90000"/>
+              </a:lnSpc>
+              <a:spcBef>
+                <a:spcPts val="500"/>
+              </a:spcBef>
+              <a:buFont typeface="Arial" panose="020B0604020202020204" pitchFamily="34" charset="0"/>
+              <a:buChar char="•"/>
+              <a:defRPr sz="2000" kern="1200">
+                <a:solidFill>
+                  <a:schemeClr val="tx1"/>
+                </a:solidFill>
+                <a:latin typeface="+mn-lt"/>
+                <a:ea typeface="+mn-ea"/>
+                <a:cs typeface="+mn-cs"/>
+              </a:defRPr>
+            </a:lvl3pPr>
+            <a:lvl4pPr marL="1600200" indent="-228600" algn="l" defTabSz="914400" rtl="0" eaLnBrk="1" latinLnBrk="0" hangingPunct="1">
+              <a:lnSpc>
+                <a:spcPct val="90000"/>
+              </a:lnSpc>
+              <a:spcBef>
+                <a:spcPts val="500"/>
+              </a:spcBef>
+              <a:buFont typeface="Arial" panose="020B0604020202020204" pitchFamily="34" charset="0"/>
+              <a:buChar char="•"/>
+              <a:defRPr sz="1800" kern="1200">
+                <a:solidFill>
+                  <a:schemeClr val="tx1"/>
+                </a:solidFill>
+                <a:latin typeface="+mn-lt"/>
+                <a:ea typeface="+mn-ea"/>
+                <a:cs typeface="+mn-cs"/>
+              </a:defRPr>
+            </a:lvl4pPr>
+            <a:lvl5pPr marL="2057400" indent="-228600" algn="l" defTabSz="914400" rtl="0" eaLnBrk="1" latinLnBrk="0" hangingPunct="1">
+              <a:lnSpc>
+                <a:spcPct val="90000"/>
+              </a:lnSpc>
+              <a:spcBef>
+                <a:spcPts val="500"/>
+              </a:spcBef>
+              <a:buFont typeface="Arial" panose="020B0604020202020204" pitchFamily="34" charset="0"/>
+              <a:buChar char="•"/>
+              <a:defRPr sz="1800" kern="1200">
+                <a:solidFill>
+                  <a:schemeClr val="tx1"/>
+                </a:solidFill>
+                <a:latin typeface="+mn-lt"/>
+                <a:ea typeface="+mn-ea"/>
+                <a:cs typeface="+mn-cs"/>
+              </a:defRPr>
+            </a:lvl5pPr>
+            <a:lvl6pPr marL="2514600" indent="-228600" algn="l" defTabSz="914400" rtl="0" eaLnBrk="1" latinLnBrk="0" hangingPunct="1">
+              <a:lnSpc>
+                <a:spcPct val="90000"/>
+              </a:lnSpc>
+              <a:spcBef>
+                <a:spcPts val="500"/>
+              </a:spcBef>
+              <a:buFont typeface="Arial" panose="020B0604020202020204" pitchFamily="34" charset="0"/>
+              <a:buChar char="•"/>
+              <a:defRPr sz="1800" kern="1200">
+                <a:solidFill>
+                  <a:schemeClr val="tx1"/>
+                </a:solidFill>
+                <a:latin typeface="+mn-lt"/>
+                <a:ea typeface="+mn-ea"/>
+                <a:cs typeface="+mn-cs"/>
+              </a:defRPr>
+            </a:lvl6pPr>
+            <a:lvl7pPr marL="2971800" indent="-228600" algn="l" defTabSz="914400" rtl="0" eaLnBrk="1" latinLnBrk="0" hangingPunct="1">
+              <a:lnSpc>
+                <a:spcPct val="90000"/>
+              </a:lnSpc>
+              <a:spcBef>
+                <a:spcPts val="500"/>
+              </a:spcBef>
+              <a:buFont typeface="Arial" panose="020B0604020202020204" pitchFamily="34" charset="0"/>
+              <a:buChar char="•"/>
+              <a:defRPr sz="1800" kern="1200">
+                <a:solidFill>
+                  <a:schemeClr val="tx1"/>
+                </a:solidFill>
+                <a:latin typeface="+mn-lt"/>
+                <a:ea typeface="+mn-ea"/>
+                <a:cs typeface="+mn-cs"/>
+              </a:defRPr>
+            </a:lvl7pPr>
+            <a:lvl8pPr marL="3429000" indent="-228600" algn="l" defTabSz="914400" rtl="0" eaLnBrk="1" latinLnBrk="0" hangingPunct="1">
+              <a:lnSpc>
+                <a:spcPct val="90000"/>
+              </a:lnSpc>
+              <a:spcBef>
+                <a:spcPts val="500"/>
+              </a:spcBef>
+              <a:buFont typeface="Arial" panose="020B0604020202020204" pitchFamily="34" charset="0"/>
+              <a:buChar char="•"/>
+              <a:defRPr sz="1800" kern="1200">
+                <a:solidFill>
+                  <a:schemeClr val="tx1"/>
+                </a:solidFill>
+                <a:latin typeface="+mn-lt"/>
+                <a:ea typeface="+mn-ea"/>
+                <a:cs typeface="+mn-cs"/>
+              </a:defRPr>
+            </a:lvl8pPr>
+            <a:lvl9pPr marL="3886200" indent="-228600" algn="l" defTabSz="914400" rtl="0" eaLnBrk="1" latinLnBrk="0" hangingPunct="1">
+              <a:lnSpc>
+                <a:spcPct val="90000"/>
+              </a:lnSpc>
+              <a:spcBef>
+                <a:spcPts val="500"/>
+              </a:spcBef>
+              <a:buFont typeface="Arial" panose="020B0604020202020204" pitchFamily="34" charset="0"/>
+              <a:buChar char="•"/>
+              <a:defRPr sz="1800" kern="1200">
+                <a:solidFill>
+                  <a:schemeClr val="tx1"/>
+                </a:solidFill>
+                <a:latin typeface="+mn-lt"/>
+                <a:ea typeface="+mn-ea"/>
+                <a:cs typeface="+mn-cs"/>
+              </a:defRPr>
+            </a:lvl9pPr>
+          </a:lstStyle>
+          <a:p>
+            <a:pPr marL="0" indent="0" algn="just">
+              <a:buNone/>
+            </a:pPr>
+            <a:r>
+              <a:rPr lang="de-DE" b="1" dirty="0"/>
+              <a:t>Aufgabe 3</a:t>
+            </a:r>
+          </a:p>
+          <a:p>
+            <a:pPr marL="0" indent="0" algn="just">
+              <a:buNone/>
+            </a:pPr>
+            <a:r>
+              <a:rPr lang="de-DE" dirty="0"/>
+              <a:t>Schreibe in dein Heft. Fülle die 6 Lücken!</a:t>
+            </a:r>
+          </a:p>
+        </p:txBody>
+      </p:sp>
+      <p:pic>
+        <p:nvPicPr>
+          <p:cNvPr id="2" name="Grafik 1" descr="Ein Bild, das Text, Schrift, Reihe, Origami enthält.&#10;&#10;KI-generierte Inhalte können fehlerhaft sein.">
+            <a:extLst>
+              <a:ext uri="{FF2B5EF4-FFF2-40B4-BE49-F238E27FC236}">
+                <a16:creationId xmlns:a16="http://schemas.microsoft.com/office/drawing/2014/main" id="{331837AE-C8B3-8928-BB35-E7247ED0A94E}"/>
+              </a:ext>
+            </a:extLst>
+          </p:cNvPr>
+          <p:cNvPicPr>
+            <a:picLocks noChangeAspect="1"/>
+          </p:cNvPicPr>
+          <p:nvPr/>
+        </p:nvPicPr>
+        <p:blipFill>
+          <a:blip r:embed="rId2"/>
+          <a:stretch>
+            <a:fillRect/>
+          </a:stretch>
+        </p:blipFill>
+        <p:spPr>
+          <a:xfrm>
+            <a:off x="423471" y="2637246"/>
+            <a:ext cx="11509575" cy="3318711"/>
+          </a:xfrm>
+          <a:prstGeom prst="rect">
+            <a:avLst/>
+          </a:prstGeom>
+        </p:spPr>
+      </p:pic>
+      <p:sp>
+        <p:nvSpPr>
+          <p:cNvPr id="4" name="Abgerundetes Rechteck 3">
+            <a:extLst>
+              <a:ext uri="{FF2B5EF4-FFF2-40B4-BE49-F238E27FC236}">
+                <a16:creationId xmlns:a16="http://schemas.microsoft.com/office/drawing/2014/main" id="{46F8BD7F-7D7F-B58C-B9E3-8DBC8159D4FF}"/>
+              </a:ext>
+            </a:extLst>
+          </p:cNvPr>
+          <p:cNvSpPr/>
+          <p:nvPr/>
+        </p:nvSpPr>
+        <p:spPr>
+          <a:xfrm>
+            <a:off x="3632886" y="3404286"/>
+            <a:ext cx="1655806" cy="327454"/>
+          </a:xfrm>
+          <a:prstGeom prst="roundRect">
+            <a:avLst/>
+          </a:prstGeom>
+        </p:spPr>
+        <p:style>
+          <a:lnRef idx="2">
+            <a:schemeClr val="accent4">
+              <a:shade val="15000"/>
+            </a:schemeClr>
+          </a:lnRef>
+          <a:fillRef idx="1">
+            <a:schemeClr val="accent4"/>
+          </a:fillRef>
+          <a:effectRef idx="0">
+            <a:schemeClr val="accent4"/>
+          </a:effectRef>
+          <a:fontRef idx="minor">
+            <a:schemeClr val="lt1"/>
+          </a:fontRef>
+        </p:style>
+        <p:txBody>
+          <a:bodyPr rtlCol="0" anchor="ctr"/>
+          <a:lstStyle/>
+          <a:p>
+            <a:pPr algn="ctr"/>
+            <a:endParaRPr lang="de-DE"/>
+          </a:p>
+        </p:txBody>
+      </p:sp>
+      <p:sp>
+        <p:nvSpPr>
+          <p:cNvPr id="5" name="Abgerundetes Rechteck 4">
+            <a:extLst>
+              <a:ext uri="{FF2B5EF4-FFF2-40B4-BE49-F238E27FC236}">
+                <a16:creationId xmlns:a16="http://schemas.microsoft.com/office/drawing/2014/main" id="{C7FBD1C8-1651-4EC9-2CA3-BBB8CDD4146C}"/>
+              </a:ext>
+            </a:extLst>
+          </p:cNvPr>
+          <p:cNvSpPr/>
+          <p:nvPr/>
+        </p:nvSpPr>
+        <p:spPr>
+          <a:xfrm>
+            <a:off x="4522452" y="4072489"/>
+            <a:ext cx="1655806" cy="327454"/>
+          </a:xfrm>
+          <a:prstGeom prst="roundRect">
+            <a:avLst/>
+          </a:prstGeom>
+        </p:spPr>
+        <p:style>
+          <a:lnRef idx="2">
+            <a:schemeClr val="accent4">
+              <a:shade val="15000"/>
+            </a:schemeClr>
+          </a:lnRef>
+          <a:fillRef idx="1">
+            <a:schemeClr val="accent4"/>
+          </a:fillRef>
+          <a:effectRef idx="0">
+            <a:schemeClr val="accent4"/>
+          </a:effectRef>
+          <a:fontRef idx="minor">
+            <a:schemeClr val="lt1"/>
+          </a:fontRef>
+        </p:style>
+        <p:txBody>
+          <a:bodyPr rtlCol="0" anchor="ctr"/>
+          <a:lstStyle/>
+          <a:p>
+            <a:pPr algn="ctr"/>
+            <a:endParaRPr lang="de-DE"/>
+          </a:p>
+        </p:txBody>
+      </p:sp>
+      <p:sp>
+        <p:nvSpPr>
+          <p:cNvPr id="9" name="Abgerundetes Rechteck 8">
+            <a:extLst>
+              <a:ext uri="{FF2B5EF4-FFF2-40B4-BE49-F238E27FC236}">
+                <a16:creationId xmlns:a16="http://schemas.microsoft.com/office/drawing/2014/main" id="{EDC435BC-AE7B-0526-CC3E-FEEFB08078B1}"/>
+              </a:ext>
+            </a:extLst>
+          </p:cNvPr>
+          <p:cNvSpPr/>
+          <p:nvPr/>
+        </p:nvSpPr>
+        <p:spPr>
+          <a:xfrm>
+            <a:off x="2684876" y="4481874"/>
+            <a:ext cx="1269286" cy="327454"/>
+          </a:xfrm>
+          <a:prstGeom prst="roundRect">
+            <a:avLst/>
+          </a:prstGeom>
+        </p:spPr>
+        <p:style>
+          <a:lnRef idx="2">
+            <a:schemeClr val="accent4">
+              <a:shade val="15000"/>
+            </a:schemeClr>
+          </a:lnRef>
+          <a:fillRef idx="1">
+            <a:schemeClr val="accent4"/>
+          </a:fillRef>
+          <a:effectRef idx="0">
+            <a:schemeClr val="accent4"/>
+          </a:effectRef>
+          <a:fontRef idx="minor">
+            <a:schemeClr val="lt1"/>
+          </a:fontRef>
+        </p:style>
+        <p:txBody>
+          <a:bodyPr rtlCol="0" anchor="ctr"/>
+          <a:lstStyle/>
+          <a:p>
+            <a:pPr algn="ctr"/>
+            <a:endParaRPr lang="de-DE"/>
+          </a:p>
+        </p:txBody>
+      </p:sp>
+      <p:sp>
+        <p:nvSpPr>
+          <p:cNvPr id="12" name="Abgerundetes Rechteck 11">
+            <a:extLst>
+              <a:ext uri="{FF2B5EF4-FFF2-40B4-BE49-F238E27FC236}">
+                <a16:creationId xmlns:a16="http://schemas.microsoft.com/office/drawing/2014/main" id="{91913AB1-81E9-73D3-C48B-D3E9F7E6ABBD}"/>
+              </a:ext>
+            </a:extLst>
+          </p:cNvPr>
+          <p:cNvSpPr/>
+          <p:nvPr/>
+        </p:nvSpPr>
+        <p:spPr>
+          <a:xfrm>
+            <a:off x="10909793" y="3027874"/>
+            <a:ext cx="717915" cy="327454"/>
+          </a:xfrm>
+          <a:prstGeom prst="roundRect">
+            <a:avLst/>
+          </a:prstGeom>
+        </p:spPr>
+        <p:style>
+          <a:lnRef idx="2">
+            <a:schemeClr val="accent4">
+              <a:shade val="15000"/>
+            </a:schemeClr>
+          </a:lnRef>
+          <a:fillRef idx="1">
+            <a:schemeClr val="accent4"/>
+          </a:fillRef>
+          <a:effectRef idx="0">
+            <a:schemeClr val="accent4"/>
+          </a:effectRef>
+          <a:fontRef idx="minor">
+            <a:schemeClr val="lt1"/>
+          </a:fontRef>
+        </p:style>
+        <p:txBody>
+          <a:bodyPr rtlCol="0" anchor="ctr"/>
+          <a:lstStyle/>
+          <a:p>
+            <a:pPr algn="ctr"/>
+            <a:endParaRPr lang="de-DE"/>
+          </a:p>
+        </p:txBody>
+      </p:sp>
+      <p:sp>
+        <p:nvSpPr>
+          <p:cNvPr id="13" name="Abgerundetes Rechteck 12">
+            <a:extLst>
+              <a:ext uri="{FF2B5EF4-FFF2-40B4-BE49-F238E27FC236}">
+                <a16:creationId xmlns:a16="http://schemas.microsoft.com/office/drawing/2014/main" id="{726401B0-3904-7849-D7C4-26FA6AC37A1A}"/>
+              </a:ext>
+            </a:extLst>
+          </p:cNvPr>
+          <p:cNvSpPr/>
+          <p:nvPr/>
+        </p:nvSpPr>
+        <p:spPr>
+          <a:xfrm>
+            <a:off x="9497658" y="4989509"/>
+            <a:ext cx="412461" cy="327454"/>
+          </a:xfrm>
+          <a:prstGeom prst="roundRect">
+            <a:avLst/>
+          </a:prstGeom>
+        </p:spPr>
+        <p:style>
+          <a:lnRef idx="2">
+            <a:schemeClr val="accent4">
+              <a:shade val="15000"/>
+            </a:schemeClr>
+          </a:lnRef>
+          <a:fillRef idx="1">
+            <a:schemeClr val="accent4"/>
+          </a:fillRef>
+          <a:effectRef idx="0">
+            <a:schemeClr val="accent4"/>
+          </a:effectRef>
+          <a:fontRef idx="minor">
+            <a:schemeClr val="lt1"/>
+          </a:fontRef>
+        </p:style>
+        <p:txBody>
+          <a:bodyPr rtlCol="0" anchor="ctr"/>
+          <a:lstStyle/>
+          <a:p>
+            <a:pPr algn="ctr"/>
+            <a:endParaRPr lang="de-DE"/>
+          </a:p>
+        </p:txBody>
+      </p:sp>
+    </p:spTree>
+    <p:extLst>
+      <p:ext uri="{BB962C8B-B14F-4D97-AF65-F5344CB8AC3E}">
+        <p14:creationId xmlns:p14="http://schemas.microsoft.com/office/powerpoint/2010/main" val="2976346737"/>
+      </p:ext>
+    </p:extLst>
+  </p:cSld>
+  <p:clrMapOvr>
+    <a:masterClrMapping/>
+  </p:clrMapOvr>
+</p:sld>
+</file>
+
+<file path=ppt/slides/slide7.xml><?xml version="1.0" encoding="utf-8"?>
+<p:sld xmlns:a="http://schemas.openxmlformats.org/drawingml/2006/main" xmlns:r="http://schemas.openxmlformats.org/officeDocument/2006/relationships" xmlns:p="http://schemas.openxmlformats.org/presentationml/2006/main">
+  <p:cSld>
+    <p:spTree>
+      <p:nvGrpSpPr>
+        <p:cNvPr id="1" name="">
+          <a:extLst>
+            <a:ext uri="{FF2B5EF4-FFF2-40B4-BE49-F238E27FC236}">
+              <a16:creationId xmlns:a16="http://schemas.microsoft.com/office/drawing/2014/main" id="{0A45ABEF-EAD6-B274-68D7-4D6B7BC5E343}"/>
+            </a:ext>
+          </a:extLst>
+        </p:cNvPr>
+        <p:cNvGrpSpPr/>
+        <p:nvPr/>
+      </p:nvGrpSpPr>
+      <p:grpSpPr>
+        <a:xfrm>
+          <a:off x="0" y="0"/>
+          <a:ext cx="0" cy="0"/>
+          <a:chOff x="0" y="0"/>
+          <a:chExt cx="0" cy="0"/>
+        </a:xfrm>
+      </p:grpSpPr>
+      <p:sp>
+        <p:nvSpPr>
+          <p:cNvPr id="3" name="Titel 1">
+            <a:extLst>
+              <a:ext uri="{FF2B5EF4-FFF2-40B4-BE49-F238E27FC236}">
+                <a16:creationId xmlns:a16="http://schemas.microsoft.com/office/drawing/2014/main" id="{7D303FE4-2650-BC88-E38F-38D50E4A1B78}"/>
+              </a:ext>
+            </a:extLst>
+          </p:cNvPr>
+          <p:cNvSpPr txBox="1">
+            <a:spLocks/>
+          </p:cNvSpPr>
+          <p:nvPr/>
+        </p:nvSpPr>
+        <p:spPr>
+          <a:xfrm>
+            <a:off x="193623" y="425086"/>
+            <a:ext cx="11768528" cy="549275"/>
+          </a:xfrm>
+          <a:prstGeom prst="rect">
+            <a:avLst/>
+          </a:prstGeom>
+        </p:spPr>
+        <p:txBody>
+          <a:bodyPr>
+            <a:normAutofit fontScale="90000" lnSpcReduction="20000"/>
+          </a:bodyPr>
+          <a:lstStyle>
+            <a:lvl1pPr algn="l" defTabSz="914400" rtl="0" eaLnBrk="1" latinLnBrk="0" hangingPunct="1">
+              <a:lnSpc>
+                <a:spcPct val="90000"/>
+              </a:lnSpc>
+              <a:spcBef>
+                <a:spcPct val="0"/>
+              </a:spcBef>
+              <a:buNone/>
+              <a:defRPr sz="4400" kern="1200">
+                <a:solidFill>
+                  <a:schemeClr val="tx1"/>
+                </a:solidFill>
+                <a:latin typeface="+mj-lt"/>
+                <a:ea typeface="+mj-ea"/>
+                <a:cs typeface="+mj-cs"/>
+              </a:defRPr>
+            </a:lvl1pPr>
+          </a:lstStyle>
+          <a:p>
+            <a:pPr algn="ctr"/>
+            <a:r>
+              <a:rPr lang="de-DE" dirty="0">
+                <a:latin typeface="ADLaM Display" panose="02010000000000000000" pitchFamily="2" charset="77"/>
+                <a:ea typeface="ADLaM Display" panose="02010000000000000000" pitchFamily="2" charset="77"/>
+                <a:cs typeface="ADLaM Display" panose="02010000000000000000" pitchFamily="2" charset="77"/>
+              </a:rPr>
+              <a:t>Wiederholung: Achsenspiegelung</a:t>
+            </a:r>
+          </a:p>
+        </p:txBody>
+      </p:sp>
+      <p:sp>
+        <p:nvSpPr>
+          <p:cNvPr id="6" name="Abgerundetes Rechteck 5">
+            <a:extLst>
+              <a:ext uri="{FF2B5EF4-FFF2-40B4-BE49-F238E27FC236}">
+                <a16:creationId xmlns:a16="http://schemas.microsoft.com/office/drawing/2014/main" id="{3798D7EF-FB23-8DEC-03C9-5B9BE1EA1201}"/>
+              </a:ext>
+            </a:extLst>
+          </p:cNvPr>
+          <p:cNvSpPr/>
+          <p:nvPr/>
+        </p:nvSpPr>
+        <p:spPr>
+          <a:xfrm>
+            <a:off x="193623" y="1240970"/>
+            <a:ext cx="11768527" cy="5382251"/>
+          </a:xfrm>
+          <a:prstGeom prst="roundRect">
+            <a:avLst/>
+          </a:prstGeom>
+        </p:spPr>
+        <p:style>
+          <a:lnRef idx="2">
+            <a:schemeClr val="accent3"/>
+          </a:lnRef>
+          <a:fillRef idx="1">
+            <a:schemeClr val="lt1"/>
+          </a:fillRef>
+          <a:effectRef idx="0">
+            <a:schemeClr val="accent3"/>
+          </a:effectRef>
+          <a:fontRef idx="minor">
+            <a:schemeClr val="dk1"/>
+          </a:fontRef>
+        </p:style>
+        <p:txBody>
+          <a:bodyPr rtlCol="0" anchor="ctr"/>
+          <a:lstStyle/>
+          <a:p>
+            <a:pPr algn="ctr"/>
+            <a:endParaRPr lang="de-DE"/>
+          </a:p>
+        </p:txBody>
+      </p:sp>
+      <p:sp>
+        <p:nvSpPr>
+          <p:cNvPr id="8" name="Inhaltsplatzhalter 2">
+            <a:extLst>
+              <a:ext uri="{FF2B5EF4-FFF2-40B4-BE49-F238E27FC236}">
+                <a16:creationId xmlns:a16="http://schemas.microsoft.com/office/drawing/2014/main" id="{3DBAED53-E2B0-B64F-FE8C-E9F34EE5905D}"/>
+              </a:ext>
+            </a:extLst>
+          </p:cNvPr>
+          <p:cNvSpPr txBox="1">
+            <a:spLocks/>
+          </p:cNvSpPr>
+          <p:nvPr/>
+        </p:nvSpPr>
+        <p:spPr>
+          <a:xfrm>
+            <a:off x="423472" y="1559658"/>
+            <a:ext cx="11327804" cy="4396299"/>
+          </a:xfrm>
+          <a:prstGeom prst="rect">
+            <a:avLst/>
+          </a:prstGeom>
+        </p:spPr>
+        <p:txBody>
+          <a:bodyPr/>
+          <a:lstStyle>
+            <a:lvl1pPr marL="228600" indent="-228600" algn="l" defTabSz="914400" rtl="0" eaLnBrk="1" latinLnBrk="0" hangingPunct="1">
+              <a:lnSpc>
+                <a:spcPct val="90000"/>
+              </a:lnSpc>
+              <a:spcBef>
+                <a:spcPts val="1000"/>
+              </a:spcBef>
+              <a:buFont typeface="Arial" panose="020B0604020202020204" pitchFamily="34" charset="0"/>
+              <a:buChar char="•"/>
+              <a:defRPr sz="2800" kern="1200">
+                <a:solidFill>
+                  <a:schemeClr val="tx1"/>
+                </a:solidFill>
+                <a:latin typeface="+mn-lt"/>
+                <a:ea typeface="+mn-ea"/>
+                <a:cs typeface="+mn-cs"/>
+              </a:defRPr>
+            </a:lvl1pPr>
+            <a:lvl2pPr marL="685800" indent="-228600" algn="l" defTabSz="914400" rtl="0" eaLnBrk="1" latinLnBrk="0" hangingPunct="1">
+              <a:lnSpc>
+                <a:spcPct val="90000"/>
+              </a:lnSpc>
+              <a:spcBef>
+                <a:spcPts val="500"/>
+              </a:spcBef>
+              <a:buFont typeface="Arial" panose="020B0604020202020204" pitchFamily="34" charset="0"/>
+              <a:buChar char="•"/>
+              <a:defRPr sz="2400" kern="1200">
+                <a:solidFill>
+                  <a:schemeClr val="tx1"/>
+                </a:solidFill>
+                <a:latin typeface="+mn-lt"/>
+                <a:ea typeface="+mn-ea"/>
+                <a:cs typeface="+mn-cs"/>
+              </a:defRPr>
+            </a:lvl2pPr>
+            <a:lvl3pPr marL="1143000" indent="-228600" algn="l" defTabSz="914400" rtl="0" eaLnBrk="1" latinLnBrk="0" hangingPunct="1">
+              <a:lnSpc>
+                <a:spcPct val="90000"/>
+              </a:lnSpc>
+              <a:spcBef>
+                <a:spcPts val="500"/>
+              </a:spcBef>
+              <a:buFont typeface="Arial" panose="020B0604020202020204" pitchFamily="34" charset="0"/>
+              <a:buChar char="•"/>
+              <a:defRPr sz="2000" kern="1200">
+                <a:solidFill>
+                  <a:schemeClr val="tx1"/>
+                </a:solidFill>
+                <a:latin typeface="+mn-lt"/>
+                <a:ea typeface="+mn-ea"/>
+                <a:cs typeface="+mn-cs"/>
+              </a:defRPr>
+            </a:lvl3pPr>
+            <a:lvl4pPr marL="1600200" indent="-228600" algn="l" defTabSz="914400" rtl="0" eaLnBrk="1" latinLnBrk="0" hangingPunct="1">
+              <a:lnSpc>
+                <a:spcPct val="90000"/>
+              </a:lnSpc>
+              <a:spcBef>
+                <a:spcPts val="500"/>
+              </a:spcBef>
+              <a:buFont typeface="Arial" panose="020B0604020202020204" pitchFamily="34" charset="0"/>
+              <a:buChar char="•"/>
+              <a:defRPr sz="1800" kern="1200">
+                <a:solidFill>
+                  <a:schemeClr val="tx1"/>
+                </a:solidFill>
+                <a:latin typeface="+mn-lt"/>
+                <a:ea typeface="+mn-ea"/>
+                <a:cs typeface="+mn-cs"/>
+              </a:defRPr>
+            </a:lvl4pPr>
+            <a:lvl5pPr marL="2057400" indent="-228600" algn="l" defTabSz="914400" rtl="0" eaLnBrk="1" latinLnBrk="0" hangingPunct="1">
+              <a:lnSpc>
+                <a:spcPct val="90000"/>
+              </a:lnSpc>
+              <a:spcBef>
+                <a:spcPts val="500"/>
+              </a:spcBef>
+              <a:buFont typeface="Arial" panose="020B0604020202020204" pitchFamily="34" charset="0"/>
+              <a:buChar char="•"/>
+              <a:defRPr sz="1800" kern="1200">
+                <a:solidFill>
+                  <a:schemeClr val="tx1"/>
+                </a:solidFill>
+                <a:latin typeface="+mn-lt"/>
+                <a:ea typeface="+mn-ea"/>
+                <a:cs typeface="+mn-cs"/>
+              </a:defRPr>
+            </a:lvl5pPr>
+            <a:lvl6pPr marL="2514600" indent="-228600" algn="l" defTabSz="914400" rtl="0" eaLnBrk="1" latinLnBrk="0" hangingPunct="1">
+              <a:lnSpc>
+                <a:spcPct val="90000"/>
+              </a:lnSpc>
+              <a:spcBef>
+                <a:spcPts val="500"/>
+              </a:spcBef>
+              <a:buFont typeface="Arial" panose="020B0604020202020204" pitchFamily="34" charset="0"/>
+              <a:buChar char="•"/>
+              <a:defRPr sz="1800" kern="1200">
+                <a:solidFill>
+                  <a:schemeClr val="tx1"/>
+                </a:solidFill>
+                <a:latin typeface="+mn-lt"/>
+                <a:ea typeface="+mn-ea"/>
+                <a:cs typeface="+mn-cs"/>
+              </a:defRPr>
+            </a:lvl6pPr>
+            <a:lvl7pPr marL="2971800" indent="-228600" algn="l" defTabSz="914400" rtl="0" eaLnBrk="1" latinLnBrk="0" hangingPunct="1">
+              <a:lnSpc>
+                <a:spcPct val="90000"/>
+              </a:lnSpc>
+              <a:spcBef>
+                <a:spcPts val="500"/>
+              </a:spcBef>
+              <a:buFont typeface="Arial" panose="020B0604020202020204" pitchFamily="34" charset="0"/>
+              <a:buChar char="•"/>
+              <a:defRPr sz="1800" kern="1200">
+                <a:solidFill>
+                  <a:schemeClr val="tx1"/>
+                </a:solidFill>
+                <a:latin typeface="+mn-lt"/>
+                <a:ea typeface="+mn-ea"/>
+                <a:cs typeface="+mn-cs"/>
+              </a:defRPr>
+            </a:lvl7pPr>
+            <a:lvl8pPr marL="3429000" indent="-228600" algn="l" defTabSz="914400" rtl="0" eaLnBrk="1" latinLnBrk="0" hangingPunct="1">
+              <a:lnSpc>
+                <a:spcPct val="90000"/>
+              </a:lnSpc>
+              <a:spcBef>
+                <a:spcPts val="500"/>
+              </a:spcBef>
+              <a:buFont typeface="Arial" panose="020B0604020202020204" pitchFamily="34" charset="0"/>
+              <a:buChar char="•"/>
+              <a:defRPr sz="1800" kern="1200">
+                <a:solidFill>
+                  <a:schemeClr val="tx1"/>
+                </a:solidFill>
+                <a:latin typeface="+mn-lt"/>
+                <a:ea typeface="+mn-ea"/>
+                <a:cs typeface="+mn-cs"/>
+              </a:defRPr>
+            </a:lvl8pPr>
+            <a:lvl9pPr marL="3886200" indent="-228600" algn="l" defTabSz="914400" rtl="0" eaLnBrk="1" latinLnBrk="0" hangingPunct="1">
+              <a:lnSpc>
+                <a:spcPct val="90000"/>
+              </a:lnSpc>
+              <a:spcBef>
+                <a:spcPts val="500"/>
+              </a:spcBef>
+              <a:buFont typeface="Arial" panose="020B0604020202020204" pitchFamily="34" charset="0"/>
+              <a:buChar char="•"/>
+              <a:defRPr sz="1800" kern="1200">
+                <a:solidFill>
+                  <a:schemeClr val="tx1"/>
+                </a:solidFill>
+                <a:latin typeface="+mn-lt"/>
+                <a:ea typeface="+mn-ea"/>
+                <a:cs typeface="+mn-cs"/>
+              </a:defRPr>
+            </a:lvl9pPr>
+          </a:lstStyle>
+          <a:p>
+            <a:pPr marL="0" indent="0" algn="just">
+              <a:buNone/>
+            </a:pPr>
+            <a:r>
+              <a:rPr lang="de-DE" b="1" dirty="0"/>
+              <a:t>Aufgabe 4</a:t>
+            </a:r>
+          </a:p>
+          <a:p>
+            <a:pPr marL="0" indent="0" algn="just">
+              <a:buNone/>
+            </a:pPr>
+            <a:r>
+              <a:rPr lang="de-DE" dirty="0"/>
+              <a:t>Schreibe in dein Heft. Fülle die 7 Lücken!</a:t>
+            </a:r>
+          </a:p>
+        </p:txBody>
+      </p:sp>
+      <p:pic>
+        <p:nvPicPr>
+          <p:cNvPr id="7" name="Grafik 6" descr="Ein Bild, das Text, Screenshot, Schrift, Reihe enthält.&#10;&#10;KI-generierte Inhalte können fehlerhaft sein.">
+            <a:extLst>
+              <a:ext uri="{FF2B5EF4-FFF2-40B4-BE49-F238E27FC236}">
+                <a16:creationId xmlns:a16="http://schemas.microsoft.com/office/drawing/2014/main" id="{95072C44-CAFF-CD38-B399-577106DB52E8}"/>
+              </a:ext>
+            </a:extLst>
+          </p:cNvPr>
+          <p:cNvPicPr>
+            <a:picLocks noChangeAspect="1"/>
+          </p:cNvPicPr>
+          <p:nvPr/>
+        </p:nvPicPr>
+        <p:blipFill>
+          <a:blip r:embed="rId2"/>
+          <a:srcRect b="62363"/>
+          <a:stretch>
+            <a:fillRect/>
+          </a:stretch>
+        </p:blipFill>
+        <p:spPr>
+          <a:xfrm>
+            <a:off x="564292" y="2445501"/>
+            <a:ext cx="10975972" cy="2033255"/>
+          </a:xfrm>
+          <a:prstGeom prst="rect">
+            <a:avLst/>
+          </a:prstGeom>
+        </p:spPr>
+      </p:pic>
+      <p:sp>
+        <p:nvSpPr>
+          <p:cNvPr id="12" name="Abgerundetes Rechteck 11">
+            <a:extLst>
+              <a:ext uri="{FF2B5EF4-FFF2-40B4-BE49-F238E27FC236}">
+                <a16:creationId xmlns:a16="http://schemas.microsoft.com/office/drawing/2014/main" id="{61032D45-22C8-27E2-88FA-E300E574CFAC}"/>
+              </a:ext>
+            </a:extLst>
+          </p:cNvPr>
+          <p:cNvSpPr/>
+          <p:nvPr/>
+        </p:nvSpPr>
+        <p:spPr>
+          <a:xfrm>
+            <a:off x="7448816" y="3310758"/>
+            <a:ext cx="978492" cy="327454"/>
+          </a:xfrm>
+          <a:prstGeom prst="roundRect">
+            <a:avLst/>
+          </a:prstGeom>
+        </p:spPr>
+        <p:style>
+          <a:lnRef idx="2">
+            <a:schemeClr val="accent4">
+              <a:shade val="15000"/>
+            </a:schemeClr>
+          </a:lnRef>
+          <a:fillRef idx="1">
+            <a:schemeClr val="accent4"/>
+          </a:fillRef>
+          <a:effectRef idx="0">
+            <a:schemeClr val="accent4"/>
+          </a:effectRef>
+          <a:fontRef idx="minor">
+            <a:schemeClr val="lt1"/>
+          </a:fontRef>
+        </p:style>
+        <p:txBody>
+          <a:bodyPr rtlCol="0" anchor="ctr"/>
+          <a:lstStyle/>
+          <a:p>
+            <a:pPr algn="ctr"/>
+            <a:endParaRPr lang="de-DE"/>
+          </a:p>
+        </p:txBody>
+      </p:sp>
+      <p:pic>
+        <p:nvPicPr>
+          <p:cNvPr id="10" name="Grafik 9" descr="Ein Bild, das Text, Screenshot, Schrift, Reihe enthält.&#10;&#10;KI-generierte Inhalte können fehlerhaft sein.">
+            <a:extLst>
+              <a:ext uri="{FF2B5EF4-FFF2-40B4-BE49-F238E27FC236}">
+                <a16:creationId xmlns:a16="http://schemas.microsoft.com/office/drawing/2014/main" id="{CC7B0C13-CB69-8F75-79F8-5847E228B420}"/>
+              </a:ext>
+            </a:extLst>
+          </p:cNvPr>
+          <p:cNvPicPr>
+            <a:picLocks noChangeAspect="1"/>
+          </p:cNvPicPr>
+          <p:nvPr/>
+        </p:nvPicPr>
+        <p:blipFill>
+          <a:blip r:embed="rId2"/>
+          <a:srcRect t="62363"/>
+          <a:stretch>
+            <a:fillRect/>
+          </a:stretch>
+        </p:blipFill>
+        <p:spPr>
+          <a:xfrm>
+            <a:off x="564291" y="4399659"/>
+            <a:ext cx="10975971" cy="2033255"/>
+          </a:xfrm>
+          <a:prstGeom prst="rect">
+            <a:avLst/>
+          </a:prstGeom>
+        </p:spPr>
+      </p:pic>
+      <p:sp>
+        <p:nvSpPr>
+          <p:cNvPr id="14" name="Abgerundetes Rechteck 13">
+            <a:extLst>
+              <a:ext uri="{FF2B5EF4-FFF2-40B4-BE49-F238E27FC236}">
+                <a16:creationId xmlns:a16="http://schemas.microsoft.com/office/drawing/2014/main" id="{37CFF0AB-ED10-CC82-2819-D1DE8CEE3E6E}"/>
+              </a:ext>
+            </a:extLst>
+          </p:cNvPr>
+          <p:cNvSpPr/>
+          <p:nvPr/>
+        </p:nvSpPr>
+        <p:spPr>
+          <a:xfrm>
+            <a:off x="4203907" y="3301766"/>
+            <a:ext cx="1257779" cy="327454"/>
+          </a:xfrm>
+          <a:prstGeom prst="roundRect">
+            <a:avLst/>
+          </a:prstGeom>
+        </p:spPr>
+        <p:style>
+          <a:lnRef idx="2">
+            <a:schemeClr val="accent4">
+              <a:shade val="15000"/>
+            </a:schemeClr>
+          </a:lnRef>
+          <a:fillRef idx="1">
+            <a:schemeClr val="accent4"/>
+          </a:fillRef>
+          <a:effectRef idx="0">
+            <a:schemeClr val="accent4"/>
+          </a:effectRef>
+          <a:fontRef idx="minor">
+            <a:schemeClr val="lt1"/>
+          </a:fontRef>
+        </p:style>
+        <p:txBody>
+          <a:bodyPr rtlCol="0" anchor="ctr"/>
+          <a:lstStyle/>
+          <a:p>
+            <a:pPr algn="ctr"/>
+            <a:endParaRPr lang="de-DE"/>
+          </a:p>
+        </p:txBody>
+      </p:sp>
+      <p:sp>
+        <p:nvSpPr>
+          <p:cNvPr id="15" name="Abgerundetes Rechteck 14">
+            <a:extLst>
+              <a:ext uri="{FF2B5EF4-FFF2-40B4-BE49-F238E27FC236}">
+                <a16:creationId xmlns:a16="http://schemas.microsoft.com/office/drawing/2014/main" id="{A9450A1F-1F29-A887-1578-3D556CA1F316}"/>
+              </a:ext>
+            </a:extLst>
+          </p:cNvPr>
+          <p:cNvSpPr/>
+          <p:nvPr/>
+        </p:nvSpPr>
+        <p:spPr>
+          <a:xfrm>
+            <a:off x="1163389" y="3904035"/>
+            <a:ext cx="1209108" cy="408472"/>
+          </a:xfrm>
+          <a:prstGeom prst="roundRect">
+            <a:avLst/>
+          </a:prstGeom>
+        </p:spPr>
+        <p:style>
+          <a:lnRef idx="2">
+            <a:schemeClr val="accent4">
+              <a:shade val="15000"/>
+            </a:schemeClr>
+          </a:lnRef>
+          <a:fillRef idx="1">
+            <a:schemeClr val="accent4"/>
+          </a:fillRef>
+          <a:effectRef idx="0">
+            <a:schemeClr val="accent4"/>
+          </a:effectRef>
+          <a:fontRef idx="minor">
+            <a:schemeClr val="lt1"/>
+          </a:fontRef>
+        </p:style>
+        <p:txBody>
+          <a:bodyPr rtlCol="0" anchor="ctr"/>
+          <a:lstStyle/>
+          <a:p>
+            <a:pPr algn="ctr"/>
+            <a:endParaRPr lang="de-DE"/>
+          </a:p>
+        </p:txBody>
+      </p:sp>
+      <p:sp>
+        <p:nvSpPr>
+          <p:cNvPr id="16" name="Abgerundetes Rechteck 15">
+            <a:extLst>
+              <a:ext uri="{FF2B5EF4-FFF2-40B4-BE49-F238E27FC236}">
+                <a16:creationId xmlns:a16="http://schemas.microsoft.com/office/drawing/2014/main" id="{E7F67A79-8933-3ED0-7220-5395C2C2A1FF}"/>
+              </a:ext>
+            </a:extLst>
+          </p:cNvPr>
+          <p:cNvSpPr/>
+          <p:nvPr/>
+        </p:nvSpPr>
+        <p:spPr>
+          <a:xfrm>
+            <a:off x="5202289" y="3625554"/>
+            <a:ext cx="400217" cy="327454"/>
+          </a:xfrm>
+          <a:prstGeom prst="roundRect">
+            <a:avLst/>
+          </a:prstGeom>
+        </p:spPr>
+        <p:style>
+          <a:lnRef idx="2">
+            <a:schemeClr val="accent4">
+              <a:shade val="15000"/>
+            </a:schemeClr>
+          </a:lnRef>
+          <a:fillRef idx="1">
+            <a:schemeClr val="accent4"/>
+          </a:fillRef>
+          <a:effectRef idx="0">
+            <a:schemeClr val="accent4"/>
+          </a:effectRef>
+          <a:fontRef idx="minor">
+            <a:schemeClr val="lt1"/>
+          </a:fontRef>
+        </p:style>
+        <p:txBody>
+          <a:bodyPr rtlCol="0" anchor="ctr"/>
+          <a:lstStyle/>
+          <a:p>
+            <a:pPr algn="ctr"/>
+            <a:endParaRPr lang="de-DE"/>
+          </a:p>
+        </p:txBody>
+      </p:sp>
+      <p:sp>
+        <p:nvSpPr>
+          <p:cNvPr id="17" name="Abgerundetes Rechteck 16">
+            <a:extLst>
+              <a:ext uri="{FF2B5EF4-FFF2-40B4-BE49-F238E27FC236}">
+                <a16:creationId xmlns:a16="http://schemas.microsoft.com/office/drawing/2014/main" id="{A767E334-5E4D-C372-5BF2-0196170565D6}"/>
+              </a:ext>
+            </a:extLst>
+          </p:cNvPr>
+          <p:cNvSpPr/>
+          <p:nvPr/>
+        </p:nvSpPr>
+        <p:spPr>
+          <a:xfrm>
+            <a:off x="2782768" y="5364599"/>
+            <a:ext cx="1542097" cy="252431"/>
+          </a:xfrm>
+          <a:prstGeom prst="roundRect">
+            <a:avLst/>
+          </a:prstGeom>
+        </p:spPr>
+        <p:style>
+          <a:lnRef idx="2">
+            <a:schemeClr val="accent4">
+              <a:shade val="15000"/>
+            </a:schemeClr>
+          </a:lnRef>
+          <a:fillRef idx="1">
+            <a:schemeClr val="accent4"/>
+          </a:fillRef>
+          <a:effectRef idx="0">
+            <a:schemeClr val="accent4"/>
+          </a:effectRef>
+          <a:fontRef idx="minor">
+            <a:schemeClr val="lt1"/>
+          </a:fontRef>
+        </p:style>
+        <p:txBody>
+          <a:bodyPr rtlCol="0" anchor="ctr"/>
+          <a:lstStyle/>
+          <a:p>
+            <a:pPr algn="ctr"/>
+            <a:endParaRPr lang="de-DE"/>
+          </a:p>
+        </p:txBody>
+      </p:sp>
+      <p:sp>
+        <p:nvSpPr>
+          <p:cNvPr id="18" name="Abgerundetes Rechteck 17">
+            <a:extLst>
+              <a:ext uri="{FF2B5EF4-FFF2-40B4-BE49-F238E27FC236}">
+                <a16:creationId xmlns:a16="http://schemas.microsoft.com/office/drawing/2014/main" id="{05AB492E-296C-4064-5F48-B2653F6FDCF0}"/>
+              </a:ext>
+            </a:extLst>
+          </p:cNvPr>
+          <p:cNvSpPr/>
+          <p:nvPr/>
+        </p:nvSpPr>
+        <p:spPr>
+          <a:xfrm>
+            <a:off x="10063876" y="5069943"/>
+            <a:ext cx="1054549" cy="358504"/>
+          </a:xfrm>
+          <a:prstGeom prst="roundRect">
+            <a:avLst/>
+          </a:prstGeom>
+        </p:spPr>
+        <p:style>
+          <a:lnRef idx="2">
+            <a:schemeClr val="accent4">
+              <a:shade val="15000"/>
+            </a:schemeClr>
+          </a:lnRef>
+          <a:fillRef idx="1">
+            <a:schemeClr val="accent4"/>
+          </a:fillRef>
+          <a:effectRef idx="0">
+            <a:schemeClr val="accent4"/>
+          </a:effectRef>
+          <a:fontRef idx="minor">
+            <a:schemeClr val="lt1"/>
+          </a:fontRef>
+        </p:style>
+        <p:txBody>
+          <a:bodyPr rtlCol="0" anchor="ctr"/>
+          <a:lstStyle/>
+          <a:p>
+            <a:pPr algn="ctr"/>
+            <a:endParaRPr lang="de-DE"/>
+          </a:p>
+        </p:txBody>
+      </p:sp>
+      <p:sp>
+        <p:nvSpPr>
+          <p:cNvPr id="19" name="Abgerundetes Rechteck 18">
+            <a:extLst>
+              <a:ext uri="{FF2B5EF4-FFF2-40B4-BE49-F238E27FC236}">
+                <a16:creationId xmlns:a16="http://schemas.microsoft.com/office/drawing/2014/main" id="{2C185F5F-F40F-6013-3ACF-1161A30CE81C}"/>
+              </a:ext>
+            </a:extLst>
+          </p:cNvPr>
+          <p:cNvSpPr/>
+          <p:nvPr/>
+        </p:nvSpPr>
+        <p:spPr>
+          <a:xfrm>
+            <a:off x="9844433" y="5487673"/>
+            <a:ext cx="219443" cy="207383"/>
+          </a:xfrm>
+          <a:prstGeom prst="roundRect">
+            <a:avLst/>
+          </a:prstGeom>
+        </p:spPr>
+        <p:style>
+          <a:lnRef idx="2">
+            <a:schemeClr val="accent4">
+              <a:shade val="15000"/>
+            </a:schemeClr>
+          </a:lnRef>
+          <a:fillRef idx="1">
+            <a:schemeClr val="accent4"/>
+          </a:fillRef>
+          <a:effectRef idx="0">
+            <a:schemeClr val="accent4"/>
+          </a:effectRef>
+          <a:fontRef idx="minor">
+            <a:schemeClr val="lt1"/>
+          </a:fontRef>
+        </p:style>
+        <p:txBody>
+          <a:bodyPr rtlCol="0" anchor="ctr"/>
+          <a:lstStyle/>
+          <a:p>
+            <a:pPr algn="ctr"/>
+            <a:endParaRPr lang="de-DE"/>
+          </a:p>
+        </p:txBody>
+      </p:sp>
+    </p:spTree>
+    <p:extLst>
+      <p:ext uri="{BB962C8B-B14F-4D97-AF65-F5344CB8AC3E}">
+        <p14:creationId xmlns:p14="http://schemas.microsoft.com/office/powerpoint/2010/main" val="979213065"/>
+      </p:ext>
+    </p:extLst>
+  </p:cSld>
+  <p:clrMapOvr>
+    <a:masterClrMapping/>
+  </p:clrMapOvr>
+</p:sld>
+</file>
+
+<file path=ppt/slides/slide8.xml><?xml version="1.0" encoding="utf-8"?>
+<p:sld xmlns:a="http://schemas.openxmlformats.org/drawingml/2006/main" xmlns:r="http://schemas.openxmlformats.org/officeDocument/2006/relationships" xmlns:p="http://schemas.openxmlformats.org/presentationml/2006/main">
+  <p:cSld>
+    <p:spTree>
+      <p:nvGrpSpPr>
+        <p:cNvPr id="1" name="">
+          <a:extLst>
+            <a:ext uri="{FF2B5EF4-FFF2-40B4-BE49-F238E27FC236}">
+              <a16:creationId xmlns:a16="http://schemas.microsoft.com/office/drawing/2014/main" id="{2ED02AC3-C9C7-9CE6-4F7F-A97EAF4EFC0D}"/>
+            </a:ext>
+          </a:extLst>
+        </p:cNvPr>
+        <p:cNvGrpSpPr/>
+        <p:nvPr/>
+      </p:nvGrpSpPr>
+      <p:grpSpPr>
+        <a:xfrm>
+          <a:off x="0" y="0"/>
+          <a:ext cx="0" cy="0"/>
+          <a:chOff x="0" y="0"/>
+          <a:chExt cx="0" cy="0"/>
+        </a:xfrm>
+      </p:grpSpPr>
+      <p:sp>
+        <p:nvSpPr>
+          <p:cNvPr id="3" name="Titel 1">
+            <a:extLst>
+              <a:ext uri="{FF2B5EF4-FFF2-40B4-BE49-F238E27FC236}">
+                <a16:creationId xmlns:a16="http://schemas.microsoft.com/office/drawing/2014/main" id="{D3D9F893-A311-C558-12E3-F45F6034819D}"/>
+              </a:ext>
+            </a:extLst>
+          </p:cNvPr>
+          <p:cNvSpPr txBox="1">
+            <a:spLocks/>
+          </p:cNvSpPr>
+          <p:nvPr/>
+        </p:nvSpPr>
+        <p:spPr>
+          <a:xfrm>
+            <a:off x="193623" y="425086"/>
+            <a:ext cx="11768528" cy="549275"/>
+          </a:xfrm>
+          <a:prstGeom prst="rect">
+            <a:avLst/>
+          </a:prstGeom>
+        </p:spPr>
+        <p:txBody>
+          <a:bodyPr>
+            <a:normAutofit fontScale="90000" lnSpcReduction="20000"/>
+          </a:bodyPr>
+          <a:lstStyle>
+            <a:lvl1pPr algn="l" defTabSz="914400" rtl="0" eaLnBrk="1" latinLnBrk="0" hangingPunct="1">
+              <a:lnSpc>
+                <a:spcPct val="90000"/>
+              </a:lnSpc>
+              <a:spcBef>
+                <a:spcPct val="0"/>
+              </a:spcBef>
+              <a:buNone/>
+              <a:defRPr sz="4400" kern="1200">
+                <a:solidFill>
+                  <a:schemeClr val="tx1"/>
+                </a:solidFill>
+                <a:latin typeface="+mj-lt"/>
+                <a:ea typeface="+mj-ea"/>
+                <a:cs typeface="+mj-cs"/>
+              </a:defRPr>
+            </a:lvl1pPr>
+          </a:lstStyle>
+          <a:p>
+            <a:pPr algn="ctr"/>
+            <a:r>
+              <a:rPr lang="de-DE" dirty="0">
+                <a:latin typeface="ADLaM Display" panose="02010000000000000000" pitchFamily="2" charset="77"/>
+                <a:ea typeface="ADLaM Display" panose="02010000000000000000" pitchFamily="2" charset="77"/>
+                <a:cs typeface="ADLaM Display" panose="02010000000000000000" pitchFamily="2" charset="77"/>
+              </a:rPr>
+              <a:t>Wiederholung: Achsenspiegelung</a:t>
+            </a:r>
+          </a:p>
+        </p:txBody>
+      </p:sp>
+      <p:sp>
+        <p:nvSpPr>
+          <p:cNvPr id="6" name="Abgerundetes Rechteck 5">
+            <a:extLst>
+              <a:ext uri="{FF2B5EF4-FFF2-40B4-BE49-F238E27FC236}">
+                <a16:creationId xmlns:a16="http://schemas.microsoft.com/office/drawing/2014/main" id="{B19C94F8-25D8-B250-2A9D-ED79DFBE7943}"/>
+              </a:ext>
+            </a:extLst>
+          </p:cNvPr>
+          <p:cNvSpPr/>
+          <p:nvPr/>
+        </p:nvSpPr>
+        <p:spPr>
+          <a:xfrm>
+            <a:off x="193623" y="1240970"/>
+            <a:ext cx="11768527" cy="5382251"/>
+          </a:xfrm>
+          <a:prstGeom prst="roundRect">
+            <a:avLst/>
+          </a:prstGeom>
+        </p:spPr>
+        <p:style>
+          <a:lnRef idx="2">
+            <a:schemeClr val="accent3"/>
+          </a:lnRef>
+          <a:fillRef idx="1">
+            <a:schemeClr val="lt1"/>
+          </a:fillRef>
+          <a:effectRef idx="0">
+            <a:schemeClr val="accent3"/>
+          </a:effectRef>
+          <a:fontRef idx="minor">
+            <a:schemeClr val="dk1"/>
+          </a:fontRef>
+        </p:style>
+        <p:txBody>
+          <a:bodyPr rtlCol="0" anchor="ctr"/>
+          <a:lstStyle/>
+          <a:p>
+            <a:pPr algn="ctr"/>
+            <a:endParaRPr lang="de-DE" b="1" dirty="0"/>
+          </a:p>
+        </p:txBody>
+      </p:sp>
+      <p:sp>
+        <p:nvSpPr>
+          <p:cNvPr id="8" name="Inhaltsplatzhalter 2">
+            <a:extLst>
+              <a:ext uri="{FF2B5EF4-FFF2-40B4-BE49-F238E27FC236}">
+                <a16:creationId xmlns:a16="http://schemas.microsoft.com/office/drawing/2014/main" id="{F3CC78CB-074C-7C1B-F1D4-56E0B3AEAB72}"/>
+              </a:ext>
+            </a:extLst>
+          </p:cNvPr>
+          <p:cNvSpPr txBox="1">
+            <a:spLocks/>
+          </p:cNvSpPr>
+          <p:nvPr/>
+        </p:nvSpPr>
+        <p:spPr>
+          <a:xfrm>
+            <a:off x="423472" y="1559658"/>
+            <a:ext cx="11327804" cy="4396299"/>
+          </a:xfrm>
+          <a:prstGeom prst="rect">
+            <a:avLst/>
+          </a:prstGeom>
+        </p:spPr>
+        <p:txBody>
+          <a:bodyPr/>
+          <a:lstStyle>
+            <a:lvl1pPr marL="228600" indent="-228600" algn="l" defTabSz="914400" rtl="0" eaLnBrk="1" latinLnBrk="0" hangingPunct="1">
+              <a:lnSpc>
+                <a:spcPct val="90000"/>
+              </a:lnSpc>
+              <a:spcBef>
+                <a:spcPts val="1000"/>
+              </a:spcBef>
+              <a:buFont typeface="Arial" panose="020B0604020202020204" pitchFamily="34" charset="0"/>
+              <a:buChar char="•"/>
+              <a:defRPr sz="2800" kern="1200">
+                <a:solidFill>
+                  <a:schemeClr val="tx1"/>
+                </a:solidFill>
+                <a:latin typeface="+mn-lt"/>
+                <a:ea typeface="+mn-ea"/>
+                <a:cs typeface="+mn-cs"/>
+              </a:defRPr>
+            </a:lvl1pPr>
+            <a:lvl2pPr marL="685800" indent="-228600" algn="l" defTabSz="914400" rtl="0" eaLnBrk="1" latinLnBrk="0" hangingPunct="1">
+              <a:lnSpc>
+                <a:spcPct val="90000"/>
+              </a:lnSpc>
+              <a:spcBef>
+                <a:spcPts val="500"/>
+              </a:spcBef>
+              <a:buFont typeface="Arial" panose="020B0604020202020204" pitchFamily="34" charset="0"/>
+              <a:buChar char="•"/>
+              <a:defRPr sz="2400" kern="1200">
+                <a:solidFill>
+                  <a:schemeClr val="tx1"/>
+                </a:solidFill>
+                <a:latin typeface="+mn-lt"/>
+                <a:ea typeface="+mn-ea"/>
+                <a:cs typeface="+mn-cs"/>
+              </a:defRPr>
+            </a:lvl2pPr>
+            <a:lvl3pPr marL="1143000" indent="-228600" algn="l" defTabSz="914400" rtl="0" eaLnBrk="1" latinLnBrk="0" hangingPunct="1">
+              <a:lnSpc>
+                <a:spcPct val="90000"/>
+              </a:lnSpc>
+              <a:spcBef>
+                <a:spcPts val="500"/>
+              </a:spcBef>
+              <a:buFont typeface="Arial" panose="020B0604020202020204" pitchFamily="34" charset="0"/>
+              <a:buChar char="•"/>
+              <a:defRPr sz="2000" kern="1200">
+                <a:solidFill>
+                  <a:schemeClr val="tx1"/>
+                </a:solidFill>
+                <a:latin typeface="+mn-lt"/>
+                <a:ea typeface="+mn-ea"/>
+                <a:cs typeface="+mn-cs"/>
+              </a:defRPr>
+            </a:lvl3pPr>
+            <a:lvl4pPr marL="1600200" indent="-228600" algn="l" defTabSz="914400" rtl="0" eaLnBrk="1" latinLnBrk="0" hangingPunct="1">
+              <a:lnSpc>
+                <a:spcPct val="90000"/>
+              </a:lnSpc>
+              <a:spcBef>
+                <a:spcPts val="500"/>
+              </a:spcBef>
+              <a:buFont typeface="Arial" panose="020B0604020202020204" pitchFamily="34" charset="0"/>
+              <a:buChar char="•"/>
+              <a:defRPr sz="1800" kern="1200">
+                <a:solidFill>
+                  <a:schemeClr val="tx1"/>
+                </a:solidFill>
+                <a:latin typeface="+mn-lt"/>
+                <a:ea typeface="+mn-ea"/>
+                <a:cs typeface="+mn-cs"/>
+              </a:defRPr>
+            </a:lvl4pPr>
+            <a:lvl5pPr marL="2057400" indent="-228600" algn="l" defTabSz="914400" rtl="0" eaLnBrk="1" latinLnBrk="0" hangingPunct="1">
+              <a:lnSpc>
+                <a:spcPct val="90000"/>
+              </a:lnSpc>
+              <a:spcBef>
+                <a:spcPts val="500"/>
+              </a:spcBef>
+              <a:buFont typeface="Arial" panose="020B0604020202020204" pitchFamily="34" charset="0"/>
+              <a:buChar char="•"/>
+              <a:defRPr sz="1800" kern="1200">
+                <a:solidFill>
+                  <a:schemeClr val="tx1"/>
+                </a:solidFill>
+                <a:latin typeface="+mn-lt"/>
+                <a:ea typeface="+mn-ea"/>
+                <a:cs typeface="+mn-cs"/>
+              </a:defRPr>
+            </a:lvl5pPr>
+            <a:lvl6pPr marL="2514600" indent="-228600" algn="l" defTabSz="914400" rtl="0" eaLnBrk="1" latinLnBrk="0" hangingPunct="1">
+              <a:lnSpc>
+                <a:spcPct val="90000"/>
+              </a:lnSpc>
+              <a:spcBef>
+                <a:spcPts val="500"/>
+              </a:spcBef>
+              <a:buFont typeface="Arial" panose="020B0604020202020204" pitchFamily="34" charset="0"/>
+              <a:buChar char="•"/>
+              <a:defRPr sz="1800" kern="1200">
+                <a:solidFill>
+                  <a:schemeClr val="tx1"/>
+                </a:solidFill>
+                <a:latin typeface="+mn-lt"/>
+                <a:ea typeface="+mn-ea"/>
+                <a:cs typeface="+mn-cs"/>
+              </a:defRPr>
+            </a:lvl6pPr>
+            <a:lvl7pPr marL="2971800" indent="-228600" algn="l" defTabSz="914400" rtl="0" eaLnBrk="1" latinLnBrk="0" hangingPunct="1">
+              <a:lnSpc>
+                <a:spcPct val="90000"/>
+              </a:lnSpc>
+              <a:spcBef>
+                <a:spcPts val="500"/>
+              </a:spcBef>
+              <a:buFont typeface="Arial" panose="020B0604020202020204" pitchFamily="34" charset="0"/>
+              <a:buChar char="•"/>
+              <a:defRPr sz="1800" kern="1200">
+                <a:solidFill>
+                  <a:schemeClr val="tx1"/>
+                </a:solidFill>
+                <a:latin typeface="+mn-lt"/>
+                <a:ea typeface="+mn-ea"/>
+                <a:cs typeface="+mn-cs"/>
+              </a:defRPr>
+            </a:lvl7pPr>
+            <a:lvl8pPr marL="3429000" indent="-228600" algn="l" defTabSz="914400" rtl="0" eaLnBrk="1" latinLnBrk="0" hangingPunct="1">
+              <a:lnSpc>
+                <a:spcPct val="90000"/>
+              </a:lnSpc>
+              <a:spcBef>
+                <a:spcPts val="500"/>
+              </a:spcBef>
+              <a:buFont typeface="Arial" panose="020B0604020202020204" pitchFamily="34" charset="0"/>
+              <a:buChar char="•"/>
+              <a:defRPr sz="1800" kern="1200">
+                <a:solidFill>
+                  <a:schemeClr val="tx1"/>
+                </a:solidFill>
+                <a:latin typeface="+mn-lt"/>
+                <a:ea typeface="+mn-ea"/>
+                <a:cs typeface="+mn-cs"/>
+              </a:defRPr>
+            </a:lvl8pPr>
+            <a:lvl9pPr marL="3886200" indent="-228600" algn="l" defTabSz="914400" rtl="0" eaLnBrk="1" latinLnBrk="0" hangingPunct="1">
+              <a:lnSpc>
+                <a:spcPct val="90000"/>
+              </a:lnSpc>
+              <a:spcBef>
+                <a:spcPts val="500"/>
+              </a:spcBef>
+              <a:buFont typeface="Arial" panose="020B0604020202020204" pitchFamily="34" charset="0"/>
+              <a:buChar char="•"/>
+              <a:defRPr sz="1800" kern="1200">
+                <a:solidFill>
+                  <a:schemeClr val="tx1"/>
+                </a:solidFill>
+                <a:latin typeface="+mn-lt"/>
+                <a:ea typeface="+mn-ea"/>
+                <a:cs typeface="+mn-cs"/>
+              </a:defRPr>
+            </a:lvl9pPr>
+          </a:lstStyle>
+          <a:p>
+            <a:pPr marL="0" indent="0" algn="just">
+              <a:buNone/>
+            </a:pPr>
+            <a:r>
+              <a:rPr lang="de-DE" b="1" dirty="0"/>
+              <a:t>Übungsaufgaben &amp; HA</a:t>
+            </a:r>
+          </a:p>
+          <a:p>
+            <a:pPr algn="just"/>
+            <a:r>
+              <a:rPr lang="de-DE" dirty="0"/>
+              <a:t>Buch S. 94, Nr. 9 bis 12</a:t>
+            </a:r>
+          </a:p>
+          <a:p>
+            <a:pPr algn="just"/>
+            <a:r>
+              <a:rPr lang="de-DE" dirty="0"/>
+              <a:t>Arbeitsheft S.29</a:t>
+            </a:r>
+          </a:p>
+          <a:p>
+            <a:pPr marL="0" indent="0" algn="just">
+              <a:buNone/>
+            </a:pPr>
+            <a:endParaRPr lang="de-DE" dirty="0"/>
+          </a:p>
+        </p:txBody>
+      </p:sp>
+      <p:pic>
+        <p:nvPicPr>
+          <p:cNvPr id="2" name="Grafik 1" descr="Ein Bild, das Text, Origami enthält.&#10;&#10;KI-generierte Inhalte können fehlerhaft sein.">
+            <a:extLst>
+              <a:ext uri="{FF2B5EF4-FFF2-40B4-BE49-F238E27FC236}">
+                <a16:creationId xmlns:a16="http://schemas.microsoft.com/office/drawing/2014/main" id="{ED81C1C3-1B7F-1B08-B6A6-1661A19FC104}"/>
+              </a:ext>
+            </a:extLst>
+          </p:cNvPr>
+          <p:cNvPicPr>
+            <a:picLocks noChangeAspect="1"/>
+          </p:cNvPicPr>
+          <p:nvPr/>
+        </p:nvPicPr>
+        <p:blipFill>
+          <a:blip r:embed="rId2"/>
+          <a:stretch>
+            <a:fillRect/>
+          </a:stretch>
+        </p:blipFill>
+        <p:spPr>
+          <a:xfrm>
+            <a:off x="5131558" y="1556801"/>
+            <a:ext cx="6428096" cy="4949065"/>
+          </a:xfrm>
+          <a:prstGeom prst="rect">
+            <a:avLst/>
+          </a:prstGeom>
+        </p:spPr>
+      </p:pic>
+    </p:spTree>
+    <p:extLst>
+      <p:ext uri="{BB962C8B-B14F-4D97-AF65-F5344CB8AC3E}">
+        <p14:creationId xmlns:p14="http://schemas.microsoft.com/office/powerpoint/2010/main" val="3780975631"/>
+      </p:ext>
+    </p:extLst>
+  </p:cSld>
+  <p:clrMapOvr>
+    <a:masterClrMapping/>
+  </p:clrMapOvr>
+</p:sld>
+</file>
+
+<file path=ppt/slides/slide9.xml><?xml version="1.0" encoding="utf-8"?>
+<p:sld xmlns:a="http://schemas.openxmlformats.org/drawingml/2006/main" xmlns:r="http://schemas.openxmlformats.org/officeDocument/2006/relationships" xmlns:p="http://schemas.openxmlformats.org/presentationml/2006/main">
+  <p:cSld>
+    <p:spTree>
+      <p:nvGrpSpPr>
+        <p:cNvPr id="1" name="">
+          <a:extLst>
+            <a:ext uri="{FF2B5EF4-FFF2-40B4-BE49-F238E27FC236}">
+              <a16:creationId xmlns:a16="http://schemas.microsoft.com/office/drawing/2014/main" id="{410076A2-4E39-F17E-5863-B9953E6B7B98}"/>
+            </a:ext>
+          </a:extLst>
+        </p:cNvPr>
+        <p:cNvGrpSpPr/>
+        <p:nvPr/>
+      </p:nvGrpSpPr>
+      <p:grpSpPr>
+        <a:xfrm>
+          <a:off x="0" y="0"/>
+          <a:ext cx="0" cy="0"/>
+          <a:chOff x="0" y="0"/>
+          <a:chExt cx="0" cy="0"/>
+        </a:xfrm>
+      </p:grpSpPr>
+      <p:sp>
+        <p:nvSpPr>
+          <p:cNvPr id="3" name="Titel 1">
+            <a:extLst>
+              <a:ext uri="{FF2B5EF4-FFF2-40B4-BE49-F238E27FC236}">
+                <a16:creationId xmlns:a16="http://schemas.microsoft.com/office/drawing/2014/main" id="{DFAA0DE8-76AE-B16E-694F-B1EB7A6407D7}"/>
+              </a:ext>
+            </a:extLst>
+          </p:cNvPr>
+          <p:cNvSpPr txBox="1">
+            <a:spLocks/>
+          </p:cNvSpPr>
+          <p:nvPr/>
+        </p:nvSpPr>
+        <p:spPr>
+          <a:xfrm>
+            <a:off x="193623" y="425086"/>
+            <a:ext cx="11768528" cy="549275"/>
+          </a:xfrm>
+          <a:prstGeom prst="rect">
+            <a:avLst/>
+          </a:prstGeom>
+        </p:spPr>
+        <p:txBody>
+          <a:bodyPr>
+            <a:normAutofit fontScale="90000" lnSpcReduction="20000"/>
+          </a:bodyPr>
+          <a:lstStyle>
+            <a:lvl1pPr algn="l" defTabSz="914400" rtl="0" eaLnBrk="1" latinLnBrk="0" hangingPunct="1">
+              <a:lnSpc>
+                <a:spcPct val="90000"/>
+              </a:lnSpc>
+              <a:spcBef>
+                <a:spcPct val="0"/>
+              </a:spcBef>
+              <a:buNone/>
+              <a:defRPr sz="4400" kern="1200">
+                <a:solidFill>
+                  <a:schemeClr val="tx1"/>
+                </a:solidFill>
+                <a:latin typeface="+mj-lt"/>
+                <a:ea typeface="+mj-ea"/>
+                <a:cs typeface="+mj-cs"/>
+              </a:defRPr>
+            </a:lvl1pPr>
+          </a:lstStyle>
+          <a:p>
+            <a:pPr algn="ctr"/>
+            <a:r>
+              <a:rPr lang="de-DE" dirty="0">
+                <a:latin typeface="ADLaM Display" panose="02010000000000000000" pitchFamily="2" charset="77"/>
+                <a:ea typeface="ADLaM Display" panose="02010000000000000000" pitchFamily="2" charset="77"/>
+                <a:cs typeface="ADLaM Display" panose="02010000000000000000" pitchFamily="2" charset="77"/>
+              </a:rPr>
+              <a:t>Wiederholung: Achsenspiegelung</a:t>
+            </a:r>
+          </a:p>
+        </p:txBody>
+      </p:sp>
+      <p:sp>
+        <p:nvSpPr>
+          <p:cNvPr id="6" name="Abgerundetes Rechteck 5">
+            <a:extLst>
+              <a:ext uri="{FF2B5EF4-FFF2-40B4-BE49-F238E27FC236}">
+                <a16:creationId xmlns:a16="http://schemas.microsoft.com/office/drawing/2014/main" id="{A4413ECE-BED0-D2A0-6D41-846E970DD14A}"/>
+              </a:ext>
+            </a:extLst>
+          </p:cNvPr>
+          <p:cNvSpPr/>
+          <p:nvPr/>
+        </p:nvSpPr>
+        <p:spPr>
+          <a:xfrm>
+            <a:off x="193623" y="1240970"/>
+            <a:ext cx="11768527" cy="5382251"/>
+          </a:xfrm>
+          <a:prstGeom prst="roundRect">
+            <a:avLst/>
+          </a:prstGeom>
+        </p:spPr>
+        <p:style>
+          <a:lnRef idx="2">
+            <a:schemeClr val="accent3"/>
+          </a:lnRef>
+          <a:fillRef idx="1">
+            <a:schemeClr val="lt1"/>
+          </a:fillRef>
+          <a:effectRef idx="0">
+            <a:schemeClr val="accent3"/>
+          </a:effectRef>
+          <a:fontRef idx="minor">
+            <a:schemeClr val="dk1"/>
+          </a:fontRef>
+        </p:style>
+        <p:txBody>
+          <a:bodyPr rtlCol="0" anchor="ctr"/>
+          <a:lstStyle/>
+          <a:p>
+            <a:pPr algn="ctr"/>
+            <a:endParaRPr lang="de-DE" b="1" dirty="0"/>
+          </a:p>
+        </p:txBody>
+      </p:sp>
+      <p:sp>
+        <p:nvSpPr>
+          <p:cNvPr id="8" name="Inhaltsplatzhalter 2">
+            <a:extLst>
+              <a:ext uri="{FF2B5EF4-FFF2-40B4-BE49-F238E27FC236}">
+                <a16:creationId xmlns:a16="http://schemas.microsoft.com/office/drawing/2014/main" id="{C6D8DCA1-9362-872F-1CAF-10437B85BA4D}"/>
+              </a:ext>
+            </a:extLst>
+          </p:cNvPr>
+          <p:cNvSpPr txBox="1">
+            <a:spLocks/>
+          </p:cNvSpPr>
+          <p:nvPr/>
+        </p:nvSpPr>
+        <p:spPr>
+          <a:xfrm>
+            <a:off x="423472" y="1559658"/>
+            <a:ext cx="11327804" cy="4396299"/>
+          </a:xfrm>
+          <a:prstGeom prst="rect">
+            <a:avLst/>
+          </a:prstGeom>
+        </p:spPr>
+        <p:txBody>
+          <a:bodyPr/>
+          <a:lstStyle>
+            <a:lvl1pPr marL="228600" indent="-228600" algn="l" defTabSz="914400" rtl="0" eaLnBrk="1" latinLnBrk="0" hangingPunct="1">
+              <a:lnSpc>
+                <a:spcPct val="90000"/>
+              </a:lnSpc>
+              <a:spcBef>
+                <a:spcPts val="1000"/>
+              </a:spcBef>
+              <a:buFont typeface="Arial" panose="020B0604020202020204" pitchFamily="34" charset="0"/>
+              <a:buChar char="•"/>
+              <a:defRPr sz="2800" kern="1200">
+                <a:solidFill>
+                  <a:schemeClr val="tx1"/>
+                </a:solidFill>
+                <a:latin typeface="+mn-lt"/>
+                <a:ea typeface="+mn-ea"/>
+                <a:cs typeface="+mn-cs"/>
+              </a:defRPr>
+            </a:lvl1pPr>
+            <a:lvl2pPr marL="685800" indent="-228600" algn="l" defTabSz="914400" rtl="0" eaLnBrk="1" latinLnBrk="0" hangingPunct="1">
+              <a:lnSpc>
+                <a:spcPct val="90000"/>
+              </a:lnSpc>
+              <a:spcBef>
+                <a:spcPts val="500"/>
+              </a:spcBef>
+              <a:buFont typeface="Arial" panose="020B0604020202020204" pitchFamily="34" charset="0"/>
+              <a:buChar char="•"/>
+              <a:defRPr sz="2400" kern="1200">
+                <a:solidFill>
+                  <a:schemeClr val="tx1"/>
+                </a:solidFill>
+                <a:latin typeface="+mn-lt"/>
+                <a:ea typeface="+mn-ea"/>
+                <a:cs typeface="+mn-cs"/>
+              </a:defRPr>
+            </a:lvl2pPr>
+            <a:lvl3pPr marL="1143000" indent="-228600" algn="l" defTabSz="914400" rtl="0" eaLnBrk="1" latinLnBrk="0" hangingPunct="1">
+              <a:lnSpc>
+                <a:spcPct val="90000"/>
+              </a:lnSpc>
+              <a:spcBef>
+                <a:spcPts val="500"/>
+              </a:spcBef>
+              <a:buFont typeface="Arial" panose="020B0604020202020204" pitchFamily="34" charset="0"/>
+              <a:buChar char="•"/>
+              <a:defRPr sz="2000" kern="1200">
+                <a:solidFill>
+                  <a:schemeClr val="tx1"/>
+                </a:solidFill>
+                <a:latin typeface="+mn-lt"/>
+                <a:ea typeface="+mn-ea"/>
+                <a:cs typeface="+mn-cs"/>
+              </a:defRPr>
+            </a:lvl3pPr>
+            <a:lvl4pPr marL="1600200" indent="-228600" algn="l" defTabSz="914400" rtl="0" eaLnBrk="1" latinLnBrk="0" hangingPunct="1">
+              <a:lnSpc>
+                <a:spcPct val="90000"/>
+              </a:lnSpc>
+              <a:spcBef>
+                <a:spcPts val="500"/>
+              </a:spcBef>
+              <a:buFont typeface="Arial" panose="020B0604020202020204" pitchFamily="34" charset="0"/>
+              <a:buChar char="•"/>
+              <a:defRPr sz="1800" kern="1200">
+                <a:solidFill>
+                  <a:schemeClr val="tx1"/>
+                </a:solidFill>
+                <a:latin typeface="+mn-lt"/>
+                <a:ea typeface="+mn-ea"/>
+                <a:cs typeface="+mn-cs"/>
+              </a:defRPr>
+            </a:lvl4pPr>
+            <a:lvl5pPr marL="2057400" indent="-228600" algn="l" defTabSz="914400" rtl="0" eaLnBrk="1" latinLnBrk="0" hangingPunct="1">
+              <a:lnSpc>
+                <a:spcPct val="90000"/>
+              </a:lnSpc>
+              <a:spcBef>
+                <a:spcPts val="500"/>
+              </a:spcBef>
+              <a:buFont typeface="Arial" panose="020B0604020202020204" pitchFamily="34" charset="0"/>
+              <a:buChar char="•"/>
+              <a:defRPr sz="1800" kern="1200">
+                <a:solidFill>
+                  <a:schemeClr val="tx1"/>
+                </a:solidFill>
+                <a:latin typeface="+mn-lt"/>
+                <a:ea typeface="+mn-ea"/>
+                <a:cs typeface="+mn-cs"/>
+              </a:defRPr>
+            </a:lvl5pPr>
+            <a:lvl6pPr marL="2514600" indent="-228600" algn="l" defTabSz="914400" rtl="0" eaLnBrk="1" latinLnBrk="0" hangingPunct="1">
+              <a:lnSpc>
+                <a:spcPct val="90000"/>
+              </a:lnSpc>
+              <a:spcBef>
+                <a:spcPts val="500"/>
+              </a:spcBef>
+              <a:buFont typeface="Arial" panose="020B0604020202020204" pitchFamily="34" charset="0"/>
+              <a:buChar char="•"/>
+              <a:defRPr sz="1800" kern="1200">
+                <a:solidFill>
+                  <a:schemeClr val="tx1"/>
+                </a:solidFill>
+                <a:latin typeface="+mn-lt"/>
+                <a:ea typeface="+mn-ea"/>
+                <a:cs typeface="+mn-cs"/>
+              </a:defRPr>
+            </a:lvl6pPr>
+            <a:lvl7pPr marL="2971800" indent="-228600" algn="l" defTabSz="914400" rtl="0" eaLnBrk="1" latinLnBrk="0" hangingPunct="1">
+              <a:lnSpc>
+                <a:spcPct val="90000"/>
+              </a:lnSpc>
+              <a:spcBef>
+                <a:spcPts val="500"/>
+              </a:spcBef>
+              <a:buFont typeface="Arial" panose="020B0604020202020204" pitchFamily="34" charset="0"/>
+              <a:buChar char="•"/>
+              <a:defRPr sz="1800" kern="1200">
+                <a:solidFill>
+                  <a:schemeClr val="tx1"/>
+                </a:solidFill>
+                <a:latin typeface="+mn-lt"/>
+                <a:ea typeface="+mn-ea"/>
+                <a:cs typeface="+mn-cs"/>
+              </a:defRPr>
+            </a:lvl7pPr>
+            <a:lvl8pPr marL="3429000" indent="-228600" algn="l" defTabSz="914400" rtl="0" eaLnBrk="1" latinLnBrk="0" hangingPunct="1">
+              <a:lnSpc>
+                <a:spcPct val="90000"/>
+              </a:lnSpc>
+              <a:spcBef>
+                <a:spcPts val="500"/>
+              </a:spcBef>
+              <a:buFont typeface="Arial" panose="020B0604020202020204" pitchFamily="34" charset="0"/>
+              <a:buChar char="•"/>
+              <a:defRPr sz="1800" kern="1200">
+                <a:solidFill>
+                  <a:schemeClr val="tx1"/>
+                </a:solidFill>
+                <a:latin typeface="+mn-lt"/>
+                <a:ea typeface="+mn-ea"/>
+                <a:cs typeface="+mn-cs"/>
+              </a:defRPr>
+            </a:lvl8pPr>
+            <a:lvl9pPr marL="3886200" indent="-228600" algn="l" defTabSz="914400" rtl="0" eaLnBrk="1" latinLnBrk="0" hangingPunct="1">
+              <a:lnSpc>
+                <a:spcPct val="90000"/>
+              </a:lnSpc>
+              <a:spcBef>
+                <a:spcPts val="500"/>
+              </a:spcBef>
+              <a:buFont typeface="Arial" panose="020B0604020202020204" pitchFamily="34" charset="0"/>
+              <a:buChar char="•"/>
+              <a:defRPr sz="1800" kern="1200">
+                <a:solidFill>
+                  <a:schemeClr val="tx1"/>
+                </a:solidFill>
+                <a:latin typeface="+mn-lt"/>
+                <a:ea typeface="+mn-ea"/>
+                <a:cs typeface="+mn-cs"/>
+              </a:defRPr>
+            </a:lvl9pPr>
+          </a:lstStyle>
+          <a:p>
+            <a:pPr marL="0" indent="0" algn="just">
+              <a:buNone/>
+            </a:pPr>
+            <a:r>
+              <a:rPr lang="de-DE" b="1" dirty="0"/>
+              <a:t>Aufgabe </a:t>
+            </a:r>
+          </a:p>
+        </p:txBody>
+      </p:sp>
+      <p:pic>
+        <p:nvPicPr>
+          <p:cNvPr id="5" name="Grafik 4" descr="Ein Bild, das Text, Screenshot, Cartoon enthält.&#10;&#10;KI-generierte Inhalte können fehlerhaft sein.">
+            <a:extLst>
+              <a:ext uri="{FF2B5EF4-FFF2-40B4-BE49-F238E27FC236}">
+                <a16:creationId xmlns:a16="http://schemas.microsoft.com/office/drawing/2014/main" id="{C0F004F6-8F3D-C1B9-51DC-5329CA3F820F}"/>
+              </a:ext>
+            </a:extLst>
+          </p:cNvPr>
+          <p:cNvPicPr>
+            <a:picLocks noChangeAspect="1"/>
+          </p:cNvPicPr>
+          <p:nvPr/>
+        </p:nvPicPr>
+        <p:blipFill>
+          <a:blip r:embed="rId2"/>
+          <a:stretch>
+            <a:fillRect/>
+          </a:stretch>
+        </p:blipFill>
+        <p:spPr>
+          <a:xfrm>
+            <a:off x="588371" y="2214562"/>
+            <a:ext cx="10887898" cy="3402468"/>
+          </a:xfrm>
+          <a:prstGeom prst="rect">
+            <a:avLst/>
+          </a:prstGeom>
+        </p:spPr>
+      </p:pic>
+    </p:spTree>
+    <p:extLst>
+      <p:ext uri="{BB962C8B-B14F-4D97-AF65-F5344CB8AC3E}">
+        <p14:creationId xmlns:p14="http://schemas.microsoft.com/office/powerpoint/2010/main" val="1902653144"/>
       </p:ext>
     </p:extLst>
   </p:cSld>

</xml_diff>

<commit_message>
Add reset button for Epochalstatistik with security confirmation
- Added reset-all-participations endpoint to reset all ratings and comments
- Added reset button in Epochalstatistik modal with security dialog
- User must type 'ZURÜCKSETZEN' to confirm reset action
- Resets all participation values to 0 and removes all comments
- Deletes all EPO grades for the group
- Fixed missing holdMessage state variable in TeacherDashboard
</commit_message>
<xml_diff>
--- a/J-M-Reihen/Mathe/Klasse 7/Kap.3 - Geometrische Abbildungen/#_Reihenplan.pptx
+++ b/J-M-Reihen/Mathe/Klasse 7/Kap.3 - Geometrische Abbildungen/#_Reihenplan.pptx
@@ -5,7 +5,7 @@
     <p:sldMasterId id="2147483648" r:id="rId1"/>
   </p:sldMasterIdLst>
   <p:notesMasterIdLst>
-    <p:notesMasterId r:id="rId14"/>
+    <p:notesMasterId r:id="rId12"/>
   </p:notesMasterIdLst>
   <p:sldIdLst>
     <p:sldId id="259" r:id="rId2"/>
@@ -13,13 +13,11 @@
     <p:sldId id="257" r:id="rId4"/>
     <p:sldId id="258" r:id="rId5"/>
     <p:sldId id="260" r:id="rId6"/>
-    <p:sldId id="265" r:id="rId7"/>
-    <p:sldId id="268" r:id="rId8"/>
-    <p:sldId id="270" r:id="rId9"/>
-    <p:sldId id="271" r:id="rId10"/>
-    <p:sldId id="273" r:id="rId11"/>
-    <p:sldId id="267" r:id="rId12"/>
-    <p:sldId id="261" r:id="rId13"/>
+    <p:sldId id="275" r:id="rId7"/>
+    <p:sldId id="276" r:id="rId8"/>
+    <p:sldId id="273" r:id="rId9"/>
+    <p:sldId id="267" r:id="rId10"/>
+    <p:sldId id="261" r:id="rId11"/>
   </p:sldIdLst>
   <p:sldSz cx="12192000" cy="6858000"/>
   <p:notesSz cx="6858000" cy="9144000"/>
@@ -208,7 +206,7 @@
           <a:p>
             <a:fld id="{0A10E92E-5F19-834A-AA97-53FA2D660DCB}" type="datetimeFigureOut">
               <a:rPr lang="de-DE" smtClean="0"/>
-              <a:t>04.01.26</a:t>
+              <a:t>08.01.26</a:t>
             </a:fld>
             <a:endParaRPr lang="de-DE"/>
           </a:p>
@@ -559,6 +557,198 @@
 </p:notes>
 </file>
 
+<file path=ppt/notesSlides/notesSlide2.xml><?xml version="1.0" encoding="utf-8"?>
+<p:notes xmlns:a="http://schemas.openxmlformats.org/drawingml/2006/main" xmlns:r="http://schemas.openxmlformats.org/officeDocument/2006/relationships" xmlns:p="http://schemas.openxmlformats.org/presentationml/2006/main">
+  <p:cSld>
+    <p:spTree>
+      <p:nvGrpSpPr>
+        <p:cNvPr id="1" name=""/>
+        <p:cNvGrpSpPr/>
+        <p:nvPr/>
+      </p:nvGrpSpPr>
+      <p:grpSpPr>
+        <a:xfrm>
+          <a:off x="0" y="0"/>
+          <a:ext cx="0" cy="0"/>
+          <a:chOff x="0" y="0"/>
+          <a:chExt cx="0" cy="0"/>
+        </a:xfrm>
+      </p:grpSpPr>
+      <p:sp>
+        <p:nvSpPr>
+          <p:cNvPr id="2" name="Folienbildplatzhalter 1"/>
+          <p:cNvSpPr>
+            <a:spLocks noGrp="1" noRot="1" noChangeAspect="1"/>
+          </p:cNvSpPr>
+          <p:nvPr>
+            <p:ph type="sldImg"/>
+          </p:nvPr>
+        </p:nvSpPr>
+        <p:spPr/>
+      </p:sp>
+      <p:sp>
+        <p:nvSpPr>
+          <p:cNvPr id="3" name="Notizenplatzhalter 2"/>
+          <p:cNvSpPr>
+            <a:spLocks noGrp="1"/>
+          </p:cNvSpPr>
+          <p:nvPr>
+            <p:ph type="body" idx="1"/>
+          </p:nvPr>
+        </p:nvSpPr>
+        <p:spPr/>
+        <p:txBody>
+          <a:bodyPr/>
+          <a:lstStyle/>
+          <a:p>
+            <a:endParaRPr lang="de-DE" dirty="0"/>
+          </a:p>
+        </p:txBody>
+      </p:sp>
+      <p:sp>
+        <p:nvSpPr>
+          <p:cNvPr id="4" name="Foliennummernplatzhalter 3"/>
+          <p:cNvSpPr>
+            <a:spLocks noGrp="1"/>
+          </p:cNvSpPr>
+          <p:nvPr>
+            <p:ph type="sldNum" sz="quarter" idx="5"/>
+          </p:nvPr>
+        </p:nvSpPr>
+        <p:spPr/>
+        <p:txBody>
+          <a:bodyPr/>
+          <a:lstStyle/>
+          <a:p>
+            <a:fld id="{5264360D-A3AE-044F-B6E9-FC0C70EEF33D}" type="slidenum">
+              <a:rPr lang="de-DE" smtClean="0"/>
+              <a:t>6</a:t>
+            </a:fld>
+            <a:endParaRPr lang="de-DE"/>
+          </a:p>
+        </p:txBody>
+      </p:sp>
+    </p:spTree>
+    <p:extLst>
+      <p:ext uri="{BB962C8B-B14F-4D97-AF65-F5344CB8AC3E}">
+        <p14:creationId xmlns:p14="http://schemas.microsoft.com/office/powerpoint/2010/main" val="2632277965"/>
+      </p:ext>
+    </p:extLst>
+  </p:cSld>
+  <p:clrMapOvr>
+    <a:masterClrMapping/>
+  </p:clrMapOvr>
+</p:notes>
+</file>
+
+<file path=ppt/notesSlides/notesSlide3.xml><?xml version="1.0" encoding="utf-8"?>
+<p:notes xmlns:a="http://schemas.openxmlformats.org/drawingml/2006/main" xmlns:r="http://schemas.openxmlformats.org/officeDocument/2006/relationships" xmlns:p="http://schemas.openxmlformats.org/presentationml/2006/main">
+  <p:cSld>
+    <p:spTree>
+      <p:nvGrpSpPr>
+        <p:cNvPr id="1" name="">
+          <a:extLst>
+            <a:ext uri="{FF2B5EF4-FFF2-40B4-BE49-F238E27FC236}">
+              <a16:creationId xmlns:a16="http://schemas.microsoft.com/office/drawing/2014/main" id="{28B05096-8626-F7C9-A510-DEE6C10FBDA1}"/>
+            </a:ext>
+          </a:extLst>
+        </p:cNvPr>
+        <p:cNvGrpSpPr/>
+        <p:nvPr/>
+      </p:nvGrpSpPr>
+      <p:grpSpPr>
+        <a:xfrm>
+          <a:off x="0" y="0"/>
+          <a:ext cx="0" cy="0"/>
+          <a:chOff x="0" y="0"/>
+          <a:chExt cx="0" cy="0"/>
+        </a:xfrm>
+      </p:grpSpPr>
+      <p:sp>
+        <p:nvSpPr>
+          <p:cNvPr id="2" name="Folienbildplatzhalter 1">
+            <a:extLst>
+              <a:ext uri="{FF2B5EF4-FFF2-40B4-BE49-F238E27FC236}">
+                <a16:creationId xmlns:a16="http://schemas.microsoft.com/office/drawing/2014/main" id="{2EC7B601-BC46-65F0-4FFE-27CBC3FB08F2}"/>
+              </a:ext>
+            </a:extLst>
+          </p:cNvPr>
+          <p:cNvSpPr>
+            <a:spLocks noGrp="1" noRot="1" noChangeAspect="1"/>
+          </p:cNvSpPr>
+          <p:nvPr>
+            <p:ph type="sldImg"/>
+          </p:nvPr>
+        </p:nvSpPr>
+        <p:spPr/>
+      </p:sp>
+      <p:sp>
+        <p:nvSpPr>
+          <p:cNvPr id="3" name="Notizenplatzhalter 2">
+            <a:extLst>
+              <a:ext uri="{FF2B5EF4-FFF2-40B4-BE49-F238E27FC236}">
+                <a16:creationId xmlns:a16="http://schemas.microsoft.com/office/drawing/2014/main" id="{05FDF686-C7F0-5367-989C-849DBB13BDAB}"/>
+              </a:ext>
+            </a:extLst>
+          </p:cNvPr>
+          <p:cNvSpPr>
+            <a:spLocks noGrp="1"/>
+          </p:cNvSpPr>
+          <p:nvPr>
+            <p:ph type="body" idx="1"/>
+          </p:nvPr>
+        </p:nvSpPr>
+        <p:spPr/>
+        <p:txBody>
+          <a:bodyPr/>
+          <a:lstStyle/>
+          <a:p>
+            <a:endParaRPr lang="de-DE" dirty="0"/>
+          </a:p>
+        </p:txBody>
+      </p:sp>
+      <p:sp>
+        <p:nvSpPr>
+          <p:cNvPr id="4" name="Foliennummernplatzhalter 3">
+            <a:extLst>
+              <a:ext uri="{FF2B5EF4-FFF2-40B4-BE49-F238E27FC236}">
+                <a16:creationId xmlns:a16="http://schemas.microsoft.com/office/drawing/2014/main" id="{9231D57F-E3DF-F64C-D61C-A085756B8884}"/>
+              </a:ext>
+            </a:extLst>
+          </p:cNvPr>
+          <p:cNvSpPr>
+            <a:spLocks noGrp="1"/>
+          </p:cNvSpPr>
+          <p:nvPr>
+            <p:ph type="sldNum" sz="quarter" idx="5"/>
+          </p:nvPr>
+        </p:nvSpPr>
+        <p:spPr/>
+        <p:txBody>
+          <a:bodyPr/>
+          <a:lstStyle/>
+          <a:p>
+            <a:fld id="{5264360D-A3AE-044F-B6E9-FC0C70EEF33D}" type="slidenum">
+              <a:rPr lang="de-DE" smtClean="0"/>
+              <a:t>7</a:t>
+            </a:fld>
+            <a:endParaRPr lang="de-DE"/>
+          </a:p>
+        </p:txBody>
+      </p:sp>
+    </p:spTree>
+    <p:extLst>
+      <p:ext uri="{BB962C8B-B14F-4D97-AF65-F5344CB8AC3E}">
+        <p14:creationId xmlns:p14="http://schemas.microsoft.com/office/powerpoint/2010/main" val="1310250480"/>
+      </p:ext>
+    </p:extLst>
+  </p:cSld>
+  <p:clrMapOvr>
+    <a:masterClrMapping/>
+  </p:clrMapOvr>
+</p:notes>
+</file>
+
 <file path=ppt/slideLayouts/slideLayout1.xml><?xml version="1.0" encoding="utf-8"?>
 <p:sldLayout xmlns:a="http://schemas.openxmlformats.org/drawingml/2006/main" xmlns:r="http://schemas.openxmlformats.org/officeDocument/2006/relationships" xmlns:p="http://schemas.openxmlformats.org/presentationml/2006/main" type="title" preserve="1">
   <p:cSld name="Titelfolie">
@@ -706,7 +896,7 @@
           <a:p>
             <a:fld id="{C72C0E08-E80E-9141-9781-077B3A888FD3}" type="datetimeFigureOut">
               <a:rPr lang="de-DE" smtClean="0"/>
-              <a:t>04.01.26</a:t>
+              <a:t>08.01.26</a:t>
             </a:fld>
             <a:endParaRPr lang="de-DE"/>
           </a:p>
@@ -904,7 +1094,7 @@
           <a:p>
             <a:fld id="{C72C0E08-E80E-9141-9781-077B3A888FD3}" type="datetimeFigureOut">
               <a:rPr lang="de-DE" smtClean="0"/>
-              <a:t>04.01.26</a:t>
+              <a:t>08.01.26</a:t>
             </a:fld>
             <a:endParaRPr lang="de-DE"/>
           </a:p>
@@ -1112,7 +1302,7 @@
           <a:p>
             <a:fld id="{C72C0E08-E80E-9141-9781-077B3A888FD3}" type="datetimeFigureOut">
               <a:rPr lang="de-DE" smtClean="0"/>
-              <a:t>04.01.26</a:t>
+              <a:t>08.01.26</a:t>
             </a:fld>
             <a:endParaRPr lang="de-DE"/>
           </a:p>
@@ -1310,7 +1500,7 @@
           <a:p>
             <a:fld id="{C72C0E08-E80E-9141-9781-077B3A888FD3}" type="datetimeFigureOut">
               <a:rPr lang="de-DE" smtClean="0"/>
-              <a:t>04.01.26</a:t>
+              <a:t>08.01.26</a:t>
             </a:fld>
             <a:endParaRPr lang="de-DE"/>
           </a:p>
@@ -1585,7 +1775,7 @@
           <a:p>
             <a:fld id="{C72C0E08-E80E-9141-9781-077B3A888FD3}" type="datetimeFigureOut">
               <a:rPr lang="de-DE" smtClean="0"/>
-              <a:t>04.01.26</a:t>
+              <a:t>08.01.26</a:t>
             </a:fld>
             <a:endParaRPr lang="de-DE"/>
           </a:p>
@@ -1850,7 +2040,7 @@
           <a:p>
             <a:fld id="{C72C0E08-E80E-9141-9781-077B3A888FD3}" type="datetimeFigureOut">
               <a:rPr lang="de-DE" smtClean="0"/>
-              <a:t>04.01.26</a:t>
+              <a:t>08.01.26</a:t>
             </a:fld>
             <a:endParaRPr lang="de-DE"/>
           </a:p>
@@ -2262,7 +2452,7 @@
           <a:p>
             <a:fld id="{C72C0E08-E80E-9141-9781-077B3A888FD3}" type="datetimeFigureOut">
               <a:rPr lang="de-DE" smtClean="0"/>
-              <a:t>04.01.26</a:t>
+              <a:t>08.01.26</a:t>
             </a:fld>
             <a:endParaRPr lang="de-DE"/>
           </a:p>
@@ -2403,7 +2593,7 @@
           <a:p>
             <a:fld id="{C72C0E08-E80E-9141-9781-077B3A888FD3}" type="datetimeFigureOut">
               <a:rPr lang="de-DE" smtClean="0"/>
-              <a:t>04.01.26</a:t>
+              <a:t>08.01.26</a:t>
             </a:fld>
             <a:endParaRPr lang="de-DE"/>
           </a:p>
@@ -2516,7 +2706,7 @@
           <a:p>
             <a:fld id="{C72C0E08-E80E-9141-9781-077B3A888FD3}" type="datetimeFigureOut">
               <a:rPr lang="de-DE" smtClean="0"/>
-              <a:t>04.01.26</a:t>
+              <a:t>08.01.26</a:t>
             </a:fld>
             <a:endParaRPr lang="de-DE"/>
           </a:p>
@@ -2827,7 +3017,7 @@
           <a:p>
             <a:fld id="{C72C0E08-E80E-9141-9781-077B3A888FD3}" type="datetimeFigureOut">
               <a:rPr lang="de-DE" smtClean="0"/>
-              <a:t>04.01.26</a:t>
+              <a:t>08.01.26</a:t>
             </a:fld>
             <a:endParaRPr lang="de-DE"/>
           </a:p>
@@ -3115,7 +3305,7 @@
           <a:p>
             <a:fld id="{C72C0E08-E80E-9141-9781-077B3A888FD3}" type="datetimeFigureOut">
               <a:rPr lang="de-DE" smtClean="0"/>
-              <a:t>04.01.26</a:t>
+              <a:t>08.01.26</a:t>
             </a:fld>
             <a:endParaRPr lang="de-DE"/>
           </a:p>
@@ -3356,7 +3546,7 @@
           <a:p>
             <a:fld id="{C72C0E08-E80E-9141-9781-077B3A888FD3}" type="datetimeFigureOut">
               <a:rPr lang="de-DE" smtClean="0"/>
-              <a:t>04.01.26</a:t>
+              <a:t>08.01.26</a:t>
             </a:fld>
             <a:endParaRPr lang="de-DE"/>
           </a:p>
@@ -3991,7 +4181,7 @@
         <p:cNvPr id="1" name="">
           <a:extLst>
             <a:ext uri="{FF2B5EF4-FFF2-40B4-BE49-F238E27FC236}">
-              <a16:creationId xmlns:a16="http://schemas.microsoft.com/office/drawing/2014/main" id="{11C59FFA-CB53-2E41-B295-6995E33AED7C}"/>
+              <a16:creationId xmlns:a16="http://schemas.microsoft.com/office/drawing/2014/main" id="{9222C1B5-FD3F-140B-0240-6286CB108925}"/>
             </a:ext>
           </a:extLst>
         </p:cNvPr>
@@ -4011,7 +4201,7 @@
           <p:cNvPr id="3" name="Titel 1">
             <a:extLst>
               <a:ext uri="{FF2B5EF4-FFF2-40B4-BE49-F238E27FC236}">
-                <a16:creationId xmlns:a16="http://schemas.microsoft.com/office/drawing/2014/main" id="{E5C95B1E-543F-86D6-A505-7DAC962D4EE4}"/>
+                <a16:creationId xmlns:a16="http://schemas.microsoft.com/office/drawing/2014/main" id="{9EC30369-1B87-EE63-02B2-F5EE2C8932EA}"/>
               </a:ext>
             </a:extLst>
           </p:cNvPr>
@@ -4060,73 +4250,29 @@
                 <a:ea typeface="ADLaM Display" panose="02010000000000000000" pitchFamily="2" charset="77"/>
                 <a:cs typeface="ADLaM Display" panose="02010000000000000000" pitchFamily="2" charset="77"/>
               </a:rPr>
-              <a:t>Wiederholung: Achsenspiegelung</a:t>
-            </a:r>
-          </a:p>
-        </p:txBody>
-      </p:sp>
-      <p:sp>
-        <p:nvSpPr>
-          <p:cNvPr id="6" name="Abgerundetes Rechteck 5">
-            <a:extLst>
-              <a:ext uri="{FF2B5EF4-FFF2-40B4-BE49-F238E27FC236}">
-                <a16:creationId xmlns:a16="http://schemas.microsoft.com/office/drawing/2014/main" id="{21030813-6EB7-A10E-6DF4-C20A6368813F}"/>
-              </a:ext>
-            </a:extLst>
-          </p:cNvPr>
-          <p:cNvSpPr/>
+              <a:t>Grundbegriffe</a:t>
+            </a:r>
+          </a:p>
+        </p:txBody>
+      </p:sp>
+      <p:sp>
+        <p:nvSpPr>
+          <p:cNvPr id="2" name="Inhaltsplatzhalter 2">
+            <a:extLst>
+              <a:ext uri="{FF2B5EF4-FFF2-40B4-BE49-F238E27FC236}">
+                <a16:creationId xmlns:a16="http://schemas.microsoft.com/office/drawing/2014/main" id="{28678534-CDB9-14A7-825C-F99236BE0A48}"/>
+              </a:ext>
+            </a:extLst>
+          </p:cNvPr>
+          <p:cNvSpPr txBox="1">
+            <a:spLocks/>
+          </p:cNvSpPr>
           <p:nvPr/>
         </p:nvSpPr>
         <p:spPr>
           <a:xfrm>
-            <a:off x="193623" y="1240970"/>
-            <a:ext cx="11768527" cy="5382251"/>
-          </a:xfrm>
-          <a:prstGeom prst="roundRect">
-            <a:avLst/>
-          </a:prstGeom>
-        </p:spPr>
-        <p:style>
-          <a:lnRef idx="2">
-            <a:schemeClr val="accent3"/>
-          </a:lnRef>
-          <a:fillRef idx="1">
-            <a:schemeClr val="lt1"/>
-          </a:fillRef>
-          <a:effectRef idx="0">
-            <a:schemeClr val="accent3"/>
-          </a:effectRef>
-          <a:fontRef idx="minor">
-            <a:schemeClr val="dk1"/>
-          </a:fontRef>
-        </p:style>
-        <p:txBody>
-          <a:bodyPr rtlCol="0" anchor="ctr"/>
-          <a:lstStyle/>
-          <a:p>
-            <a:pPr algn="ctr"/>
-            <a:endParaRPr lang="de-DE" b="1" dirty="0"/>
-          </a:p>
-        </p:txBody>
-      </p:sp>
-      <p:sp>
-        <p:nvSpPr>
-          <p:cNvPr id="8" name="Inhaltsplatzhalter 2">
-            <a:extLst>
-              <a:ext uri="{FF2B5EF4-FFF2-40B4-BE49-F238E27FC236}">
-                <a16:creationId xmlns:a16="http://schemas.microsoft.com/office/drawing/2014/main" id="{51CD4DA6-533A-1C11-CF38-30C2128D053A}"/>
-              </a:ext>
-            </a:extLst>
-          </p:cNvPr>
-          <p:cNvSpPr txBox="1">
-            <a:spLocks/>
-          </p:cNvSpPr>
-          <p:nvPr/>
-        </p:nvSpPr>
-        <p:spPr>
-          <a:xfrm>
-            <a:off x="423472" y="1559658"/>
-            <a:ext cx="11327804" cy="4396299"/>
+            <a:off x="193623" y="5577840"/>
+            <a:ext cx="11768528" cy="1034955"/>
           </a:xfrm>
           <a:prstGeom prst="rect">
             <a:avLst/>
@@ -4299,83 +4445,30 @@
             </a:lvl9pPr>
           </a:lstStyle>
           <a:p>
-            <a:pPr marL="0" indent="0" algn="just">
+            <a:pPr marL="0" indent="0">
               <a:buNone/>
             </a:pPr>
             <a:r>
               <a:rPr lang="de-DE" b="1" dirty="0"/>
-              <a:t>Übungsaufgaben &amp; HA </a:t>
-            </a:r>
-          </a:p>
-          <a:p>
-            <a:pPr algn="just"/>
+              <a:t>HA - </a:t>
+            </a:r>
             <a:r>
               <a:rPr lang="de-DE" dirty="0"/>
-              <a:t>Buch S.97, Nr. 3</a:t>
-            </a:r>
-          </a:p>
-          <a:p>
-            <a:pPr algn="just"/>
+              <a:t>Arbeitsheft </a:t>
+            </a:r>
+          </a:p>
+          <a:p>
             <a:r>
               <a:rPr lang="de-DE" dirty="0"/>
-              <a:t>Arbeitsheft S.30</a:t>
-            </a:r>
-          </a:p>
-          <a:p>
-            <a:pPr algn="just"/>
-            <a:r>
-              <a:rPr lang="de-DE" b="1" dirty="0"/>
-              <a:t>Bonus</a:t>
-            </a:r>
-            <a:r>
-              <a:rPr lang="de-DE" dirty="0"/>
-              <a:t>: Nr. 4</a:t>
-            </a:r>
-          </a:p>
-          <a:p>
-            <a:pPr algn="just"/>
-            <a:endParaRPr lang="de-DE" b="1" dirty="0"/>
-          </a:p>
-          <a:p>
-            <a:pPr algn="just"/>
-            <a:endParaRPr lang="de-DE" b="1" dirty="0"/>
-          </a:p>
-        </p:txBody>
-      </p:sp>
-      <p:pic>
-        <p:nvPicPr>
-          <p:cNvPr id="10" name="Grafik 9" descr="Ein Bild, das Text, Screenshot enthält.&#10;&#10;KI-generierte Inhalte können fehlerhaft sein.">
-            <a:extLst>
-              <a:ext uri="{FF2B5EF4-FFF2-40B4-BE49-F238E27FC236}">
-                <a16:creationId xmlns:a16="http://schemas.microsoft.com/office/drawing/2014/main" id="{5EEBACB8-7346-AD53-4754-4D335152D411}"/>
-              </a:ext>
-            </a:extLst>
-          </p:cNvPr>
-          <p:cNvPicPr>
-            <a:picLocks noChangeAspect="1"/>
-          </p:cNvPicPr>
-          <p:nvPr/>
-        </p:nvPicPr>
-        <p:blipFill>
-          <a:blip r:embed="rId2"/>
-          <a:stretch>
-            <a:fillRect/>
-          </a:stretch>
-        </p:blipFill>
-        <p:spPr>
-          <a:xfrm>
-            <a:off x="4796228" y="2010230"/>
-            <a:ext cx="6972300" cy="3606800"/>
-          </a:xfrm>
-          <a:prstGeom prst="rect">
-            <a:avLst/>
-          </a:prstGeom>
-        </p:spPr>
-      </p:pic>
+              <a:t>S. 33 bis 37 - Doppelspiegelung</a:t>
+            </a:r>
+          </a:p>
+        </p:txBody>
+      </p:sp>
     </p:spTree>
     <p:extLst>
       <p:ext uri="{BB962C8B-B14F-4D97-AF65-F5344CB8AC3E}">
-        <p14:creationId xmlns:p14="http://schemas.microsoft.com/office/powerpoint/2010/main" val="3172547515"/>
+        <p14:creationId xmlns:p14="http://schemas.microsoft.com/office/powerpoint/2010/main" val="2611820202"/>
       </p:ext>
     </p:extLst>
   </p:cSld>
@@ -4385,7 +4478,7 @@
 </p:sld>
 </file>
 
-<file path=ppt/slides/slide11.xml><?xml version="1.0" encoding="utf-8"?>
+<file path=ppt/slides/slide2.xml><?xml version="1.0" encoding="utf-8"?>
 <p:sld xmlns:a="http://schemas.openxmlformats.org/drawingml/2006/main" xmlns:r="http://schemas.openxmlformats.org/officeDocument/2006/relationships" xmlns:p="http://schemas.openxmlformats.org/presentationml/2006/main">
   <p:cSld>
     <p:spTree>
@@ -4393,7 +4486,7 @@
         <p:cNvPr id="1" name="">
           <a:extLst>
             <a:ext uri="{FF2B5EF4-FFF2-40B4-BE49-F238E27FC236}">
-              <a16:creationId xmlns:a16="http://schemas.microsoft.com/office/drawing/2014/main" id="{D6F9E721-EB3B-BCB5-BE3B-CA6255C50FF9}"/>
+              <a16:creationId xmlns:a16="http://schemas.microsoft.com/office/drawing/2014/main" id="{53DF5F4C-102E-2FAA-E0F6-EAC29427C1C2}"/>
             </a:ext>
           </a:extLst>
         </p:cNvPr>
@@ -4410,21 +4503,436 @@
       </p:grpSpPr>
       <p:sp>
         <p:nvSpPr>
-          <p:cNvPr id="3" name="Titel 1">
-            <a:extLst>
-              <a:ext uri="{FF2B5EF4-FFF2-40B4-BE49-F238E27FC236}">
-                <a16:creationId xmlns:a16="http://schemas.microsoft.com/office/drawing/2014/main" id="{68D2655B-9794-C641-BFA5-6367C8865A9C}"/>
-              </a:ext>
-            </a:extLst>
-          </p:cNvPr>
-          <p:cNvSpPr txBox="1">
-            <a:spLocks/>
-          </p:cNvSpPr>
-          <p:nvPr/>
+          <p:cNvPr id="2" name="Titel 1">
+            <a:extLst>
+              <a:ext uri="{FF2B5EF4-FFF2-40B4-BE49-F238E27FC236}">
+                <a16:creationId xmlns:a16="http://schemas.microsoft.com/office/drawing/2014/main" id="{68DC2F80-0867-583C-AC58-8829AB16F9DD}"/>
+              </a:ext>
+            </a:extLst>
+          </p:cNvPr>
+          <p:cNvSpPr>
+            <a:spLocks noGrp="1"/>
+          </p:cNvSpPr>
+          <p:nvPr>
+            <p:ph type="title"/>
+          </p:nvPr>
         </p:nvSpPr>
         <p:spPr>
           <a:xfrm>
             <a:off x="193623" y="425086"/>
+            <a:ext cx="11768528" cy="549275"/>
+          </a:xfrm>
+        </p:spPr>
+        <p:txBody>
+          <a:bodyPr>
+            <a:normAutofit fontScale="90000"/>
+          </a:bodyPr>
+          <a:lstStyle/>
+          <a:p>
+            <a:pPr algn="ctr"/>
+            <a:r>
+              <a:rPr lang="de-DE" dirty="0">
+                <a:latin typeface="ADLaM Display" panose="02010000000000000000" pitchFamily="2" charset="77"/>
+                <a:ea typeface="ADLaM Display" panose="02010000000000000000" pitchFamily="2" charset="77"/>
+                <a:cs typeface="ADLaM Display" panose="02010000000000000000" pitchFamily="2" charset="77"/>
+              </a:rPr>
+              <a:t>Sitzordnung Computerraum</a:t>
+            </a:r>
+          </a:p>
+        </p:txBody>
+      </p:sp>
+      <p:sp>
+        <p:nvSpPr>
+          <p:cNvPr id="3" name="Inhaltsplatzhalter 2">
+            <a:extLst>
+              <a:ext uri="{FF2B5EF4-FFF2-40B4-BE49-F238E27FC236}">
+                <a16:creationId xmlns:a16="http://schemas.microsoft.com/office/drawing/2014/main" id="{FB5C29FB-88F6-4809-15BC-1B0316BD3AC4}"/>
+              </a:ext>
+            </a:extLst>
+          </p:cNvPr>
+          <p:cNvSpPr>
+            <a:spLocks noGrp="1"/>
+          </p:cNvSpPr>
+          <p:nvPr>
+            <p:ph sz="half" idx="1"/>
+          </p:nvPr>
+        </p:nvSpPr>
+        <p:spPr>
+          <a:xfrm>
+            <a:off x="193623" y="1497496"/>
+            <a:ext cx="11768528" cy="5115299"/>
+          </a:xfrm>
+        </p:spPr>
+        <p:txBody>
+          <a:bodyPr>
+            <a:normAutofit fontScale="92500" lnSpcReduction="20000"/>
+          </a:bodyPr>
+          <a:lstStyle/>
+          <a:p>
+            <a:pPr marL="0" indent="0" fontAlgn="ctr">
+              <a:buNone/>
+            </a:pPr>
+            <a:r>
+              <a:rPr lang="de-DE" dirty="0"/>
+              <a:t>Louisa					Marlene K.		 Adela</a:t>
+            </a:r>
+          </a:p>
+          <a:p>
+            <a:pPr marL="0" indent="0" fontAlgn="ctr">
+              <a:buNone/>
+            </a:pPr>
+            <a:r>
+              <a:rPr lang="de-DE" dirty="0"/>
+              <a:t>Julia		Marlene G.		 	Jasmin 		Friederike</a:t>
+            </a:r>
+          </a:p>
+          <a:p>
+            <a:pPr marL="0" indent="0" fontAlgn="ctr">
+              <a:buNone/>
+            </a:pPr>
+            <a:endParaRPr lang="de-DE" dirty="0"/>
+          </a:p>
+          <a:p>
+            <a:pPr marL="0" indent="0" fontAlgn="ctr">
+              <a:buNone/>
+            </a:pPr>
+            <a:r>
+              <a:rPr lang="de-DE" dirty="0"/>
+              <a:t>Jonas		Samuel			Dennis		Luise</a:t>
+            </a:r>
+          </a:p>
+          <a:p>
+            <a:pPr marL="0" indent="0" algn="just" fontAlgn="ctr">
+              <a:buNone/>
+            </a:pPr>
+            <a:r>
+              <a:rPr lang="de-DE" dirty="0"/>
+              <a:t>Kilian 		Jan				Vincent 		Hannah</a:t>
+            </a:r>
+          </a:p>
+          <a:p>
+            <a:pPr marL="0" indent="0" fontAlgn="ctr">
+              <a:buNone/>
+            </a:pPr>
+            <a:endParaRPr lang="de-DE" dirty="0"/>
+          </a:p>
+          <a:p>
+            <a:pPr marL="0" indent="0" fontAlgn="ctr">
+              <a:buNone/>
+            </a:pPr>
+            <a:endParaRPr lang="de-DE" dirty="0"/>
+          </a:p>
+          <a:p>
+            <a:pPr marL="0" indent="0" fontAlgn="ctr">
+              <a:buNone/>
+            </a:pPr>
+            <a:r>
+              <a:rPr lang="de-DE" dirty="0"/>
+              <a:t>Miró 		Freya				Felix			Niklas</a:t>
+            </a:r>
+          </a:p>
+          <a:p>
+            <a:pPr marL="0" indent="0" fontAlgn="ctr">
+              <a:buNone/>
+            </a:pPr>
+            <a:r>
+              <a:rPr lang="de-DE" dirty="0"/>
+              <a:t>Jonathan 	Josefine			</a:t>
+            </a:r>
+            <a:r>
+              <a:rPr lang="de-DE" dirty="0" err="1"/>
+              <a:t>Lennas</a:t>
+            </a:r>
+            <a:r>
+              <a:rPr lang="de-DE" dirty="0"/>
+              <a:t>		Nils</a:t>
+            </a:r>
+          </a:p>
+          <a:p>
+            <a:pPr marL="0" indent="0" fontAlgn="ctr">
+              <a:buNone/>
+            </a:pPr>
+            <a:endParaRPr lang="de-DE" dirty="0"/>
+          </a:p>
+          <a:p>
+            <a:pPr marL="0" indent="0" fontAlgn="ctr">
+              <a:buNone/>
+            </a:pPr>
+            <a:r>
+              <a:rPr lang="de-DE" dirty="0"/>
+              <a:t>Louis		Bruno				Fabio			Robin</a:t>
+            </a:r>
+          </a:p>
+          <a:p>
+            <a:pPr marL="0" indent="0" fontAlgn="ctr">
+              <a:buNone/>
+            </a:pPr>
+            <a:r>
+              <a:rPr lang="de-DE" dirty="0"/>
+              <a:t>Arthur 	Andreas			Jakob		 	Paul</a:t>
+            </a:r>
+          </a:p>
+        </p:txBody>
+      </p:sp>
+    </p:spTree>
+    <p:extLst>
+      <p:ext uri="{BB962C8B-B14F-4D97-AF65-F5344CB8AC3E}">
+        <p14:creationId xmlns:p14="http://schemas.microsoft.com/office/powerpoint/2010/main" val="3335560466"/>
+      </p:ext>
+    </p:extLst>
+  </p:cSld>
+  <p:clrMapOvr>
+    <a:masterClrMapping/>
+  </p:clrMapOvr>
+</p:sld>
+</file>
+
+<file path=ppt/slides/slide3.xml><?xml version="1.0" encoding="utf-8"?>
+<p:sld xmlns:a="http://schemas.openxmlformats.org/drawingml/2006/main" xmlns:r="http://schemas.openxmlformats.org/officeDocument/2006/relationships" xmlns:p="http://schemas.openxmlformats.org/presentationml/2006/main">
+  <p:cSld>
+    <p:spTree>
+      <p:nvGrpSpPr>
+        <p:cNvPr id="1" name=""/>
+        <p:cNvGrpSpPr/>
+        <p:nvPr/>
+      </p:nvGrpSpPr>
+      <p:grpSpPr>
+        <a:xfrm>
+          <a:off x="0" y="0"/>
+          <a:ext cx="0" cy="0"/>
+          <a:chOff x="0" y="0"/>
+          <a:chExt cx="0" cy="0"/>
+        </a:xfrm>
+      </p:grpSpPr>
+      <p:pic>
+        <p:nvPicPr>
+          <p:cNvPr id="10" name="Grafik 9" descr="Ein Bild, das Text, Papier, Brief, Origami enthält.&#10;&#10;KI-generierte Inhalte können fehlerhaft sein.">
+            <a:extLst>
+              <a:ext uri="{FF2B5EF4-FFF2-40B4-BE49-F238E27FC236}">
+                <a16:creationId xmlns:a16="http://schemas.microsoft.com/office/drawing/2014/main" id="{A4BE09B9-6415-6507-A377-A5DAD30E29A1}"/>
+              </a:ext>
+            </a:extLst>
+          </p:cNvPr>
+          <p:cNvPicPr>
+            <a:picLocks noChangeAspect="1"/>
+          </p:cNvPicPr>
+          <p:nvPr/>
+        </p:nvPicPr>
+        <p:blipFill>
+          <a:blip r:embed="rId3"/>
+          <a:srcRect b="28743"/>
+          <a:stretch>
+            <a:fillRect/>
+          </a:stretch>
+        </p:blipFill>
+        <p:spPr>
+          <a:xfrm>
+            <a:off x="0" y="468441"/>
+            <a:ext cx="5924918" cy="5448926"/>
+          </a:xfrm>
+          <a:prstGeom prst="rect">
+            <a:avLst/>
+          </a:prstGeom>
+        </p:spPr>
+      </p:pic>
+      <p:pic>
+        <p:nvPicPr>
+          <p:cNvPr id="12" name="Grafik 11" descr="Ein Bild, das Text, Schrift, Reihe, Diagramm enthält.&#10;&#10;KI-generierte Inhalte können fehlerhaft sein.">
+            <a:extLst>
+              <a:ext uri="{FF2B5EF4-FFF2-40B4-BE49-F238E27FC236}">
+                <a16:creationId xmlns:a16="http://schemas.microsoft.com/office/drawing/2014/main" id="{E2B21C04-4E69-2ACA-5B47-6F85E6498F34}"/>
+              </a:ext>
+            </a:extLst>
+          </p:cNvPr>
+          <p:cNvPicPr>
+            <a:picLocks noChangeAspect="1"/>
+          </p:cNvPicPr>
+          <p:nvPr/>
+        </p:nvPicPr>
+        <p:blipFill>
+          <a:blip r:embed="rId4"/>
+          <a:stretch>
+            <a:fillRect/>
+          </a:stretch>
+        </p:blipFill>
+        <p:spPr>
+          <a:xfrm>
+            <a:off x="6096000" y="3762532"/>
+            <a:ext cx="6048117" cy="1244184"/>
+          </a:xfrm>
+          <a:prstGeom prst="rect">
+            <a:avLst/>
+          </a:prstGeom>
+        </p:spPr>
+      </p:pic>
+      <p:pic>
+        <p:nvPicPr>
+          <p:cNvPr id="15" name="Grafik 14" descr="Ein Bild, das Text, Papier, Brief, Origami enthält.&#10;&#10;KI-generierte Inhalte können fehlerhaft sein.">
+            <a:extLst>
+              <a:ext uri="{FF2B5EF4-FFF2-40B4-BE49-F238E27FC236}">
+                <a16:creationId xmlns:a16="http://schemas.microsoft.com/office/drawing/2014/main" id="{721158B0-DCA0-18E3-E2BB-A2D9AF0126FD}"/>
+              </a:ext>
+            </a:extLst>
+          </p:cNvPr>
+          <p:cNvPicPr>
+            <a:picLocks noChangeAspect="1"/>
+          </p:cNvPicPr>
+          <p:nvPr/>
+        </p:nvPicPr>
+        <p:blipFill>
+          <a:blip r:embed="rId3"/>
+          <a:srcRect t="71257"/>
+          <a:stretch>
+            <a:fillRect/>
+          </a:stretch>
+        </p:blipFill>
+        <p:spPr>
+          <a:xfrm>
+            <a:off x="6096000" y="1499016"/>
+            <a:ext cx="6101642" cy="2263516"/>
+          </a:xfrm>
+          <a:prstGeom prst="rect">
+            <a:avLst/>
+          </a:prstGeom>
+        </p:spPr>
+      </p:pic>
+    </p:spTree>
+    <p:extLst>
+      <p:ext uri="{BB962C8B-B14F-4D97-AF65-F5344CB8AC3E}">
+        <p14:creationId xmlns:p14="http://schemas.microsoft.com/office/powerpoint/2010/main" val="330369928"/>
+      </p:ext>
+    </p:extLst>
+  </p:cSld>
+  <p:clrMapOvr>
+    <a:masterClrMapping/>
+  </p:clrMapOvr>
+</p:sld>
+</file>
+
+<file path=ppt/slides/slide4.xml><?xml version="1.0" encoding="utf-8"?>
+<p:sld xmlns:a="http://schemas.openxmlformats.org/drawingml/2006/main" xmlns:r="http://schemas.openxmlformats.org/officeDocument/2006/relationships" xmlns:p="http://schemas.openxmlformats.org/presentationml/2006/main">
+  <p:cSld>
+    <p:spTree>
+      <p:nvGrpSpPr>
+        <p:cNvPr id="1" name=""/>
+        <p:cNvGrpSpPr/>
+        <p:nvPr/>
+      </p:nvGrpSpPr>
+      <p:grpSpPr>
+        <a:xfrm>
+          <a:off x="0" y="0"/>
+          <a:ext cx="0" cy="0"/>
+          <a:chOff x="0" y="0"/>
+          <a:chExt cx="0" cy="0"/>
+        </a:xfrm>
+      </p:grpSpPr>
+      <p:pic>
+        <p:nvPicPr>
+          <p:cNvPr id="2" name="Grafik 1" descr="Ein Bild, das Text, Screenshot, Schrift, Brief enthält.&#10;&#10;KI-generierte Inhalte können fehlerhaft sein.">
+            <a:extLst>
+              <a:ext uri="{FF2B5EF4-FFF2-40B4-BE49-F238E27FC236}">
+                <a16:creationId xmlns:a16="http://schemas.microsoft.com/office/drawing/2014/main" id="{1530B3CA-E079-015A-6244-3B16165C6FD6}"/>
+              </a:ext>
+            </a:extLst>
+          </p:cNvPr>
+          <p:cNvPicPr>
+            <a:picLocks noChangeAspect="1"/>
+          </p:cNvPicPr>
+          <p:nvPr/>
+        </p:nvPicPr>
+        <p:blipFill>
+          <a:blip r:embed="rId2"/>
+          <a:stretch>
+            <a:fillRect/>
+          </a:stretch>
+        </p:blipFill>
+        <p:spPr>
+          <a:xfrm>
+            <a:off x="3267856" y="-1863"/>
+            <a:ext cx="5666282" cy="6873850"/>
+          </a:xfrm>
+          <a:prstGeom prst="rect">
+            <a:avLst/>
+          </a:prstGeom>
+        </p:spPr>
+      </p:pic>
+    </p:spTree>
+    <p:extLst>
+      <p:ext uri="{BB962C8B-B14F-4D97-AF65-F5344CB8AC3E}">
+        <p14:creationId xmlns:p14="http://schemas.microsoft.com/office/powerpoint/2010/main" val="3079377886"/>
+      </p:ext>
+    </p:extLst>
+  </p:cSld>
+  <p:clrMapOvr>
+    <a:masterClrMapping/>
+  </p:clrMapOvr>
+</p:sld>
+</file>
+
+<file path=ppt/slides/slide5.xml><?xml version="1.0" encoding="utf-8"?>
+<p:sld xmlns:a="http://schemas.openxmlformats.org/drawingml/2006/main" xmlns:r="http://schemas.openxmlformats.org/officeDocument/2006/relationships" xmlns:p="http://schemas.openxmlformats.org/presentationml/2006/main">
+  <p:cSld>
+    <p:spTree>
+      <p:nvGrpSpPr>
+        <p:cNvPr id="1" name=""/>
+        <p:cNvGrpSpPr/>
+        <p:nvPr/>
+      </p:nvGrpSpPr>
+      <p:grpSpPr>
+        <a:xfrm>
+          <a:off x="0" y="0"/>
+          <a:ext cx="0" cy="0"/>
+          <a:chOff x="0" y="0"/>
+          <a:chExt cx="0" cy="0"/>
+        </a:xfrm>
+      </p:grpSpPr>
+      <p:pic>
+        <p:nvPicPr>
+          <p:cNvPr id="11" name="Grafik 10" descr="Ein Bild, das Text, Schrift, Reihe, Origami enthält.&#10;&#10;KI-generierte Inhalte können fehlerhaft sein.">
+            <a:extLst>
+              <a:ext uri="{FF2B5EF4-FFF2-40B4-BE49-F238E27FC236}">
+                <a16:creationId xmlns:a16="http://schemas.microsoft.com/office/drawing/2014/main" id="{B861861D-BCA9-26B9-DCB6-C80CD54D52C4}"/>
+              </a:ext>
+            </a:extLst>
+          </p:cNvPr>
+          <p:cNvPicPr>
+            <a:picLocks noChangeAspect="1"/>
+          </p:cNvPicPr>
+          <p:nvPr/>
+        </p:nvPicPr>
+        <p:blipFill>
+          <a:blip r:embed="rId2"/>
+          <a:stretch>
+            <a:fillRect/>
+          </a:stretch>
+        </p:blipFill>
+        <p:spPr>
+          <a:xfrm>
+            <a:off x="432098" y="4218535"/>
+            <a:ext cx="7970721" cy="2298305"/>
+          </a:xfrm>
+          <a:prstGeom prst="rect">
+            <a:avLst/>
+          </a:prstGeom>
+        </p:spPr>
+      </p:pic>
+      <p:sp>
+        <p:nvSpPr>
+          <p:cNvPr id="3" name="Titel 1">
+            <a:extLst>
+              <a:ext uri="{FF2B5EF4-FFF2-40B4-BE49-F238E27FC236}">
+                <a16:creationId xmlns:a16="http://schemas.microsoft.com/office/drawing/2014/main" id="{BA140C9D-1408-E733-FF1E-44847D93BFFB}"/>
+              </a:ext>
+            </a:extLst>
+          </p:cNvPr>
+          <p:cNvSpPr txBox="1">
+            <a:spLocks/>
+          </p:cNvSpPr>
+          <p:nvPr/>
+        </p:nvSpPr>
+        <p:spPr>
+          <a:xfrm>
+            <a:off x="211736" y="141622"/>
             <a:ext cx="11768528" cy="549275"/>
           </a:xfrm>
           <a:prstGeom prst="rect">
@@ -4462,17 +4970,17 @@
                 <a:ea typeface="ADLaM Display" panose="02010000000000000000" pitchFamily="2" charset="77"/>
                 <a:cs typeface="ADLaM Display" panose="02010000000000000000" pitchFamily="2" charset="77"/>
               </a:rPr>
-              <a:t>Wiederholung: Zirkel &amp; Punkspiegelung</a:t>
-            </a:r>
-          </a:p>
-        </p:txBody>
-      </p:sp>
-      <p:sp>
-        <p:nvSpPr>
-          <p:cNvPr id="2" name="Inhaltsplatzhalter 2">
-            <a:extLst>
-              <a:ext uri="{FF2B5EF4-FFF2-40B4-BE49-F238E27FC236}">
-                <a16:creationId xmlns:a16="http://schemas.microsoft.com/office/drawing/2014/main" id="{42FC0499-C856-06B5-5E9F-6DB0ABE3E14F}"/>
+              <a:t>Wiederholung: Achsenspiegelung</a:t>
+            </a:r>
+          </a:p>
+        </p:txBody>
+      </p:sp>
+      <p:sp>
+        <p:nvSpPr>
+          <p:cNvPr id="8" name="Inhaltsplatzhalter 2">
+            <a:extLst>
+              <a:ext uri="{FF2B5EF4-FFF2-40B4-BE49-F238E27FC236}">
+                <a16:creationId xmlns:a16="http://schemas.microsoft.com/office/drawing/2014/main" id="{D1B812B5-42BF-7EF8-4EF2-953E9E589C6F}"/>
               </a:ext>
             </a:extLst>
           </p:cNvPr>
@@ -4483,8 +4991,8 @@
         </p:nvSpPr>
         <p:spPr>
           <a:xfrm>
-            <a:off x="193623" y="5078627"/>
-            <a:ext cx="11768528" cy="1534168"/>
+            <a:off x="432098" y="919579"/>
+            <a:ext cx="11327804" cy="2600862"/>
           </a:xfrm>
           <a:prstGeom prst="rect">
             <a:avLst/>
@@ -4657,42 +5165,330 @@
             </a:lvl9pPr>
           </a:lstStyle>
           <a:p>
-            <a:pPr marL="0" indent="0">
+            <a:pPr marL="0" indent="0" algn="just">
               <a:buNone/>
             </a:pPr>
             <a:r>
-              <a:rPr lang="de-DE" b="1" dirty="0"/>
-              <a:t>HA</a:t>
-            </a:r>
-            <a:r>
-              <a:rPr lang="de-DE" dirty="0"/>
-              <a:t> - Arbeitsheft</a:t>
-            </a:r>
-          </a:p>
-          <a:p>
-            <a:r>
-              <a:rPr lang="de-DE" dirty="0"/>
-              <a:t>S. 31 – Zirkel				-- WDH</a:t>
-            </a:r>
-          </a:p>
-          <a:p>
-            <a:r>
-              <a:rPr lang="de-DE" dirty="0"/>
-              <a:t>S. 32 – Punktspiegelung		-- WDH</a:t>
-            </a:r>
-          </a:p>
-          <a:p>
-            <a:pPr marL="0" indent="0">
+              <a:rPr lang="de-DE" sz="2000" b="1" dirty="0"/>
+              <a:t>Aufgabe 1</a:t>
+            </a:r>
+          </a:p>
+          <a:p>
+            <a:pPr marL="0" indent="0" algn="just">
               <a:buNone/>
             </a:pPr>
-            <a:endParaRPr lang="de-DE" dirty="0"/>
+            <a:r>
+              <a:rPr lang="de-DE" sz="2000" dirty="0"/>
+              <a:t>Zeichne das Dreieck ABC mit den Eckpunkten A(2/3), B(8,5/1) und C(5/4) sowie die Gerade CD durch die Punkte C und D(3/0). Spiegele dann das Dreieck ABC an der Geraden CD.</a:t>
+            </a:r>
+          </a:p>
+          <a:p>
+            <a:pPr marL="0" indent="0" algn="just">
+              <a:buNone/>
+            </a:pPr>
+            <a:r>
+              <a:rPr lang="de-DE" sz="2000" b="1" dirty="0"/>
+              <a:t>Aufgabe 2</a:t>
+            </a:r>
+          </a:p>
+          <a:p>
+            <a:pPr marL="0" indent="0" algn="just">
+              <a:buNone/>
+            </a:pPr>
+            <a:r>
+              <a:rPr lang="de-DE" sz="2000" dirty="0"/>
+              <a:t>Schreibe einen Text der folgende Begriffe beinhaltet:</a:t>
+            </a:r>
+          </a:p>
+          <a:p>
+            <a:pPr marL="0" indent="0" algn="just">
+              <a:buNone/>
+            </a:pPr>
+            <a:r>
+              <a:rPr lang="de-DE" sz="1800" dirty="0">
+                <a:solidFill>
+                  <a:schemeClr val="tx2">
+                    <a:lumMod val="75000"/>
+                    <a:lumOff val="25000"/>
+                  </a:schemeClr>
+                </a:solidFill>
+                <a:latin typeface="Cavolini" panose="03000502040302020204" pitchFamily="66" charset="0"/>
+                <a:ea typeface="ADLaM Display" panose="02010000000000000000" pitchFamily="2" charset="77"/>
+                <a:cs typeface="Cavolini" panose="03000502040302020204" pitchFamily="66" charset="0"/>
+              </a:rPr>
+              <a:t>Originalpunkt, Spiegelachse, parallel, Abstand, Bildpunkt, P, verschiedene Seiten, denselben, P‘, Fixpunkt, Achsenspiegelung, Mittellinie, Geodreieck</a:t>
+            </a:r>
+          </a:p>
+          <a:p>
+            <a:pPr marL="0" indent="0" algn="just">
+              <a:buNone/>
+            </a:pPr>
+            <a:r>
+              <a:rPr lang="de-DE" sz="1800" b="1" dirty="0"/>
+              <a:t>Aufgabe 3</a:t>
+            </a:r>
+          </a:p>
+          <a:p>
+            <a:pPr marL="0" indent="0" algn="just">
+              <a:buNone/>
+            </a:pPr>
+            <a:r>
+              <a:rPr lang="de-DE" sz="1800" dirty="0"/>
+              <a:t>Schreibe in dein Heft. Fülle die 5 Lücken!</a:t>
+            </a:r>
+          </a:p>
+          <a:p>
+            <a:pPr marL="0" indent="0" algn="just">
+              <a:buNone/>
+            </a:pPr>
+            <a:endParaRPr lang="de-DE" sz="1800" dirty="0">
+              <a:solidFill>
+                <a:schemeClr val="tx2">
+                  <a:lumMod val="75000"/>
+                  <a:lumOff val="25000"/>
+                </a:schemeClr>
+              </a:solidFill>
+              <a:latin typeface="Cavolini" panose="03000502040302020204" pitchFamily="66" charset="0"/>
+              <a:ea typeface="ADLaM Display" panose="02010000000000000000" pitchFamily="2" charset="77"/>
+              <a:cs typeface="Cavolini" panose="03000502040302020204" pitchFamily="66" charset="0"/>
+            </a:endParaRPr>
+          </a:p>
+        </p:txBody>
+      </p:sp>
+      <p:sp>
+        <p:nvSpPr>
+          <p:cNvPr id="4" name="Abgerundetes Rechteck 3">
+            <a:extLst>
+              <a:ext uri="{FF2B5EF4-FFF2-40B4-BE49-F238E27FC236}">
+                <a16:creationId xmlns:a16="http://schemas.microsoft.com/office/drawing/2014/main" id="{B6DCCC7E-20F0-289F-2793-F4B96F42B2A8}"/>
+              </a:ext>
+            </a:extLst>
+          </p:cNvPr>
+          <p:cNvSpPr/>
+          <p:nvPr/>
+        </p:nvSpPr>
+        <p:spPr>
+          <a:xfrm>
+            <a:off x="2649291" y="4733105"/>
+            <a:ext cx="1154613" cy="227915"/>
+          </a:xfrm>
+          <a:prstGeom prst="roundRect">
+            <a:avLst/>
+          </a:prstGeom>
+        </p:spPr>
+        <p:style>
+          <a:lnRef idx="2">
+            <a:schemeClr val="accent4">
+              <a:shade val="15000"/>
+            </a:schemeClr>
+          </a:lnRef>
+          <a:fillRef idx="1">
+            <a:schemeClr val="accent4"/>
+          </a:fillRef>
+          <a:effectRef idx="0">
+            <a:schemeClr val="accent4"/>
+          </a:effectRef>
+          <a:fontRef idx="minor">
+            <a:schemeClr val="lt1"/>
+          </a:fontRef>
+        </p:style>
+        <p:txBody>
+          <a:bodyPr rtlCol="0" anchor="ctr"/>
+          <a:lstStyle/>
+          <a:p>
+            <a:pPr algn="ctr"/>
+            <a:endParaRPr lang="de-DE" sz="1400"/>
+          </a:p>
+        </p:txBody>
+      </p:sp>
+      <p:sp>
+        <p:nvSpPr>
+          <p:cNvPr id="5" name="Abgerundetes Rechteck 4">
+            <a:extLst>
+              <a:ext uri="{FF2B5EF4-FFF2-40B4-BE49-F238E27FC236}">
+                <a16:creationId xmlns:a16="http://schemas.microsoft.com/office/drawing/2014/main" id="{7AD7AD1C-F1E6-B229-1865-3325B3626DB3}"/>
+              </a:ext>
+            </a:extLst>
+          </p:cNvPr>
+          <p:cNvSpPr/>
+          <p:nvPr/>
+        </p:nvSpPr>
+        <p:spPr>
+          <a:xfrm>
+            <a:off x="3278868" y="5229409"/>
+            <a:ext cx="899572" cy="253285"/>
+          </a:xfrm>
+          <a:prstGeom prst="roundRect">
+            <a:avLst/>
+          </a:prstGeom>
+        </p:spPr>
+        <p:style>
+          <a:lnRef idx="2">
+            <a:schemeClr val="accent4">
+              <a:shade val="15000"/>
+            </a:schemeClr>
+          </a:lnRef>
+          <a:fillRef idx="1">
+            <a:schemeClr val="accent4"/>
+          </a:fillRef>
+          <a:effectRef idx="0">
+            <a:schemeClr val="accent4"/>
+          </a:effectRef>
+          <a:fontRef idx="minor">
+            <a:schemeClr val="lt1"/>
+          </a:fontRef>
+        </p:style>
+        <p:txBody>
+          <a:bodyPr rtlCol="0" anchor="ctr"/>
+          <a:lstStyle/>
+          <a:p>
+            <a:pPr algn="ctr"/>
+            <a:endParaRPr lang="de-DE" sz="1400"/>
+          </a:p>
+        </p:txBody>
+      </p:sp>
+      <p:sp>
+        <p:nvSpPr>
+          <p:cNvPr id="7" name="Abgerundetes Rechteck 6">
+            <a:extLst>
+              <a:ext uri="{FF2B5EF4-FFF2-40B4-BE49-F238E27FC236}">
+                <a16:creationId xmlns:a16="http://schemas.microsoft.com/office/drawing/2014/main" id="{835BEB63-3444-7293-A9BA-C749865B0DEE}"/>
+              </a:ext>
+            </a:extLst>
+          </p:cNvPr>
+          <p:cNvSpPr/>
+          <p:nvPr/>
+        </p:nvSpPr>
+        <p:spPr>
+          <a:xfrm>
+            <a:off x="1962500" y="5482694"/>
+            <a:ext cx="899572" cy="204874"/>
+          </a:xfrm>
+          <a:prstGeom prst="roundRect">
+            <a:avLst/>
+          </a:prstGeom>
+        </p:spPr>
+        <p:style>
+          <a:lnRef idx="2">
+            <a:schemeClr val="accent4">
+              <a:shade val="15000"/>
+            </a:schemeClr>
+          </a:lnRef>
+          <a:fillRef idx="1">
+            <a:schemeClr val="accent4"/>
+          </a:fillRef>
+          <a:effectRef idx="0">
+            <a:schemeClr val="accent4"/>
+          </a:effectRef>
+          <a:fontRef idx="minor">
+            <a:schemeClr val="lt1"/>
+          </a:fontRef>
+        </p:style>
+        <p:txBody>
+          <a:bodyPr rtlCol="0" anchor="ctr"/>
+          <a:lstStyle/>
+          <a:p>
+            <a:pPr algn="ctr"/>
+            <a:endParaRPr lang="de-DE" sz="1400"/>
+          </a:p>
+        </p:txBody>
+      </p:sp>
+      <p:sp>
+        <p:nvSpPr>
+          <p:cNvPr id="9" name="Abgerundetes Rechteck 8">
+            <a:extLst>
+              <a:ext uri="{FF2B5EF4-FFF2-40B4-BE49-F238E27FC236}">
+                <a16:creationId xmlns:a16="http://schemas.microsoft.com/office/drawing/2014/main" id="{105D1C43-F261-11EF-566C-98049B5E033E}"/>
+              </a:ext>
+            </a:extLst>
+          </p:cNvPr>
+          <p:cNvSpPr/>
+          <p:nvPr/>
+        </p:nvSpPr>
+        <p:spPr>
+          <a:xfrm>
+            <a:off x="7750459" y="4466088"/>
+            <a:ext cx="471766" cy="267017"/>
+          </a:xfrm>
+          <a:prstGeom prst="roundRect">
+            <a:avLst/>
+          </a:prstGeom>
+        </p:spPr>
+        <p:style>
+          <a:lnRef idx="2">
+            <a:schemeClr val="accent4">
+              <a:shade val="15000"/>
+            </a:schemeClr>
+          </a:lnRef>
+          <a:fillRef idx="1">
+            <a:schemeClr val="accent4"/>
+          </a:fillRef>
+          <a:effectRef idx="0">
+            <a:schemeClr val="accent4"/>
+          </a:effectRef>
+          <a:fontRef idx="minor">
+            <a:schemeClr val="lt1"/>
+          </a:fontRef>
+        </p:style>
+        <p:txBody>
+          <a:bodyPr rtlCol="0" anchor="ctr"/>
+          <a:lstStyle/>
+          <a:p>
+            <a:pPr algn="ctr"/>
+            <a:endParaRPr lang="de-DE" sz="1400"/>
+          </a:p>
+        </p:txBody>
+      </p:sp>
+      <p:sp>
+        <p:nvSpPr>
+          <p:cNvPr id="10" name="Abgerundetes Rechteck 9">
+            <a:extLst>
+              <a:ext uri="{FF2B5EF4-FFF2-40B4-BE49-F238E27FC236}">
+                <a16:creationId xmlns:a16="http://schemas.microsoft.com/office/drawing/2014/main" id="{43E74064-7903-448D-E415-AB4B6B6BA2B5}"/>
+              </a:ext>
+            </a:extLst>
+          </p:cNvPr>
+          <p:cNvSpPr/>
+          <p:nvPr/>
+        </p:nvSpPr>
+        <p:spPr>
+          <a:xfrm>
+            <a:off x="6727027" y="5847717"/>
+            <a:ext cx="249846" cy="273354"/>
+          </a:xfrm>
+          <a:prstGeom prst="roundRect">
+            <a:avLst/>
+          </a:prstGeom>
+        </p:spPr>
+        <p:style>
+          <a:lnRef idx="2">
+            <a:schemeClr val="accent4">
+              <a:shade val="15000"/>
+            </a:schemeClr>
+          </a:lnRef>
+          <a:fillRef idx="1">
+            <a:schemeClr val="accent4"/>
+          </a:fillRef>
+          <a:effectRef idx="0">
+            <a:schemeClr val="accent4"/>
+          </a:effectRef>
+          <a:fontRef idx="minor">
+            <a:schemeClr val="lt1"/>
+          </a:fontRef>
+        </p:style>
+        <p:txBody>
+          <a:bodyPr rtlCol="0" anchor="ctr"/>
+          <a:lstStyle/>
+          <a:p>
+            <a:pPr algn="ctr"/>
+            <a:endParaRPr lang="de-DE" sz="1400"/>
           </a:p>
         </p:txBody>
       </p:sp>
     </p:spTree>
     <p:extLst>
       <p:ext uri="{BB962C8B-B14F-4D97-AF65-F5344CB8AC3E}">
-        <p14:creationId xmlns:p14="http://schemas.microsoft.com/office/powerpoint/2010/main" val="3519360287"/>
+        <p14:creationId xmlns:p14="http://schemas.microsoft.com/office/powerpoint/2010/main" val="3178181211"/>
       </p:ext>
     </p:extLst>
   </p:cSld>
@@ -4702,7 +5498,7 @@
 </p:sld>
 </file>
 
-<file path=ppt/slides/slide12.xml><?xml version="1.0" encoding="utf-8"?>
+<file path=ppt/slides/slide6.xml><?xml version="1.0" encoding="utf-8"?>
 <p:sld xmlns:a="http://schemas.openxmlformats.org/drawingml/2006/main" xmlns:r="http://schemas.openxmlformats.org/officeDocument/2006/relationships" xmlns:p="http://schemas.openxmlformats.org/presentationml/2006/main">
   <p:cSld>
     <p:spTree>
@@ -4710,7 +5506,7 @@
         <p:cNvPr id="1" name="">
           <a:extLst>
             <a:ext uri="{FF2B5EF4-FFF2-40B4-BE49-F238E27FC236}">
-              <a16:creationId xmlns:a16="http://schemas.microsoft.com/office/drawing/2014/main" id="{9222C1B5-FD3F-140B-0240-6286CB108925}"/>
+              <a16:creationId xmlns:a16="http://schemas.microsoft.com/office/drawing/2014/main" id="{8D19743F-1585-79F3-1290-17ED8D6958FC}"/>
             </a:ext>
           </a:extLst>
         </p:cNvPr>
@@ -4730,7 +5526,7 @@
           <p:cNvPr id="3" name="Titel 1">
             <a:extLst>
               <a:ext uri="{FF2B5EF4-FFF2-40B4-BE49-F238E27FC236}">
-                <a16:creationId xmlns:a16="http://schemas.microsoft.com/office/drawing/2014/main" id="{9EC30369-1B87-EE63-02B2-F5EE2C8932EA}"/>
+                <a16:creationId xmlns:a16="http://schemas.microsoft.com/office/drawing/2014/main" id="{DD2BFBEF-8E72-C63A-15AB-AD1B850F0F62}"/>
               </a:ext>
             </a:extLst>
           </p:cNvPr>
@@ -4741,7 +5537,7 @@
         </p:nvSpPr>
         <p:spPr>
           <a:xfrm>
-            <a:off x="193623" y="425086"/>
+            <a:off x="211736" y="141622"/>
             <a:ext cx="11768528" cy="549275"/>
           </a:xfrm>
           <a:prstGeom prst="rect">
@@ -4779,17 +5575,17 @@
                 <a:ea typeface="ADLaM Display" panose="02010000000000000000" pitchFamily="2" charset="77"/>
                 <a:cs typeface="ADLaM Display" panose="02010000000000000000" pitchFamily="2" charset="77"/>
               </a:rPr>
-              <a:t>Grundbegriffe</a:t>
-            </a:r>
-          </a:p>
-        </p:txBody>
-      </p:sp>
-      <p:sp>
-        <p:nvSpPr>
-          <p:cNvPr id="2" name="Inhaltsplatzhalter 2">
-            <a:extLst>
-              <a:ext uri="{FF2B5EF4-FFF2-40B4-BE49-F238E27FC236}">
-                <a16:creationId xmlns:a16="http://schemas.microsoft.com/office/drawing/2014/main" id="{28678534-CDB9-14A7-825C-F99236BE0A48}"/>
+              <a:t>Wiederholung: Achsenspiegelung</a:t>
+            </a:r>
+          </a:p>
+        </p:txBody>
+      </p:sp>
+      <p:sp>
+        <p:nvSpPr>
+          <p:cNvPr id="12" name="Inhaltsplatzhalter 2">
+            <a:extLst>
+              <a:ext uri="{FF2B5EF4-FFF2-40B4-BE49-F238E27FC236}">
+                <a16:creationId xmlns:a16="http://schemas.microsoft.com/office/drawing/2014/main" id="{1780EC57-1D70-8A7C-72FB-802D33F64CB9}"/>
               </a:ext>
             </a:extLst>
           </p:cNvPr>
@@ -4800,8 +5596,8 @@
         </p:nvSpPr>
         <p:spPr>
           <a:xfrm>
-            <a:off x="193623" y="5577840"/>
-            <a:ext cx="11768528" cy="1034955"/>
+            <a:off x="186090" y="778049"/>
+            <a:ext cx="11327804" cy="5356525"/>
           </a:xfrm>
           <a:prstGeom prst="rect">
             <a:avLst/>
@@ -4974,30 +5770,614 @@
             </a:lvl9pPr>
           </a:lstStyle>
           <a:p>
-            <a:pPr marL="0" indent="0">
+            <a:pPr marL="0" indent="0" algn="just">
               <a:buNone/>
             </a:pPr>
             <a:r>
-              <a:rPr lang="de-DE" b="1" dirty="0"/>
-              <a:t>HA - </a:t>
-            </a:r>
-            <a:r>
-              <a:rPr lang="de-DE" dirty="0"/>
-              <a:t>Arbeitsheft </a:t>
-            </a:r>
-          </a:p>
-          <a:p>
-            <a:r>
-              <a:rPr lang="de-DE" dirty="0"/>
-              <a:t>S. 33 bis 37 - Doppelspiegelung</a:t>
-            </a:r>
-          </a:p>
-        </p:txBody>
-      </p:sp>
+              <a:rPr lang="de-DE" sz="2000" b="1" dirty="0"/>
+              <a:t>Aufgabe 4</a:t>
+            </a:r>
+          </a:p>
+          <a:p>
+            <a:pPr marL="0" indent="0" algn="just">
+              <a:buNone/>
+            </a:pPr>
+            <a:r>
+              <a:rPr lang="de-DE" sz="2000" dirty="0"/>
+              <a:t>Schreibe in dein Heft. Fülle die 7 Lücken!</a:t>
+            </a:r>
+          </a:p>
+          <a:p>
+            <a:pPr marL="0" indent="0" algn="just">
+              <a:buNone/>
+            </a:pPr>
+            <a:endParaRPr lang="de-DE" sz="2000" dirty="0"/>
+          </a:p>
+          <a:p>
+            <a:pPr marL="0" indent="0" algn="just">
+              <a:buNone/>
+            </a:pPr>
+            <a:endParaRPr lang="de-DE" sz="2000" dirty="0"/>
+          </a:p>
+          <a:p>
+            <a:pPr marL="0" indent="0" algn="just">
+              <a:buNone/>
+            </a:pPr>
+            <a:endParaRPr lang="de-DE" sz="2000" dirty="0"/>
+          </a:p>
+          <a:p>
+            <a:pPr marL="0" indent="0" algn="just">
+              <a:buNone/>
+            </a:pPr>
+            <a:endParaRPr lang="de-DE" sz="2000" dirty="0"/>
+          </a:p>
+          <a:p>
+            <a:pPr marL="0" indent="0" algn="just">
+              <a:buNone/>
+            </a:pPr>
+            <a:endParaRPr lang="de-DE" sz="2000" dirty="0"/>
+          </a:p>
+          <a:p>
+            <a:pPr marL="0" indent="0" algn="just">
+              <a:buNone/>
+            </a:pPr>
+            <a:endParaRPr lang="de-DE" sz="2000" dirty="0"/>
+          </a:p>
+          <a:p>
+            <a:pPr marL="0" indent="0" algn="just">
+              <a:buNone/>
+            </a:pPr>
+            <a:endParaRPr lang="de-DE" sz="2000" dirty="0"/>
+          </a:p>
+          <a:p>
+            <a:pPr marL="0" indent="0" algn="just">
+              <a:buNone/>
+            </a:pPr>
+            <a:endParaRPr lang="de-DE" sz="2000" dirty="0"/>
+          </a:p>
+          <a:p>
+            <a:pPr marL="0" indent="0" algn="just">
+              <a:buNone/>
+            </a:pPr>
+            <a:r>
+              <a:rPr lang="de-DE" sz="2000" b="1" dirty="0"/>
+              <a:t>Übungsaufgaben &amp; HA</a:t>
+            </a:r>
+          </a:p>
+          <a:p>
+            <a:pPr algn="just"/>
+            <a:r>
+              <a:rPr lang="de-DE" sz="2000" dirty="0"/>
+              <a:t>Buch S. 94, Nr. 9 bis 12</a:t>
+            </a:r>
+          </a:p>
+          <a:p>
+            <a:pPr algn="just"/>
+            <a:r>
+              <a:rPr lang="de-DE" sz="2000" dirty="0"/>
+              <a:t>Arbeitsheft S.29</a:t>
+            </a:r>
+          </a:p>
+          <a:p>
+            <a:pPr marL="0" indent="0" algn="just">
+              <a:buNone/>
+            </a:pPr>
+            <a:endParaRPr lang="de-DE" sz="2000" dirty="0"/>
+          </a:p>
+          <a:p>
+            <a:pPr marL="0" indent="0" algn="just">
+              <a:buNone/>
+            </a:pPr>
+            <a:endParaRPr lang="de-DE" sz="2000" dirty="0"/>
+          </a:p>
+        </p:txBody>
+      </p:sp>
+      <p:pic>
+        <p:nvPicPr>
+          <p:cNvPr id="13" name="Grafik 12" descr="Ein Bild, das Text, Screenshot, Schrift, Reihe enthält.&#10;&#10;KI-generierte Inhalte können fehlerhaft sein.">
+            <a:extLst>
+              <a:ext uri="{FF2B5EF4-FFF2-40B4-BE49-F238E27FC236}">
+                <a16:creationId xmlns:a16="http://schemas.microsoft.com/office/drawing/2014/main" id="{7116A367-2B22-F5BC-2861-BAC0839DB03C}"/>
+              </a:ext>
+            </a:extLst>
+          </p:cNvPr>
+          <p:cNvPicPr>
+            <a:picLocks noChangeAspect="1"/>
+          </p:cNvPicPr>
+          <p:nvPr/>
+        </p:nvPicPr>
+        <p:blipFill>
+          <a:blip r:embed="rId3"/>
+          <a:srcRect b="62363"/>
+          <a:stretch>
+            <a:fillRect/>
+          </a:stretch>
+        </p:blipFill>
+        <p:spPr>
+          <a:xfrm>
+            <a:off x="211736" y="1514700"/>
+            <a:ext cx="8811494" cy="1632294"/>
+          </a:xfrm>
+          <a:prstGeom prst="rect">
+            <a:avLst/>
+          </a:prstGeom>
+        </p:spPr>
+      </p:pic>
+      <p:sp>
+        <p:nvSpPr>
+          <p:cNvPr id="14" name="Abgerundetes Rechteck 13">
+            <a:extLst>
+              <a:ext uri="{FF2B5EF4-FFF2-40B4-BE49-F238E27FC236}">
+                <a16:creationId xmlns:a16="http://schemas.microsoft.com/office/drawing/2014/main" id="{755C27E3-4A05-0F1F-EA55-F5DEABF896B9}"/>
+              </a:ext>
+            </a:extLst>
+          </p:cNvPr>
+          <p:cNvSpPr/>
+          <p:nvPr/>
+        </p:nvSpPr>
+        <p:spPr>
+          <a:xfrm>
+            <a:off x="7448816" y="3310758"/>
+            <a:ext cx="978492" cy="327454"/>
+          </a:xfrm>
+          <a:prstGeom prst="roundRect">
+            <a:avLst/>
+          </a:prstGeom>
+        </p:spPr>
+        <p:style>
+          <a:lnRef idx="2">
+            <a:schemeClr val="accent4">
+              <a:shade val="15000"/>
+            </a:schemeClr>
+          </a:lnRef>
+          <a:fillRef idx="1">
+            <a:schemeClr val="accent4"/>
+          </a:fillRef>
+          <a:effectRef idx="0">
+            <a:schemeClr val="accent4"/>
+          </a:effectRef>
+          <a:fontRef idx="minor">
+            <a:schemeClr val="lt1"/>
+          </a:fontRef>
+        </p:style>
+        <p:txBody>
+          <a:bodyPr rtlCol="0" anchor="ctr"/>
+          <a:lstStyle/>
+          <a:p>
+            <a:pPr algn="ctr"/>
+            <a:endParaRPr lang="de-DE"/>
+          </a:p>
+        </p:txBody>
+      </p:sp>
+      <p:pic>
+        <p:nvPicPr>
+          <p:cNvPr id="15" name="Grafik 14" descr="Ein Bild, das Text, Screenshot, Schrift, Reihe enthält.&#10;&#10;KI-generierte Inhalte können fehlerhaft sein.">
+            <a:extLst>
+              <a:ext uri="{FF2B5EF4-FFF2-40B4-BE49-F238E27FC236}">
+                <a16:creationId xmlns:a16="http://schemas.microsoft.com/office/drawing/2014/main" id="{5A43414C-B395-59E0-BEDD-24CA4349213D}"/>
+              </a:ext>
+            </a:extLst>
+          </p:cNvPr>
+          <p:cNvPicPr>
+            <a:picLocks noChangeAspect="1"/>
+          </p:cNvPicPr>
+          <p:nvPr/>
+        </p:nvPicPr>
+        <p:blipFill>
+          <a:blip r:embed="rId3"/>
+          <a:srcRect t="62363"/>
+          <a:stretch>
+            <a:fillRect/>
+          </a:stretch>
+        </p:blipFill>
+        <p:spPr>
+          <a:xfrm>
+            <a:off x="362006" y="3138144"/>
+            <a:ext cx="8811493" cy="1632294"/>
+          </a:xfrm>
+          <a:prstGeom prst="rect">
+            <a:avLst/>
+          </a:prstGeom>
+        </p:spPr>
+      </p:pic>
+      <p:sp>
+        <p:nvSpPr>
+          <p:cNvPr id="16" name="Abgerundetes Rechteck 15">
+            <a:extLst>
+              <a:ext uri="{FF2B5EF4-FFF2-40B4-BE49-F238E27FC236}">
+                <a16:creationId xmlns:a16="http://schemas.microsoft.com/office/drawing/2014/main" id="{70341C1A-CB06-F378-6637-1B73E318EEE6}"/>
+              </a:ext>
+            </a:extLst>
+          </p:cNvPr>
+          <p:cNvSpPr/>
+          <p:nvPr/>
+        </p:nvSpPr>
+        <p:spPr>
+          <a:xfrm>
+            <a:off x="3160111" y="2259600"/>
+            <a:ext cx="963315" cy="190302"/>
+          </a:xfrm>
+          <a:prstGeom prst="roundRect">
+            <a:avLst/>
+          </a:prstGeom>
+        </p:spPr>
+        <p:style>
+          <a:lnRef idx="2">
+            <a:schemeClr val="accent4">
+              <a:shade val="15000"/>
+            </a:schemeClr>
+          </a:lnRef>
+          <a:fillRef idx="1">
+            <a:schemeClr val="accent4"/>
+          </a:fillRef>
+          <a:effectRef idx="0">
+            <a:schemeClr val="accent4"/>
+          </a:effectRef>
+          <a:fontRef idx="minor">
+            <a:schemeClr val="lt1"/>
+          </a:fontRef>
+        </p:style>
+        <p:txBody>
+          <a:bodyPr rtlCol="0" anchor="ctr"/>
+          <a:lstStyle/>
+          <a:p>
+            <a:pPr algn="ctr"/>
+            <a:endParaRPr lang="de-DE"/>
+          </a:p>
+        </p:txBody>
+      </p:sp>
+      <p:sp>
+        <p:nvSpPr>
+          <p:cNvPr id="17" name="Abgerundetes Rechteck 16">
+            <a:extLst>
+              <a:ext uri="{FF2B5EF4-FFF2-40B4-BE49-F238E27FC236}">
+                <a16:creationId xmlns:a16="http://schemas.microsoft.com/office/drawing/2014/main" id="{8C345699-248A-C645-9948-E4F33AED3479}"/>
+              </a:ext>
+            </a:extLst>
+          </p:cNvPr>
+          <p:cNvSpPr/>
+          <p:nvPr/>
+        </p:nvSpPr>
+        <p:spPr>
+          <a:xfrm>
+            <a:off x="678106" y="2713408"/>
+            <a:ext cx="745252" cy="234485"/>
+          </a:xfrm>
+          <a:prstGeom prst="roundRect">
+            <a:avLst/>
+          </a:prstGeom>
+        </p:spPr>
+        <p:style>
+          <a:lnRef idx="2">
+            <a:schemeClr val="accent4">
+              <a:shade val="15000"/>
+            </a:schemeClr>
+          </a:lnRef>
+          <a:fillRef idx="1">
+            <a:schemeClr val="accent4"/>
+          </a:fillRef>
+          <a:effectRef idx="0">
+            <a:schemeClr val="accent4"/>
+          </a:effectRef>
+          <a:fontRef idx="minor">
+            <a:schemeClr val="lt1"/>
+          </a:fontRef>
+        </p:style>
+        <p:txBody>
+          <a:bodyPr rtlCol="0" anchor="ctr"/>
+          <a:lstStyle/>
+          <a:p>
+            <a:pPr algn="ctr"/>
+            <a:endParaRPr lang="de-DE"/>
+          </a:p>
+        </p:txBody>
+      </p:sp>
+      <p:sp>
+        <p:nvSpPr>
+          <p:cNvPr id="18" name="Abgerundetes Rechteck 17">
+            <a:extLst>
+              <a:ext uri="{FF2B5EF4-FFF2-40B4-BE49-F238E27FC236}">
+                <a16:creationId xmlns:a16="http://schemas.microsoft.com/office/drawing/2014/main" id="{3EED6E10-F4DC-5A09-08EC-217293252565}"/>
+              </a:ext>
+            </a:extLst>
+          </p:cNvPr>
+          <p:cNvSpPr/>
+          <p:nvPr/>
+        </p:nvSpPr>
+        <p:spPr>
+          <a:xfrm>
+            <a:off x="3971517" y="2442838"/>
+            <a:ext cx="267184" cy="270570"/>
+          </a:xfrm>
+          <a:prstGeom prst="roundRect">
+            <a:avLst/>
+          </a:prstGeom>
+        </p:spPr>
+        <p:style>
+          <a:lnRef idx="2">
+            <a:schemeClr val="accent4">
+              <a:shade val="15000"/>
+            </a:schemeClr>
+          </a:lnRef>
+          <a:fillRef idx="1">
+            <a:schemeClr val="accent4"/>
+          </a:fillRef>
+          <a:effectRef idx="0">
+            <a:schemeClr val="accent4"/>
+          </a:effectRef>
+          <a:fontRef idx="minor">
+            <a:schemeClr val="lt1"/>
+          </a:fontRef>
+        </p:style>
+        <p:txBody>
+          <a:bodyPr rtlCol="0" anchor="ctr"/>
+          <a:lstStyle/>
+          <a:p>
+            <a:pPr algn="ctr"/>
+            <a:endParaRPr lang="de-DE"/>
+          </a:p>
+        </p:txBody>
+      </p:sp>
+      <p:sp>
+        <p:nvSpPr>
+          <p:cNvPr id="19" name="Abgerundetes Rechteck 18">
+            <a:extLst>
+              <a:ext uri="{FF2B5EF4-FFF2-40B4-BE49-F238E27FC236}">
+                <a16:creationId xmlns:a16="http://schemas.microsoft.com/office/drawing/2014/main" id="{4484FBDB-0575-6BE8-AA81-730E0F74C724}"/>
+              </a:ext>
+            </a:extLst>
+          </p:cNvPr>
+          <p:cNvSpPr/>
+          <p:nvPr/>
+        </p:nvSpPr>
+        <p:spPr>
+          <a:xfrm>
+            <a:off x="5744643" y="2228535"/>
+            <a:ext cx="820060" cy="252431"/>
+          </a:xfrm>
+          <a:prstGeom prst="roundRect">
+            <a:avLst/>
+          </a:prstGeom>
+        </p:spPr>
+        <p:style>
+          <a:lnRef idx="2">
+            <a:schemeClr val="accent4">
+              <a:shade val="15000"/>
+            </a:schemeClr>
+          </a:lnRef>
+          <a:fillRef idx="1">
+            <a:schemeClr val="accent4"/>
+          </a:fillRef>
+          <a:effectRef idx="0">
+            <a:schemeClr val="accent4"/>
+          </a:effectRef>
+          <a:fontRef idx="minor">
+            <a:schemeClr val="lt1"/>
+          </a:fontRef>
+        </p:style>
+        <p:txBody>
+          <a:bodyPr rtlCol="0" anchor="ctr"/>
+          <a:lstStyle/>
+          <a:p>
+            <a:pPr algn="ctr"/>
+            <a:endParaRPr lang="de-DE"/>
+          </a:p>
+        </p:txBody>
+      </p:sp>
+      <p:sp>
+        <p:nvSpPr>
+          <p:cNvPr id="20" name="Abgerundetes Rechteck 19">
+            <a:extLst>
+              <a:ext uri="{FF2B5EF4-FFF2-40B4-BE49-F238E27FC236}">
+                <a16:creationId xmlns:a16="http://schemas.microsoft.com/office/drawing/2014/main" id="{5260007D-C4EC-14F3-084E-C13C6A47C698}"/>
+              </a:ext>
+            </a:extLst>
+          </p:cNvPr>
+          <p:cNvSpPr/>
+          <p:nvPr/>
+        </p:nvSpPr>
+        <p:spPr>
+          <a:xfrm>
+            <a:off x="8015307" y="3638212"/>
+            <a:ext cx="844021" cy="343016"/>
+          </a:xfrm>
+          <a:prstGeom prst="roundRect">
+            <a:avLst/>
+          </a:prstGeom>
+        </p:spPr>
+        <p:style>
+          <a:lnRef idx="2">
+            <a:schemeClr val="accent4">
+              <a:shade val="15000"/>
+            </a:schemeClr>
+          </a:lnRef>
+          <a:fillRef idx="1">
+            <a:schemeClr val="accent4"/>
+          </a:fillRef>
+          <a:effectRef idx="0">
+            <a:schemeClr val="accent4"/>
+          </a:effectRef>
+          <a:fontRef idx="minor">
+            <a:schemeClr val="lt1"/>
+          </a:fontRef>
+        </p:style>
+        <p:txBody>
+          <a:bodyPr rtlCol="0" anchor="ctr"/>
+          <a:lstStyle/>
+          <a:p>
+            <a:pPr algn="ctr"/>
+            <a:endParaRPr lang="de-DE"/>
+          </a:p>
+        </p:txBody>
+      </p:sp>
+      <p:sp>
+        <p:nvSpPr>
+          <p:cNvPr id="21" name="Abgerundetes Rechteck 20">
+            <a:extLst>
+              <a:ext uri="{FF2B5EF4-FFF2-40B4-BE49-F238E27FC236}">
+                <a16:creationId xmlns:a16="http://schemas.microsoft.com/office/drawing/2014/main" id="{11924946-D785-6487-9D12-3FD9AB500349}"/>
+              </a:ext>
+            </a:extLst>
+          </p:cNvPr>
+          <p:cNvSpPr/>
+          <p:nvPr/>
+        </p:nvSpPr>
+        <p:spPr>
+          <a:xfrm>
+            <a:off x="7828340" y="4025738"/>
+            <a:ext cx="219443" cy="207383"/>
+          </a:xfrm>
+          <a:prstGeom prst="roundRect">
+            <a:avLst/>
+          </a:prstGeom>
+        </p:spPr>
+        <p:style>
+          <a:lnRef idx="2">
+            <a:schemeClr val="accent4">
+              <a:shade val="15000"/>
+            </a:schemeClr>
+          </a:lnRef>
+          <a:fillRef idx="1">
+            <a:schemeClr val="accent4"/>
+          </a:fillRef>
+          <a:effectRef idx="0">
+            <a:schemeClr val="accent4"/>
+          </a:effectRef>
+          <a:fontRef idx="minor">
+            <a:schemeClr val="lt1"/>
+          </a:fontRef>
+        </p:style>
+        <p:txBody>
+          <a:bodyPr rtlCol="0" anchor="ctr"/>
+          <a:lstStyle/>
+          <a:p>
+            <a:pPr algn="ctr"/>
+            <a:endParaRPr lang="de-DE"/>
+          </a:p>
+        </p:txBody>
+      </p:sp>
+      <p:sp>
+        <p:nvSpPr>
+          <p:cNvPr id="22" name="Abgerundetes Rechteck 21">
+            <a:extLst>
+              <a:ext uri="{FF2B5EF4-FFF2-40B4-BE49-F238E27FC236}">
+                <a16:creationId xmlns:a16="http://schemas.microsoft.com/office/drawing/2014/main" id="{5B2D5E35-14E6-C5D4-A4C6-5C7C15FEC671}"/>
+              </a:ext>
+            </a:extLst>
+          </p:cNvPr>
+          <p:cNvSpPr/>
+          <p:nvPr/>
+        </p:nvSpPr>
+        <p:spPr>
+          <a:xfrm>
+            <a:off x="2130692" y="3939126"/>
+            <a:ext cx="844021" cy="207383"/>
+          </a:xfrm>
+          <a:prstGeom prst="roundRect">
+            <a:avLst/>
+          </a:prstGeom>
+        </p:spPr>
+        <p:style>
+          <a:lnRef idx="2">
+            <a:schemeClr val="accent4">
+              <a:shade val="15000"/>
+            </a:schemeClr>
+          </a:lnRef>
+          <a:fillRef idx="1">
+            <a:schemeClr val="accent4"/>
+          </a:fillRef>
+          <a:effectRef idx="0">
+            <a:schemeClr val="accent4"/>
+          </a:effectRef>
+          <a:fontRef idx="minor">
+            <a:schemeClr val="lt1"/>
+          </a:fontRef>
+        </p:style>
+        <p:txBody>
+          <a:bodyPr rtlCol="0" anchor="ctr"/>
+          <a:lstStyle/>
+          <a:p>
+            <a:pPr algn="ctr"/>
+            <a:endParaRPr lang="de-DE"/>
+          </a:p>
+        </p:txBody>
+      </p:sp>
+      <p:pic>
+        <p:nvPicPr>
+          <p:cNvPr id="24" name="Grafik 23" descr="Ein Bild, das Text, Origami enthält.&#10;&#10;KI-generierte Inhalte können fehlerhaft sein.">
+            <a:extLst>
+              <a:ext uri="{FF2B5EF4-FFF2-40B4-BE49-F238E27FC236}">
+                <a16:creationId xmlns:a16="http://schemas.microsoft.com/office/drawing/2014/main" id="{CC976162-BFC8-A7B2-904D-8291B4C5F750}"/>
+              </a:ext>
+            </a:extLst>
+          </p:cNvPr>
+          <p:cNvPicPr>
+            <a:picLocks noChangeAspect="1"/>
+          </p:cNvPicPr>
+          <p:nvPr/>
+        </p:nvPicPr>
+        <p:blipFill>
+          <a:blip r:embed="rId4"/>
+          <a:srcRect l="20022" b="56020"/>
+          <a:stretch>
+            <a:fillRect/>
+          </a:stretch>
+        </p:blipFill>
+        <p:spPr>
+          <a:xfrm>
+            <a:off x="3641768" y="4877854"/>
+            <a:ext cx="3161775" cy="1338602"/>
+          </a:xfrm>
+          <a:prstGeom prst="rect">
+            <a:avLst/>
+          </a:prstGeom>
+          <a:ln>
+            <a:solidFill>
+              <a:schemeClr val="tx1"/>
+            </a:solidFill>
+          </a:ln>
+        </p:spPr>
+      </p:pic>
+      <p:pic>
+        <p:nvPicPr>
+          <p:cNvPr id="25" name="Grafik 24" descr="Ein Bild, das Text, Origami enthält.&#10;&#10;KI-generierte Inhalte können fehlerhaft sein.">
+            <a:extLst>
+              <a:ext uri="{FF2B5EF4-FFF2-40B4-BE49-F238E27FC236}">
+                <a16:creationId xmlns:a16="http://schemas.microsoft.com/office/drawing/2014/main" id="{F20FCD64-9804-FC14-B941-93512B1632DC}"/>
+              </a:ext>
+            </a:extLst>
+          </p:cNvPr>
+          <p:cNvPicPr>
+            <a:picLocks noChangeAspect="1"/>
+          </p:cNvPicPr>
+          <p:nvPr/>
+        </p:nvPicPr>
+        <p:blipFill>
+          <a:blip r:embed="rId4"/>
+          <a:srcRect t="45828"/>
+          <a:stretch>
+            <a:fillRect/>
+          </a:stretch>
+        </p:blipFill>
+        <p:spPr>
+          <a:xfrm>
+            <a:off x="6997967" y="4877854"/>
+            <a:ext cx="4235358" cy="1766485"/>
+          </a:xfrm>
+          <a:prstGeom prst="rect">
+            <a:avLst/>
+          </a:prstGeom>
+          <a:ln>
+            <a:solidFill>
+              <a:schemeClr val="tx1"/>
+            </a:solidFill>
+          </a:ln>
+        </p:spPr>
+      </p:pic>
     </p:spTree>
     <p:extLst>
       <p:ext uri="{BB962C8B-B14F-4D97-AF65-F5344CB8AC3E}">
-        <p14:creationId xmlns:p14="http://schemas.microsoft.com/office/powerpoint/2010/main" val="2611820202"/>
+        <p14:creationId xmlns:p14="http://schemas.microsoft.com/office/powerpoint/2010/main" val="3162902525"/>
       </p:ext>
     </p:extLst>
   </p:cSld>
@@ -5007,7 +6387,7 @@
 </p:sld>
 </file>
 
-<file path=ppt/slides/slide2.xml><?xml version="1.0" encoding="utf-8"?>
+<file path=ppt/slides/slide7.xml><?xml version="1.0" encoding="utf-8"?>
 <p:sld xmlns:a="http://schemas.openxmlformats.org/drawingml/2006/main" xmlns:r="http://schemas.openxmlformats.org/officeDocument/2006/relationships" xmlns:p="http://schemas.openxmlformats.org/presentationml/2006/main">
   <p:cSld>
     <p:spTree>
@@ -5015,7 +6395,7 @@
         <p:cNvPr id="1" name="">
           <a:extLst>
             <a:ext uri="{FF2B5EF4-FFF2-40B4-BE49-F238E27FC236}">
-              <a16:creationId xmlns:a16="http://schemas.microsoft.com/office/drawing/2014/main" id="{53DF5F4C-102E-2FAA-E0F6-EAC29427C1C2}"/>
+              <a16:creationId xmlns:a16="http://schemas.microsoft.com/office/drawing/2014/main" id="{031D9A79-4F64-6AF1-CEBD-0A216DEAF88B}"/>
             </a:ext>
           </a:extLst>
         </p:cNvPr>
@@ -5032,406 +6412,21 @@
       </p:grpSpPr>
       <p:sp>
         <p:nvSpPr>
-          <p:cNvPr id="2" name="Titel 1">
-            <a:extLst>
-              <a:ext uri="{FF2B5EF4-FFF2-40B4-BE49-F238E27FC236}">
-                <a16:creationId xmlns:a16="http://schemas.microsoft.com/office/drawing/2014/main" id="{68DC2F80-0867-583C-AC58-8829AB16F9DD}"/>
-              </a:ext>
-            </a:extLst>
-          </p:cNvPr>
-          <p:cNvSpPr>
-            <a:spLocks noGrp="1"/>
-          </p:cNvSpPr>
-          <p:nvPr>
-            <p:ph type="title"/>
-          </p:nvPr>
+          <p:cNvPr id="3" name="Titel 1">
+            <a:extLst>
+              <a:ext uri="{FF2B5EF4-FFF2-40B4-BE49-F238E27FC236}">
+                <a16:creationId xmlns:a16="http://schemas.microsoft.com/office/drawing/2014/main" id="{FE22BE25-984B-7AF3-4C01-F0B3633F00DC}"/>
+              </a:ext>
+            </a:extLst>
+          </p:cNvPr>
+          <p:cNvSpPr txBox="1">
+            <a:spLocks/>
+          </p:cNvSpPr>
+          <p:nvPr/>
         </p:nvSpPr>
         <p:spPr>
           <a:xfrm>
-            <a:off x="193623" y="425086"/>
-            <a:ext cx="11768528" cy="549275"/>
-          </a:xfrm>
-        </p:spPr>
-        <p:txBody>
-          <a:bodyPr>
-            <a:normAutofit fontScale="90000"/>
-          </a:bodyPr>
-          <a:lstStyle/>
-          <a:p>
-            <a:pPr algn="ctr"/>
-            <a:r>
-              <a:rPr lang="de-DE" dirty="0">
-                <a:latin typeface="ADLaM Display" panose="02010000000000000000" pitchFamily="2" charset="77"/>
-                <a:ea typeface="ADLaM Display" panose="02010000000000000000" pitchFamily="2" charset="77"/>
-                <a:cs typeface="ADLaM Display" panose="02010000000000000000" pitchFamily="2" charset="77"/>
-              </a:rPr>
-              <a:t>Sitzordnung Computerraum</a:t>
-            </a:r>
-          </a:p>
-        </p:txBody>
-      </p:sp>
-      <p:sp>
-        <p:nvSpPr>
-          <p:cNvPr id="3" name="Inhaltsplatzhalter 2">
-            <a:extLst>
-              <a:ext uri="{FF2B5EF4-FFF2-40B4-BE49-F238E27FC236}">
-                <a16:creationId xmlns:a16="http://schemas.microsoft.com/office/drawing/2014/main" id="{FB5C29FB-88F6-4809-15BC-1B0316BD3AC4}"/>
-              </a:ext>
-            </a:extLst>
-          </p:cNvPr>
-          <p:cNvSpPr>
-            <a:spLocks noGrp="1"/>
-          </p:cNvSpPr>
-          <p:nvPr>
-            <p:ph sz="half" idx="1"/>
-          </p:nvPr>
-        </p:nvSpPr>
-        <p:spPr>
-          <a:xfrm>
-            <a:off x="193623" y="1497496"/>
-            <a:ext cx="11768528" cy="5115299"/>
-          </a:xfrm>
-        </p:spPr>
-        <p:txBody>
-          <a:bodyPr>
-            <a:normAutofit fontScale="92500" lnSpcReduction="20000"/>
-          </a:bodyPr>
-          <a:lstStyle/>
-          <a:p>
-            <a:pPr marL="0" indent="0" fontAlgn="ctr">
-              <a:buNone/>
-            </a:pPr>
-            <a:r>
-              <a:rPr lang="de-DE" dirty="0"/>
-              <a:t>Louisa					Marlene K.		 Adela</a:t>
-            </a:r>
-          </a:p>
-          <a:p>
-            <a:pPr marL="0" indent="0" fontAlgn="ctr">
-              <a:buNone/>
-            </a:pPr>
-            <a:r>
-              <a:rPr lang="de-DE" dirty="0"/>
-              <a:t>Julia		Marlene G.		 	Jasmin 		Friederike</a:t>
-            </a:r>
-          </a:p>
-          <a:p>
-            <a:pPr marL="0" indent="0" fontAlgn="ctr">
-              <a:buNone/>
-            </a:pPr>
-            <a:endParaRPr lang="de-DE" dirty="0"/>
-          </a:p>
-          <a:p>
-            <a:pPr marL="0" indent="0" fontAlgn="ctr">
-              <a:buNone/>
-            </a:pPr>
-            <a:r>
-              <a:rPr lang="de-DE" dirty="0"/>
-              <a:t>Jonas		Samuel			Dennis		Luise</a:t>
-            </a:r>
-          </a:p>
-          <a:p>
-            <a:pPr marL="0" indent="0" algn="just" fontAlgn="ctr">
-              <a:buNone/>
-            </a:pPr>
-            <a:r>
-              <a:rPr lang="de-DE" dirty="0"/>
-              <a:t>Kilian 		Jan				Vincent 		Hannah</a:t>
-            </a:r>
-          </a:p>
-          <a:p>
-            <a:pPr marL="0" indent="0" fontAlgn="ctr">
-              <a:buNone/>
-            </a:pPr>
-            <a:endParaRPr lang="de-DE" dirty="0"/>
-          </a:p>
-          <a:p>
-            <a:pPr marL="0" indent="0" fontAlgn="ctr">
-              <a:buNone/>
-            </a:pPr>
-            <a:endParaRPr lang="de-DE" dirty="0"/>
-          </a:p>
-          <a:p>
-            <a:pPr marL="0" indent="0" fontAlgn="ctr">
-              <a:buNone/>
-            </a:pPr>
-            <a:r>
-              <a:rPr lang="de-DE" dirty="0"/>
-              <a:t>Miró 		Freya				Felix			Niklas</a:t>
-            </a:r>
-          </a:p>
-          <a:p>
-            <a:pPr marL="0" indent="0" fontAlgn="ctr">
-              <a:buNone/>
-            </a:pPr>
-            <a:r>
-              <a:rPr lang="de-DE" dirty="0"/>
-              <a:t>Jonathan 	Josefine			</a:t>
-            </a:r>
-            <a:r>
-              <a:rPr lang="de-DE" dirty="0" err="1"/>
-              <a:t>Lennas</a:t>
-            </a:r>
-            <a:r>
-              <a:rPr lang="de-DE" dirty="0"/>
-              <a:t>		Nils</a:t>
-            </a:r>
-          </a:p>
-          <a:p>
-            <a:pPr marL="0" indent="0" fontAlgn="ctr">
-              <a:buNone/>
-            </a:pPr>
-            <a:endParaRPr lang="de-DE" dirty="0"/>
-          </a:p>
-          <a:p>
-            <a:pPr marL="0" indent="0" fontAlgn="ctr">
-              <a:buNone/>
-            </a:pPr>
-            <a:r>
-              <a:rPr lang="de-DE" dirty="0"/>
-              <a:t>Louis		Bruno				Fabio			Robin</a:t>
-            </a:r>
-          </a:p>
-          <a:p>
-            <a:pPr marL="0" indent="0" fontAlgn="ctr">
-              <a:buNone/>
-            </a:pPr>
-            <a:r>
-              <a:rPr lang="de-DE" dirty="0"/>
-              <a:t>Arthur 	Andreas			Jakob		 	Paul</a:t>
-            </a:r>
-          </a:p>
-        </p:txBody>
-      </p:sp>
-    </p:spTree>
-    <p:extLst>
-      <p:ext uri="{BB962C8B-B14F-4D97-AF65-F5344CB8AC3E}">
-        <p14:creationId xmlns:p14="http://schemas.microsoft.com/office/powerpoint/2010/main" val="3335560466"/>
-      </p:ext>
-    </p:extLst>
-  </p:cSld>
-  <p:clrMapOvr>
-    <a:masterClrMapping/>
-  </p:clrMapOvr>
-</p:sld>
-</file>
-
-<file path=ppt/slides/slide3.xml><?xml version="1.0" encoding="utf-8"?>
-<p:sld xmlns:a="http://schemas.openxmlformats.org/drawingml/2006/main" xmlns:r="http://schemas.openxmlformats.org/officeDocument/2006/relationships" xmlns:p="http://schemas.openxmlformats.org/presentationml/2006/main">
-  <p:cSld>
-    <p:spTree>
-      <p:nvGrpSpPr>
-        <p:cNvPr id="1" name=""/>
-        <p:cNvGrpSpPr/>
-        <p:nvPr/>
-      </p:nvGrpSpPr>
-      <p:grpSpPr>
-        <a:xfrm>
-          <a:off x="0" y="0"/>
-          <a:ext cx="0" cy="0"/>
-          <a:chOff x="0" y="0"/>
-          <a:chExt cx="0" cy="0"/>
-        </a:xfrm>
-      </p:grpSpPr>
-      <p:pic>
-        <p:nvPicPr>
-          <p:cNvPr id="10" name="Grafik 9" descr="Ein Bild, das Text, Papier, Brief, Origami enthält.&#10;&#10;KI-generierte Inhalte können fehlerhaft sein.">
-            <a:extLst>
-              <a:ext uri="{FF2B5EF4-FFF2-40B4-BE49-F238E27FC236}">
-                <a16:creationId xmlns:a16="http://schemas.microsoft.com/office/drawing/2014/main" id="{A4BE09B9-6415-6507-A377-A5DAD30E29A1}"/>
-              </a:ext>
-            </a:extLst>
-          </p:cNvPr>
-          <p:cNvPicPr>
-            <a:picLocks noChangeAspect="1"/>
-          </p:cNvPicPr>
-          <p:nvPr/>
-        </p:nvPicPr>
-        <p:blipFill>
-          <a:blip r:embed="rId3"/>
-          <a:srcRect b="28743"/>
-          <a:stretch>
-            <a:fillRect/>
-          </a:stretch>
-        </p:blipFill>
-        <p:spPr>
-          <a:xfrm>
-            <a:off x="0" y="468441"/>
-            <a:ext cx="5924918" cy="5448926"/>
-          </a:xfrm>
-          <a:prstGeom prst="rect">
-            <a:avLst/>
-          </a:prstGeom>
-        </p:spPr>
-      </p:pic>
-      <p:pic>
-        <p:nvPicPr>
-          <p:cNvPr id="12" name="Grafik 11" descr="Ein Bild, das Text, Schrift, Reihe, Diagramm enthält.&#10;&#10;KI-generierte Inhalte können fehlerhaft sein.">
-            <a:extLst>
-              <a:ext uri="{FF2B5EF4-FFF2-40B4-BE49-F238E27FC236}">
-                <a16:creationId xmlns:a16="http://schemas.microsoft.com/office/drawing/2014/main" id="{E2B21C04-4E69-2ACA-5B47-6F85E6498F34}"/>
-              </a:ext>
-            </a:extLst>
-          </p:cNvPr>
-          <p:cNvPicPr>
-            <a:picLocks noChangeAspect="1"/>
-          </p:cNvPicPr>
-          <p:nvPr/>
-        </p:nvPicPr>
-        <p:blipFill>
-          <a:blip r:embed="rId4"/>
-          <a:stretch>
-            <a:fillRect/>
-          </a:stretch>
-        </p:blipFill>
-        <p:spPr>
-          <a:xfrm>
-            <a:off x="6096000" y="3762532"/>
-            <a:ext cx="6048117" cy="1244184"/>
-          </a:xfrm>
-          <a:prstGeom prst="rect">
-            <a:avLst/>
-          </a:prstGeom>
-        </p:spPr>
-      </p:pic>
-      <p:pic>
-        <p:nvPicPr>
-          <p:cNvPr id="15" name="Grafik 14" descr="Ein Bild, das Text, Papier, Brief, Origami enthält.&#10;&#10;KI-generierte Inhalte können fehlerhaft sein.">
-            <a:extLst>
-              <a:ext uri="{FF2B5EF4-FFF2-40B4-BE49-F238E27FC236}">
-                <a16:creationId xmlns:a16="http://schemas.microsoft.com/office/drawing/2014/main" id="{721158B0-DCA0-18E3-E2BB-A2D9AF0126FD}"/>
-              </a:ext>
-            </a:extLst>
-          </p:cNvPr>
-          <p:cNvPicPr>
-            <a:picLocks noChangeAspect="1"/>
-          </p:cNvPicPr>
-          <p:nvPr/>
-        </p:nvPicPr>
-        <p:blipFill>
-          <a:blip r:embed="rId3"/>
-          <a:srcRect t="71257"/>
-          <a:stretch>
-            <a:fillRect/>
-          </a:stretch>
-        </p:blipFill>
-        <p:spPr>
-          <a:xfrm>
-            <a:off x="6096000" y="1499016"/>
-            <a:ext cx="6101642" cy="2263516"/>
-          </a:xfrm>
-          <a:prstGeom prst="rect">
-            <a:avLst/>
-          </a:prstGeom>
-        </p:spPr>
-      </p:pic>
-    </p:spTree>
-    <p:extLst>
-      <p:ext uri="{BB962C8B-B14F-4D97-AF65-F5344CB8AC3E}">
-        <p14:creationId xmlns:p14="http://schemas.microsoft.com/office/powerpoint/2010/main" val="330369928"/>
-      </p:ext>
-    </p:extLst>
-  </p:cSld>
-  <p:clrMapOvr>
-    <a:masterClrMapping/>
-  </p:clrMapOvr>
-</p:sld>
-</file>
-
-<file path=ppt/slides/slide4.xml><?xml version="1.0" encoding="utf-8"?>
-<p:sld xmlns:a="http://schemas.openxmlformats.org/drawingml/2006/main" xmlns:r="http://schemas.openxmlformats.org/officeDocument/2006/relationships" xmlns:p="http://schemas.openxmlformats.org/presentationml/2006/main">
-  <p:cSld>
-    <p:spTree>
-      <p:nvGrpSpPr>
-        <p:cNvPr id="1" name=""/>
-        <p:cNvGrpSpPr/>
-        <p:nvPr/>
-      </p:nvGrpSpPr>
-      <p:grpSpPr>
-        <a:xfrm>
-          <a:off x="0" y="0"/>
-          <a:ext cx="0" cy="0"/>
-          <a:chOff x="0" y="0"/>
-          <a:chExt cx="0" cy="0"/>
-        </a:xfrm>
-      </p:grpSpPr>
-      <p:pic>
-        <p:nvPicPr>
-          <p:cNvPr id="2" name="Grafik 1" descr="Ein Bild, das Text, Screenshot, Schrift, Brief enthält.&#10;&#10;KI-generierte Inhalte können fehlerhaft sein.">
-            <a:extLst>
-              <a:ext uri="{FF2B5EF4-FFF2-40B4-BE49-F238E27FC236}">
-                <a16:creationId xmlns:a16="http://schemas.microsoft.com/office/drawing/2014/main" id="{1530B3CA-E079-015A-6244-3B16165C6FD6}"/>
-              </a:ext>
-            </a:extLst>
-          </p:cNvPr>
-          <p:cNvPicPr>
-            <a:picLocks noChangeAspect="1"/>
-          </p:cNvPicPr>
-          <p:nvPr/>
-        </p:nvPicPr>
-        <p:blipFill>
-          <a:blip r:embed="rId2"/>
-          <a:stretch>
-            <a:fillRect/>
-          </a:stretch>
-        </p:blipFill>
-        <p:spPr>
-          <a:xfrm>
-            <a:off x="3267856" y="-1863"/>
-            <a:ext cx="5666282" cy="6873850"/>
-          </a:xfrm>
-          <a:prstGeom prst="rect">
-            <a:avLst/>
-          </a:prstGeom>
-        </p:spPr>
-      </p:pic>
-    </p:spTree>
-    <p:extLst>
-      <p:ext uri="{BB962C8B-B14F-4D97-AF65-F5344CB8AC3E}">
-        <p14:creationId xmlns:p14="http://schemas.microsoft.com/office/powerpoint/2010/main" val="3079377886"/>
-      </p:ext>
-    </p:extLst>
-  </p:cSld>
-  <p:clrMapOvr>
-    <a:masterClrMapping/>
-  </p:clrMapOvr>
-</p:sld>
-</file>
-
-<file path=ppt/slides/slide5.xml><?xml version="1.0" encoding="utf-8"?>
-<p:sld xmlns:a="http://schemas.openxmlformats.org/drawingml/2006/main" xmlns:r="http://schemas.openxmlformats.org/officeDocument/2006/relationships" xmlns:p="http://schemas.openxmlformats.org/presentationml/2006/main">
-  <p:cSld>
-    <p:spTree>
-      <p:nvGrpSpPr>
-        <p:cNvPr id="1" name=""/>
-        <p:cNvGrpSpPr/>
-        <p:nvPr/>
-      </p:nvGrpSpPr>
-      <p:grpSpPr>
-        <a:xfrm>
-          <a:off x="0" y="0"/>
-          <a:ext cx="0" cy="0"/>
-          <a:chOff x="0" y="0"/>
-          <a:chExt cx="0" cy="0"/>
-        </a:xfrm>
-      </p:grpSpPr>
-      <p:sp>
-        <p:nvSpPr>
-          <p:cNvPr id="3" name="Titel 1">
-            <a:extLst>
-              <a:ext uri="{FF2B5EF4-FFF2-40B4-BE49-F238E27FC236}">
-                <a16:creationId xmlns:a16="http://schemas.microsoft.com/office/drawing/2014/main" id="{BA140C9D-1408-E733-FF1E-44847D93BFFB}"/>
-              </a:ext>
-            </a:extLst>
-          </p:cNvPr>
-          <p:cNvSpPr txBox="1">
-            <a:spLocks/>
-          </p:cNvSpPr>
-          <p:nvPr/>
-        </p:nvSpPr>
-        <p:spPr>
-          <a:xfrm>
-            <a:off x="193623" y="425086"/>
+            <a:off x="211736" y="141622"/>
             <a:ext cx="11768528" cy="549275"/>
           </a:xfrm>
           <a:prstGeom prst="rect">
@@ -5476,65 +6471,21 @@
       </p:sp>
       <p:sp>
         <p:nvSpPr>
-          <p:cNvPr id="6" name="Abgerundetes Rechteck 5">
-            <a:extLst>
-              <a:ext uri="{FF2B5EF4-FFF2-40B4-BE49-F238E27FC236}">
-                <a16:creationId xmlns:a16="http://schemas.microsoft.com/office/drawing/2014/main" id="{584FD70A-0EC3-02CD-02E6-2F0482628609}"/>
-              </a:ext>
-            </a:extLst>
-          </p:cNvPr>
-          <p:cNvSpPr/>
+          <p:cNvPr id="2" name="Inhaltsplatzhalter 2">
+            <a:extLst>
+              <a:ext uri="{FF2B5EF4-FFF2-40B4-BE49-F238E27FC236}">
+                <a16:creationId xmlns:a16="http://schemas.microsoft.com/office/drawing/2014/main" id="{B605FC50-ADA1-0E6A-2CC3-4E7AF5CBAD91}"/>
+              </a:ext>
+            </a:extLst>
+          </p:cNvPr>
+          <p:cNvSpPr txBox="1">
+            <a:spLocks/>
+          </p:cNvSpPr>
           <p:nvPr/>
         </p:nvSpPr>
         <p:spPr>
           <a:xfrm>
-            <a:off x="193623" y="1240970"/>
-            <a:ext cx="11768527" cy="5382251"/>
-          </a:xfrm>
-          <a:prstGeom prst="roundRect">
-            <a:avLst/>
-          </a:prstGeom>
-        </p:spPr>
-        <p:style>
-          <a:lnRef idx="2">
-            <a:schemeClr val="accent3"/>
-          </a:lnRef>
-          <a:fillRef idx="1">
-            <a:schemeClr val="lt1"/>
-          </a:fillRef>
-          <a:effectRef idx="0">
-            <a:schemeClr val="accent3"/>
-          </a:effectRef>
-          <a:fontRef idx="minor">
-            <a:schemeClr val="dk1"/>
-          </a:fontRef>
-        </p:style>
-        <p:txBody>
-          <a:bodyPr rtlCol="0" anchor="ctr"/>
-          <a:lstStyle/>
-          <a:p>
-            <a:pPr algn="ctr"/>
-            <a:endParaRPr lang="de-DE"/>
-          </a:p>
-        </p:txBody>
-      </p:sp>
-      <p:sp>
-        <p:nvSpPr>
-          <p:cNvPr id="8" name="Inhaltsplatzhalter 2">
-            <a:extLst>
-              <a:ext uri="{FF2B5EF4-FFF2-40B4-BE49-F238E27FC236}">
-                <a16:creationId xmlns:a16="http://schemas.microsoft.com/office/drawing/2014/main" id="{D1B812B5-42BF-7EF8-4EF2-953E9E589C6F}"/>
-              </a:ext>
-            </a:extLst>
-          </p:cNvPr>
-          <p:cNvSpPr txBox="1">
-            <a:spLocks/>
-          </p:cNvSpPr>
-          <p:nvPr/>
-        </p:nvSpPr>
-        <p:spPr>
-          <a:xfrm>
-            <a:off x="423472" y="1559658"/>
+            <a:off x="148465" y="690897"/>
             <a:ext cx="11327804" cy="4396299"/>
           </a:xfrm>
           <a:prstGeom prst="rect">
@@ -5712,76 +6663,46 @@
               <a:buNone/>
             </a:pPr>
             <a:r>
-              <a:rPr lang="de-DE" b="1" dirty="0"/>
-              <a:t>Aufgabe 1</a:t>
-            </a:r>
-          </a:p>
-          <a:p>
-            <a:pPr marL="0" indent="0" algn="just">
-              <a:buNone/>
-            </a:pPr>
-            <a:r>
-              <a:rPr lang="de-DE" dirty="0"/>
-              <a:t>Zeichne das Dreieck ABC mit den Eckpunkten A(2/3), B(8,5/1) und C(5/4) sowie die </a:t>
-            </a:r>
-            <a:r>
-              <a:rPr lang="de-DE" dirty="0" err="1"/>
-              <a:t>Berade</a:t>
-            </a:r>
-            <a:r>
-              <a:rPr lang="de-DE" dirty="0"/>
-              <a:t> CD durch die Punkte C und D(3/0). Spiegele dann das Dreieck ABC an der Geraden CD.</a:t>
-            </a:r>
-          </a:p>
-          <a:p>
-            <a:pPr marL="0" indent="0" algn="just">
-              <a:buNone/>
-            </a:pPr>
-            <a:endParaRPr lang="de-DE" dirty="0"/>
-          </a:p>
-          <a:p>
-            <a:pPr marL="0" indent="0" algn="just">
-              <a:buNone/>
-            </a:pPr>
-            <a:r>
-              <a:rPr lang="de-DE" b="1" dirty="0"/>
-              <a:t>Aufgabe 2</a:t>
-            </a:r>
-          </a:p>
-          <a:p>
-            <a:pPr marL="0" indent="0" algn="just">
-              <a:buNone/>
-            </a:pPr>
-            <a:r>
-              <a:rPr lang="de-DE" dirty="0"/>
-              <a:t>Schreibe einen Text der folgende Begriffe beinhaltet:</a:t>
-            </a:r>
-          </a:p>
-          <a:p>
-            <a:pPr marL="0" indent="0" algn="just">
-              <a:buNone/>
-            </a:pPr>
-            <a:r>
-              <a:rPr lang="de-DE" sz="2400" dirty="0">
-                <a:solidFill>
-                  <a:schemeClr val="tx2">
-                    <a:lumMod val="75000"/>
-                    <a:lumOff val="25000"/>
-                  </a:schemeClr>
-                </a:solidFill>
-                <a:latin typeface="Cavolini" panose="03000502040302020204" pitchFamily="66" charset="0"/>
-                <a:ea typeface="ADLaM Display" panose="02010000000000000000" pitchFamily="2" charset="77"/>
-                <a:cs typeface="Cavolini" panose="03000502040302020204" pitchFamily="66" charset="0"/>
-              </a:rPr>
-              <a:t>Originalpunkt, Spiegelachse, parallel, Abstand, Bildpunkt, P, verschiedene Seiten, denselben, P‘, Fixpunkt, Achsenspiegelung, Mittellinie, Geodreieck</a:t>
-            </a:r>
-          </a:p>
-        </p:txBody>
-      </p:sp>
+              <a:rPr lang="de-DE" sz="2000" b="1" dirty="0"/>
+              <a:t>Aufgabe </a:t>
+            </a:r>
+          </a:p>
+        </p:txBody>
+      </p:sp>
+      <p:pic>
+        <p:nvPicPr>
+          <p:cNvPr id="4" name="Grafik 3" descr="Ein Bild, das Text, Screenshot, Cartoon enthält.&#10;&#10;KI-generierte Inhalte können fehlerhaft sein.">
+            <a:extLst>
+              <a:ext uri="{FF2B5EF4-FFF2-40B4-BE49-F238E27FC236}">
+                <a16:creationId xmlns:a16="http://schemas.microsoft.com/office/drawing/2014/main" id="{E39361E8-78AB-BC2C-08DB-E072014FB428}"/>
+              </a:ext>
+            </a:extLst>
+          </p:cNvPr>
+          <p:cNvPicPr>
+            <a:picLocks noChangeAspect="1"/>
+          </p:cNvPicPr>
+          <p:nvPr/>
+        </p:nvPicPr>
+        <p:blipFill>
+          <a:blip r:embed="rId3"/>
+          <a:stretch>
+            <a:fillRect/>
+          </a:stretch>
+        </p:blipFill>
+        <p:spPr>
+          <a:xfrm>
+            <a:off x="588371" y="1187812"/>
+            <a:ext cx="10887898" cy="3402468"/>
+          </a:xfrm>
+          <a:prstGeom prst="rect">
+            <a:avLst/>
+          </a:prstGeom>
+        </p:spPr>
+      </p:pic>
     </p:spTree>
     <p:extLst>
       <p:ext uri="{BB962C8B-B14F-4D97-AF65-F5344CB8AC3E}">
-        <p14:creationId xmlns:p14="http://schemas.microsoft.com/office/powerpoint/2010/main" val="3178181211"/>
+        <p14:creationId xmlns:p14="http://schemas.microsoft.com/office/powerpoint/2010/main" val="2406126268"/>
       </p:ext>
     </p:extLst>
   </p:cSld>
@@ -5791,7 +6712,7 @@
 </p:sld>
 </file>
 
-<file path=ppt/slides/slide6.xml><?xml version="1.0" encoding="utf-8"?>
+<file path=ppt/slides/slide8.xml><?xml version="1.0" encoding="utf-8"?>
 <p:sld xmlns:a="http://schemas.openxmlformats.org/drawingml/2006/main" xmlns:r="http://schemas.openxmlformats.org/officeDocument/2006/relationships" xmlns:p="http://schemas.openxmlformats.org/presentationml/2006/main">
   <p:cSld>
     <p:spTree>
@@ -5799,7 +6720,7 @@
         <p:cNvPr id="1" name="">
           <a:extLst>
             <a:ext uri="{FF2B5EF4-FFF2-40B4-BE49-F238E27FC236}">
-              <a16:creationId xmlns:a16="http://schemas.microsoft.com/office/drawing/2014/main" id="{9E9A4012-513C-1652-41DD-76A8CF12A7BB}"/>
+              <a16:creationId xmlns:a16="http://schemas.microsoft.com/office/drawing/2014/main" id="{11C59FFA-CB53-2E41-B295-6995E33AED7C}"/>
             </a:ext>
           </a:extLst>
         </p:cNvPr>
@@ -5819,7 +6740,7 @@
           <p:cNvPr id="3" name="Titel 1">
             <a:extLst>
               <a:ext uri="{FF2B5EF4-FFF2-40B4-BE49-F238E27FC236}">
-                <a16:creationId xmlns:a16="http://schemas.microsoft.com/office/drawing/2014/main" id="{DA84CAF6-1015-5B92-11EB-B7C4A9A15ABB}"/>
+                <a16:creationId xmlns:a16="http://schemas.microsoft.com/office/drawing/2014/main" id="{E5C95B1E-543F-86D6-A505-7DAC962D4EE4}"/>
               </a:ext>
             </a:extLst>
           </p:cNvPr>
@@ -5878,7 +6799,7 @@
           <p:cNvPr id="6" name="Abgerundetes Rechteck 5">
             <a:extLst>
               <a:ext uri="{FF2B5EF4-FFF2-40B4-BE49-F238E27FC236}">
-                <a16:creationId xmlns:a16="http://schemas.microsoft.com/office/drawing/2014/main" id="{E4979463-21F0-7B46-6790-38104BDD00F1}"/>
+                <a16:creationId xmlns:a16="http://schemas.microsoft.com/office/drawing/2014/main" id="{21030813-6EB7-A10E-6DF4-C20A6368813F}"/>
               </a:ext>
             </a:extLst>
           </p:cNvPr>
@@ -5913,7 +6834,7 @@
           <a:lstStyle/>
           <a:p>
             <a:pPr algn="ctr"/>
-            <a:endParaRPr lang="de-DE"/>
+            <a:endParaRPr lang="de-DE" b="1" dirty="0"/>
           </a:p>
         </p:txBody>
       </p:sp>
@@ -5922,7 +6843,7 @@
           <p:cNvPr id="8" name="Inhaltsplatzhalter 2">
             <a:extLst>
               <a:ext uri="{FF2B5EF4-FFF2-40B4-BE49-F238E27FC236}">
-                <a16:creationId xmlns:a16="http://schemas.microsoft.com/office/drawing/2014/main" id="{FDCFFAF8-DA45-C902-D19F-089239CD514F}"/>
+                <a16:creationId xmlns:a16="http://schemas.microsoft.com/office/drawing/2014/main" id="{51CD4DA6-533A-1C11-CF38-30C2128D053A}"/>
               </a:ext>
             </a:extLst>
           </p:cNvPr>
@@ -6111,27 +7032,51 @@
               <a:buNone/>
             </a:pPr>
             <a:r>
-              <a:rPr lang="de-DE" b="1" dirty="0"/>
-              <a:t>Aufgabe 3</a:t>
-            </a:r>
-          </a:p>
-          <a:p>
-            <a:pPr marL="0" indent="0" algn="just">
-              <a:buNone/>
-            </a:pPr>
-            <a:r>
-              <a:rPr lang="de-DE" dirty="0"/>
-              <a:t>Schreibe in dein Heft. Fülle die 6 Lücken!</a:t>
-            </a:r>
+              <a:rPr lang="de-DE" sz="2000" b="1" dirty="0"/>
+              <a:t>Übungsaufgaben &amp; HA </a:t>
+            </a:r>
+          </a:p>
+          <a:p>
+            <a:pPr algn="just"/>
+            <a:r>
+              <a:rPr lang="de-DE" sz="2000" dirty="0"/>
+              <a:t>Buch S.97, Nr. 3</a:t>
+            </a:r>
+          </a:p>
+          <a:p>
+            <a:pPr algn="just"/>
+            <a:r>
+              <a:rPr lang="de-DE" sz="2000" dirty="0"/>
+              <a:t>Arbeitsheft S.30</a:t>
+            </a:r>
+          </a:p>
+          <a:p>
+            <a:pPr algn="just"/>
+            <a:r>
+              <a:rPr lang="de-DE" sz="2000" b="1" dirty="0"/>
+              <a:t>Bonus</a:t>
+            </a:r>
+            <a:r>
+              <a:rPr lang="de-DE" sz="2000" dirty="0"/>
+              <a:t>: Nr. 4</a:t>
+            </a:r>
+          </a:p>
+          <a:p>
+            <a:pPr algn="just"/>
+            <a:endParaRPr lang="de-DE" sz="2000" b="1" dirty="0"/>
+          </a:p>
+          <a:p>
+            <a:pPr algn="just"/>
+            <a:endParaRPr lang="de-DE" sz="2000" b="1" dirty="0"/>
           </a:p>
         </p:txBody>
       </p:sp>
       <p:pic>
         <p:nvPicPr>
-          <p:cNvPr id="2" name="Grafik 1" descr="Ein Bild, das Text, Schrift, Reihe, Origami enthält.&#10;&#10;KI-generierte Inhalte können fehlerhaft sein.">
-            <a:extLst>
-              <a:ext uri="{FF2B5EF4-FFF2-40B4-BE49-F238E27FC236}">
-                <a16:creationId xmlns:a16="http://schemas.microsoft.com/office/drawing/2014/main" id="{331837AE-C8B3-8928-BB35-E7247ED0A94E}"/>
+          <p:cNvPr id="10" name="Grafik 9" descr="Ein Bild, das Text, Screenshot enthält.&#10;&#10;KI-generierte Inhalte können fehlerhaft sein.">
+            <a:extLst>
+              <a:ext uri="{FF2B5EF4-FFF2-40B4-BE49-F238E27FC236}">
+                <a16:creationId xmlns:a16="http://schemas.microsoft.com/office/drawing/2014/main" id="{5EEBACB8-7346-AD53-4754-4D335152D411}"/>
               </a:ext>
             </a:extLst>
           </p:cNvPr>
@@ -6148,248 +7093,23 @@
         </p:blipFill>
         <p:spPr>
           <a:xfrm>
-            <a:off x="423471" y="2637246"/>
-            <a:ext cx="11509575" cy="3318711"/>
+            <a:off x="4549485" y="1559658"/>
+            <a:ext cx="6972300" cy="3606800"/>
           </a:xfrm>
           <a:prstGeom prst="rect">
             <a:avLst/>
           </a:prstGeom>
+          <a:ln>
+            <a:solidFill>
+              <a:schemeClr val="tx1"/>
+            </a:solidFill>
+          </a:ln>
         </p:spPr>
       </p:pic>
-      <p:sp>
-        <p:nvSpPr>
-          <p:cNvPr id="4" name="Abgerundetes Rechteck 3">
-            <a:extLst>
-              <a:ext uri="{FF2B5EF4-FFF2-40B4-BE49-F238E27FC236}">
-                <a16:creationId xmlns:a16="http://schemas.microsoft.com/office/drawing/2014/main" id="{46F8BD7F-7D7F-B58C-B9E3-8DBC8159D4FF}"/>
-              </a:ext>
-            </a:extLst>
-          </p:cNvPr>
-          <p:cNvSpPr/>
-          <p:nvPr/>
-        </p:nvSpPr>
-        <p:spPr>
-          <a:xfrm>
-            <a:off x="3632886" y="3404286"/>
-            <a:ext cx="1655806" cy="327454"/>
-          </a:xfrm>
-          <a:prstGeom prst="roundRect">
-            <a:avLst/>
-          </a:prstGeom>
-        </p:spPr>
-        <p:style>
-          <a:lnRef idx="2">
-            <a:schemeClr val="accent4">
-              <a:shade val="15000"/>
-            </a:schemeClr>
-          </a:lnRef>
-          <a:fillRef idx="1">
-            <a:schemeClr val="accent4"/>
-          </a:fillRef>
-          <a:effectRef idx="0">
-            <a:schemeClr val="accent4"/>
-          </a:effectRef>
-          <a:fontRef idx="minor">
-            <a:schemeClr val="lt1"/>
-          </a:fontRef>
-        </p:style>
-        <p:txBody>
-          <a:bodyPr rtlCol="0" anchor="ctr"/>
-          <a:lstStyle/>
-          <a:p>
-            <a:pPr algn="ctr"/>
-            <a:endParaRPr lang="de-DE"/>
-          </a:p>
-        </p:txBody>
-      </p:sp>
-      <p:sp>
-        <p:nvSpPr>
-          <p:cNvPr id="5" name="Abgerundetes Rechteck 4">
-            <a:extLst>
-              <a:ext uri="{FF2B5EF4-FFF2-40B4-BE49-F238E27FC236}">
-                <a16:creationId xmlns:a16="http://schemas.microsoft.com/office/drawing/2014/main" id="{C7FBD1C8-1651-4EC9-2CA3-BBB8CDD4146C}"/>
-              </a:ext>
-            </a:extLst>
-          </p:cNvPr>
-          <p:cNvSpPr/>
-          <p:nvPr/>
-        </p:nvSpPr>
-        <p:spPr>
-          <a:xfrm>
-            <a:off x="4522452" y="4072489"/>
-            <a:ext cx="1655806" cy="327454"/>
-          </a:xfrm>
-          <a:prstGeom prst="roundRect">
-            <a:avLst/>
-          </a:prstGeom>
-        </p:spPr>
-        <p:style>
-          <a:lnRef idx="2">
-            <a:schemeClr val="accent4">
-              <a:shade val="15000"/>
-            </a:schemeClr>
-          </a:lnRef>
-          <a:fillRef idx="1">
-            <a:schemeClr val="accent4"/>
-          </a:fillRef>
-          <a:effectRef idx="0">
-            <a:schemeClr val="accent4"/>
-          </a:effectRef>
-          <a:fontRef idx="minor">
-            <a:schemeClr val="lt1"/>
-          </a:fontRef>
-        </p:style>
-        <p:txBody>
-          <a:bodyPr rtlCol="0" anchor="ctr"/>
-          <a:lstStyle/>
-          <a:p>
-            <a:pPr algn="ctr"/>
-            <a:endParaRPr lang="de-DE"/>
-          </a:p>
-        </p:txBody>
-      </p:sp>
-      <p:sp>
-        <p:nvSpPr>
-          <p:cNvPr id="9" name="Abgerundetes Rechteck 8">
-            <a:extLst>
-              <a:ext uri="{FF2B5EF4-FFF2-40B4-BE49-F238E27FC236}">
-                <a16:creationId xmlns:a16="http://schemas.microsoft.com/office/drawing/2014/main" id="{EDC435BC-AE7B-0526-CC3E-FEEFB08078B1}"/>
-              </a:ext>
-            </a:extLst>
-          </p:cNvPr>
-          <p:cNvSpPr/>
-          <p:nvPr/>
-        </p:nvSpPr>
-        <p:spPr>
-          <a:xfrm>
-            <a:off x="2684876" y="4481874"/>
-            <a:ext cx="1269286" cy="327454"/>
-          </a:xfrm>
-          <a:prstGeom prst="roundRect">
-            <a:avLst/>
-          </a:prstGeom>
-        </p:spPr>
-        <p:style>
-          <a:lnRef idx="2">
-            <a:schemeClr val="accent4">
-              <a:shade val="15000"/>
-            </a:schemeClr>
-          </a:lnRef>
-          <a:fillRef idx="1">
-            <a:schemeClr val="accent4"/>
-          </a:fillRef>
-          <a:effectRef idx="0">
-            <a:schemeClr val="accent4"/>
-          </a:effectRef>
-          <a:fontRef idx="minor">
-            <a:schemeClr val="lt1"/>
-          </a:fontRef>
-        </p:style>
-        <p:txBody>
-          <a:bodyPr rtlCol="0" anchor="ctr"/>
-          <a:lstStyle/>
-          <a:p>
-            <a:pPr algn="ctr"/>
-            <a:endParaRPr lang="de-DE"/>
-          </a:p>
-        </p:txBody>
-      </p:sp>
-      <p:sp>
-        <p:nvSpPr>
-          <p:cNvPr id="12" name="Abgerundetes Rechteck 11">
-            <a:extLst>
-              <a:ext uri="{FF2B5EF4-FFF2-40B4-BE49-F238E27FC236}">
-                <a16:creationId xmlns:a16="http://schemas.microsoft.com/office/drawing/2014/main" id="{91913AB1-81E9-73D3-C48B-D3E9F7E6ABBD}"/>
-              </a:ext>
-            </a:extLst>
-          </p:cNvPr>
-          <p:cNvSpPr/>
-          <p:nvPr/>
-        </p:nvSpPr>
-        <p:spPr>
-          <a:xfrm>
-            <a:off x="10909793" y="3027874"/>
-            <a:ext cx="717915" cy="327454"/>
-          </a:xfrm>
-          <a:prstGeom prst="roundRect">
-            <a:avLst/>
-          </a:prstGeom>
-        </p:spPr>
-        <p:style>
-          <a:lnRef idx="2">
-            <a:schemeClr val="accent4">
-              <a:shade val="15000"/>
-            </a:schemeClr>
-          </a:lnRef>
-          <a:fillRef idx="1">
-            <a:schemeClr val="accent4"/>
-          </a:fillRef>
-          <a:effectRef idx="0">
-            <a:schemeClr val="accent4"/>
-          </a:effectRef>
-          <a:fontRef idx="minor">
-            <a:schemeClr val="lt1"/>
-          </a:fontRef>
-        </p:style>
-        <p:txBody>
-          <a:bodyPr rtlCol="0" anchor="ctr"/>
-          <a:lstStyle/>
-          <a:p>
-            <a:pPr algn="ctr"/>
-            <a:endParaRPr lang="de-DE"/>
-          </a:p>
-        </p:txBody>
-      </p:sp>
-      <p:sp>
-        <p:nvSpPr>
-          <p:cNvPr id="13" name="Abgerundetes Rechteck 12">
-            <a:extLst>
-              <a:ext uri="{FF2B5EF4-FFF2-40B4-BE49-F238E27FC236}">
-                <a16:creationId xmlns:a16="http://schemas.microsoft.com/office/drawing/2014/main" id="{726401B0-3904-7849-D7C4-26FA6AC37A1A}"/>
-              </a:ext>
-            </a:extLst>
-          </p:cNvPr>
-          <p:cNvSpPr/>
-          <p:nvPr/>
-        </p:nvSpPr>
-        <p:spPr>
-          <a:xfrm>
-            <a:off x="9497658" y="4989509"/>
-            <a:ext cx="412461" cy="327454"/>
-          </a:xfrm>
-          <a:prstGeom prst="roundRect">
-            <a:avLst/>
-          </a:prstGeom>
-        </p:spPr>
-        <p:style>
-          <a:lnRef idx="2">
-            <a:schemeClr val="accent4">
-              <a:shade val="15000"/>
-            </a:schemeClr>
-          </a:lnRef>
-          <a:fillRef idx="1">
-            <a:schemeClr val="accent4"/>
-          </a:fillRef>
-          <a:effectRef idx="0">
-            <a:schemeClr val="accent4"/>
-          </a:effectRef>
-          <a:fontRef idx="minor">
-            <a:schemeClr val="lt1"/>
-          </a:fontRef>
-        </p:style>
-        <p:txBody>
-          <a:bodyPr rtlCol="0" anchor="ctr"/>
-          <a:lstStyle/>
-          <a:p>
-            <a:pPr algn="ctr"/>
-            <a:endParaRPr lang="de-DE"/>
-          </a:p>
-        </p:txBody>
-      </p:sp>
     </p:spTree>
     <p:extLst>
       <p:ext uri="{BB962C8B-B14F-4D97-AF65-F5344CB8AC3E}">
-        <p14:creationId xmlns:p14="http://schemas.microsoft.com/office/powerpoint/2010/main" val="2976346737"/>
+        <p14:creationId xmlns:p14="http://schemas.microsoft.com/office/powerpoint/2010/main" val="3172547515"/>
       </p:ext>
     </p:extLst>
   </p:cSld>
@@ -6399,7 +7119,7 @@
 </p:sld>
 </file>
 
-<file path=ppt/slides/slide7.xml><?xml version="1.0" encoding="utf-8"?>
+<file path=ppt/slides/slide9.xml><?xml version="1.0" encoding="utf-8"?>
 <p:sld xmlns:a="http://schemas.openxmlformats.org/drawingml/2006/main" xmlns:r="http://schemas.openxmlformats.org/officeDocument/2006/relationships" xmlns:p="http://schemas.openxmlformats.org/presentationml/2006/main">
   <p:cSld>
     <p:spTree>
@@ -6407,7 +7127,7 @@
         <p:cNvPr id="1" name="">
           <a:extLst>
             <a:ext uri="{FF2B5EF4-FFF2-40B4-BE49-F238E27FC236}">
-              <a16:creationId xmlns:a16="http://schemas.microsoft.com/office/drawing/2014/main" id="{0A45ABEF-EAD6-B274-68D7-4D6B7BC5E343}"/>
+              <a16:creationId xmlns:a16="http://schemas.microsoft.com/office/drawing/2014/main" id="{D6F9E721-EB3B-BCB5-BE3B-CA6255C50FF9}"/>
             </a:ext>
           </a:extLst>
         </p:cNvPr>
@@ -6427,7 +7147,7 @@
           <p:cNvPr id="3" name="Titel 1">
             <a:extLst>
               <a:ext uri="{FF2B5EF4-FFF2-40B4-BE49-F238E27FC236}">
-                <a16:creationId xmlns:a16="http://schemas.microsoft.com/office/drawing/2014/main" id="{7D303FE4-2650-BC88-E38F-38D50E4A1B78}"/>
+                <a16:creationId xmlns:a16="http://schemas.microsoft.com/office/drawing/2014/main" id="{68D2655B-9794-C641-BFA5-6367C8865A9C}"/>
               </a:ext>
             </a:extLst>
           </p:cNvPr>
@@ -6476,73 +7196,29 @@
                 <a:ea typeface="ADLaM Display" panose="02010000000000000000" pitchFamily="2" charset="77"/>
                 <a:cs typeface="ADLaM Display" panose="02010000000000000000" pitchFamily="2" charset="77"/>
               </a:rPr>
-              <a:t>Wiederholung: Achsenspiegelung</a:t>
-            </a:r>
-          </a:p>
-        </p:txBody>
-      </p:sp>
-      <p:sp>
-        <p:nvSpPr>
-          <p:cNvPr id="6" name="Abgerundetes Rechteck 5">
-            <a:extLst>
-              <a:ext uri="{FF2B5EF4-FFF2-40B4-BE49-F238E27FC236}">
-                <a16:creationId xmlns:a16="http://schemas.microsoft.com/office/drawing/2014/main" id="{3798D7EF-FB23-8DEC-03C9-5B9BE1EA1201}"/>
-              </a:ext>
-            </a:extLst>
-          </p:cNvPr>
-          <p:cNvSpPr/>
+              <a:t>Wiederholung: Zirkel &amp; Punkspiegelung</a:t>
+            </a:r>
+          </a:p>
+        </p:txBody>
+      </p:sp>
+      <p:sp>
+        <p:nvSpPr>
+          <p:cNvPr id="2" name="Inhaltsplatzhalter 2">
+            <a:extLst>
+              <a:ext uri="{FF2B5EF4-FFF2-40B4-BE49-F238E27FC236}">
+                <a16:creationId xmlns:a16="http://schemas.microsoft.com/office/drawing/2014/main" id="{42FC0499-C856-06B5-5E9F-6DB0ABE3E14F}"/>
+              </a:ext>
+            </a:extLst>
+          </p:cNvPr>
+          <p:cNvSpPr txBox="1">
+            <a:spLocks/>
+          </p:cNvSpPr>
           <p:nvPr/>
         </p:nvSpPr>
         <p:spPr>
           <a:xfrm>
-            <a:off x="193623" y="1240970"/>
-            <a:ext cx="11768527" cy="5382251"/>
-          </a:xfrm>
-          <a:prstGeom prst="roundRect">
-            <a:avLst/>
-          </a:prstGeom>
-        </p:spPr>
-        <p:style>
-          <a:lnRef idx="2">
-            <a:schemeClr val="accent3"/>
-          </a:lnRef>
-          <a:fillRef idx="1">
-            <a:schemeClr val="lt1"/>
-          </a:fillRef>
-          <a:effectRef idx="0">
-            <a:schemeClr val="accent3"/>
-          </a:effectRef>
-          <a:fontRef idx="minor">
-            <a:schemeClr val="dk1"/>
-          </a:fontRef>
-        </p:style>
-        <p:txBody>
-          <a:bodyPr rtlCol="0" anchor="ctr"/>
-          <a:lstStyle/>
-          <a:p>
-            <a:pPr algn="ctr"/>
-            <a:endParaRPr lang="de-DE"/>
-          </a:p>
-        </p:txBody>
-      </p:sp>
-      <p:sp>
-        <p:nvSpPr>
-          <p:cNvPr id="8" name="Inhaltsplatzhalter 2">
-            <a:extLst>
-              <a:ext uri="{FF2B5EF4-FFF2-40B4-BE49-F238E27FC236}">
-                <a16:creationId xmlns:a16="http://schemas.microsoft.com/office/drawing/2014/main" id="{3DBAED53-E2B0-B64F-FE8C-E9F34EE5905D}"/>
-              </a:ext>
-            </a:extLst>
-          </p:cNvPr>
-          <p:cNvSpPr txBox="1">
-            <a:spLocks/>
-          </p:cNvSpPr>
-          <p:nvPr/>
-        </p:nvSpPr>
-        <p:spPr>
-          <a:xfrm>
-            <a:off x="423472" y="1559658"/>
-            <a:ext cx="11327804" cy="4396299"/>
+            <a:off x="193623" y="5078627"/>
+            <a:ext cx="11768528" cy="1534168"/>
           </a:xfrm>
           <a:prstGeom prst="rect">
             <a:avLst/>
@@ -6715,1171 +7391,42 @@
             </a:lvl9pPr>
           </a:lstStyle>
           <a:p>
-            <a:pPr marL="0" indent="0" algn="just">
+            <a:pPr marL="0" indent="0">
               <a:buNone/>
             </a:pPr>
             <a:r>
               <a:rPr lang="de-DE" b="1" dirty="0"/>
-              <a:t>Aufgabe 4</a:t>
-            </a:r>
-          </a:p>
-          <a:p>
-            <a:pPr marL="0" indent="0" algn="just">
+              <a:t>HA</a:t>
+            </a:r>
+            <a:r>
+              <a:rPr lang="de-DE" dirty="0"/>
+              <a:t> - Arbeitsheft</a:t>
+            </a:r>
+          </a:p>
+          <a:p>
+            <a:r>
+              <a:rPr lang="de-DE" dirty="0"/>
+              <a:t>S. 31 – Zirkel				-- WDH</a:t>
+            </a:r>
+          </a:p>
+          <a:p>
+            <a:r>
+              <a:rPr lang="de-DE" dirty="0"/>
+              <a:t>S. 32 – Punktspiegelung		-- WDH</a:t>
+            </a:r>
+          </a:p>
+          <a:p>
+            <a:pPr marL="0" indent="0">
               <a:buNone/>
             </a:pPr>
-            <a:r>
-              <a:rPr lang="de-DE" dirty="0"/>
-              <a:t>Schreibe in dein Heft. Fülle die 7 Lücken!</a:t>
-            </a:r>
-          </a:p>
-        </p:txBody>
-      </p:sp>
-      <p:pic>
-        <p:nvPicPr>
-          <p:cNvPr id="7" name="Grafik 6" descr="Ein Bild, das Text, Screenshot, Schrift, Reihe enthält.&#10;&#10;KI-generierte Inhalte können fehlerhaft sein.">
-            <a:extLst>
-              <a:ext uri="{FF2B5EF4-FFF2-40B4-BE49-F238E27FC236}">
-                <a16:creationId xmlns:a16="http://schemas.microsoft.com/office/drawing/2014/main" id="{95072C44-CAFF-CD38-B399-577106DB52E8}"/>
-              </a:ext>
-            </a:extLst>
-          </p:cNvPr>
-          <p:cNvPicPr>
-            <a:picLocks noChangeAspect="1"/>
-          </p:cNvPicPr>
-          <p:nvPr/>
-        </p:nvPicPr>
-        <p:blipFill>
-          <a:blip r:embed="rId2"/>
-          <a:srcRect b="62363"/>
-          <a:stretch>
-            <a:fillRect/>
-          </a:stretch>
-        </p:blipFill>
-        <p:spPr>
-          <a:xfrm>
-            <a:off x="564292" y="2445501"/>
-            <a:ext cx="10975972" cy="2033255"/>
-          </a:xfrm>
-          <a:prstGeom prst="rect">
-            <a:avLst/>
-          </a:prstGeom>
-        </p:spPr>
-      </p:pic>
-      <p:sp>
-        <p:nvSpPr>
-          <p:cNvPr id="12" name="Abgerundetes Rechteck 11">
-            <a:extLst>
-              <a:ext uri="{FF2B5EF4-FFF2-40B4-BE49-F238E27FC236}">
-                <a16:creationId xmlns:a16="http://schemas.microsoft.com/office/drawing/2014/main" id="{61032D45-22C8-27E2-88FA-E300E574CFAC}"/>
-              </a:ext>
-            </a:extLst>
-          </p:cNvPr>
-          <p:cNvSpPr/>
-          <p:nvPr/>
-        </p:nvSpPr>
-        <p:spPr>
-          <a:xfrm>
-            <a:off x="7448816" y="3310758"/>
-            <a:ext cx="978492" cy="327454"/>
-          </a:xfrm>
-          <a:prstGeom prst="roundRect">
-            <a:avLst/>
-          </a:prstGeom>
-        </p:spPr>
-        <p:style>
-          <a:lnRef idx="2">
-            <a:schemeClr val="accent4">
-              <a:shade val="15000"/>
-            </a:schemeClr>
-          </a:lnRef>
-          <a:fillRef idx="1">
-            <a:schemeClr val="accent4"/>
-          </a:fillRef>
-          <a:effectRef idx="0">
-            <a:schemeClr val="accent4"/>
-          </a:effectRef>
-          <a:fontRef idx="minor">
-            <a:schemeClr val="lt1"/>
-          </a:fontRef>
-        </p:style>
-        <p:txBody>
-          <a:bodyPr rtlCol="0" anchor="ctr"/>
-          <a:lstStyle/>
-          <a:p>
-            <a:pPr algn="ctr"/>
-            <a:endParaRPr lang="de-DE"/>
-          </a:p>
-        </p:txBody>
-      </p:sp>
-      <p:pic>
-        <p:nvPicPr>
-          <p:cNvPr id="10" name="Grafik 9" descr="Ein Bild, das Text, Screenshot, Schrift, Reihe enthält.&#10;&#10;KI-generierte Inhalte können fehlerhaft sein.">
-            <a:extLst>
-              <a:ext uri="{FF2B5EF4-FFF2-40B4-BE49-F238E27FC236}">
-                <a16:creationId xmlns:a16="http://schemas.microsoft.com/office/drawing/2014/main" id="{CC7B0C13-CB69-8F75-79F8-5847E228B420}"/>
-              </a:ext>
-            </a:extLst>
-          </p:cNvPr>
-          <p:cNvPicPr>
-            <a:picLocks noChangeAspect="1"/>
-          </p:cNvPicPr>
-          <p:nvPr/>
-        </p:nvPicPr>
-        <p:blipFill>
-          <a:blip r:embed="rId2"/>
-          <a:srcRect t="62363"/>
-          <a:stretch>
-            <a:fillRect/>
-          </a:stretch>
-        </p:blipFill>
-        <p:spPr>
-          <a:xfrm>
-            <a:off x="564291" y="4399659"/>
-            <a:ext cx="10975971" cy="2033255"/>
-          </a:xfrm>
-          <a:prstGeom prst="rect">
-            <a:avLst/>
-          </a:prstGeom>
-        </p:spPr>
-      </p:pic>
-      <p:sp>
-        <p:nvSpPr>
-          <p:cNvPr id="14" name="Abgerundetes Rechteck 13">
-            <a:extLst>
-              <a:ext uri="{FF2B5EF4-FFF2-40B4-BE49-F238E27FC236}">
-                <a16:creationId xmlns:a16="http://schemas.microsoft.com/office/drawing/2014/main" id="{37CFF0AB-ED10-CC82-2819-D1DE8CEE3E6E}"/>
-              </a:ext>
-            </a:extLst>
-          </p:cNvPr>
-          <p:cNvSpPr/>
-          <p:nvPr/>
-        </p:nvSpPr>
-        <p:spPr>
-          <a:xfrm>
-            <a:off x="4203907" y="3301766"/>
-            <a:ext cx="1257779" cy="327454"/>
-          </a:xfrm>
-          <a:prstGeom prst="roundRect">
-            <a:avLst/>
-          </a:prstGeom>
-        </p:spPr>
-        <p:style>
-          <a:lnRef idx="2">
-            <a:schemeClr val="accent4">
-              <a:shade val="15000"/>
-            </a:schemeClr>
-          </a:lnRef>
-          <a:fillRef idx="1">
-            <a:schemeClr val="accent4"/>
-          </a:fillRef>
-          <a:effectRef idx="0">
-            <a:schemeClr val="accent4"/>
-          </a:effectRef>
-          <a:fontRef idx="minor">
-            <a:schemeClr val="lt1"/>
-          </a:fontRef>
-        </p:style>
-        <p:txBody>
-          <a:bodyPr rtlCol="0" anchor="ctr"/>
-          <a:lstStyle/>
-          <a:p>
-            <a:pPr algn="ctr"/>
-            <a:endParaRPr lang="de-DE"/>
-          </a:p>
-        </p:txBody>
-      </p:sp>
-      <p:sp>
-        <p:nvSpPr>
-          <p:cNvPr id="15" name="Abgerundetes Rechteck 14">
-            <a:extLst>
-              <a:ext uri="{FF2B5EF4-FFF2-40B4-BE49-F238E27FC236}">
-                <a16:creationId xmlns:a16="http://schemas.microsoft.com/office/drawing/2014/main" id="{A9450A1F-1F29-A887-1578-3D556CA1F316}"/>
-              </a:ext>
-            </a:extLst>
-          </p:cNvPr>
-          <p:cNvSpPr/>
-          <p:nvPr/>
-        </p:nvSpPr>
-        <p:spPr>
-          <a:xfrm>
-            <a:off x="1163389" y="3904035"/>
-            <a:ext cx="1209108" cy="408472"/>
-          </a:xfrm>
-          <a:prstGeom prst="roundRect">
-            <a:avLst/>
-          </a:prstGeom>
-        </p:spPr>
-        <p:style>
-          <a:lnRef idx="2">
-            <a:schemeClr val="accent4">
-              <a:shade val="15000"/>
-            </a:schemeClr>
-          </a:lnRef>
-          <a:fillRef idx="1">
-            <a:schemeClr val="accent4"/>
-          </a:fillRef>
-          <a:effectRef idx="0">
-            <a:schemeClr val="accent4"/>
-          </a:effectRef>
-          <a:fontRef idx="minor">
-            <a:schemeClr val="lt1"/>
-          </a:fontRef>
-        </p:style>
-        <p:txBody>
-          <a:bodyPr rtlCol="0" anchor="ctr"/>
-          <a:lstStyle/>
-          <a:p>
-            <a:pPr algn="ctr"/>
-            <a:endParaRPr lang="de-DE"/>
-          </a:p>
-        </p:txBody>
-      </p:sp>
-      <p:sp>
-        <p:nvSpPr>
-          <p:cNvPr id="16" name="Abgerundetes Rechteck 15">
-            <a:extLst>
-              <a:ext uri="{FF2B5EF4-FFF2-40B4-BE49-F238E27FC236}">
-                <a16:creationId xmlns:a16="http://schemas.microsoft.com/office/drawing/2014/main" id="{E7F67A79-8933-3ED0-7220-5395C2C2A1FF}"/>
-              </a:ext>
-            </a:extLst>
-          </p:cNvPr>
-          <p:cNvSpPr/>
-          <p:nvPr/>
-        </p:nvSpPr>
-        <p:spPr>
-          <a:xfrm>
-            <a:off x="5202289" y="3625554"/>
-            <a:ext cx="400217" cy="327454"/>
-          </a:xfrm>
-          <a:prstGeom prst="roundRect">
-            <a:avLst/>
-          </a:prstGeom>
-        </p:spPr>
-        <p:style>
-          <a:lnRef idx="2">
-            <a:schemeClr val="accent4">
-              <a:shade val="15000"/>
-            </a:schemeClr>
-          </a:lnRef>
-          <a:fillRef idx="1">
-            <a:schemeClr val="accent4"/>
-          </a:fillRef>
-          <a:effectRef idx="0">
-            <a:schemeClr val="accent4"/>
-          </a:effectRef>
-          <a:fontRef idx="minor">
-            <a:schemeClr val="lt1"/>
-          </a:fontRef>
-        </p:style>
-        <p:txBody>
-          <a:bodyPr rtlCol="0" anchor="ctr"/>
-          <a:lstStyle/>
-          <a:p>
-            <a:pPr algn="ctr"/>
-            <a:endParaRPr lang="de-DE"/>
-          </a:p>
-        </p:txBody>
-      </p:sp>
-      <p:sp>
-        <p:nvSpPr>
-          <p:cNvPr id="17" name="Abgerundetes Rechteck 16">
-            <a:extLst>
-              <a:ext uri="{FF2B5EF4-FFF2-40B4-BE49-F238E27FC236}">
-                <a16:creationId xmlns:a16="http://schemas.microsoft.com/office/drawing/2014/main" id="{A767E334-5E4D-C372-5BF2-0196170565D6}"/>
-              </a:ext>
-            </a:extLst>
-          </p:cNvPr>
-          <p:cNvSpPr/>
-          <p:nvPr/>
-        </p:nvSpPr>
-        <p:spPr>
-          <a:xfrm>
-            <a:off x="2782768" y="5364599"/>
-            <a:ext cx="1542097" cy="252431"/>
-          </a:xfrm>
-          <a:prstGeom prst="roundRect">
-            <a:avLst/>
-          </a:prstGeom>
-        </p:spPr>
-        <p:style>
-          <a:lnRef idx="2">
-            <a:schemeClr val="accent4">
-              <a:shade val="15000"/>
-            </a:schemeClr>
-          </a:lnRef>
-          <a:fillRef idx="1">
-            <a:schemeClr val="accent4"/>
-          </a:fillRef>
-          <a:effectRef idx="0">
-            <a:schemeClr val="accent4"/>
-          </a:effectRef>
-          <a:fontRef idx="minor">
-            <a:schemeClr val="lt1"/>
-          </a:fontRef>
-        </p:style>
-        <p:txBody>
-          <a:bodyPr rtlCol="0" anchor="ctr"/>
-          <a:lstStyle/>
-          <a:p>
-            <a:pPr algn="ctr"/>
-            <a:endParaRPr lang="de-DE"/>
-          </a:p>
-        </p:txBody>
-      </p:sp>
-      <p:sp>
-        <p:nvSpPr>
-          <p:cNvPr id="18" name="Abgerundetes Rechteck 17">
-            <a:extLst>
-              <a:ext uri="{FF2B5EF4-FFF2-40B4-BE49-F238E27FC236}">
-                <a16:creationId xmlns:a16="http://schemas.microsoft.com/office/drawing/2014/main" id="{05AB492E-296C-4064-5F48-B2653F6FDCF0}"/>
-              </a:ext>
-            </a:extLst>
-          </p:cNvPr>
-          <p:cNvSpPr/>
-          <p:nvPr/>
-        </p:nvSpPr>
-        <p:spPr>
-          <a:xfrm>
-            <a:off x="10063876" y="5069943"/>
-            <a:ext cx="1054549" cy="358504"/>
-          </a:xfrm>
-          <a:prstGeom prst="roundRect">
-            <a:avLst/>
-          </a:prstGeom>
-        </p:spPr>
-        <p:style>
-          <a:lnRef idx="2">
-            <a:schemeClr val="accent4">
-              <a:shade val="15000"/>
-            </a:schemeClr>
-          </a:lnRef>
-          <a:fillRef idx="1">
-            <a:schemeClr val="accent4"/>
-          </a:fillRef>
-          <a:effectRef idx="0">
-            <a:schemeClr val="accent4"/>
-          </a:effectRef>
-          <a:fontRef idx="minor">
-            <a:schemeClr val="lt1"/>
-          </a:fontRef>
-        </p:style>
-        <p:txBody>
-          <a:bodyPr rtlCol="0" anchor="ctr"/>
-          <a:lstStyle/>
-          <a:p>
-            <a:pPr algn="ctr"/>
-            <a:endParaRPr lang="de-DE"/>
-          </a:p>
-        </p:txBody>
-      </p:sp>
-      <p:sp>
-        <p:nvSpPr>
-          <p:cNvPr id="19" name="Abgerundetes Rechteck 18">
-            <a:extLst>
-              <a:ext uri="{FF2B5EF4-FFF2-40B4-BE49-F238E27FC236}">
-                <a16:creationId xmlns:a16="http://schemas.microsoft.com/office/drawing/2014/main" id="{2C185F5F-F40F-6013-3ACF-1161A30CE81C}"/>
-              </a:ext>
-            </a:extLst>
-          </p:cNvPr>
-          <p:cNvSpPr/>
-          <p:nvPr/>
-        </p:nvSpPr>
-        <p:spPr>
-          <a:xfrm>
-            <a:off x="9844433" y="5487673"/>
-            <a:ext cx="219443" cy="207383"/>
-          </a:xfrm>
-          <a:prstGeom prst="roundRect">
-            <a:avLst/>
-          </a:prstGeom>
-        </p:spPr>
-        <p:style>
-          <a:lnRef idx="2">
-            <a:schemeClr val="accent4">
-              <a:shade val="15000"/>
-            </a:schemeClr>
-          </a:lnRef>
-          <a:fillRef idx="1">
-            <a:schemeClr val="accent4"/>
-          </a:fillRef>
-          <a:effectRef idx="0">
-            <a:schemeClr val="accent4"/>
-          </a:effectRef>
-          <a:fontRef idx="minor">
-            <a:schemeClr val="lt1"/>
-          </a:fontRef>
-        </p:style>
-        <p:txBody>
-          <a:bodyPr rtlCol="0" anchor="ctr"/>
-          <a:lstStyle/>
-          <a:p>
-            <a:pPr algn="ctr"/>
-            <a:endParaRPr lang="de-DE"/>
+            <a:endParaRPr lang="de-DE" dirty="0"/>
           </a:p>
         </p:txBody>
       </p:sp>
     </p:spTree>
     <p:extLst>
       <p:ext uri="{BB962C8B-B14F-4D97-AF65-F5344CB8AC3E}">
-        <p14:creationId xmlns:p14="http://schemas.microsoft.com/office/powerpoint/2010/main" val="979213065"/>
-      </p:ext>
-    </p:extLst>
-  </p:cSld>
-  <p:clrMapOvr>
-    <a:masterClrMapping/>
-  </p:clrMapOvr>
-</p:sld>
-</file>
-
-<file path=ppt/slides/slide8.xml><?xml version="1.0" encoding="utf-8"?>
-<p:sld xmlns:a="http://schemas.openxmlformats.org/drawingml/2006/main" xmlns:r="http://schemas.openxmlformats.org/officeDocument/2006/relationships" xmlns:p="http://schemas.openxmlformats.org/presentationml/2006/main">
-  <p:cSld>
-    <p:spTree>
-      <p:nvGrpSpPr>
-        <p:cNvPr id="1" name="">
-          <a:extLst>
-            <a:ext uri="{FF2B5EF4-FFF2-40B4-BE49-F238E27FC236}">
-              <a16:creationId xmlns:a16="http://schemas.microsoft.com/office/drawing/2014/main" id="{2ED02AC3-C9C7-9CE6-4F7F-A97EAF4EFC0D}"/>
-            </a:ext>
-          </a:extLst>
-        </p:cNvPr>
-        <p:cNvGrpSpPr/>
-        <p:nvPr/>
-      </p:nvGrpSpPr>
-      <p:grpSpPr>
-        <a:xfrm>
-          <a:off x="0" y="0"/>
-          <a:ext cx="0" cy="0"/>
-          <a:chOff x="0" y="0"/>
-          <a:chExt cx="0" cy="0"/>
-        </a:xfrm>
-      </p:grpSpPr>
-      <p:sp>
-        <p:nvSpPr>
-          <p:cNvPr id="3" name="Titel 1">
-            <a:extLst>
-              <a:ext uri="{FF2B5EF4-FFF2-40B4-BE49-F238E27FC236}">
-                <a16:creationId xmlns:a16="http://schemas.microsoft.com/office/drawing/2014/main" id="{D3D9F893-A311-C558-12E3-F45F6034819D}"/>
-              </a:ext>
-            </a:extLst>
-          </p:cNvPr>
-          <p:cNvSpPr txBox="1">
-            <a:spLocks/>
-          </p:cNvSpPr>
-          <p:nvPr/>
-        </p:nvSpPr>
-        <p:spPr>
-          <a:xfrm>
-            <a:off x="193623" y="425086"/>
-            <a:ext cx="11768528" cy="549275"/>
-          </a:xfrm>
-          <a:prstGeom prst="rect">
-            <a:avLst/>
-          </a:prstGeom>
-        </p:spPr>
-        <p:txBody>
-          <a:bodyPr>
-            <a:normAutofit fontScale="90000" lnSpcReduction="20000"/>
-          </a:bodyPr>
-          <a:lstStyle>
-            <a:lvl1pPr algn="l" defTabSz="914400" rtl="0" eaLnBrk="1" latinLnBrk="0" hangingPunct="1">
-              <a:lnSpc>
-                <a:spcPct val="90000"/>
-              </a:lnSpc>
-              <a:spcBef>
-                <a:spcPct val="0"/>
-              </a:spcBef>
-              <a:buNone/>
-              <a:defRPr sz="4400" kern="1200">
-                <a:solidFill>
-                  <a:schemeClr val="tx1"/>
-                </a:solidFill>
-                <a:latin typeface="+mj-lt"/>
-                <a:ea typeface="+mj-ea"/>
-                <a:cs typeface="+mj-cs"/>
-              </a:defRPr>
-            </a:lvl1pPr>
-          </a:lstStyle>
-          <a:p>
-            <a:pPr algn="ctr"/>
-            <a:r>
-              <a:rPr lang="de-DE" dirty="0">
-                <a:latin typeface="ADLaM Display" panose="02010000000000000000" pitchFamily="2" charset="77"/>
-                <a:ea typeface="ADLaM Display" panose="02010000000000000000" pitchFamily="2" charset="77"/>
-                <a:cs typeface="ADLaM Display" panose="02010000000000000000" pitchFamily="2" charset="77"/>
-              </a:rPr>
-              <a:t>Wiederholung: Achsenspiegelung</a:t>
-            </a:r>
-          </a:p>
-        </p:txBody>
-      </p:sp>
-      <p:sp>
-        <p:nvSpPr>
-          <p:cNvPr id="6" name="Abgerundetes Rechteck 5">
-            <a:extLst>
-              <a:ext uri="{FF2B5EF4-FFF2-40B4-BE49-F238E27FC236}">
-                <a16:creationId xmlns:a16="http://schemas.microsoft.com/office/drawing/2014/main" id="{B19C94F8-25D8-B250-2A9D-ED79DFBE7943}"/>
-              </a:ext>
-            </a:extLst>
-          </p:cNvPr>
-          <p:cNvSpPr/>
-          <p:nvPr/>
-        </p:nvSpPr>
-        <p:spPr>
-          <a:xfrm>
-            <a:off x="193623" y="1240970"/>
-            <a:ext cx="11768527" cy="5382251"/>
-          </a:xfrm>
-          <a:prstGeom prst="roundRect">
-            <a:avLst/>
-          </a:prstGeom>
-        </p:spPr>
-        <p:style>
-          <a:lnRef idx="2">
-            <a:schemeClr val="accent3"/>
-          </a:lnRef>
-          <a:fillRef idx="1">
-            <a:schemeClr val="lt1"/>
-          </a:fillRef>
-          <a:effectRef idx="0">
-            <a:schemeClr val="accent3"/>
-          </a:effectRef>
-          <a:fontRef idx="minor">
-            <a:schemeClr val="dk1"/>
-          </a:fontRef>
-        </p:style>
-        <p:txBody>
-          <a:bodyPr rtlCol="0" anchor="ctr"/>
-          <a:lstStyle/>
-          <a:p>
-            <a:pPr algn="ctr"/>
-            <a:endParaRPr lang="de-DE" b="1" dirty="0"/>
-          </a:p>
-        </p:txBody>
-      </p:sp>
-      <p:sp>
-        <p:nvSpPr>
-          <p:cNvPr id="8" name="Inhaltsplatzhalter 2">
-            <a:extLst>
-              <a:ext uri="{FF2B5EF4-FFF2-40B4-BE49-F238E27FC236}">
-                <a16:creationId xmlns:a16="http://schemas.microsoft.com/office/drawing/2014/main" id="{F3CC78CB-074C-7C1B-F1D4-56E0B3AEAB72}"/>
-              </a:ext>
-            </a:extLst>
-          </p:cNvPr>
-          <p:cNvSpPr txBox="1">
-            <a:spLocks/>
-          </p:cNvSpPr>
-          <p:nvPr/>
-        </p:nvSpPr>
-        <p:spPr>
-          <a:xfrm>
-            <a:off x="423472" y="1559658"/>
-            <a:ext cx="11327804" cy="4396299"/>
-          </a:xfrm>
-          <a:prstGeom prst="rect">
-            <a:avLst/>
-          </a:prstGeom>
-        </p:spPr>
-        <p:txBody>
-          <a:bodyPr/>
-          <a:lstStyle>
-            <a:lvl1pPr marL="228600" indent="-228600" algn="l" defTabSz="914400" rtl="0" eaLnBrk="1" latinLnBrk="0" hangingPunct="1">
-              <a:lnSpc>
-                <a:spcPct val="90000"/>
-              </a:lnSpc>
-              <a:spcBef>
-                <a:spcPts val="1000"/>
-              </a:spcBef>
-              <a:buFont typeface="Arial" panose="020B0604020202020204" pitchFamily="34" charset="0"/>
-              <a:buChar char="•"/>
-              <a:defRPr sz="2800" kern="1200">
-                <a:solidFill>
-                  <a:schemeClr val="tx1"/>
-                </a:solidFill>
-                <a:latin typeface="+mn-lt"/>
-                <a:ea typeface="+mn-ea"/>
-                <a:cs typeface="+mn-cs"/>
-              </a:defRPr>
-            </a:lvl1pPr>
-            <a:lvl2pPr marL="685800" indent="-228600" algn="l" defTabSz="914400" rtl="0" eaLnBrk="1" latinLnBrk="0" hangingPunct="1">
-              <a:lnSpc>
-                <a:spcPct val="90000"/>
-              </a:lnSpc>
-              <a:spcBef>
-                <a:spcPts val="500"/>
-              </a:spcBef>
-              <a:buFont typeface="Arial" panose="020B0604020202020204" pitchFamily="34" charset="0"/>
-              <a:buChar char="•"/>
-              <a:defRPr sz="2400" kern="1200">
-                <a:solidFill>
-                  <a:schemeClr val="tx1"/>
-                </a:solidFill>
-                <a:latin typeface="+mn-lt"/>
-                <a:ea typeface="+mn-ea"/>
-                <a:cs typeface="+mn-cs"/>
-              </a:defRPr>
-            </a:lvl2pPr>
-            <a:lvl3pPr marL="1143000" indent="-228600" algn="l" defTabSz="914400" rtl="0" eaLnBrk="1" latinLnBrk="0" hangingPunct="1">
-              <a:lnSpc>
-                <a:spcPct val="90000"/>
-              </a:lnSpc>
-              <a:spcBef>
-                <a:spcPts val="500"/>
-              </a:spcBef>
-              <a:buFont typeface="Arial" panose="020B0604020202020204" pitchFamily="34" charset="0"/>
-              <a:buChar char="•"/>
-              <a:defRPr sz="2000" kern="1200">
-                <a:solidFill>
-                  <a:schemeClr val="tx1"/>
-                </a:solidFill>
-                <a:latin typeface="+mn-lt"/>
-                <a:ea typeface="+mn-ea"/>
-                <a:cs typeface="+mn-cs"/>
-              </a:defRPr>
-            </a:lvl3pPr>
-            <a:lvl4pPr marL="1600200" indent="-228600" algn="l" defTabSz="914400" rtl="0" eaLnBrk="1" latinLnBrk="0" hangingPunct="1">
-              <a:lnSpc>
-                <a:spcPct val="90000"/>
-              </a:lnSpc>
-              <a:spcBef>
-                <a:spcPts val="500"/>
-              </a:spcBef>
-              <a:buFont typeface="Arial" panose="020B0604020202020204" pitchFamily="34" charset="0"/>
-              <a:buChar char="•"/>
-              <a:defRPr sz="1800" kern="1200">
-                <a:solidFill>
-                  <a:schemeClr val="tx1"/>
-                </a:solidFill>
-                <a:latin typeface="+mn-lt"/>
-                <a:ea typeface="+mn-ea"/>
-                <a:cs typeface="+mn-cs"/>
-              </a:defRPr>
-            </a:lvl4pPr>
-            <a:lvl5pPr marL="2057400" indent="-228600" algn="l" defTabSz="914400" rtl="0" eaLnBrk="1" latinLnBrk="0" hangingPunct="1">
-              <a:lnSpc>
-                <a:spcPct val="90000"/>
-              </a:lnSpc>
-              <a:spcBef>
-                <a:spcPts val="500"/>
-              </a:spcBef>
-              <a:buFont typeface="Arial" panose="020B0604020202020204" pitchFamily="34" charset="0"/>
-              <a:buChar char="•"/>
-              <a:defRPr sz="1800" kern="1200">
-                <a:solidFill>
-                  <a:schemeClr val="tx1"/>
-                </a:solidFill>
-                <a:latin typeface="+mn-lt"/>
-                <a:ea typeface="+mn-ea"/>
-                <a:cs typeface="+mn-cs"/>
-              </a:defRPr>
-            </a:lvl5pPr>
-            <a:lvl6pPr marL="2514600" indent="-228600" algn="l" defTabSz="914400" rtl="0" eaLnBrk="1" latinLnBrk="0" hangingPunct="1">
-              <a:lnSpc>
-                <a:spcPct val="90000"/>
-              </a:lnSpc>
-              <a:spcBef>
-                <a:spcPts val="500"/>
-              </a:spcBef>
-              <a:buFont typeface="Arial" panose="020B0604020202020204" pitchFamily="34" charset="0"/>
-              <a:buChar char="•"/>
-              <a:defRPr sz="1800" kern="1200">
-                <a:solidFill>
-                  <a:schemeClr val="tx1"/>
-                </a:solidFill>
-                <a:latin typeface="+mn-lt"/>
-                <a:ea typeface="+mn-ea"/>
-                <a:cs typeface="+mn-cs"/>
-              </a:defRPr>
-            </a:lvl6pPr>
-            <a:lvl7pPr marL="2971800" indent="-228600" algn="l" defTabSz="914400" rtl="0" eaLnBrk="1" latinLnBrk="0" hangingPunct="1">
-              <a:lnSpc>
-                <a:spcPct val="90000"/>
-              </a:lnSpc>
-              <a:spcBef>
-                <a:spcPts val="500"/>
-              </a:spcBef>
-              <a:buFont typeface="Arial" panose="020B0604020202020204" pitchFamily="34" charset="0"/>
-              <a:buChar char="•"/>
-              <a:defRPr sz="1800" kern="1200">
-                <a:solidFill>
-                  <a:schemeClr val="tx1"/>
-                </a:solidFill>
-                <a:latin typeface="+mn-lt"/>
-                <a:ea typeface="+mn-ea"/>
-                <a:cs typeface="+mn-cs"/>
-              </a:defRPr>
-            </a:lvl7pPr>
-            <a:lvl8pPr marL="3429000" indent="-228600" algn="l" defTabSz="914400" rtl="0" eaLnBrk="1" latinLnBrk="0" hangingPunct="1">
-              <a:lnSpc>
-                <a:spcPct val="90000"/>
-              </a:lnSpc>
-              <a:spcBef>
-                <a:spcPts val="500"/>
-              </a:spcBef>
-              <a:buFont typeface="Arial" panose="020B0604020202020204" pitchFamily="34" charset="0"/>
-              <a:buChar char="•"/>
-              <a:defRPr sz="1800" kern="1200">
-                <a:solidFill>
-                  <a:schemeClr val="tx1"/>
-                </a:solidFill>
-                <a:latin typeface="+mn-lt"/>
-                <a:ea typeface="+mn-ea"/>
-                <a:cs typeface="+mn-cs"/>
-              </a:defRPr>
-            </a:lvl8pPr>
-            <a:lvl9pPr marL="3886200" indent="-228600" algn="l" defTabSz="914400" rtl="0" eaLnBrk="1" latinLnBrk="0" hangingPunct="1">
-              <a:lnSpc>
-                <a:spcPct val="90000"/>
-              </a:lnSpc>
-              <a:spcBef>
-                <a:spcPts val="500"/>
-              </a:spcBef>
-              <a:buFont typeface="Arial" panose="020B0604020202020204" pitchFamily="34" charset="0"/>
-              <a:buChar char="•"/>
-              <a:defRPr sz="1800" kern="1200">
-                <a:solidFill>
-                  <a:schemeClr val="tx1"/>
-                </a:solidFill>
-                <a:latin typeface="+mn-lt"/>
-                <a:ea typeface="+mn-ea"/>
-                <a:cs typeface="+mn-cs"/>
-              </a:defRPr>
-            </a:lvl9pPr>
-          </a:lstStyle>
-          <a:p>
-            <a:pPr marL="0" indent="0" algn="just">
-              <a:buNone/>
-            </a:pPr>
-            <a:r>
-              <a:rPr lang="de-DE" b="1" dirty="0"/>
-              <a:t>Übungsaufgaben &amp; HA</a:t>
-            </a:r>
-          </a:p>
-          <a:p>
-            <a:pPr algn="just"/>
-            <a:r>
-              <a:rPr lang="de-DE" dirty="0"/>
-              <a:t>Buch S. 94, Nr. 9 bis 12</a:t>
-            </a:r>
-          </a:p>
-          <a:p>
-            <a:pPr algn="just"/>
-            <a:r>
-              <a:rPr lang="de-DE" dirty="0"/>
-              <a:t>Arbeitsheft S.29</a:t>
-            </a:r>
-          </a:p>
-          <a:p>
-            <a:pPr marL="0" indent="0" algn="just">
-              <a:buNone/>
-            </a:pPr>
-            <a:endParaRPr lang="de-DE" dirty="0"/>
-          </a:p>
-        </p:txBody>
-      </p:sp>
-      <p:pic>
-        <p:nvPicPr>
-          <p:cNvPr id="2" name="Grafik 1" descr="Ein Bild, das Text, Origami enthält.&#10;&#10;KI-generierte Inhalte können fehlerhaft sein.">
-            <a:extLst>
-              <a:ext uri="{FF2B5EF4-FFF2-40B4-BE49-F238E27FC236}">
-                <a16:creationId xmlns:a16="http://schemas.microsoft.com/office/drawing/2014/main" id="{ED81C1C3-1B7F-1B08-B6A6-1661A19FC104}"/>
-              </a:ext>
-            </a:extLst>
-          </p:cNvPr>
-          <p:cNvPicPr>
-            <a:picLocks noChangeAspect="1"/>
-          </p:cNvPicPr>
-          <p:nvPr/>
-        </p:nvPicPr>
-        <p:blipFill>
-          <a:blip r:embed="rId2"/>
-          <a:stretch>
-            <a:fillRect/>
-          </a:stretch>
-        </p:blipFill>
-        <p:spPr>
-          <a:xfrm>
-            <a:off x="5131558" y="1556801"/>
-            <a:ext cx="6428096" cy="4949065"/>
-          </a:xfrm>
-          <a:prstGeom prst="rect">
-            <a:avLst/>
-          </a:prstGeom>
-        </p:spPr>
-      </p:pic>
-    </p:spTree>
-    <p:extLst>
-      <p:ext uri="{BB962C8B-B14F-4D97-AF65-F5344CB8AC3E}">
-        <p14:creationId xmlns:p14="http://schemas.microsoft.com/office/powerpoint/2010/main" val="3780975631"/>
-      </p:ext>
-    </p:extLst>
-  </p:cSld>
-  <p:clrMapOvr>
-    <a:masterClrMapping/>
-  </p:clrMapOvr>
-</p:sld>
-</file>
-
-<file path=ppt/slides/slide9.xml><?xml version="1.0" encoding="utf-8"?>
-<p:sld xmlns:a="http://schemas.openxmlformats.org/drawingml/2006/main" xmlns:r="http://schemas.openxmlformats.org/officeDocument/2006/relationships" xmlns:p="http://schemas.openxmlformats.org/presentationml/2006/main">
-  <p:cSld>
-    <p:spTree>
-      <p:nvGrpSpPr>
-        <p:cNvPr id="1" name="">
-          <a:extLst>
-            <a:ext uri="{FF2B5EF4-FFF2-40B4-BE49-F238E27FC236}">
-              <a16:creationId xmlns:a16="http://schemas.microsoft.com/office/drawing/2014/main" id="{410076A2-4E39-F17E-5863-B9953E6B7B98}"/>
-            </a:ext>
-          </a:extLst>
-        </p:cNvPr>
-        <p:cNvGrpSpPr/>
-        <p:nvPr/>
-      </p:nvGrpSpPr>
-      <p:grpSpPr>
-        <a:xfrm>
-          <a:off x="0" y="0"/>
-          <a:ext cx="0" cy="0"/>
-          <a:chOff x="0" y="0"/>
-          <a:chExt cx="0" cy="0"/>
-        </a:xfrm>
-      </p:grpSpPr>
-      <p:sp>
-        <p:nvSpPr>
-          <p:cNvPr id="3" name="Titel 1">
-            <a:extLst>
-              <a:ext uri="{FF2B5EF4-FFF2-40B4-BE49-F238E27FC236}">
-                <a16:creationId xmlns:a16="http://schemas.microsoft.com/office/drawing/2014/main" id="{DFAA0DE8-76AE-B16E-694F-B1EB7A6407D7}"/>
-              </a:ext>
-            </a:extLst>
-          </p:cNvPr>
-          <p:cNvSpPr txBox="1">
-            <a:spLocks/>
-          </p:cNvSpPr>
-          <p:nvPr/>
-        </p:nvSpPr>
-        <p:spPr>
-          <a:xfrm>
-            <a:off x="193623" y="425086"/>
-            <a:ext cx="11768528" cy="549275"/>
-          </a:xfrm>
-          <a:prstGeom prst="rect">
-            <a:avLst/>
-          </a:prstGeom>
-        </p:spPr>
-        <p:txBody>
-          <a:bodyPr>
-            <a:normAutofit fontScale="90000" lnSpcReduction="20000"/>
-          </a:bodyPr>
-          <a:lstStyle>
-            <a:lvl1pPr algn="l" defTabSz="914400" rtl="0" eaLnBrk="1" latinLnBrk="0" hangingPunct="1">
-              <a:lnSpc>
-                <a:spcPct val="90000"/>
-              </a:lnSpc>
-              <a:spcBef>
-                <a:spcPct val="0"/>
-              </a:spcBef>
-              <a:buNone/>
-              <a:defRPr sz="4400" kern="1200">
-                <a:solidFill>
-                  <a:schemeClr val="tx1"/>
-                </a:solidFill>
-                <a:latin typeface="+mj-lt"/>
-                <a:ea typeface="+mj-ea"/>
-                <a:cs typeface="+mj-cs"/>
-              </a:defRPr>
-            </a:lvl1pPr>
-          </a:lstStyle>
-          <a:p>
-            <a:pPr algn="ctr"/>
-            <a:r>
-              <a:rPr lang="de-DE" dirty="0">
-                <a:latin typeface="ADLaM Display" panose="02010000000000000000" pitchFamily="2" charset="77"/>
-                <a:ea typeface="ADLaM Display" panose="02010000000000000000" pitchFamily="2" charset="77"/>
-                <a:cs typeface="ADLaM Display" panose="02010000000000000000" pitchFamily="2" charset="77"/>
-              </a:rPr>
-              <a:t>Wiederholung: Achsenspiegelung</a:t>
-            </a:r>
-          </a:p>
-        </p:txBody>
-      </p:sp>
-      <p:sp>
-        <p:nvSpPr>
-          <p:cNvPr id="6" name="Abgerundetes Rechteck 5">
-            <a:extLst>
-              <a:ext uri="{FF2B5EF4-FFF2-40B4-BE49-F238E27FC236}">
-                <a16:creationId xmlns:a16="http://schemas.microsoft.com/office/drawing/2014/main" id="{A4413ECE-BED0-D2A0-6D41-846E970DD14A}"/>
-              </a:ext>
-            </a:extLst>
-          </p:cNvPr>
-          <p:cNvSpPr/>
-          <p:nvPr/>
-        </p:nvSpPr>
-        <p:spPr>
-          <a:xfrm>
-            <a:off x="193623" y="1240970"/>
-            <a:ext cx="11768527" cy="5382251"/>
-          </a:xfrm>
-          <a:prstGeom prst="roundRect">
-            <a:avLst/>
-          </a:prstGeom>
-        </p:spPr>
-        <p:style>
-          <a:lnRef idx="2">
-            <a:schemeClr val="accent3"/>
-          </a:lnRef>
-          <a:fillRef idx="1">
-            <a:schemeClr val="lt1"/>
-          </a:fillRef>
-          <a:effectRef idx="0">
-            <a:schemeClr val="accent3"/>
-          </a:effectRef>
-          <a:fontRef idx="minor">
-            <a:schemeClr val="dk1"/>
-          </a:fontRef>
-        </p:style>
-        <p:txBody>
-          <a:bodyPr rtlCol="0" anchor="ctr"/>
-          <a:lstStyle/>
-          <a:p>
-            <a:pPr algn="ctr"/>
-            <a:endParaRPr lang="de-DE" b="1" dirty="0"/>
-          </a:p>
-        </p:txBody>
-      </p:sp>
-      <p:sp>
-        <p:nvSpPr>
-          <p:cNvPr id="8" name="Inhaltsplatzhalter 2">
-            <a:extLst>
-              <a:ext uri="{FF2B5EF4-FFF2-40B4-BE49-F238E27FC236}">
-                <a16:creationId xmlns:a16="http://schemas.microsoft.com/office/drawing/2014/main" id="{C6D8DCA1-9362-872F-1CAF-10437B85BA4D}"/>
-              </a:ext>
-            </a:extLst>
-          </p:cNvPr>
-          <p:cNvSpPr txBox="1">
-            <a:spLocks/>
-          </p:cNvSpPr>
-          <p:nvPr/>
-        </p:nvSpPr>
-        <p:spPr>
-          <a:xfrm>
-            <a:off x="423472" y="1559658"/>
-            <a:ext cx="11327804" cy="4396299"/>
-          </a:xfrm>
-          <a:prstGeom prst="rect">
-            <a:avLst/>
-          </a:prstGeom>
-        </p:spPr>
-        <p:txBody>
-          <a:bodyPr/>
-          <a:lstStyle>
-            <a:lvl1pPr marL="228600" indent="-228600" algn="l" defTabSz="914400" rtl="0" eaLnBrk="1" latinLnBrk="0" hangingPunct="1">
-              <a:lnSpc>
-                <a:spcPct val="90000"/>
-              </a:lnSpc>
-              <a:spcBef>
-                <a:spcPts val="1000"/>
-              </a:spcBef>
-              <a:buFont typeface="Arial" panose="020B0604020202020204" pitchFamily="34" charset="0"/>
-              <a:buChar char="•"/>
-              <a:defRPr sz="2800" kern="1200">
-                <a:solidFill>
-                  <a:schemeClr val="tx1"/>
-                </a:solidFill>
-                <a:latin typeface="+mn-lt"/>
-                <a:ea typeface="+mn-ea"/>
-                <a:cs typeface="+mn-cs"/>
-              </a:defRPr>
-            </a:lvl1pPr>
-            <a:lvl2pPr marL="685800" indent="-228600" algn="l" defTabSz="914400" rtl="0" eaLnBrk="1" latinLnBrk="0" hangingPunct="1">
-              <a:lnSpc>
-                <a:spcPct val="90000"/>
-              </a:lnSpc>
-              <a:spcBef>
-                <a:spcPts val="500"/>
-              </a:spcBef>
-              <a:buFont typeface="Arial" panose="020B0604020202020204" pitchFamily="34" charset="0"/>
-              <a:buChar char="•"/>
-              <a:defRPr sz="2400" kern="1200">
-                <a:solidFill>
-                  <a:schemeClr val="tx1"/>
-                </a:solidFill>
-                <a:latin typeface="+mn-lt"/>
-                <a:ea typeface="+mn-ea"/>
-                <a:cs typeface="+mn-cs"/>
-              </a:defRPr>
-            </a:lvl2pPr>
-            <a:lvl3pPr marL="1143000" indent="-228600" algn="l" defTabSz="914400" rtl="0" eaLnBrk="1" latinLnBrk="0" hangingPunct="1">
-              <a:lnSpc>
-                <a:spcPct val="90000"/>
-              </a:lnSpc>
-              <a:spcBef>
-                <a:spcPts val="500"/>
-              </a:spcBef>
-              <a:buFont typeface="Arial" panose="020B0604020202020204" pitchFamily="34" charset="0"/>
-              <a:buChar char="•"/>
-              <a:defRPr sz="2000" kern="1200">
-                <a:solidFill>
-                  <a:schemeClr val="tx1"/>
-                </a:solidFill>
-                <a:latin typeface="+mn-lt"/>
-                <a:ea typeface="+mn-ea"/>
-                <a:cs typeface="+mn-cs"/>
-              </a:defRPr>
-            </a:lvl3pPr>
-            <a:lvl4pPr marL="1600200" indent="-228600" algn="l" defTabSz="914400" rtl="0" eaLnBrk="1" latinLnBrk="0" hangingPunct="1">
-              <a:lnSpc>
-                <a:spcPct val="90000"/>
-              </a:lnSpc>
-              <a:spcBef>
-                <a:spcPts val="500"/>
-              </a:spcBef>
-              <a:buFont typeface="Arial" panose="020B0604020202020204" pitchFamily="34" charset="0"/>
-              <a:buChar char="•"/>
-              <a:defRPr sz="1800" kern="1200">
-                <a:solidFill>
-                  <a:schemeClr val="tx1"/>
-                </a:solidFill>
-                <a:latin typeface="+mn-lt"/>
-                <a:ea typeface="+mn-ea"/>
-                <a:cs typeface="+mn-cs"/>
-              </a:defRPr>
-            </a:lvl4pPr>
-            <a:lvl5pPr marL="2057400" indent="-228600" algn="l" defTabSz="914400" rtl="0" eaLnBrk="1" latinLnBrk="0" hangingPunct="1">
-              <a:lnSpc>
-                <a:spcPct val="90000"/>
-              </a:lnSpc>
-              <a:spcBef>
-                <a:spcPts val="500"/>
-              </a:spcBef>
-              <a:buFont typeface="Arial" panose="020B0604020202020204" pitchFamily="34" charset="0"/>
-              <a:buChar char="•"/>
-              <a:defRPr sz="1800" kern="1200">
-                <a:solidFill>
-                  <a:schemeClr val="tx1"/>
-                </a:solidFill>
-                <a:latin typeface="+mn-lt"/>
-                <a:ea typeface="+mn-ea"/>
-                <a:cs typeface="+mn-cs"/>
-              </a:defRPr>
-            </a:lvl5pPr>
-            <a:lvl6pPr marL="2514600" indent="-228600" algn="l" defTabSz="914400" rtl="0" eaLnBrk="1" latinLnBrk="0" hangingPunct="1">
-              <a:lnSpc>
-                <a:spcPct val="90000"/>
-              </a:lnSpc>
-              <a:spcBef>
-                <a:spcPts val="500"/>
-              </a:spcBef>
-              <a:buFont typeface="Arial" panose="020B0604020202020204" pitchFamily="34" charset="0"/>
-              <a:buChar char="•"/>
-              <a:defRPr sz="1800" kern="1200">
-                <a:solidFill>
-                  <a:schemeClr val="tx1"/>
-                </a:solidFill>
-                <a:latin typeface="+mn-lt"/>
-                <a:ea typeface="+mn-ea"/>
-                <a:cs typeface="+mn-cs"/>
-              </a:defRPr>
-            </a:lvl6pPr>
-            <a:lvl7pPr marL="2971800" indent="-228600" algn="l" defTabSz="914400" rtl="0" eaLnBrk="1" latinLnBrk="0" hangingPunct="1">
-              <a:lnSpc>
-                <a:spcPct val="90000"/>
-              </a:lnSpc>
-              <a:spcBef>
-                <a:spcPts val="500"/>
-              </a:spcBef>
-              <a:buFont typeface="Arial" panose="020B0604020202020204" pitchFamily="34" charset="0"/>
-              <a:buChar char="•"/>
-              <a:defRPr sz="1800" kern="1200">
-                <a:solidFill>
-                  <a:schemeClr val="tx1"/>
-                </a:solidFill>
-                <a:latin typeface="+mn-lt"/>
-                <a:ea typeface="+mn-ea"/>
-                <a:cs typeface="+mn-cs"/>
-              </a:defRPr>
-            </a:lvl7pPr>
-            <a:lvl8pPr marL="3429000" indent="-228600" algn="l" defTabSz="914400" rtl="0" eaLnBrk="1" latinLnBrk="0" hangingPunct="1">
-              <a:lnSpc>
-                <a:spcPct val="90000"/>
-              </a:lnSpc>
-              <a:spcBef>
-                <a:spcPts val="500"/>
-              </a:spcBef>
-              <a:buFont typeface="Arial" panose="020B0604020202020204" pitchFamily="34" charset="0"/>
-              <a:buChar char="•"/>
-              <a:defRPr sz="1800" kern="1200">
-                <a:solidFill>
-                  <a:schemeClr val="tx1"/>
-                </a:solidFill>
-                <a:latin typeface="+mn-lt"/>
-                <a:ea typeface="+mn-ea"/>
-                <a:cs typeface="+mn-cs"/>
-              </a:defRPr>
-            </a:lvl8pPr>
-            <a:lvl9pPr marL="3886200" indent="-228600" algn="l" defTabSz="914400" rtl="0" eaLnBrk="1" latinLnBrk="0" hangingPunct="1">
-              <a:lnSpc>
-                <a:spcPct val="90000"/>
-              </a:lnSpc>
-              <a:spcBef>
-                <a:spcPts val="500"/>
-              </a:spcBef>
-              <a:buFont typeface="Arial" panose="020B0604020202020204" pitchFamily="34" charset="0"/>
-              <a:buChar char="•"/>
-              <a:defRPr sz="1800" kern="1200">
-                <a:solidFill>
-                  <a:schemeClr val="tx1"/>
-                </a:solidFill>
-                <a:latin typeface="+mn-lt"/>
-                <a:ea typeface="+mn-ea"/>
-                <a:cs typeface="+mn-cs"/>
-              </a:defRPr>
-            </a:lvl9pPr>
-          </a:lstStyle>
-          <a:p>
-            <a:pPr marL="0" indent="0" algn="just">
-              <a:buNone/>
-            </a:pPr>
-            <a:r>
-              <a:rPr lang="de-DE" b="1" dirty="0"/>
-              <a:t>Aufgabe </a:t>
-            </a:r>
-          </a:p>
-        </p:txBody>
-      </p:sp>
-      <p:pic>
-        <p:nvPicPr>
-          <p:cNvPr id="5" name="Grafik 4" descr="Ein Bild, das Text, Screenshot, Cartoon enthält.&#10;&#10;KI-generierte Inhalte können fehlerhaft sein.">
-            <a:extLst>
-              <a:ext uri="{FF2B5EF4-FFF2-40B4-BE49-F238E27FC236}">
-                <a16:creationId xmlns:a16="http://schemas.microsoft.com/office/drawing/2014/main" id="{C0F004F6-8F3D-C1B9-51DC-5329CA3F820F}"/>
-              </a:ext>
-            </a:extLst>
-          </p:cNvPr>
-          <p:cNvPicPr>
-            <a:picLocks noChangeAspect="1"/>
-          </p:cNvPicPr>
-          <p:nvPr/>
-        </p:nvPicPr>
-        <p:blipFill>
-          <a:blip r:embed="rId2"/>
-          <a:stretch>
-            <a:fillRect/>
-          </a:stretch>
-        </p:blipFill>
-        <p:spPr>
-          <a:xfrm>
-            <a:off x="588371" y="2214562"/>
-            <a:ext cx="10887898" cy="3402468"/>
-          </a:xfrm>
-          <a:prstGeom prst="rect">
-            <a:avLst/>
-          </a:prstGeom>
-        </p:spPr>
-      </p:pic>
-    </p:spTree>
-    <p:extLst>
-      <p:ext uri="{BB962C8B-B14F-4D97-AF65-F5344CB8AC3E}">
-        <p14:creationId xmlns:p14="http://schemas.microsoft.com/office/powerpoint/2010/main" val="1902653144"/>
+        <p14:creationId xmlns:p14="http://schemas.microsoft.com/office/powerpoint/2010/main" val="3519360287"/>
       </p:ext>
     </p:extLst>
   </p:cSld>

</xml_diff>

<commit_message>
Update: Alle Änderungen für Portainer.io Deployment
- Prisma Client Fehlerbehandlung für veralteten Client
- seatingOrder und statisticsOrder Funktionalität
- isReleased Fehlerbehandlung
- Login-Code Suche verbessert
- Grade Release Fehlerbehandlung
- Lesson Keywords Fehlerbehandlung
</commit_message>
<xml_diff>
--- a/J-M-Reihen/Mathe/Klasse 7/Kap.3 - Geometrische Abbildungen/#_Reihenplan.pptx
+++ b/J-M-Reihen/Mathe/Klasse 7/Kap.3 - Geometrische Abbildungen/#_Reihenplan.pptx
@@ -5,7 +5,7 @@
     <p:sldMasterId id="2147483648" r:id="rId1"/>
   </p:sldMasterIdLst>
   <p:notesMasterIdLst>
-    <p:notesMasterId r:id="rId12"/>
+    <p:notesMasterId r:id="rId13"/>
   </p:notesMasterIdLst>
   <p:sldIdLst>
     <p:sldId id="259" r:id="rId2"/>
@@ -14,10 +14,11 @@
     <p:sldId id="258" r:id="rId5"/>
     <p:sldId id="260" r:id="rId6"/>
     <p:sldId id="275" r:id="rId7"/>
-    <p:sldId id="276" r:id="rId8"/>
-    <p:sldId id="273" r:id="rId9"/>
-    <p:sldId id="267" r:id="rId10"/>
-    <p:sldId id="261" r:id="rId11"/>
+    <p:sldId id="277" r:id="rId8"/>
+    <p:sldId id="276" r:id="rId9"/>
+    <p:sldId id="273" r:id="rId10"/>
+    <p:sldId id="267" r:id="rId11"/>
+    <p:sldId id="261" r:id="rId12"/>
   </p:sldIdLst>
   <p:sldSz cx="12192000" cy="6858000"/>
   <p:notesSz cx="6858000" cy="9144000"/>
@@ -206,7 +207,7 @@
           <a:p>
             <a:fld id="{0A10E92E-5F19-834A-AA97-53FA2D660DCB}" type="datetimeFigureOut">
               <a:rPr lang="de-DE" smtClean="0"/>
-              <a:t>08.01.26</a:t>
+              <a:t>13.01.26</a:t>
             </a:fld>
             <a:endParaRPr lang="de-DE"/>
           </a:p>
@@ -730,7 +731,7 @@
           <a:p>
             <a:fld id="{5264360D-A3AE-044F-B6E9-FC0C70EEF33D}" type="slidenum">
               <a:rPr lang="de-DE" smtClean="0"/>
-              <a:t>7</a:t>
+              <a:t>8</a:t>
             </a:fld>
             <a:endParaRPr lang="de-DE"/>
           </a:p>
@@ -896,7 +897,7 @@
           <a:p>
             <a:fld id="{C72C0E08-E80E-9141-9781-077B3A888FD3}" type="datetimeFigureOut">
               <a:rPr lang="de-DE" smtClean="0"/>
-              <a:t>08.01.26</a:t>
+              <a:t>13.01.26</a:t>
             </a:fld>
             <a:endParaRPr lang="de-DE"/>
           </a:p>
@@ -1094,7 +1095,7 @@
           <a:p>
             <a:fld id="{C72C0E08-E80E-9141-9781-077B3A888FD3}" type="datetimeFigureOut">
               <a:rPr lang="de-DE" smtClean="0"/>
-              <a:t>08.01.26</a:t>
+              <a:t>13.01.26</a:t>
             </a:fld>
             <a:endParaRPr lang="de-DE"/>
           </a:p>
@@ -1302,7 +1303,7 @@
           <a:p>
             <a:fld id="{C72C0E08-E80E-9141-9781-077B3A888FD3}" type="datetimeFigureOut">
               <a:rPr lang="de-DE" smtClean="0"/>
-              <a:t>08.01.26</a:t>
+              <a:t>13.01.26</a:t>
             </a:fld>
             <a:endParaRPr lang="de-DE"/>
           </a:p>
@@ -1500,7 +1501,7 @@
           <a:p>
             <a:fld id="{C72C0E08-E80E-9141-9781-077B3A888FD3}" type="datetimeFigureOut">
               <a:rPr lang="de-DE" smtClean="0"/>
-              <a:t>08.01.26</a:t>
+              <a:t>13.01.26</a:t>
             </a:fld>
             <a:endParaRPr lang="de-DE"/>
           </a:p>
@@ -1775,7 +1776,7 @@
           <a:p>
             <a:fld id="{C72C0E08-E80E-9141-9781-077B3A888FD3}" type="datetimeFigureOut">
               <a:rPr lang="de-DE" smtClean="0"/>
-              <a:t>08.01.26</a:t>
+              <a:t>13.01.26</a:t>
             </a:fld>
             <a:endParaRPr lang="de-DE"/>
           </a:p>
@@ -2040,7 +2041,7 @@
           <a:p>
             <a:fld id="{C72C0E08-E80E-9141-9781-077B3A888FD3}" type="datetimeFigureOut">
               <a:rPr lang="de-DE" smtClean="0"/>
-              <a:t>08.01.26</a:t>
+              <a:t>13.01.26</a:t>
             </a:fld>
             <a:endParaRPr lang="de-DE"/>
           </a:p>
@@ -2452,7 +2453,7 @@
           <a:p>
             <a:fld id="{C72C0E08-E80E-9141-9781-077B3A888FD3}" type="datetimeFigureOut">
               <a:rPr lang="de-DE" smtClean="0"/>
-              <a:t>08.01.26</a:t>
+              <a:t>13.01.26</a:t>
             </a:fld>
             <a:endParaRPr lang="de-DE"/>
           </a:p>
@@ -2593,7 +2594,7 @@
           <a:p>
             <a:fld id="{C72C0E08-E80E-9141-9781-077B3A888FD3}" type="datetimeFigureOut">
               <a:rPr lang="de-DE" smtClean="0"/>
-              <a:t>08.01.26</a:t>
+              <a:t>13.01.26</a:t>
             </a:fld>
             <a:endParaRPr lang="de-DE"/>
           </a:p>
@@ -2706,7 +2707,7 @@
           <a:p>
             <a:fld id="{C72C0E08-E80E-9141-9781-077B3A888FD3}" type="datetimeFigureOut">
               <a:rPr lang="de-DE" smtClean="0"/>
-              <a:t>08.01.26</a:t>
+              <a:t>13.01.26</a:t>
             </a:fld>
             <a:endParaRPr lang="de-DE"/>
           </a:p>
@@ -3017,7 +3018,7 @@
           <a:p>
             <a:fld id="{C72C0E08-E80E-9141-9781-077B3A888FD3}" type="datetimeFigureOut">
               <a:rPr lang="de-DE" smtClean="0"/>
-              <a:t>08.01.26</a:t>
+              <a:t>13.01.26</a:t>
             </a:fld>
             <a:endParaRPr lang="de-DE"/>
           </a:p>
@@ -3305,7 +3306,7 @@
           <a:p>
             <a:fld id="{C72C0E08-E80E-9141-9781-077B3A888FD3}" type="datetimeFigureOut">
               <a:rPr lang="de-DE" smtClean="0"/>
-              <a:t>08.01.26</a:t>
+              <a:t>13.01.26</a:t>
             </a:fld>
             <a:endParaRPr lang="de-DE"/>
           </a:p>
@@ -3546,7 +3547,7 @@
           <a:p>
             <a:fld id="{C72C0E08-E80E-9141-9781-077B3A888FD3}" type="datetimeFigureOut">
               <a:rPr lang="de-DE" smtClean="0"/>
-              <a:t>08.01.26</a:t>
+              <a:t>13.01.26</a:t>
             </a:fld>
             <a:endParaRPr lang="de-DE"/>
           </a:p>
@@ -4181,7 +4182,7 @@
         <p:cNvPr id="1" name="">
           <a:extLst>
             <a:ext uri="{FF2B5EF4-FFF2-40B4-BE49-F238E27FC236}">
-              <a16:creationId xmlns:a16="http://schemas.microsoft.com/office/drawing/2014/main" id="{9222C1B5-FD3F-140B-0240-6286CB108925}"/>
+              <a16:creationId xmlns:a16="http://schemas.microsoft.com/office/drawing/2014/main" id="{D6F9E721-EB3B-BCB5-BE3B-CA6255C50FF9}"/>
             </a:ext>
           </a:extLst>
         </p:cNvPr>
@@ -4201,7 +4202,7 @@
           <p:cNvPr id="3" name="Titel 1">
             <a:extLst>
               <a:ext uri="{FF2B5EF4-FFF2-40B4-BE49-F238E27FC236}">
-                <a16:creationId xmlns:a16="http://schemas.microsoft.com/office/drawing/2014/main" id="{9EC30369-1B87-EE63-02B2-F5EE2C8932EA}"/>
+                <a16:creationId xmlns:a16="http://schemas.microsoft.com/office/drawing/2014/main" id="{68D2655B-9794-C641-BFA5-6367C8865A9C}"/>
               </a:ext>
             </a:extLst>
           </p:cNvPr>
@@ -4250,7 +4251,7 @@
                 <a:ea typeface="ADLaM Display" panose="02010000000000000000" pitchFamily="2" charset="77"/>
                 <a:cs typeface="ADLaM Display" panose="02010000000000000000" pitchFamily="2" charset="77"/>
               </a:rPr>
-              <a:t>Grundbegriffe</a:t>
+              <a:t>Wiederholung: Zirkel &amp; Punkspiegelung</a:t>
             </a:r>
           </a:p>
         </p:txBody>
@@ -4260,7 +4261,7 @@
           <p:cNvPr id="2" name="Inhaltsplatzhalter 2">
             <a:extLst>
               <a:ext uri="{FF2B5EF4-FFF2-40B4-BE49-F238E27FC236}">
-                <a16:creationId xmlns:a16="http://schemas.microsoft.com/office/drawing/2014/main" id="{28678534-CDB9-14A7-825C-F99236BE0A48}"/>
+                <a16:creationId xmlns:a16="http://schemas.microsoft.com/office/drawing/2014/main" id="{42FC0499-C856-06B5-5E9F-6DB0ABE3E14F}"/>
               </a:ext>
             </a:extLst>
           </p:cNvPr>
@@ -4271,8 +4272,8 @@
         </p:nvSpPr>
         <p:spPr>
           <a:xfrm>
-            <a:off x="193623" y="5577840"/>
-            <a:ext cx="11768528" cy="1034955"/>
+            <a:off x="193623" y="5078627"/>
+            <a:ext cx="11768528" cy="1534168"/>
           </a:xfrm>
           <a:prstGeom prst="rect">
             <a:avLst/>
@@ -4450,25 +4451,37 @@
             </a:pPr>
             <a:r>
               <a:rPr lang="de-DE" b="1" dirty="0"/>
-              <a:t>HA - </a:t>
+              <a:t>HA</a:t>
             </a:r>
             <a:r>
               <a:rPr lang="de-DE" dirty="0"/>
-              <a:t>Arbeitsheft </a:t>
+              <a:t> - Arbeitsheft</a:t>
             </a:r>
           </a:p>
           <a:p>
             <a:r>
               <a:rPr lang="de-DE" dirty="0"/>
-              <a:t>S. 33 bis 37 - Doppelspiegelung</a:t>
-            </a:r>
+              <a:t>S. 31 – Zirkel				-- WDH</a:t>
+            </a:r>
+          </a:p>
+          <a:p>
+            <a:r>
+              <a:rPr lang="de-DE" dirty="0"/>
+              <a:t>S. 32 – Punktspiegelung		-- WDH</a:t>
+            </a:r>
+          </a:p>
+          <a:p>
+            <a:pPr marL="0" indent="0">
+              <a:buNone/>
+            </a:pPr>
+            <a:endParaRPr lang="de-DE" dirty="0"/>
           </a:p>
         </p:txBody>
       </p:sp>
     </p:spTree>
     <p:extLst>
       <p:ext uri="{BB962C8B-B14F-4D97-AF65-F5344CB8AC3E}">
-        <p14:creationId xmlns:p14="http://schemas.microsoft.com/office/powerpoint/2010/main" val="2611820202"/>
+        <p14:creationId xmlns:p14="http://schemas.microsoft.com/office/powerpoint/2010/main" val="3519360287"/>
       </p:ext>
     </p:extLst>
   </p:cSld>
@@ -4478,7 +4491,7 @@
 </p:sld>
 </file>
 
-<file path=ppt/slides/slide2.xml><?xml version="1.0" encoding="utf-8"?>
+<file path=ppt/slides/slide11.xml><?xml version="1.0" encoding="utf-8"?>
 <p:sld xmlns:a="http://schemas.openxmlformats.org/drawingml/2006/main" xmlns:r="http://schemas.openxmlformats.org/officeDocument/2006/relationships" xmlns:p="http://schemas.openxmlformats.org/presentationml/2006/main">
   <p:cSld>
     <p:spTree>
@@ -4486,7 +4499,7 @@
         <p:cNvPr id="1" name="">
           <a:extLst>
             <a:ext uri="{FF2B5EF4-FFF2-40B4-BE49-F238E27FC236}">
-              <a16:creationId xmlns:a16="http://schemas.microsoft.com/office/drawing/2014/main" id="{53DF5F4C-102E-2FAA-E0F6-EAC29427C1C2}"/>
+              <a16:creationId xmlns:a16="http://schemas.microsoft.com/office/drawing/2014/main" id="{9222C1B5-FD3F-140B-0240-6286CB108925}"/>
             </a:ext>
           </a:extLst>
         </p:cNvPr>
@@ -4503,436 +4516,21 @@
       </p:grpSpPr>
       <p:sp>
         <p:nvSpPr>
-          <p:cNvPr id="2" name="Titel 1">
-            <a:extLst>
-              <a:ext uri="{FF2B5EF4-FFF2-40B4-BE49-F238E27FC236}">
-                <a16:creationId xmlns:a16="http://schemas.microsoft.com/office/drawing/2014/main" id="{68DC2F80-0867-583C-AC58-8829AB16F9DD}"/>
-              </a:ext>
-            </a:extLst>
-          </p:cNvPr>
-          <p:cNvSpPr>
-            <a:spLocks noGrp="1"/>
-          </p:cNvSpPr>
-          <p:nvPr>
-            <p:ph type="title"/>
-          </p:nvPr>
+          <p:cNvPr id="3" name="Titel 1">
+            <a:extLst>
+              <a:ext uri="{FF2B5EF4-FFF2-40B4-BE49-F238E27FC236}">
+                <a16:creationId xmlns:a16="http://schemas.microsoft.com/office/drawing/2014/main" id="{9EC30369-1B87-EE63-02B2-F5EE2C8932EA}"/>
+              </a:ext>
+            </a:extLst>
+          </p:cNvPr>
+          <p:cNvSpPr txBox="1">
+            <a:spLocks/>
+          </p:cNvSpPr>
+          <p:nvPr/>
         </p:nvSpPr>
         <p:spPr>
           <a:xfrm>
             <a:off x="193623" y="425086"/>
-            <a:ext cx="11768528" cy="549275"/>
-          </a:xfrm>
-        </p:spPr>
-        <p:txBody>
-          <a:bodyPr>
-            <a:normAutofit fontScale="90000"/>
-          </a:bodyPr>
-          <a:lstStyle/>
-          <a:p>
-            <a:pPr algn="ctr"/>
-            <a:r>
-              <a:rPr lang="de-DE" dirty="0">
-                <a:latin typeface="ADLaM Display" panose="02010000000000000000" pitchFamily="2" charset="77"/>
-                <a:ea typeface="ADLaM Display" panose="02010000000000000000" pitchFamily="2" charset="77"/>
-                <a:cs typeface="ADLaM Display" panose="02010000000000000000" pitchFamily="2" charset="77"/>
-              </a:rPr>
-              <a:t>Sitzordnung Computerraum</a:t>
-            </a:r>
-          </a:p>
-        </p:txBody>
-      </p:sp>
-      <p:sp>
-        <p:nvSpPr>
-          <p:cNvPr id="3" name="Inhaltsplatzhalter 2">
-            <a:extLst>
-              <a:ext uri="{FF2B5EF4-FFF2-40B4-BE49-F238E27FC236}">
-                <a16:creationId xmlns:a16="http://schemas.microsoft.com/office/drawing/2014/main" id="{FB5C29FB-88F6-4809-15BC-1B0316BD3AC4}"/>
-              </a:ext>
-            </a:extLst>
-          </p:cNvPr>
-          <p:cNvSpPr>
-            <a:spLocks noGrp="1"/>
-          </p:cNvSpPr>
-          <p:nvPr>
-            <p:ph sz="half" idx="1"/>
-          </p:nvPr>
-        </p:nvSpPr>
-        <p:spPr>
-          <a:xfrm>
-            <a:off x="193623" y="1497496"/>
-            <a:ext cx="11768528" cy="5115299"/>
-          </a:xfrm>
-        </p:spPr>
-        <p:txBody>
-          <a:bodyPr>
-            <a:normAutofit fontScale="92500" lnSpcReduction="20000"/>
-          </a:bodyPr>
-          <a:lstStyle/>
-          <a:p>
-            <a:pPr marL="0" indent="0" fontAlgn="ctr">
-              <a:buNone/>
-            </a:pPr>
-            <a:r>
-              <a:rPr lang="de-DE" dirty="0"/>
-              <a:t>Louisa					Marlene K.		 Adela</a:t>
-            </a:r>
-          </a:p>
-          <a:p>
-            <a:pPr marL="0" indent="0" fontAlgn="ctr">
-              <a:buNone/>
-            </a:pPr>
-            <a:r>
-              <a:rPr lang="de-DE" dirty="0"/>
-              <a:t>Julia		Marlene G.		 	Jasmin 		Friederike</a:t>
-            </a:r>
-          </a:p>
-          <a:p>
-            <a:pPr marL="0" indent="0" fontAlgn="ctr">
-              <a:buNone/>
-            </a:pPr>
-            <a:endParaRPr lang="de-DE" dirty="0"/>
-          </a:p>
-          <a:p>
-            <a:pPr marL="0" indent="0" fontAlgn="ctr">
-              <a:buNone/>
-            </a:pPr>
-            <a:r>
-              <a:rPr lang="de-DE" dirty="0"/>
-              <a:t>Jonas		Samuel			Dennis		Luise</a:t>
-            </a:r>
-          </a:p>
-          <a:p>
-            <a:pPr marL="0" indent="0" algn="just" fontAlgn="ctr">
-              <a:buNone/>
-            </a:pPr>
-            <a:r>
-              <a:rPr lang="de-DE" dirty="0"/>
-              <a:t>Kilian 		Jan				Vincent 		Hannah</a:t>
-            </a:r>
-          </a:p>
-          <a:p>
-            <a:pPr marL="0" indent="0" fontAlgn="ctr">
-              <a:buNone/>
-            </a:pPr>
-            <a:endParaRPr lang="de-DE" dirty="0"/>
-          </a:p>
-          <a:p>
-            <a:pPr marL="0" indent="0" fontAlgn="ctr">
-              <a:buNone/>
-            </a:pPr>
-            <a:endParaRPr lang="de-DE" dirty="0"/>
-          </a:p>
-          <a:p>
-            <a:pPr marL="0" indent="0" fontAlgn="ctr">
-              <a:buNone/>
-            </a:pPr>
-            <a:r>
-              <a:rPr lang="de-DE" dirty="0"/>
-              <a:t>Miró 		Freya				Felix			Niklas</a:t>
-            </a:r>
-          </a:p>
-          <a:p>
-            <a:pPr marL="0" indent="0" fontAlgn="ctr">
-              <a:buNone/>
-            </a:pPr>
-            <a:r>
-              <a:rPr lang="de-DE" dirty="0"/>
-              <a:t>Jonathan 	Josefine			</a:t>
-            </a:r>
-            <a:r>
-              <a:rPr lang="de-DE" dirty="0" err="1"/>
-              <a:t>Lennas</a:t>
-            </a:r>
-            <a:r>
-              <a:rPr lang="de-DE" dirty="0"/>
-              <a:t>		Nils</a:t>
-            </a:r>
-          </a:p>
-          <a:p>
-            <a:pPr marL="0" indent="0" fontAlgn="ctr">
-              <a:buNone/>
-            </a:pPr>
-            <a:endParaRPr lang="de-DE" dirty="0"/>
-          </a:p>
-          <a:p>
-            <a:pPr marL="0" indent="0" fontAlgn="ctr">
-              <a:buNone/>
-            </a:pPr>
-            <a:r>
-              <a:rPr lang="de-DE" dirty="0"/>
-              <a:t>Louis		Bruno				Fabio			Robin</a:t>
-            </a:r>
-          </a:p>
-          <a:p>
-            <a:pPr marL="0" indent="0" fontAlgn="ctr">
-              <a:buNone/>
-            </a:pPr>
-            <a:r>
-              <a:rPr lang="de-DE" dirty="0"/>
-              <a:t>Arthur 	Andreas			Jakob		 	Paul</a:t>
-            </a:r>
-          </a:p>
-        </p:txBody>
-      </p:sp>
-    </p:spTree>
-    <p:extLst>
-      <p:ext uri="{BB962C8B-B14F-4D97-AF65-F5344CB8AC3E}">
-        <p14:creationId xmlns:p14="http://schemas.microsoft.com/office/powerpoint/2010/main" val="3335560466"/>
-      </p:ext>
-    </p:extLst>
-  </p:cSld>
-  <p:clrMapOvr>
-    <a:masterClrMapping/>
-  </p:clrMapOvr>
-</p:sld>
-</file>
-
-<file path=ppt/slides/slide3.xml><?xml version="1.0" encoding="utf-8"?>
-<p:sld xmlns:a="http://schemas.openxmlformats.org/drawingml/2006/main" xmlns:r="http://schemas.openxmlformats.org/officeDocument/2006/relationships" xmlns:p="http://schemas.openxmlformats.org/presentationml/2006/main">
-  <p:cSld>
-    <p:spTree>
-      <p:nvGrpSpPr>
-        <p:cNvPr id="1" name=""/>
-        <p:cNvGrpSpPr/>
-        <p:nvPr/>
-      </p:nvGrpSpPr>
-      <p:grpSpPr>
-        <a:xfrm>
-          <a:off x="0" y="0"/>
-          <a:ext cx="0" cy="0"/>
-          <a:chOff x="0" y="0"/>
-          <a:chExt cx="0" cy="0"/>
-        </a:xfrm>
-      </p:grpSpPr>
-      <p:pic>
-        <p:nvPicPr>
-          <p:cNvPr id="10" name="Grafik 9" descr="Ein Bild, das Text, Papier, Brief, Origami enthält.&#10;&#10;KI-generierte Inhalte können fehlerhaft sein.">
-            <a:extLst>
-              <a:ext uri="{FF2B5EF4-FFF2-40B4-BE49-F238E27FC236}">
-                <a16:creationId xmlns:a16="http://schemas.microsoft.com/office/drawing/2014/main" id="{A4BE09B9-6415-6507-A377-A5DAD30E29A1}"/>
-              </a:ext>
-            </a:extLst>
-          </p:cNvPr>
-          <p:cNvPicPr>
-            <a:picLocks noChangeAspect="1"/>
-          </p:cNvPicPr>
-          <p:nvPr/>
-        </p:nvPicPr>
-        <p:blipFill>
-          <a:blip r:embed="rId3"/>
-          <a:srcRect b="28743"/>
-          <a:stretch>
-            <a:fillRect/>
-          </a:stretch>
-        </p:blipFill>
-        <p:spPr>
-          <a:xfrm>
-            <a:off x="0" y="468441"/>
-            <a:ext cx="5924918" cy="5448926"/>
-          </a:xfrm>
-          <a:prstGeom prst="rect">
-            <a:avLst/>
-          </a:prstGeom>
-        </p:spPr>
-      </p:pic>
-      <p:pic>
-        <p:nvPicPr>
-          <p:cNvPr id="12" name="Grafik 11" descr="Ein Bild, das Text, Schrift, Reihe, Diagramm enthält.&#10;&#10;KI-generierte Inhalte können fehlerhaft sein.">
-            <a:extLst>
-              <a:ext uri="{FF2B5EF4-FFF2-40B4-BE49-F238E27FC236}">
-                <a16:creationId xmlns:a16="http://schemas.microsoft.com/office/drawing/2014/main" id="{E2B21C04-4E69-2ACA-5B47-6F85E6498F34}"/>
-              </a:ext>
-            </a:extLst>
-          </p:cNvPr>
-          <p:cNvPicPr>
-            <a:picLocks noChangeAspect="1"/>
-          </p:cNvPicPr>
-          <p:nvPr/>
-        </p:nvPicPr>
-        <p:blipFill>
-          <a:blip r:embed="rId4"/>
-          <a:stretch>
-            <a:fillRect/>
-          </a:stretch>
-        </p:blipFill>
-        <p:spPr>
-          <a:xfrm>
-            <a:off x="6096000" y="3762532"/>
-            <a:ext cx="6048117" cy="1244184"/>
-          </a:xfrm>
-          <a:prstGeom prst="rect">
-            <a:avLst/>
-          </a:prstGeom>
-        </p:spPr>
-      </p:pic>
-      <p:pic>
-        <p:nvPicPr>
-          <p:cNvPr id="15" name="Grafik 14" descr="Ein Bild, das Text, Papier, Brief, Origami enthält.&#10;&#10;KI-generierte Inhalte können fehlerhaft sein.">
-            <a:extLst>
-              <a:ext uri="{FF2B5EF4-FFF2-40B4-BE49-F238E27FC236}">
-                <a16:creationId xmlns:a16="http://schemas.microsoft.com/office/drawing/2014/main" id="{721158B0-DCA0-18E3-E2BB-A2D9AF0126FD}"/>
-              </a:ext>
-            </a:extLst>
-          </p:cNvPr>
-          <p:cNvPicPr>
-            <a:picLocks noChangeAspect="1"/>
-          </p:cNvPicPr>
-          <p:nvPr/>
-        </p:nvPicPr>
-        <p:blipFill>
-          <a:blip r:embed="rId3"/>
-          <a:srcRect t="71257"/>
-          <a:stretch>
-            <a:fillRect/>
-          </a:stretch>
-        </p:blipFill>
-        <p:spPr>
-          <a:xfrm>
-            <a:off x="6096000" y="1499016"/>
-            <a:ext cx="6101642" cy="2263516"/>
-          </a:xfrm>
-          <a:prstGeom prst="rect">
-            <a:avLst/>
-          </a:prstGeom>
-        </p:spPr>
-      </p:pic>
-    </p:spTree>
-    <p:extLst>
-      <p:ext uri="{BB962C8B-B14F-4D97-AF65-F5344CB8AC3E}">
-        <p14:creationId xmlns:p14="http://schemas.microsoft.com/office/powerpoint/2010/main" val="330369928"/>
-      </p:ext>
-    </p:extLst>
-  </p:cSld>
-  <p:clrMapOvr>
-    <a:masterClrMapping/>
-  </p:clrMapOvr>
-</p:sld>
-</file>
-
-<file path=ppt/slides/slide4.xml><?xml version="1.0" encoding="utf-8"?>
-<p:sld xmlns:a="http://schemas.openxmlformats.org/drawingml/2006/main" xmlns:r="http://schemas.openxmlformats.org/officeDocument/2006/relationships" xmlns:p="http://schemas.openxmlformats.org/presentationml/2006/main">
-  <p:cSld>
-    <p:spTree>
-      <p:nvGrpSpPr>
-        <p:cNvPr id="1" name=""/>
-        <p:cNvGrpSpPr/>
-        <p:nvPr/>
-      </p:nvGrpSpPr>
-      <p:grpSpPr>
-        <a:xfrm>
-          <a:off x="0" y="0"/>
-          <a:ext cx="0" cy="0"/>
-          <a:chOff x="0" y="0"/>
-          <a:chExt cx="0" cy="0"/>
-        </a:xfrm>
-      </p:grpSpPr>
-      <p:pic>
-        <p:nvPicPr>
-          <p:cNvPr id="2" name="Grafik 1" descr="Ein Bild, das Text, Screenshot, Schrift, Brief enthält.&#10;&#10;KI-generierte Inhalte können fehlerhaft sein.">
-            <a:extLst>
-              <a:ext uri="{FF2B5EF4-FFF2-40B4-BE49-F238E27FC236}">
-                <a16:creationId xmlns:a16="http://schemas.microsoft.com/office/drawing/2014/main" id="{1530B3CA-E079-015A-6244-3B16165C6FD6}"/>
-              </a:ext>
-            </a:extLst>
-          </p:cNvPr>
-          <p:cNvPicPr>
-            <a:picLocks noChangeAspect="1"/>
-          </p:cNvPicPr>
-          <p:nvPr/>
-        </p:nvPicPr>
-        <p:blipFill>
-          <a:blip r:embed="rId2"/>
-          <a:stretch>
-            <a:fillRect/>
-          </a:stretch>
-        </p:blipFill>
-        <p:spPr>
-          <a:xfrm>
-            <a:off x="3267856" y="-1863"/>
-            <a:ext cx="5666282" cy="6873850"/>
-          </a:xfrm>
-          <a:prstGeom prst="rect">
-            <a:avLst/>
-          </a:prstGeom>
-        </p:spPr>
-      </p:pic>
-    </p:spTree>
-    <p:extLst>
-      <p:ext uri="{BB962C8B-B14F-4D97-AF65-F5344CB8AC3E}">
-        <p14:creationId xmlns:p14="http://schemas.microsoft.com/office/powerpoint/2010/main" val="3079377886"/>
-      </p:ext>
-    </p:extLst>
-  </p:cSld>
-  <p:clrMapOvr>
-    <a:masterClrMapping/>
-  </p:clrMapOvr>
-</p:sld>
-</file>
-
-<file path=ppt/slides/slide5.xml><?xml version="1.0" encoding="utf-8"?>
-<p:sld xmlns:a="http://schemas.openxmlformats.org/drawingml/2006/main" xmlns:r="http://schemas.openxmlformats.org/officeDocument/2006/relationships" xmlns:p="http://schemas.openxmlformats.org/presentationml/2006/main">
-  <p:cSld>
-    <p:spTree>
-      <p:nvGrpSpPr>
-        <p:cNvPr id="1" name=""/>
-        <p:cNvGrpSpPr/>
-        <p:nvPr/>
-      </p:nvGrpSpPr>
-      <p:grpSpPr>
-        <a:xfrm>
-          <a:off x="0" y="0"/>
-          <a:ext cx="0" cy="0"/>
-          <a:chOff x="0" y="0"/>
-          <a:chExt cx="0" cy="0"/>
-        </a:xfrm>
-      </p:grpSpPr>
-      <p:pic>
-        <p:nvPicPr>
-          <p:cNvPr id="11" name="Grafik 10" descr="Ein Bild, das Text, Schrift, Reihe, Origami enthält.&#10;&#10;KI-generierte Inhalte können fehlerhaft sein.">
-            <a:extLst>
-              <a:ext uri="{FF2B5EF4-FFF2-40B4-BE49-F238E27FC236}">
-                <a16:creationId xmlns:a16="http://schemas.microsoft.com/office/drawing/2014/main" id="{B861861D-BCA9-26B9-DCB6-C80CD54D52C4}"/>
-              </a:ext>
-            </a:extLst>
-          </p:cNvPr>
-          <p:cNvPicPr>
-            <a:picLocks noChangeAspect="1"/>
-          </p:cNvPicPr>
-          <p:nvPr/>
-        </p:nvPicPr>
-        <p:blipFill>
-          <a:blip r:embed="rId2"/>
-          <a:stretch>
-            <a:fillRect/>
-          </a:stretch>
-        </p:blipFill>
-        <p:spPr>
-          <a:xfrm>
-            <a:off x="432098" y="4218535"/>
-            <a:ext cx="7970721" cy="2298305"/>
-          </a:xfrm>
-          <a:prstGeom prst="rect">
-            <a:avLst/>
-          </a:prstGeom>
-        </p:spPr>
-      </p:pic>
-      <p:sp>
-        <p:nvSpPr>
-          <p:cNvPr id="3" name="Titel 1">
-            <a:extLst>
-              <a:ext uri="{FF2B5EF4-FFF2-40B4-BE49-F238E27FC236}">
-                <a16:creationId xmlns:a16="http://schemas.microsoft.com/office/drawing/2014/main" id="{BA140C9D-1408-E733-FF1E-44847D93BFFB}"/>
-              </a:ext>
-            </a:extLst>
-          </p:cNvPr>
-          <p:cNvSpPr txBox="1">
-            <a:spLocks/>
-          </p:cNvSpPr>
-          <p:nvPr/>
-        </p:nvSpPr>
-        <p:spPr>
-          <a:xfrm>
-            <a:off x="211736" y="141622"/>
             <a:ext cx="11768528" cy="549275"/>
           </a:xfrm>
           <a:prstGeom prst="rect">
@@ -4970,17 +4568,17 @@
                 <a:ea typeface="ADLaM Display" panose="02010000000000000000" pitchFamily="2" charset="77"/>
                 <a:cs typeface="ADLaM Display" panose="02010000000000000000" pitchFamily="2" charset="77"/>
               </a:rPr>
-              <a:t>Wiederholung: Achsenspiegelung</a:t>
-            </a:r>
-          </a:p>
-        </p:txBody>
-      </p:sp>
-      <p:sp>
-        <p:nvSpPr>
-          <p:cNvPr id="8" name="Inhaltsplatzhalter 2">
-            <a:extLst>
-              <a:ext uri="{FF2B5EF4-FFF2-40B4-BE49-F238E27FC236}">
-                <a16:creationId xmlns:a16="http://schemas.microsoft.com/office/drawing/2014/main" id="{D1B812B5-42BF-7EF8-4EF2-953E9E589C6F}"/>
+              <a:t>Grundbegriffe</a:t>
+            </a:r>
+          </a:p>
+        </p:txBody>
+      </p:sp>
+      <p:sp>
+        <p:nvSpPr>
+          <p:cNvPr id="2" name="Inhaltsplatzhalter 2">
+            <a:extLst>
+              <a:ext uri="{FF2B5EF4-FFF2-40B4-BE49-F238E27FC236}">
+                <a16:creationId xmlns:a16="http://schemas.microsoft.com/office/drawing/2014/main" id="{28678534-CDB9-14A7-825C-F99236BE0A48}"/>
               </a:ext>
             </a:extLst>
           </p:cNvPr>
@@ -4991,8 +4589,8 @@
         </p:nvSpPr>
         <p:spPr>
           <a:xfrm>
-            <a:off x="432098" y="919579"/>
-            <a:ext cx="11327804" cy="2600862"/>
+            <a:off x="193623" y="5577840"/>
+            <a:ext cx="11768528" cy="1034955"/>
           </a:xfrm>
           <a:prstGeom prst="rect">
             <a:avLst/>
@@ -5165,330 +4763,30 @@
             </a:lvl9pPr>
           </a:lstStyle>
           <a:p>
-            <a:pPr marL="0" indent="0" algn="just">
+            <a:pPr marL="0" indent="0">
               <a:buNone/>
             </a:pPr>
             <a:r>
-              <a:rPr lang="de-DE" sz="2000" b="1" dirty="0"/>
-              <a:t>Aufgabe 1</a:t>
-            </a:r>
-          </a:p>
-          <a:p>
-            <a:pPr marL="0" indent="0" algn="just">
-              <a:buNone/>
-            </a:pPr>
-            <a:r>
-              <a:rPr lang="de-DE" sz="2000" dirty="0"/>
-              <a:t>Zeichne das Dreieck ABC mit den Eckpunkten A(2/3), B(8,5/1) und C(5/4) sowie die Gerade CD durch die Punkte C und D(3/0). Spiegele dann das Dreieck ABC an der Geraden CD.</a:t>
-            </a:r>
-          </a:p>
-          <a:p>
-            <a:pPr marL="0" indent="0" algn="just">
-              <a:buNone/>
-            </a:pPr>
-            <a:r>
-              <a:rPr lang="de-DE" sz="2000" b="1" dirty="0"/>
-              <a:t>Aufgabe 2</a:t>
-            </a:r>
-          </a:p>
-          <a:p>
-            <a:pPr marL="0" indent="0" algn="just">
-              <a:buNone/>
-            </a:pPr>
-            <a:r>
-              <a:rPr lang="de-DE" sz="2000" dirty="0"/>
-              <a:t>Schreibe einen Text der folgende Begriffe beinhaltet:</a:t>
-            </a:r>
-          </a:p>
-          <a:p>
-            <a:pPr marL="0" indent="0" algn="just">
-              <a:buNone/>
-            </a:pPr>
-            <a:r>
-              <a:rPr lang="de-DE" sz="1800" dirty="0">
-                <a:solidFill>
-                  <a:schemeClr val="tx2">
-                    <a:lumMod val="75000"/>
-                    <a:lumOff val="25000"/>
-                  </a:schemeClr>
-                </a:solidFill>
-                <a:latin typeface="Cavolini" panose="03000502040302020204" pitchFamily="66" charset="0"/>
-                <a:ea typeface="ADLaM Display" panose="02010000000000000000" pitchFamily="2" charset="77"/>
-                <a:cs typeface="Cavolini" panose="03000502040302020204" pitchFamily="66" charset="0"/>
-              </a:rPr>
-              <a:t>Originalpunkt, Spiegelachse, parallel, Abstand, Bildpunkt, P, verschiedene Seiten, denselben, P‘, Fixpunkt, Achsenspiegelung, Mittellinie, Geodreieck</a:t>
-            </a:r>
-          </a:p>
-          <a:p>
-            <a:pPr marL="0" indent="0" algn="just">
-              <a:buNone/>
-            </a:pPr>
-            <a:r>
-              <a:rPr lang="de-DE" sz="1800" b="1" dirty="0"/>
-              <a:t>Aufgabe 3</a:t>
-            </a:r>
-          </a:p>
-          <a:p>
-            <a:pPr marL="0" indent="0" algn="just">
-              <a:buNone/>
-            </a:pPr>
-            <a:r>
-              <a:rPr lang="de-DE" sz="1800" dirty="0"/>
-              <a:t>Schreibe in dein Heft. Fülle die 5 Lücken!</a:t>
-            </a:r>
-          </a:p>
-          <a:p>
-            <a:pPr marL="0" indent="0" algn="just">
-              <a:buNone/>
-            </a:pPr>
-            <a:endParaRPr lang="de-DE" sz="1800" dirty="0">
-              <a:solidFill>
-                <a:schemeClr val="tx2">
-                  <a:lumMod val="75000"/>
-                  <a:lumOff val="25000"/>
-                </a:schemeClr>
-              </a:solidFill>
-              <a:latin typeface="Cavolini" panose="03000502040302020204" pitchFamily="66" charset="0"/>
-              <a:ea typeface="ADLaM Display" panose="02010000000000000000" pitchFamily="2" charset="77"/>
-              <a:cs typeface="Cavolini" panose="03000502040302020204" pitchFamily="66" charset="0"/>
-            </a:endParaRPr>
-          </a:p>
-        </p:txBody>
-      </p:sp>
-      <p:sp>
-        <p:nvSpPr>
-          <p:cNvPr id="4" name="Abgerundetes Rechteck 3">
-            <a:extLst>
-              <a:ext uri="{FF2B5EF4-FFF2-40B4-BE49-F238E27FC236}">
-                <a16:creationId xmlns:a16="http://schemas.microsoft.com/office/drawing/2014/main" id="{B6DCCC7E-20F0-289F-2793-F4B96F42B2A8}"/>
-              </a:ext>
-            </a:extLst>
-          </p:cNvPr>
-          <p:cNvSpPr/>
-          <p:nvPr/>
-        </p:nvSpPr>
-        <p:spPr>
-          <a:xfrm>
-            <a:off x="2649291" y="4733105"/>
-            <a:ext cx="1154613" cy="227915"/>
-          </a:xfrm>
-          <a:prstGeom prst="roundRect">
-            <a:avLst/>
-          </a:prstGeom>
-        </p:spPr>
-        <p:style>
-          <a:lnRef idx="2">
-            <a:schemeClr val="accent4">
-              <a:shade val="15000"/>
-            </a:schemeClr>
-          </a:lnRef>
-          <a:fillRef idx="1">
-            <a:schemeClr val="accent4"/>
-          </a:fillRef>
-          <a:effectRef idx="0">
-            <a:schemeClr val="accent4"/>
-          </a:effectRef>
-          <a:fontRef idx="minor">
-            <a:schemeClr val="lt1"/>
-          </a:fontRef>
-        </p:style>
-        <p:txBody>
-          <a:bodyPr rtlCol="0" anchor="ctr"/>
-          <a:lstStyle/>
-          <a:p>
-            <a:pPr algn="ctr"/>
-            <a:endParaRPr lang="de-DE" sz="1400"/>
-          </a:p>
-        </p:txBody>
-      </p:sp>
-      <p:sp>
-        <p:nvSpPr>
-          <p:cNvPr id="5" name="Abgerundetes Rechteck 4">
-            <a:extLst>
-              <a:ext uri="{FF2B5EF4-FFF2-40B4-BE49-F238E27FC236}">
-                <a16:creationId xmlns:a16="http://schemas.microsoft.com/office/drawing/2014/main" id="{7AD7AD1C-F1E6-B229-1865-3325B3626DB3}"/>
-              </a:ext>
-            </a:extLst>
-          </p:cNvPr>
-          <p:cNvSpPr/>
-          <p:nvPr/>
-        </p:nvSpPr>
-        <p:spPr>
-          <a:xfrm>
-            <a:off x="3278868" y="5229409"/>
-            <a:ext cx="899572" cy="253285"/>
-          </a:xfrm>
-          <a:prstGeom prst="roundRect">
-            <a:avLst/>
-          </a:prstGeom>
-        </p:spPr>
-        <p:style>
-          <a:lnRef idx="2">
-            <a:schemeClr val="accent4">
-              <a:shade val="15000"/>
-            </a:schemeClr>
-          </a:lnRef>
-          <a:fillRef idx="1">
-            <a:schemeClr val="accent4"/>
-          </a:fillRef>
-          <a:effectRef idx="0">
-            <a:schemeClr val="accent4"/>
-          </a:effectRef>
-          <a:fontRef idx="minor">
-            <a:schemeClr val="lt1"/>
-          </a:fontRef>
-        </p:style>
-        <p:txBody>
-          <a:bodyPr rtlCol="0" anchor="ctr"/>
-          <a:lstStyle/>
-          <a:p>
-            <a:pPr algn="ctr"/>
-            <a:endParaRPr lang="de-DE" sz="1400"/>
-          </a:p>
-        </p:txBody>
-      </p:sp>
-      <p:sp>
-        <p:nvSpPr>
-          <p:cNvPr id="7" name="Abgerundetes Rechteck 6">
-            <a:extLst>
-              <a:ext uri="{FF2B5EF4-FFF2-40B4-BE49-F238E27FC236}">
-                <a16:creationId xmlns:a16="http://schemas.microsoft.com/office/drawing/2014/main" id="{835BEB63-3444-7293-A9BA-C749865B0DEE}"/>
-              </a:ext>
-            </a:extLst>
-          </p:cNvPr>
-          <p:cNvSpPr/>
-          <p:nvPr/>
-        </p:nvSpPr>
-        <p:spPr>
-          <a:xfrm>
-            <a:off x="1962500" y="5482694"/>
-            <a:ext cx="899572" cy="204874"/>
-          </a:xfrm>
-          <a:prstGeom prst="roundRect">
-            <a:avLst/>
-          </a:prstGeom>
-        </p:spPr>
-        <p:style>
-          <a:lnRef idx="2">
-            <a:schemeClr val="accent4">
-              <a:shade val="15000"/>
-            </a:schemeClr>
-          </a:lnRef>
-          <a:fillRef idx="1">
-            <a:schemeClr val="accent4"/>
-          </a:fillRef>
-          <a:effectRef idx="0">
-            <a:schemeClr val="accent4"/>
-          </a:effectRef>
-          <a:fontRef idx="minor">
-            <a:schemeClr val="lt1"/>
-          </a:fontRef>
-        </p:style>
-        <p:txBody>
-          <a:bodyPr rtlCol="0" anchor="ctr"/>
-          <a:lstStyle/>
-          <a:p>
-            <a:pPr algn="ctr"/>
-            <a:endParaRPr lang="de-DE" sz="1400"/>
-          </a:p>
-        </p:txBody>
-      </p:sp>
-      <p:sp>
-        <p:nvSpPr>
-          <p:cNvPr id="9" name="Abgerundetes Rechteck 8">
-            <a:extLst>
-              <a:ext uri="{FF2B5EF4-FFF2-40B4-BE49-F238E27FC236}">
-                <a16:creationId xmlns:a16="http://schemas.microsoft.com/office/drawing/2014/main" id="{105D1C43-F261-11EF-566C-98049B5E033E}"/>
-              </a:ext>
-            </a:extLst>
-          </p:cNvPr>
-          <p:cNvSpPr/>
-          <p:nvPr/>
-        </p:nvSpPr>
-        <p:spPr>
-          <a:xfrm>
-            <a:off x="7750459" y="4466088"/>
-            <a:ext cx="471766" cy="267017"/>
-          </a:xfrm>
-          <a:prstGeom prst="roundRect">
-            <a:avLst/>
-          </a:prstGeom>
-        </p:spPr>
-        <p:style>
-          <a:lnRef idx="2">
-            <a:schemeClr val="accent4">
-              <a:shade val="15000"/>
-            </a:schemeClr>
-          </a:lnRef>
-          <a:fillRef idx="1">
-            <a:schemeClr val="accent4"/>
-          </a:fillRef>
-          <a:effectRef idx="0">
-            <a:schemeClr val="accent4"/>
-          </a:effectRef>
-          <a:fontRef idx="minor">
-            <a:schemeClr val="lt1"/>
-          </a:fontRef>
-        </p:style>
-        <p:txBody>
-          <a:bodyPr rtlCol="0" anchor="ctr"/>
-          <a:lstStyle/>
-          <a:p>
-            <a:pPr algn="ctr"/>
-            <a:endParaRPr lang="de-DE" sz="1400"/>
-          </a:p>
-        </p:txBody>
-      </p:sp>
-      <p:sp>
-        <p:nvSpPr>
-          <p:cNvPr id="10" name="Abgerundetes Rechteck 9">
-            <a:extLst>
-              <a:ext uri="{FF2B5EF4-FFF2-40B4-BE49-F238E27FC236}">
-                <a16:creationId xmlns:a16="http://schemas.microsoft.com/office/drawing/2014/main" id="{43E74064-7903-448D-E415-AB4B6B6BA2B5}"/>
-              </a:ext>
-            </a:extLst>
-          </p:cNvPr>
-          <p:cNvSpPr/>
-          <p:nvPr/>
-        </p:nvSpPr>
-        <p:spPr>
-          <a:xfrm>
-            <a:off x="6727027" y="5847717"/>
-            <a:ext cx="249846" cy="273354"/>
-          </a:xfrm>
-          <a:prstGeom prst="roundRect">
-            <a:avLst/>
-          </a:prstGeom>
-        </p:spPr>
-        <p:style>
-          <a:lnRef idx="2">
-            <a:schemeClr val="accent4">
-              <a:shade val="15000"/>
-            </a:schemeClr>
-          </a:lnRef>
-          <a:fillRef idx="1">
-            <a:schemeClr val="accent4"/>
-          </a:fillRef>
-          <a:effectRef idx="0">
-            <a:schemeClr val="accent4"/>
-          </a:effectRef>
-          <a:fontRef idx="minor">
-            <a:schemeClr val="lt1"/>
-          </a:fontRef>
-        </p:style>
-        <p:txBody>
-          <a:bodyPr rtlCol="0" anchor="ctr"/>
-          <a:lstStyle/>
-          <a:p>
-            <a:pPr algn="ctr"/>
-            <a:endParaRPr lang="de-DE" sz="1400"/>
+              <a:rPr lang="de-DE" b="1" dirty="0"/>
+              <a:t>HA - </a:t>
+            </a:r>
+            <a:r>
+              <a:rPr lang="de-DE" dirty="0"/>
+              <a:t>Arbeitsheft </a:t>
+            </a:r>
+          </a:p>
+          <a:p>
+            <a:r>
+              <a:rPr lang="de-DE" dirty="0"/>
+              <a:t>S. 33 bis 37 - Doppelspiegelung</a:t>
+            </a:r>
           </a:p>
         </p:txBody>
       </p:sp>
     </p:spTree>
     <p:extLst>
       <p:ext uri="{BB962C8B-B14F-4D97-AF65-F5344CB8AC3E}">
-        <p14:creationId xmlns:p14="http://schemas.microsoft.com/office/powerpoint/2010/main" val="3178181211"/>
+        <p14:creationId xmlns:p14="http://schemas.microsoft.com/office/powerpoint/2010/main" val="2611820202"/>
       </p:ext>
     </p:extLst>
   </p:cSld>
@@ -5498,7 +4796,7 @@
 </p:sld>
 </file>
 
-<file path=ppt/slides/slide6.xml><?xml version="1.0" encoding="utf-8"?>
+<file path=ppt/slides/slide2.xml><?xml version="1.0" encoding="utf-8"?>
 <p:sld xmlns:a="http://schemas.openxmlformats.org/drawingml/2006/main" xmlns:r="http://schemas.openxmlformats.org/officeDocument/2006/relationships" xmlns:p="http://schemas.openxmlformats.org/presentationml/2006/main">
   <p:cSld>
     <p:spTree>
@@ -5506,7 +4804,7 @@
         <p:cNvPr id="1" name="">
           <a:extLst>
             <a:ext uri="{FF2B5EF4-FFF2-40B4-BE49-F238E27FC236}">
-              <a16:creationId xmlns:a16="http://schemas.microsoft.com/office/drawing/2014/main" id="{8D19743F-1585-79F3-1290-17ED8D6958FC}"/>
+              <a16:creationId xmlns:a16="http://schemas.microsoft.com/office/drawing/2014/main" id="{53DF5F4C-102E-2FAA-E0F6-EAC29427C1C2}"/>
             </a:ext>
           </a:extLst>
         </p:cNvPr>
@@ -5523,10 +4821,425 @@
       </p:grpSpPr>
       <p:sp>
         <p:nvSpPr>
+          <p:cNvPr id="2" name="Titel 1">
+            <a:extLst>
+              <a:ext uri="{FF2B5EF4-FFF2-40B4-BE49-F238E27FC236}">
+                <a16:creationId xmlns:a16="http://schemas.microsoft.com/office/drawing/2014/main" id="{68DC2F80-0867-583C-AC58-8829AB16F9DD}"/>
+              </a:ext>
+            </a:extLst>
+          </p:cNvPr>
+          <p:cNvSpPr>
+            <a:spLocks noGrp="1"/>
+          </p:cNvSpPr>
+          <p:nvPr>
+            <p:ph type="title"/>
+          </p:nvPr>
+        </p:nvSpPr>
+        <p:spPr>
+          <a:xfrm>
+            <a:off x="193623" y="425086"/>
+            <a:ext cx="11768528" cy="549275"/>
+          </a:xfrm>
+        </p:spPr>
+        <p:txBody>
+          <a:bodyPr>
+            <a:normAutofit fontScale="90000"/>
+          </a:bodyPr>
+          <a:lstStyle/>
+          <a:p>
+            <a:pPr algn="ctr"/>
+            <a:r>
+              <a:rPr lang="de-DE" dirty="0">
+                <a:latin typeface="ADLaM Display" panose="02010000000000000000" pitchFamily="2" charset="77"/>
+                <a:ea typeface="ADLaM Display" panose="02010000000000000000" pitchFamily="2" charset="77"/>
+                <a:cs typeface="ADLaM Display" panose="02010000000000000000" pitchFamily="2" charset="77"/>
+              </a:rPr>
+              <a:t>Sitzordnung Computerraum</a:t>
+            </a:r>
+          </a:p>
+        </p:txBody>
+      </p:sp>
+      <p:sp>
+        <p:nvSpPr>
+          <p:cNvPr id="3" name="Inhaltsplatzhalter 2">
+            <a:extLst>
+              <a:ext uri="{FF2B5EF4-FFF2-40B4-BE49-F238E27FC236}">
+                <a16:creationId xmlns:a16="http://schemas.microsoft.com/office/drawing/2014/main" id="{FB5C29FB-88F6-4809-15BC-1B0316BD3AC4}"/>
+              </a:ext>
+            </a:extLst>
+          </p:cNvPr>
+          <p:cNvSpPr>
+            <a:spLocks noGrp="1"/>
+          </p:cNvSpPr>
+          <p:nvPr>
+            <p:ph sz="half" idx="1"/>
+          </p:nvPr>
+        </p:nvSpPr>
+        <p:spPr>
+          <a:xfrm>
+            <a:off x="193623" y="1497496"/>
+            <a:ext cx="11768528" cy="5115299"/>
+          </a:xfrm>
+        </p:spPr>
+        <p:txBody>
+          <a:bodyPr>
+            <a:normAutofit fontScale="92500" lnSpcReduction="20000"/>
+          </a:bodyPr>
+          <a:lstStyle/>
+          <a:p>
+            <a:pPr marL="0" indent="0" fontAlgn="ctr">
+              <a:buNone/>
+            </a:pPr>
+            <a:r>
+              <a:rPr lang="de-DE" dirty="0"/>
+              <a:t>Louisa					Marlene K.		 Adela</a:t>
+            </a:r>
+          </a:p>
+          <a:p>
+            <a:pPr marL="0" indent="0" fontAlgn="ctr">
+              <a:buNone/>
+            </a:pPr>
+            <a:r>
+              <a:rPr lang="de-DE" dirty="0"/>
+              <a:t>Julia		Marlene G.		 	Jasmin 		Friederike</a:t>
+            </a:r>
+          </a:p>
+          <a:p>
+            <a:pPr marL="0" indent="0" fontAlgn="ctr">
+              <a:buNone/>
+            </a:pPr>
+            <a:endParaRPr lang="de-DE" dirty="0"/>
+          </a:p>
+          <a:p>
+            <a:pPr marL="0" indent="0" fontAlgn="ctr">
+              <a:buNone/>
+            </a:pPr>
+            <a:r>
+              <a:rPr lang="de-DE" dirty="0"/>
+              <a:t>Jonas		Samuel			Dennis		Luise</a:t>
+            </a:r>
+          </a:p>
+          <a:p>
+            <a:pPr marL="0" indent="0" algn="just" fontAlgn="ctr">
+              <a:buNone/>
+            </a:pPr>
+            <a:r>
+              <a:rPr lang="de-DE" dirty="0"/>
+              <a:t>Kilian 		Jan				Vincent 		Hannah</a:t>
+            </a:r>
+          </a:p>
+          <a:p>
+            <a:pPr marL="0" indent="0" fontAlgn="ctr">
+              <a:buNone/>
+            </a:pPr>
+            <a:endParaRPr lang="de-DE" dirty="0"/>
+          </a:p>
+          <a:p>
+            <a:pPr marL="0" indent="0" fontAlgn="ctr">
+              <a:buNone/>
+            </a:pPr>
+            <a:endParaRPr lang="de-DE" dirty="0"/>
+          </a:p>
+          <a:p>
+            <a:pPr marL="0" indent="0" fontAlgn="ctr">
+              <a:buNone/>
+            </a:pPr>
+            <a:r>
+              <a:rPr lang="de-DE" dirty="0"/>
+              <a:t>Miró 		Freya				Felix			Niklas</a:t>
+            </a:r>
+          </a:p>
+          <a:p>
+            <a:pPr marL="0" indent="0" fontAlgn="ctr">
+              <a:buNone/>
+            </a:pPr>
+            <a:r>
+              <a:rPr lang="de-DE" dirty="0"/>
+              <a:t>Jonathan 	Josefine			</a:t>
+            </a:r>
+            <a:r>
+              <a:rPr lang="de-DE" dirty="0" err="1"/>
+              <a:t>Lennas</a:t>
+            </a:r>
+            <a:r>
+              <a:rPr lang="de-DE" dirty="0"/>
+              <a:t>		Nils</a:t>
+            </a:r>
+          </a:p>
+          <a:p>
+            <a:pPr marL="0" indent="0" fontAlgn="ctr">
+              <a:buNone/>
+            </a:pPr>
+            <a:endParaRPr lang="de-DE" dirty="0"/>
+          </a:p>
+          <a:p>
+            <a:pPr marL="0" indent="0" fontAlgn="ctr">
+              <a:buNone/>
+            </a:pPr>
+            <a:r>
+              <a:rPr lang="de-DE" dirty="0"/>
+              <a:t>Louis		Bruno				Fabio			Robin</a:t>
+            </a:r>
+          </a:p>
+          <a:p>
+            <a:pPr marL="0" indent="0" fontAlgn="ctr">
+              <a:buNone/>
+            </a:pPr>
+            <a:r>
+              <a:rPr lang="de-DE" dirty="0"/>
+              <a:t>Arthur 	Andreas			Jakob		 	Paul</a:t>
+            </a:r>
+          </a:p>
+        </p:txBody>
+      </p:sp>
+    </p:spTree>
+    <p:extLst>
+      <p:ext uri="{BB962C8B-B14F-4D97-AF65-F5344CB8AC3E}">
+        <p14:creationId xmlns:p14="http://schemas.microsoft.com/office/powerpoint/2010/main" val="3335560466"/>
+      </p:ext>
+    </p:extLst>
+  </p:cSld>
+  <p:clrMapOvr>
+    <a:masterClrMapping/>
+  </p:clrMapOvr>
+</p:sld>
+</file>
+
+<file path=ppt/slides/slide3.xml><?xml version="1.0" encoding="utf-8"?>
+<p:sld xmlns:a="http://schemas.openxmlformats.org/drawingml/2006/main" xmlns:r="http://schemas.openxmlformats.org/officeDocument/2006/relationships" xmlns:p="http://schemas.openxmlformats.org/presentationml/2006/main">
+  <p:cSld>
+    <p:spTree>
+      <p:nvGrpSpPr>
+        <p:cNvPr id="1" name=""/>
+        <p:cNvGrpSpPr/>
+        <p:nvPr/>
+      </p:nvGrpSpPr>
+      <p:grpSpPr>
+        <a:xfrm>
+          <a:off x="0" y="0"/>
+          <a:ext cx="0" cy="0"/>
+          <a:chOff x="0" y="0"/>
+          <a:chExt cx="0" cy="0"/>
+        </a:xfrm>
+      </p:grpSpPr>
+      <p:pic>
+        <p:nvPicPr>
+          <p:cNvPr id="10" name="Grafik 9" descr="Ein Bild, das Text, Papier, Brief, Origami enthält.&#10;&#10;KI-generierte Inhalte können fehlerhaft sein.">
+            <a:extLst>
+              <a:ext uri="{FF2B5EF4-FFF2-40B4-BE49-F238E27FC236}">
+                <a16:creationId xmlns:a16="http://schemas.microsoft.com/office/drawing/2014/main" id="{A4BE09B9-6415-6507-A377-A5DAD30E29A1}"/>
+              </a:ext>
+            </a:extLst>
+          </p:cNvPr>
+          <p:cNvPicPr>
+            <a:picLocks noChangeAspect="1"/>
+          </p:cNvPicPr>
+          <p:nvPr/>
+        </p:nvPicPr>
+        <p:blipFill>
+          <a:blip r:embed="rId3"/>
+          <a:srcRect b="28743"/>
+          <a:stretch>
+            <a:fillRect/>
+          </a:stretch>
+        </p:blipFill>
+        <p:spPr>
+          <a:xfrm>
+            <a:off x="0" y="468441"/>
+            <a:ext cx="5924918" cy="5448926"/>
+          </a:xfrm>
+          <a:prstGeom prst="rect">
+            <a:avLst/>
+          </a:prstGeom>
+        </p:spPr>
+      </p:pic>
+      <p:pic>
+        <p:nvPicPr>
+          <p:cNvPr id="12" name="Grafik 11" descr="Ein Bild, das Text, Schrift, Reihe, Diagramm enthält.&#10;&#10;KI-generierte Inhalte können fehlerhaft sein.">
+            <a:extLst>
+              <a:ext uri="{FF2B5EF4-FFF2-40B4-BE49-F238E27FC236}">
+                <a16:creationId xmlns:a16="http://schemas.microsoft.com/office/drawing/2014/main" id="{E2B21C04-4E69-2ACA-5B47-6F85E6498F34}"/>
+              </a:ext>
+            </a:extLst>
+          </p:cNvPr>
+          <p:cNvPicPr>
+            <a:picLocks noChangeAspect="1"/>
+          </p:cNvPicPr>
+          <p:nvPr/>
+        </p:nvPicPr>
+        <p:blipFill>
+          <a:blip r:embed="rId4"/>
+          <a:stretch>
+            <a:fillRect/>
+          </a:stretch>
+        </p:blipFill>
+        <p:spPr>
+          <a:xfrm>
+            <a:off x="6096000" y="3762532"/>
+            <a:ext cx="6048117" cy="1244184"/>
+          </a:xfrm>
+          <a:prstGeom prst="rect">
+            <a:avLst/>
+          </a:prstGeom>
+        </p:spPr>
+      </p:pic>
+      <p:pic>
+        <p:nvPicPr>
+          <p:cNvPr id="15" name="Grafik 14" descr="Ein Bild, das Text, Papier, Brief, Origami enthält.&#10;&#10;KI-generierte Inhalte können fehlerhaft sein.">
+            <a:extLst>
+              <a:ext uri="{FF2B5EF4-FFF2-40B4-BE49-F238E27FC236}">
+                <a16:creationId xmlns:a16="http://schemas.microsoft.com/office/drawing/2014/main" id="{721158B0-DCA0-18E3-E2BB-A2D9AF0126FD}"/>
+              </a:ext>
+            </a:extLst>
+          </p:cNvPr>
+          <p:cNvPicPr>
+            <a:picLocks noChangeAspect="1"/>
+          </p:cNvPicPr>
+          <p:nvPr/>
+        </p:nvPicPr>
+        <p:blipFill>
+          <a:blip r:embed="rId3"/>
+          <a:srcRect t="71257"/>
+          <a:stretch>
+            <a:fillRect/>
+          </a:stretch>
+        </p:blipFill>
+        <p:spPr>
+          <a:xfrm>
+            <a:off x="6096000" y="1499016"/>
+            <a:ext cx="6101642" cy="2263516"/>
+          </a:xfrm>
+          <a:prstGeom prst="rect">
+            <a:avLst/>
+          </a:prstGeom>
+        </p:spPr>
+      </p:pic>
+    </p:spTree>
+    <p:extLst>
+      <p:ext uri="{BB962C8B-B14F-4D97-AF65-F5344CB8AC3E}">
+        <p14:creationId xmlns:p14="http://schemas.microsoft.com/office/powerpoint/2010/main" val="330369928"/>
+      </p:ext>
+    </p:extLst>
+  </p:cSld>
+  <p:clrMapOvr>
+    <a:masterClrMapping/>
+  </p:clrMapOvr>
+</p:sld>
+</file>
+
+<file path=ppt/slides/slide4.xml><?xml version="1.0" encoding="utf-8"?>
+<p:sld xmlns:a="http://schemas.openxmlformats.org/drawingml/2006/main" xmlns:r="http://schemas.openxmlformats.org/officeDocument/2006/relationships" xmlns:p="http://schemas.openxmlformats.org/presentationml/2006/main">
+  <p:cSld>
+    <p:spTree>
+      <p:nvGrpSpPr>
+        <p:cNvPr id="1" name=""/>
+        <p:cNvGrpSpPr/>
+        <p:nvPr/>
+      </p:nvGrpSpPr>
+      <p:grpSpPr>
+        <a:xfrm>
+          <a:off x="0" y="0"/>
+          <a:ext cx="0" cy="0"/>
+          <a:chOff x="0" y="0"/>
+          <a:chExt cx="0" cy="0"/>
+        </a:xfrm>
+      </p:grpSpPr>
+      <p:pic>
+        <p:nvPicPr>
+          <p:cNvPr id="2" name="Grafik 1" descr="Ein Bild, das Text, Screenshot, Schrift, Brief enthält.&#10;&#10;KI-generierte Inhalte können fehlerhaft sein.">
+            <a:extLst>
+              <a:ext uri="{FF2B5EF4-FFF2-40B4-BE49-F238E27FC236}">
+                <a16:creationId xmlns:a16="http://schemas.microsoft.com/office/drawing/2014/main" id="{1530B3CA-E079-015A-6244-3B16165C6FD6}"/>
+              </a:ext>
+            </a:extLst>
+          </p:cNvPr>
+          <p:cNvPicPr>
+            <a:picLocks noChangeAspect="1"/>
+          </p:cNvPicPr>
+          <p:nvPr/>
+        </p:nvPicPr>
+        <p:blipFill>
+          <a:blip r:embed="rId2"/>
+          <a:stretch>
+            <a:fillRect/>
+          </a:stretch>
+        </p:blipFill>
+        <p:spPr>
+          <a:xfrm>
+            <a:off x="3267856" y="-1863"/>
+            <a:ext cx="5666282" cy="6873850"/>
+          </a:xfrm>
+          <a:prstGeom prst="rect">
+            <a:avLst/>
+          </a:prstGeom>
+        </p:spPr>
+      </p:pic>
+    </p:spTree>
+    <p:extLst>
+      <p:ext uri="{BB962C8B-B14F-4D97-AF65-F5344CB8AC3E}">
+        <p14:creationId xmlns:p14="http://schemas.microsoft.com/office/powerpoint/2010/main" val="3079377886"/>
+      </p:ext>
+    </p:extLst>
+  </p:cSld>
+  <p:clrMapOvr>
+    <a:masterClrMapping/>
+  </p:clrMapOvr>
+</p:sld>
+</file>
+
+<file path=ppt/slides/slide5.xml><?xml version="1.0" encoding="utf-8"?>
+<p:sld xmlns:a="http://schemas.openxmlformats.org/drawingml/2006/main" xmlns:r="http://schemas.openxmlformats.org/officeDocument/2006/relationships" xmlns:p="http://schemas.openxmlformats.org/presentationml/2006/main">
+  <p:cSld>
+    <p:spTree>
+      <p:nvGrpSpPr>
+        <p:cNvPr id="1" name=""/>
+        <p:cNvGrpSpPr/>
+        <p:nvPr/>
+      </p:nvGrpSpPr>
+      <p:grpSpPr>
+        <a:xfrm>
+          <a:off x="0" y="0"/>
+          <a:ext cx="0" cy="0"/>
+          <a:chOff x="0" y="0"/>
+          <a:chExt cx="0" cy="0"/>
+        </a:xfrm>
+      </p:grpSpPr>
+      <p:pic>
+        <p:nvPicPr>
+          <p:cNvPr id="11" name="Grafik 10" descr="Ein Bild, das Text, Schrift, Reihe, Origami enthält.&#10;&#10;KI-generierte Inhalte können fehlerhaft sein.">
+            <a:extLst>
+              <a:ext uri="{FF2B5EF4-FFF2-40B4-BE49-F238E27FC236}">
+                <a16:creationId xmlns:a16="http://schemas.microsoft.com/office/drawing/2014/main" id="{B861861D-BCA9-26B9-DCB6-C80CD54D52C4}"/>
+              </a:ext>
+            </a:extLst>
+          </p:cNvPr>
+          <p:cNvPicPr>
+            <a:picLocks noChangeAspect="1"/>
+          </p:cNvPicPr>
+          <p:nvPr/>
+        </p:nvPicPr>
+        <p:blipFill>
+          <a:blip r:embed="rId2"/>
+          <a:stretch>
+            <a:fillRect/>
+          </a:stretch>
+        </p:blipFill>
+        <p:spPr>
+          <a:xfrm>
+            <a:off x="432098" y="4218535"/>
+            <a:ext cx="7970721" cy="2298305"/>
+          </a:xfrm>
+          <a:prstGeom prst="rect">
+            <a:avLst/>
+          </a:prstGeom>
+        </p:spPr>
+      </p:pic>
+      <p:sp>
+        <p:nvSpPr>
           <p:cNvPr id="3" name="Titel 1">
             <a:extLst>
               <a:ext uri="{FF2B5EF4-FFF2-40B4-BE49-F238E27FC236}">
-                <a16:creationId xmlns:a16="http://schemas.microsoft.com/office/drawing/2014/main" id="{DD2BFBEF-8E72-C63A-15AB-AD1B850F0F62}"/>
+                <a16:creationId xmlns:a16="http://schemas.microsoft.com/office/drawing/2014/main" id="{BA140C9D-1408-E733-FF1E-44847D93BFFB}"/>
               </a:ext>
             </a:extLst>
           </p:cNvPr>
@@ -5582,10 +5295,10 @@
       </p:sp>
       <p:sp>
         <p:nvSpPr>
-          <p:cNvPr id="12" name="Inhaltsplatzhalter 2">
-            <a:extLst>
-              <a:ext uri="{FF2B5EF4-FFF2-40B4-BE49-F238E27FC236}">
-                <a16:creationId xmlns:a16="http://schemas.microsoft.com/office/drawing/2014/main" id="{1780EC57-1D70-8A7C-72FB-802D33F64CB9}"/>
+          <p:cNvPr id="8" name="Inhaltsplatzhalter 2">
+            <a:extLst>
+              <a:ext uri="{FF2B5EF4-FFF2-40B4-BE49-F238E27FC236}">
+                <a16:creationId xmlns:a16="http://schemas.microsoft.com/office/drawing/2014/main" id="{D1B812B5-42BF-7EF8-4EF2-953E9E589C6F}"/>
               </a:ext>
             </a:extLst>
           </p:cNvPr>
@@ -5596,8 +5309,8 @@
         </p:nvSpPr>
         <p:spPr>
           <a:xfrm>
-            <a:off x="186090" y="778049"/>
-            <a:ext cx="11327804" cy="5356525"/>
+            <a:off x="432098" y="919579"/>
+            <a:ext cx="11327804" cy="2600862"/>
           </a:xfrm>
           <a:prstGeom prst="rect">
             <a:avLst/>
@@ -5775,7 +5488,7 @@
             </a:pPr>
             <a:r>
               <a:rPr lang="de-DE" sz="2000" b="1" dirty="0"/>
-              <a:t>Aufgabe 4</a:t>
+              <a:t>Aufgabe 1</a:t>
             </a:r>
           </a:p>
           <a:p>
@@ -5784,141 +5497,98 @@
             </a:pPr>
             <a:r>
               <a:rPr lang="de-DE" sz="2000" dirty="0"/>
-              <a:t>Schreibe in dein Heft. Fülle die 7 Lücken!</a:t>
+              <a:t>Zeichne das Dreieck ABC mit den Eckpunkten A(2/3), B(8,5/1) und C(5/4) sowie die Gerade CD durch die Punkte C und D(3/0). Spiegele dann das Dreieck ABC an der Geraden CD.</a:t>
             </a:r>
           </a:p>
           <a:p>
             <a:pPr marL="0" indent="0" algn="just">
               <a:buNone/>
             </a:pPr>
-            <a:endParaRPr lang="de-DE" sz="2000" dirty="0"/>
+            <a:r>
+              <a:rPr lang="de-DE" sz="2000" b="1" dirty="0"/>
+              <a:t>Aufgabe 2</a:t>
+            </a:r>
           </a:p>
           <a:p>
             <a:pPr marL="0" indent="0" algn="just">
               <a:buNone/>
             </a:pPr>
-            <a:endParaRPr lang="de-DE" sz="2000" dirty="0"/>
+            <a:r>
+              <a:rPr lang="de-DE" sz="2000" dirty="0"/>
+              <a:t>Schreibe einen Text der folgende Begriffe beinhaltet:</a:t>
+            </a:r>
           </a:p>
           <a:p>
             <a:pPr marL="0" indent="0" algn="just">
               <a:buNone/>
             </a:pPr>
-            <a:endParaRPr lang="de-DE" sz="2000" dirty="0"/>
+            <a:r>
+              <a:rPr lang="de-DE" sz="1800" dirty="0">
+                <a:solidFill>
+                  <a:schemeClr val="tx2">
+                    <a:lumMod val="75000"/>
+                    <a:lumOff val="25000"/>
+                  </a:schemeClr>
+                </a:solidFill>
+                <a:latin typeface="Cavolini" panose="03000502040302020204" pitchFamily="66" charset="0"/>
+                <a:ea typeface="ADLaM Display" panose="02010000000000000000" pitchFamily="2" charset="77"/>
+                <a:cs typeface="Cavolini" panose="03000502040302020204" pitchFamily="66" charset="0"/>
+              </a:rPr>
+              <a:t>Originalpunkt, Spiegelachse, parallel, Abstand, Bildpunkt, P, verschiedene Seiten, denselben, P‘, Fixpunkt, Achsenspiegelung, Mittellinie, Geodreieck</a:t>
+            </a:r>
           </a:p>
           <a:p>
             <a:pPr marL="0" indent="0" algn="just">
               <a:buNone/>
             </a:pPr>
-            <a:endParaRPr lang="de-DE" sz="2000" dirty="0"/>
+            <a:r>
+              <a:rPr lang="de-DE" sz="1800" b="1" dirty="0"/>
+              <a:t>Aufgabe 3</a:t>
+            </a:r>
           </a:p>
           <a:p>
             <a:pPr marL="0" indent="0" algn="just">
               <a:buNone/>
             </a:pPr>
-            <a:endParaRPr lang="de-DE" sz="2000" dirty="0"/>
+            <a:r>
+              <a:rPr lang="de-DE" sz="1800" dirty="0"/>
+              <a:t>Schreibe in dein Heft. Fülle die 5 Lücken!</a:t>
+            </a:r>
           </a:p>
           <a:p>
             <a:pPr marL="0" indent="0" algn="just">
               <a:buNone/>
             </a:pPr>
-            <a:endParaRPr lang="de-DE" sz="2000" dirty="0"/>
-          </a:p>
-          <a:p>
-            <a:pPr marL="0" indent="0" algn="just">
-              <a:buNone/>
-            </a:pPr>
-            <a:endParaRPr lang="de-DE" sz="2000" dirty="0"/>
-          </a:p>
-          <a:p>
-            <a:pPr marL="0" indent="0" algn="just">
-              <a:buNone/>
-            </a:pPr>
-            <a:endParaRPr lang="de-DE" sz="2000" dirty="0"/>
-          </a:p>
-          <a:p>
-            <a:pPr marL="0" indent="0" algn="just">
-              <a:buNone/>
-            </a:pPr>
-            <a:r>
-              <a:rPr lang="de-DE" sz="2000" b="1" dirty="0"/>
-              <a:t>Übungsaufgaben &amp; HA</a:t>
-            </a:r>
-          </a:p>
-          <a:p>
-            <a:pPr algn="just"/>
-            <a:r>
-              <a:rPr lang="de-DE" sz="2000" dirty="0"/>
-              <a:t>Buch S. 94, Nr. 9 bis 12</a:t>
-            </a:r>
-          </a:p>
-          <a:p>
-            <a:pPr algn="just"/>
-            <a:r>
-              <a:rPr lang="de-DE" sz="2000" dirty="0"/>
-              <a:t>Arbeitsheft S.29</a:t>
-            </a:r>
-          </a:p>
-          <a:p>
-            <a:pPr marL="0" indent="0" algn="just">
-              <a:buNone/>
-            </a:pPr>
-            <a:endParaRPr lang="de-DE" sz="2000" dirty="0"/>
-          </a:p>
-          <a:p>
-            <a:pPr marL="0" indent="0" algn="just">
-              <a:buNone/>
-            </a:pPr>
-            <a:endParaRPr lang="de-DE" sz="2000" dirty="0"/>
-          </a:p>
-        </p:txBody>
-      </p:sp>
-      <p:pic>
-        <p:nvPicPr>
-          <p:cNvPr id="13" name="Grafik 12" descr="Ein Bild, das Text, Screenshot, Schrift, Reihe enthält.&#10;&#10;KI-generierte Inhalte können fehlerhaft sein.">
-            <a:extLst>
-              <a:ext uri="{FF2B5EF4-FFF2-40B4-BE49-F238E27FC236}">
-                <a16:creationId xmlns:a16="http://schemas.microsoft.com/office/drawing/2014/main" id="{7116A367-2B22-F5BC-2861-BAC0839DB03C}"/>
-              </a:ext>
-            </a:extLst>
-          </p:cNvPr>
-          <p:cNvPicPr>
-            <a:picLocks noChangeAspect="1"/>
-          </p:cNvPicPr>
+            <a:endParaRPr lang="de-DE" sz="1800" dirty="0">
+              <a:solidFill>
+                <a:schemeClr val="tx2">
+                  <a:lumMod val="75000"/>
+                  <a:lumOff val="25000"/>
+                </a:schemeClr>
+              </a:solidFill>
+              <a:latin typeface="Cavolini" panose="03000502040302020204" pitchFamily="66" charset="0"/>
+              <a:ea typeface="ADLaM Display" panose="02010000000000000000" pitchFamily="2" charset="77"/>
+              <a:cs typeface="Cavolini" panose="03000502040302020204" pitchFamily="66" charset="0"/>
+            </a:endParaRPr>
+          </a:p>
+        </p:txBody>
+      </p:sp>
+      <p:sp>
+        <p:nvSpPr>
+          <p:cNvPr id="4" name="Abgerundetes Rechteck 3">
+            <a:extLst>
+              <a:ext uri="{FF2B5EF4-FFF2-40B4-BE49-F238E27FC236}">
+                <a16:creationId xmlns:a16="http://schemas.microsoft.com/office/drawing/2014/main" id="{B6DCCC7E-20F0-289F-2793-F4B96F42B2A8}"/>
+              </a:ext>
+            </a:extLst>
+          </p:cNvPr>
+          <p:cNvSpPr/>
           <p:nvPr/>
-        </p:nvPicPr>
-        <p:blipFill>
-          <a:blip r:embed="rId3"/>
-          <a:srcRect b="62363"/>
-          <a:stretch>
-            <a:fillRect/>
-          </a:stretch>
-        </p:blipFill>
+        </p:nvSpPr>
         <p:spPr>
           <a:xfrm>
-            <a:off x="211736" y="1514700"/>
-            <a:ext cx="8811494" cy="1632294"/>
-          </a:xfrm>
-          <a:prstGeom prst="rect">
-            <a:avLst/>
-          </a:prstGeom>
-        </p:spPr>
-      </p:pic>
-      <p:sp>
-        <p:nvSpPr>
-          <p:cNvPr id="14" name="Abgerundetes Rechteck 13">
-            <a:extLst>
-              <a:ext uri="{FF2B5EF4-FFF2-40B4-BE49-F238E27FC236}">
-                <a16:creationId xmlns:a16="http://schemas.microsoft.com/office/drawing/2014/main" id="{755C27E3-4A05-0F1F-EA55-F5DEABF896B9}"/>
-              </a:ext>
-            </a:extLst>
-          </p:cNvPr>
-          <p:cNvSpPr/>
-          <p:nvPr/>
-        </p:nvSpPr>
-        <p:spPr>
-          <a:xfrm>
-            <a:off x="7448816" y="3310758"/>
-            <a:ext cx="978492" cy="327454"/>
+            <a:off x="2649291" y="4733105"/>
+            <a:ext cx="1154613" cy="227915"/>
           </a:xfrm>
           <a:prstGeom prst="roundRect">
             <a:avLst/>
@@ -5945,57 +5615,26 @@
           <a:lstStyle/>
           <a:p>
             <a:pPr algn="ctr"/>
-            <a:endParaRPr lang="de-DE"/>
-          </a:p>
-        </p:txBody>
-      </p:sp>
-      <p:pic>
-        <p:nvPicPr>
-          <p:cNvPr id="15" name="Grafik 14" descr="Ein Bild, das Text, Screenshot, Schrift, Reihe enthält.&#10;&#10;KI-generierte Inhalte können fehlerhaft sein.">
-            <a:extLst>
-              <a:ext uri="{FF2B5EF4-FFF2-40B4-BE49-F238E27FC236}">
-                <a16:creationId xmlns:a16="http://schemas.microsoft.com/office/drawing/2014/main" id="{5A43414C-B395-59E0-BEDD-24CA4349213D}"/>
-              </a:ext>
-            </a:extLst>
-          </p:cNvPr>
-          <p:cNvPicPr>
-            <a:picLocks noChangeAspect="1"/>
-          </p:cNvPicPr>
+            <a:endParaRPr lang="de-DE" sz="1400"/>
+          </a:p>
+        </p:txBody>
+      </p:sp>
+      <p:sp>
+        <p:nvSpPr>
+          <p:cNvPr id="5" name="Abgerundetes Rechteck 4">
+            <a:extLst>
+              <a:ext uri="{FF2B5EF4-FFF2-40B4-BE49-F238E27FC236}">
+                <a16:creationId xmlns:a16="http://schemas.microsoft.com/office/drawing/2014/main" id="{7AD7AD1C-F1E6-B229-1865-3325B3626DB3}"/>
+              </a:ext>
+            </a:extLst>
+          </p:cNvPr>
+          <p:cNvSpPr/>
           <p:nvPr/>
-        </p:nvPicPr>
-        <p:blipFill>
-          <a:blip r:embed="rId3"/>
-          <a:srcRect t="62363"/>
-          <a:stretch>
-            <a:fillRect/>
-          </a:stretch>
-        </p:blipFill>
+        </p:nvSpPr>
         <p:spPr>
           <a:xfrm>
-            <a:off x="362006" y="3138144"/>
-            <a:ext cx="8811493" cy="1632294"/>
-          </a:xfrm>
-          <a:prstGeom prst="rect">
-            <a:avLst/>
-          </a:prstGeom>
-        </p:spPr>
-      </p:pic>
-      <p:sp>
-        <p:nvSpPr>
-          <p:cNvPr id="16" name="Abgerundetes Rechteck 15">
-            <a:extLst>
-              <a:ext uri="{FF2B5EF4-FFF2-40B4-BE49-F238E27FC236}">
-                <a16:creationId xmlns:a16="http://schemas.microsoft.com/office/drawing/2014/main" id="{70341C1A-CB06-F378-6637-1B73E318EEE6}"/>
-              </a:ext>
-            </a:extLst>
-          </p:cNvPr>
-          <p:cNvSpPr/>
-          <p:nvPr/>
-        </p:nvSpPr>
-        <p:spPr>
-          <a:xfrm>
-            <a:off x="3160111" y="2259600"/>
-            <a:ext cx="963315" cy="190302"/>
+            <a:off x="3278868" y="5229409"/>
+            <a:ext cx="899572" cy="253285"/>
           </a:xfrm>
           <a:prstGeom prst="roundRect">
             <a:avLst/>
@@ -6022,16 +5661,16 @@
           <a:lstStyle/>
           <a:p>
             <a:pPr algn="ctr"/>
-            <a:endParaRPr lang="de-DE"/>
-          </a:p>
-        </p:txBody>
-      </p:sp>
-      <p:sp>
-        <p:nvSpPr>
-          <p:cNvPr id="17" name="Abgerundetes Rechteck 16">
-            <a:extLst>
-              <a:ext uri="{FF2B5EF4-FFF2-40B4-BE49-F238E27FC236}">
-                <a16:creationId xmlns:a16="http://schemas.microsoft.com/office/drawing/2014/main" id="{8C345699-248A-C645-9948-E4F33AED3479}"/>
+            <a:endParaRPr lang="de-DE" sz="1400"/>
+          </a:p>
+        </p:txBody>
+      </p:sp>
+      <p:sp>
+        <p:nvSpPr>
+          <p:cNvPr id="7" name="Abgerundetes Rechteck 6">
+            <a:extLst>
+              <a:ext uri="{FF2B5EF4-FFF2-40B4-BE49-F238E27FC236}">
+                <a16:creationId xmlns:a16="http://schemas.microsoft.com/office/drawing/2014/main" id="{835BEB63-3444-7293-A9BA-C749865B0DEE}"/>
               </a:ext>
             </a:extLst>
           </p:cNvPr>
@@ -6040,8 +5679,8 @@
         </p:nvSpPr>
         <p:spPr>
           <a:xfrm>
-            <a:off x="678106" y="2713408"/>
-            <a:ext cx="745252" cy="234485"/>
+            <a:off x="1962500" y="5482694"/>
+            <a:ext cx="899572" cy="204874"/>
           </a:xfrm>
           <a:prstGeom prst="roundRect">
             <a:avLst/>
@@ -6068,16 +5707,16 @@
           <a:lstStyle/>
           <a:p>
             <a:pPr algn="ctr"/>
-            <a:endParaRPr lang="de-DE"/>
-          </a:p>
-        </p:txBody>
-      </p:sp>
-      <p:sp>
-        <p:nvSpPr>
-          <p:cNvPr id="18" name="Abgerundetes Rechteck 17">
-            <a:extLst>
-              <a:ext uri="{FF2B5EF4-FFF2-40B4-BE49-F238E27FC236}">
-                <a16:creationId xmlns:a16="http://schemas.microsoft.com/office/drawing/2014/main" id="{3EED6E10-F4DC-5A09-08EC-217293252565}"/>
+            <a:endParaRPr lang="de-DE" sz="1400"/>
+          </a:p>
+        </p:txBody>
+      </p:sp>
+      <p:sp>
+        <p:nvSpPr>
+          <p:cNvPr id="9" name="Abgerundetes Rechteck 8">
+            <a:extLst>
+              <a:ext uri="{FF2B5EF4-FFF2-40B4-BE49-F238E27FC236}">
+                <a16:creationId xmlns:a16="http://schemas.microsoft.com/office/drawing/2014/main" id="{105D1C43-F261-11EF-566C-98049B5E033E}"/>
               </a:ext>
             </a:extLst>
           </p:cNvPr>
@@ -6086,8 +5725,8 @@
         </p:nvSpPr>
         <p:spPr>
           <a:xfrm>
-            <a:off x="3971517" y="2442838"/>
-            <a:ext cx="267184" cy="270570"/>
+            <a:off x="7750459" y="4466088"/>
+            <a:ext cx="471766" cy="267017"/>
           </a:xfrm>
           <a:prstGeom prst="roundRect">
             <a:avLst/>
@@ -6114,16 +5753,16 @@
           <a:lstStyle/>
           <a:p>
             <a:pPr algn="ctr"/>
-            <a:endParaRPr lang="de-DE"/>
-          </a:p>
-        </p:txBody>
-      </p:sp>
-      <p:sp>
-        <p:nvSpPr>
-          <p:cNvPr id="19" name="Abgerundetes Rechteck 18">
-            <a:extLst>
-              <a:ext uri="{FF2B5EF4-FFF2-40B4-BE49-F238E27FC236}">
-                <a16:creationId xmlns:a16="http://schemas.microsoft.com/office/drawing/2014/main" id="{4484FBDB-0575-6BE8-AA81-730E0F74C724}"/>
+            <a:endParaRPr lang="de-DE" sz="1400"/>
+          </a:p>
+        </p:txBody>
+      </p:sp>
+      <p:sp>
+        <p:nvSpPr>
+          <p:cNvPr id="10" name="Abgerundetes Rechteck 9">
+            <a:extLst>
+              <a:ext uri="{FF2B5EF4-FFF2-40B4-BE49-F238E27FC236}">
+                <a16:creationId xmlns:a16="http://schemas.microsoft.com/office/drawing/2014/main" id="{43E74064-7903-448D-E415-AB4B6B6BA2B5}"/>
               </a:ext>
             </a:extLst>
           </p:cNvPr>
@@ -6132,8 +5771,8 @@
         </p:nvSpPr>
         <p:spPr>
           <a:xfrm>
-            <a:off x="5744643" y="2228535"/>
-            <a:ext cx="820060" cy="252431"/>
+            <a:off x="6727027" y="5847717"/>
+            <a:ext cx="249846" cy="273354"/>
           </a:xfrm>
           <a:prstGeom prst="roundRect">
             <a:avLst/>
@@ -6160,224 +5799,14 @@
           <a:lstStyle/>
           <a:p>
             <a:pPr algn="ctr"/>
-            <a:endParaRPr lang="de-DE"/>
-          </a:p>
-        </p:txBody>
-      </p:sp>
-      <p:sp>
-        <p:nvSpPr>
-          <p:cNvPr id="20" name="Abgerundetes Rechteck 19">
-            <a:extLst>
-              <a:ext uri="{FF2B5EF4-FFF2-40B4-BE49-F238E27FC236}">
-                <a16:creationId xmlns:a16="http://schemas.microsoft.com/office/drawing/2014/main" id="{5260007D-C4EC-14F3-084E-C13C6A47C698}"/>
-              </a:ext>
-            </a:extLst>
-          </p:cNvPr>
-          <p:cNvSpPr/>
-          <p:nvPr/>
-        </p:nvSpPr>
-        <p:spPr>
-          <a:xfrm>
-            <a:off x="8015307" y="3638212"/>
-            <a:ext cx="844021" cy="343016"/>
-          </a:xfrm>
-          <a:prstGeom prst="roundRect">
-            <a:avLst/>
-          </a:prstGeom>
-        </p:spPr>
-        <p:style>
-          <a:lnRef idx="2">
-            <a:schemeClr val="accent4">
-              <a:shade val="15000"/>
-            </a:schemeClr>
-          </a:lnRef>
-          <a:fillRef idx="1">
-            <a:schemeClr val="accent4"/>
-          </a:fillRef>
-          <a:effectRef idx="0">
-            <a:schemeClr val="accent4"/>
-          </a:effectRef>
-          <a:fontRef idx="minor">
-            <a:schemeClr val="lt1"/>
-          </a:fontRef>
-        </p:style>
-        <p:txBody>
-          <a:bodyPr rtlCol="0" anchor="ctr"/>
-          <a:lstStyle/>
-          <a:p>
-            <a:pPr algn="ctr"/>
-            <a:endParaRPr lang="de-DE"/>
-          </a:p>
-        </p:txBody>
-      </p:sp>
-      <p:sp>
-        <p:nvSpPr>
-          <p:cNvPr id="21" name="Abgerundetes Rechteck 20">
-            <a:extLst>
-              <a:ext uri="{FF2B5EF4-FFF2-40B4-BE49-F238E27FC236}">
-                <a16:creationId xmlns:a16="http://schemas.microsoft.com/office/drawing/2014/main" id="{11924946-D785-6487-9D12-3FD9AB500349}"/>
-              </a:ext>
-            </a:extLst>
-          </p:cNvPr>
-          <p:cNvSpPr/>
-          <p:nvPr/>
-        </p:nvSpPr>
-        <p:spPr>
-          <a:xfrm>
-            <a:off x="7828340" y="4025738"/>
-            <a:ext cx="219443" cy="207383"/>
-          </a:xfrm>
-          <a:prstGeom prst="roundRect">
-            <a:avLst/>
-          </a:prstGeom>
-        </p:spPr>
-        <p:style>
-          <a:lnRef idx="2">
-            <a:schemeClr val="accent4">
-              <a:shade val="15000"/>
-            </a:schemeClr>
-          </a:lnRef>
-          <a:fillRef idx="1">
-            <a:schemeClr val="accent4"/>
-          </a:fillRef>
-          <a:effectRef idx="0">
-            <a:schemeClr val="accent4"/>
-          </a:effectRef>
-          <a:fontRef idx="minor">
-            <a:schemeClr val="lt1"/>
-          </a:fontRef>
-        </p:style>
-        <p:txBody>
-          <a:bodyPr rtlCol="0" anchor="ctr"/>
-          <a:lstStyle/>
-          <a:p>
-            <a:pPr algn="ctr"/>
-            <a:endParaRPr lang="de-DE"/>
-          </a:p>
-        </p:txBody>
-      </p:sp>
-      <p:sp>
-        <p:nvSpPr>
-          <p:cNvPr id="22" name="Abgerundetes Rechteck 21">
-            <a:extLst>
-              <a:ext uri="{FF2B5EF4-FFF2-40B4-BE49-F238E27FC236}">
-                <a16:creationId xmlns:a16="http://schemas.microsoft.com/office/drawing/2014/main" id="{5B2D5E35-14E6-C5D4-A4C6-5C7C15FEC671}"/>
-              </a:ext>
-            </a:extLst>
-          </p:cNvPr>
-          <p:cNvSpPr/>
-          <p:nvPr/>
-        </p:nvSpPr>
-        <p:spPr>
-          <a:xfrm>
-            <a:off x="2130692" y="3939126"/>
-            <a:ext cx="844021" cy="207383"/>
-          </a:xfrm>
-          <a:prstGeom prst="roundRect">
-            <a:avLst/>
-          </a:prstGeom>
-        </p:spPr>
-        <p:style>
-          <a:lnRef idx="2">
-            <a:schemeClr val="accent4">
-              <a:shade val="15000"/>
-            </a:schemeClr>
-          </a:lnRef>
-          <a:fillRef idx="1">
-            <a:schemeClr val="accent4"/>
-          </a:fillRef>
-          <a:effectRef idx="0">
-            <a:schemeClr val="accent4"/>
-          </a:effectRef>
-          <a:fontRef idx="minor">
-            <a:schemeClr val="lt1"/>
-          </a:fontRef>
-        </p:style>
-        <p:txBody>
-          <a:bodyPr rtlCol="0" anchor="ctr"/>
-          <a:lstStyle/>
-          <a:p>
-            <a:pPr algn="ctr"/>
-            <a:endParaRPr lang="de-DE"/>
-          </a:p>
-        </p:txBody>
-      </p:sp>
-      <p:pic>
-        <p:nvPicPr>
-          <p:cNvPr id="24" name="Grafik 23" descr="Ein Bild, das Text, Origami enthält.&#10;&#10;KI-generierte Inhalte können fehlerhaft sein.">
-            <a:extLst>
-              <a:ext uri="{FF2B5EF4-FFF2-40B4-BE49-F238E27FC236}">
-                <a16:creationId xmlns:a16="http://schemas.microsoft.com/office/drawing/2014/main" id="{CC976162-BFC8-A7B2-904D-8291B4C5F750}"/>
-              </a:ext>
-            </a:extLst>
-          </p:cNvPr>
-          <p:cNvPicPr>
-            <a:picLocks noChangeAspect="1"/>
-          </p:cNvPicPr>
-          <p:nvPr/>
-        </p:nvPicPr>
-        <p:blipFill>
-          <a:blip r:embed="rId4"/>
-          <a:srcRect l="20022" b="56020"/>
-          <a:stretch>
-            <a:fillRect/>
-          </a:stretch>
-        </p:blipFill>
-        <p:spPr>
-          <a:xfrm>
-            <a:off x="3641768" y="4877854"/>
-            <a:ext cx="3161775" cy="1338602"/>
-          </a:xfrm>
-          <a:prstGeom prst="rect">
-            <a:avLst/>
-          </a:prstGeom>
-          <a:ln>
-            <a:solidFill>
-              <a:schemeClr val="tx1"/>
-            </a:solidFill>
-          </a:ln>
-        </p:spPr>
-      </p:pic>
-      <p:pic>
-        <p:nvPicPr>
-          <p:cNvPr id="25" name="Grafik 24" descr="Ein Bild, das Text, Origami enthält.&#10;&#10;KI-generierte Inhalte können fehlerhaft sein.">
-            <a:extLst>
-              <a:ext uri="{FF2B5EF4-FFF2-40B4-BE49-F238E27FC236}">
-                <a16:creationId xmlns:a16="http://schemas.microsoft.com/office/drawing/2014/main" id="{F20FCD64-9804-FC14-B941-93512B1632DC}"/>
-              </a:ext>
-            </a:extLst>
-          </p:cNvPr>
-          <p:cNvPicPr>
-            <a:picLocks noChangeAspect="1"/>
-          </p:cNvPicPr>
-          <p:nvPr/>
-        </p:nvPicPr>
-        <p:blipFill>
-          <a:blip r:embed="rId4"/>
-          <a:srcRect t="45828"/>
-          <a:stretch>
-            <a:fillRect/>
-          </a:stretch>
-        </p:blipFill>
-        <p:spPr>
-          <a:xfrm>
-            <a:off x="6997967" y="4877854"/>
-            <a:ext cx="4235358" cy="1766485"/>
-          </a:xfrm>
-          <a:prstGeom prst="rect">
-            <a:avLst/>
-          </a:prstGeom>
-          <a:ln>
-            <a:solidFill>
-              <a:schemeClr val="tx1"/>
-            </a:solidFill>
-          </a:ln>
-        </p:spPr>
-      </p:pic>
+            <a:endParaRPr lang="de-DE" sz="1400"/>
+          </a:p>
+        </p:txBody>
+      </p:sp>
     </p:spTree>
     <p:extLst>
       <p:ext uri="{BB962C8B-B14F-4D97-AF65-F5344CB8AC3E}">
-        <p14:creationId xmlns:p14="http://schemas.microsoft.com/office/powerpoint/2010/main" val="3162902525"/>
+        <p14:creationId xmlns:p14="http://schemas.microsoft.com/office/powerpoint/2010/main" val="3178181211"/>
       </p:ext>
     </p:extLst>
   </p:cSld>
@@ -6387,7 +5816,7 @@
 </p:sld>
 </file>
 
-<file path=ppt/slides/slide7.xml><?xml version="1.0" encoding="utf-8"?>
+<file path=ppt/slides/slide6.xml><?xml version="1.0" encoding="utf-8"?>
 <p:sld xmlns:a="http://schemas.openxmlformats.org/drawingml/2006/main" xmlns:r="http://schemas.openxmlformats.org/officeDocument/2006/relationships" xmlns:p="http://schemas.openxmlformats.org/presentationml/2006/main">
   <p:cSld>
     <p:spTree>
@@ -6395,7 +5824,7 @@
         <p:cNvPr id="1" name="">
           <a:extLst>
             <a:ext uri="{FF2B5EF4-FFF2-40B4-BE49-F238E27FC236}">
-              <a16:creationId xmlns:a16="http://schemas.microsoft.com/office/drawing/2014/main" id="{031D9A79-4F64-6AF1-CEBD-0A216DEAF88B}"/>
+              <a16:creationId xmlns:a16="http://schemas.microsoft.com/office/drawing/2014/main" id="{8D19743F-1585-79F3-1290-17ED8D6958FC}"/>
             </a:ext>
           </a:extLst>
         </p:cNvPr>
@@ -6415,7 +5844,7 @@
           <p:cNvPr id="3" name="Titel 1">
             <a:extLst>
               <a:ext uri="{FF2B5EF4-FFF2-40B4-BE49-F238E27FC236}">
-                <a16:creationId xmlns:a16="http://schemas.microsoft.com/office/drawing/2014/main" id="{FE22BE25-984B-7AF3-4C01-F0B3633F00DC}"/>
+                <a16:creationId xmlns:a16="http://schemas.microsoft.com/office/drawing/2014/main" id="{DD2BFBEF-8E72-C63A-15AB-AD1B850F0F62}"/>
               </a:ext>
             </a:extLst>
           </p:cNvPr>
@@ -6471,10 +5900,10 @@
       </p:sp>
       <p:sp>
         <p:nvSpPr>
-          <p:cNvPr id="2" name="Inhaltsplatzhalter 2">
-            <a:extLst>
-              <a:ext uri="{FF2B5EF4-FFF2-40B4-BE49-F238E27FC236}">
-                <a16:creationId xmlns:a16="http://schemas.microsoft.com/office/drawing/2014/main" id="{B605FC50-ADA1-0E6A-2CC3-4E7AF5CBAD91}"/>
+          <p:cNvPr id="12" name="Inhaltsplatzhalter 2">
+            <a:extLst>
+              <a:ext uri="{FF2B5EF4-FFF2-40B4-BE49-F238E27FC236}">
+                <a16:creationId xmlns:a16="http://schemas.microsoft.com/office/drawing/2014/main" id="{1780EC57-1D70-8A7C-72FB-802D33F64CB9}"/>
               </a:ext>
             </a:extLst>
           </p:cNvPr>
@@ -6485,8 +5914,8 @@
         </p:nvSpPr>
         <p:spPr>
           <a:xfrm>
-            <a:off x="148465" y="690897"/>
-            <a:ext cx="11327804" cy="4396299"/>
+            <a:off x="186090" y="778049"/>
+            <a:ext cx="11327804" cy="5356525"/>
           </a:xfrm>
           <a:prstGeom prst="rect">
             <a:avLst/>
@@ -6664,17 +6093,109 @@
             </a:pPr>
             <a:r>
               <a:rPr lang="de-DE" sz="2000" b="1" dirty="0"/>
-              <a:t>Aufgabe </a:t>
-            </a:r>
+              <a:t>Aufgabe 4</a:t>
+            </a:r>
+          </a:p>
+          <a:p>
+            <a:pPr marL="0" indent="0" algn="just">
+              <a:buNone/>
+            </a:pPr>
+            <a:r>
+              <a:rPr lang="de-DE" sz="2000" dirty="0"/>
+              <a:t>Schreibe in dein Heft. Fülle die 7 Lücken!</a:t>
+            </a:r>
+          </a:p>
+          <a:p>
+            <a:pPr marL="0" indent="0" algn="just">
+              <a:buNone/>
+            </a:pPr>
+            <a:endParaRPr lang="de-DE" sz="2000" dirty="0"/>
+          </a:p>
+          <a:p>
+            <a:pPr marL="0" indent="0" algn="just">
+              <a:buNone/>
+            </a:pPr>
+            <a:endParaRPr lang="de-DE" sz="2000" dirty="0"/>
+          </a:p>
+          <a:p>
+            <a:pPr marL="0" indent="0" algn="just">
+              <a:buNone/>
+            </a:pPr>
+            <a:endParaRPr lang="de-DE" sz="2000" dirty="0"/>
+          </a:p>
+          <a:p>
+            <a:pPr marL="0" indent="0" algn="just">
+              <a:buNone/>
+            </a:pPr>
+            <a:endParaRPr lang="de-DE" sz="2000" dirty="0"/>
+          </a:p>
+          <a:p>
+            <a:pPr marL="0" indent="0" algn="just">
+              <a:buNone/>
+            </a:pPr>
+            <a:endParaRPr lang="de-DE" sz="2000" dirty="0"/>
+          </a:p>
+          <a:p>
+            <a:pPr marL="0" indent="0" algn="just">
+              <a:buNone/>
+            </a:pPr>
+            <a:endParaRPr lang="de-DE" sz="2000" dirty="0"/>
+          </a:p>
+          <a:p>
+            <a:pPr marL="0" indent="0" algn="just">
+              <a:buNone/>
+            </a:pPr>
+            <a:endParaRPr lang="de-DE" sz="2000" dirty="0"/>
+          </a:p>
+          <a:p>
+            <a:pPr marL="0" indent="0" algn="just">
+              <a:buNone/>
+            </a:pPr>
+            <a:endParaRPr lang="de-DE" sz="2000" dirty="0"/>
+          </a:p>
+          <a:p>
+            <a:pPr marL="0" indent="0" algn="just">
+              <a:buNone/>
+            </a:pPr>
+            <a:r>
+              <a:rPr lang="de-DE" sz="2000" b="1" dirty="0"/>
+              <a:t>Übungsaufgaben &amp; HA</a:t>
+            </a:r>
+          </a:p>
+          <a:p>
+            <a:pPr algn="just"/>
+            <a:r>
+              <a:rPr lang="de-DE" sz="2000" dirty="0"/>
+              <a:t>Buch S. 94, Nr. 9 bis 12</a:t>
+            </a:r>
+          </a:p>
+          <a:p>
+            <a:pPr algn="just"/>
+            <a:r>
+              <a:rPr lang="de-DE" sz="2000" dirty="0"/>
+              <a:t>Arbeitsheft S.29</a:t>
+            </a:r>
+          </a:p>
+          <a:p>
+            <a:pPr marL="0" indent="0" algn="just">
+              <a:buNone/>
+            </a:pPr>
+            <a:endParaRPr lang="de-DE" sz="2000" dirty="0"/>
+          </a:p>
+          <a:p>
+            <a:pPr marL="0" indent="0" algn="just">
+              <a:buNone/>
+            </a:pPr>
+            <a:endParaRPr lang="de-DE" sz="2000" dirty="0"/>
           </a:p>
         </p:txBody>
       </p:sp>
       <p:pic>
         <p:nvPicPr>
-          <p:cNvPr id="4" name="Grafik 3" descr="Ein Bild, das Text, Screenshot, Cartoon enthält.&#10;&#10;KI-generierte Inhalte können fehlerhaft sein.">
-            <a:extLst>
-              <a:ext uri="{FF2B5EF4-FFF2-40B4-BE49-F238E27FC236}">
-                <a16:creationId xmlns:a16="http://schemas.microsoft.com/office/drawing/2014/main" id="{E39361E8-78AB-BC2C-08DB-E072014FB428}"/>
+          <p:cNvPr id="13" name="Grafik 12" descr="Ein Bild, das Text, Screenshot, Schrift, Reihe enthält.&#10;&#10;KI-generierte Inhalte können fehlerhaft sein.">
+            <a:extLst>
+              <a:ext uri="{FF2B5EF4-FFF2-40B4-BE49-F238E27FC236}">
+                <a16:creationId xmlns:a16="http://schemas.microsoft.com/office/drawing/2014/main" id="{7116A367-2B22-F5BC-2861-BAC0839DB03C}"/>
               </a:ext>
             </a:extLst>
           </p:cNvPr>
@@ -6685,24 +6206,526 @@
         </p:nvPicPr>
         <p:blipFill>
           <a:blip r:embed="rId3"/>
+          <a:srcRect b="62363"/>
           <a:stretch>
             <a:fillRect/>
           </a:stretch>
         </p:blipFill>
         <p:spPr>
           <a:xfrm>
-            <a:off x="588371" y="1187812"/>
-            <a:ext cx="10887898" cy="3402468"/>
+            <a:off x="211736" y="1514700"/>
+            <a:ext cx="8811494" cy="1632294"/>
           </a:xfrm>
           <a:prstGeom prst="rect">
             <a:avLst/>
           </a:prstGeom>
         </p:spPr>
       </p:pic>
+      <p:sp>
+        <p:nvSpPr>
+          <p:cNvPr id="14" name="Abgerundetes Rechteck 13">
+            <a:extLst>
+              <a:ext uri="{FF2B5EF4-FFF2-40B4-BE49-F238E27FC236}">
+                <a16:creationId xmlns:a16="http://schemas.microsoft.com/office/drawing/2014/main" id="{755C27E3-4A05-0F1F-EA55-F5DEABF896B9}"/>
+              </a:ext>
+            </a:extLst>
+          </p:cNvPr>
+          <p:cNvSpPr/>
+          <p:nvPr/>
+        </p:nvSpPr>
+        <p:spPr>
+          <a:xfrm>
+            <a:off x="7448816" y="3310758"/>
+            <a:ext cx="978492" cy="327454"/>
+          </a:xfrm>
+          <a:prstGeom prst="roundRect">
+            <a:avLst/>
+          </a:prstGeom>
+        </p:spPr>
+        <p:style>
+          <a:lnRef idx="2">
+            <a:schemeClr val="accent4">
+              <a:shade val="15000"/>
+            </a:schemeClr>
+          </a:lnRef>
+          <a:fillRef idx="1">
+            <a:schemeClr val="accent4"/>
+          </a:fillRef>
+          <a:effectRef idx="0">
+            <a:schemeClr val="accent4"/>
+          </a:effectRef>
+          <a:fontRef idx="minor">
+            <a:schemeClr val="lt1"/>
+          </a:fontRef>
+        </p:style>
+        <p:txBody>
+          <a:bodyPr rtlCol="0" anchor="ctr"/>
+          <a:lstStyle/>
+          <a:p>
+            <a:pPr algn="ctr"/>
+            <a:endParaRPr lang="de-DE"/>
+          </a:p>
+        </p:txBody>
+      </p:sp>
+      <p:pic>
+        <p:nvPicPr>
+          <p:cNvPr id="15" name="Grafik 14" descr="Ein Bild, das Text, Screenshot, Schrift, Reihe enthält.&#10;&#10;KI-generierte Inhalte können fehlerhaft sein.">
+            <a:extLst>
+              <a:ext uri="{FF2B5EF4-FFF2-40B4-BE49-F238E27FC236}">
+                <a16:creationId xmlns:a16="http://schemas.microsoft.com/office/drawing/2014/main" id="{5A43414C-B395-59E0-BEDD-24CA4349213D}"/>
+              </a:ext>
+            </a:extLst>
+          </p:cNvPr>
+          <p:cNvPicPr>
+            <a:picLocks noChangeAspect="1"/>
+          </p:cNvPicPr>
+          <p:nvPr/>
+        </p:nvPicPr>
+        <p:blipFill>
+          <a:blip r:embed="rId3"/>
+          <a:srcRect t="62363"/>
+          <a:stretch>
+            <a:fillRect/>
+          </a:stretch>
+        </p:blipFill>
+        <p:spPr>
+          <a:xfrm>
+            <a:off x="362006" y="3138144"/>
+            <a:ext cx="8811493" cy="1632294"/>
+          </a:xfrm>
+          <a:prstGeom prst="rect">
+            <a:avLst/>
+          </a:prstGeom>
+        </p:spPr>
+      </p:pic>
+      <p:sp>
+        <p:nvSpPr>
+          <p:cNvPr id="16" name="Abgerundetes Rechteck 15">
+            <a:extLst>
+              <a:ext uri="{FF2B5EF4-FFF2-40B4-BE49-F238E27FC236}">
+                <a16:creationId xmlns:a16="http://schemas.microsoft.com/office/drawing/2014/main" id="{70341C1A-CB06-F378-6637-1B73E318EEE6}"/>
+              </a:ext>
+            </a:extLst>
+          </p:cNvPr>
+          <p:cNvSpPr/>
+          <p:nvPr/>
+        </p:nvSpPr>
+        <p:spPr>
+          <a:xfrm>
+            <a:off x="3160111" y="2259600"/>
+            <a:ext cx="963315" cy="190302"/>
+          </a:xfrm>
+          <a:prstGeom prst="roundRect">
+            <a:avLst/>
+          </a:prstGeom>
+        </p:spPr>
+        <p:style>
+          <a:lnRef idx="2">
+            <a:schemeClr val="accent4">
+              <a:shade val="15000"/>
+            </a:schemeClr>
+          </a:lnRef>
+          <a:fillRef idx="1">
+            <a:schemeClr val="accent4"/>
+          </a:fillRef>
+          <a:effectRef idx="0">
+            <a:schemeClr val="accent4"/>
+          </a:effectRef>
+          <a:fontRef idx="minor">
+            <a:schemeClr val="lt1"/>
+          </a:fontRef>
+        </p:style>
+        <p:txBody>
+          <a:bodyPr rtlCol="0" anchor="ctr"/>
+          <a:lstStyle/>
+          <a:p>
+            <a:pPr algn="ctr"/>
+            <a:endParaRPr lang="de-DE"/>
+          </a:p>
+        </p:txBody>
+      </p:sp>
+      <p:sp>
+        <p:nvSpPr>
+          <p:cNvPr id="17" name="Abgerundetes Rechteck 16">
+            <a:extLst>
+              <a:ext uri="{FF2B5EF4-FFF2-40B4-BE49-F238E27FC236}">
+                <a16:creationId xmlns:a16="http://schemas.microsoft.com/office/drawing/2014/main" id="{8C345699-248A-C645-9948-E4F33AED3479}"/>
+              </a:ext>
+            </a:extLst>
+          </p:cNvPr>
+          <p:cNvSpPr/>
+          <p:nvPr/>
+        </p:nvSpPr>
+        <p:spPr>
+          <a:xfrm>
+            <a:off x="678106" y="2713408"/>
+            <a:ext cx="745252" cy="234485"/>
+          </a:xfrm>
+          <a:prstGeom prst="roundRect">
+            <a:avLst/>
+          </a:prstGeom>
+        </p:spPr>
+        <p:style>
+          <a:lnRef idx="2">
+            <a:schemeClr val="accent4">
+              <a:shade val="15000"/>
+            </a:schemeClr>
+          </a:lnRef>
+          <a:fillRef idx="1">
+            <a:schemeClr val="accent4"/>
+          </a:fillRef>
+          <a:effectRef idx="0">
+            <a:schemeClr val="accent4"/>
+          </a:effectRef>
+          <a:fontRef idx="minor">
+            <a:schemeClr val="lt1"/>
+          </a:fontRef>
+        </p:style>
+        <p:txBody>
+          <a:bodyPr rtlCol="0" anchor="ctr"/>
+          <a:lstStyle/>
+          <a:p>
+            <a:pPr algn="ctr"/>
+            <a:endParaRPr lang="de-DE"/>
+          </a:p>
+        </p:txBody>
+      </p:sp>
+      <p:sp>
+        <p:nvSpPr>
+          <p:cNvPr id="18" name="Abgerundetes Rechteck 17">
+            <a:extLst>
+              <a:ext uri="{FF2B5EF4-FFF2-40B4-BE49-F238E27FC236}">
+                <a16:creationId xmlns:a16="http://schemas.microsoft.com/office/drawing/2014/main" id="{3EED6E10-F4DC-5A09-08EC-217293252565}"/>
+              </a:ext>
+            </a:extLst>
+          </p:cNvPr>
+          <p:cNvSpPr/>
+          <p:nvPr/>
+        </p:nvSpPr>
+        <p:spPr>
+          <a:xfrm>
+            <a:off x="3971517" y="2442838"/>
+            <a:ext cx="267184" cy="270570"/>
+          </a:xfrm>
+          <a:prstGeom prst="roundRect">
+            <a:avLst/>
+          </a:prstGeom>
+        </p:spPr>
+        <p:style>
+          <a:lnRef idx="2">
+            <a:schemeClr val="accent4">
+              <a:shade val="15000"/>
+            </a:schemeClr>
+          </a:lnRef>
+          <a:fillRef idx="1">
+            <a:schemeClr val="accent4"/>
+          </a:fillRef>
+          <a:effectRef idx="0">
+            <a:schemeClr val="accent4"/>
+          </a:effectRef>
+          <a:fontRef idx="minor">
+            <a:schemeClr val="lt1"/>
+          </a:fontRef>
+        </p:style>
+        <p:txBody>
+          <a:bodyPr rtlCol="0" anchor="ctr"/>
+          <a:lstStyle/>
+          <a:p>
+            <a:pPr algn="ctr"/>
+            <a:endParaRPr lang="de-DE"/>
+          </a:p>
+        </p:txBody>
+      </p:sp>
+      <p:sp>
+        <p:nvSpPr>
+          <p:cNvPr id="19" name="Abgerundetes Rechteck 18">
+            <a:extLst>
+              <a:ext uri="{FF2B5EF4-FFF2-40B4-BE49-F238E27FC236}">
+                <a16:creationId xmlns:a16="http://schemas.microsoft.com/office/drawing/2014/main" id="{4484FBDB-0575-6BE8-AA81-730E0F74C724}"/>
+              </a:ext>
+            </a:extLst>
+          </p:cNvPr>
+          <p:cNvSpPr/>
+          <p:nvPr/>
+        </p:nvSpPr>
+        <p:spPr>
+          <a:xfrm>
+            <a:off x="5744643" y="2228535"/>
+            <a:ext cx="820060" cy="252431"/>
+          </a:xfrm>
+          <a:prstGeom prst="roundRect">
+            <a:avLst/>
+          </a:prstGeom>
+        </p:spPr>
+        <p:style>
+          <a:lnRef idx="2">
+            <a:schemeClr val="accent4">
+              <a:shade val="15000"/>
+            </a:schemeClr>
+          </a:lnRef>
+          <a:fillRef idx="1">
+            <a:schemeClr val="accent4"/>
+          </a:fillRef>
+          <a:effectRef idx="0">
+            <a:schemeClr val="accent4"/>
+          </a:effectRef>
+          <a:fontRef idx="minor">
+            <a:schemeClr val="lt1"/>
+          </a:fontRef>
+        </p:style>
+        <p:txBody>
+          <a:bodyPr rtlCol="0" anchor="ctr"/>
+          <a:lstStyle/>
+          <a:p>
+            <a:pPr algn="ctr"/>
+            <a:endParaRPr lang="de-DE"/>
+          </a:p>
+        </p:txBody>
+      </p:sp>
+      <p:sp>
+        <p:nvSpPr>
+          <p:cNvPr id="20" name="Abgerundetes Rechteck 19">
+            <a:extLst>
+              <a:ext uri="{FF2B5EF4-FFF2-40B4-BE49-F238E27FC236}">
+                <a16:creationId xmlns:a16="http://schemas.microsoft.com/office/drawing/2014/main" id="{5260007D-C4EC-14F3-084E-C13C6A47C698}"/>
+              </a:ext>
+            </a:extLst>
+          </p:cNvPr>
+          <p:cNvSpPr/>
+          <p:nvPr/>
+        </p:nvSpPr>
+        <p:spPr>
+          <a:xfrm>
+            <a:off x="8015307" y="3638212"/>
+            <a:ext cx="844021" cy="343016"/>
+          </a:xfrm>
+          <a:prstGeom prst="roundRect">
+            <a:avLst/>
+          </a:prstGeom>
+        </p:spPr>
+        <p:style>
+          <a:lnRef idx="2">
+            <a:schemeClr val="accent4">
+              <a:shade val="15000"/>
+            </a:schemeClr>
+          </a:lnRef>
+          <a:fillRef idx="1">
+            <a:schemeClr val="accent4"/>
+          </a:fillRef>
+          <a:effectRef idx="0">
+            <a:schemeClr val="accent4"/>
+          </a:effectRef>
+          <a:fontRef idx="minor">
+            <a:schemeClr val="lt1"/>
+          </a:fontRef>
+        </p:style>
+        <p:txBody>
+          <a:bodyPr rtlCol="0" anchor="ctr"/>
+          <a:lstStyle/>
+          <a:p>
+            <a:pPr algn="ctr"/>
+            <a:endParaRPr lang="de-DE"/>
+          </a:p>
+        </p:txBody>
+      </p:sp>
+      <p:sp>
+        <p:nvSpPr>
+          <p:cNvPr id="21" name="Abgerundetes Rechteck 20">
+            <a:extLst>
+              <a:ext uri="{FF2B5EF4-FFF2-40B4-BE49-F238E27FC236}">
+                <a16:creationId xmlns:a16="http://schemas.microsoft.com/office/drawing/2014/main" id="{11924946-D785-6487-9D12-3FD9AB500349}"/>
+              </a:ext>
+            </a:extLst>
+          </p:cNvPr>
+          <p:cNvSpPr/>
+          <p:nvPr/>
+        </p:nvSpPr>
+        <p:spPr>
+          <a:xfrm>
+            <a:off x="7828340" y="4025738"/>
+            <a:ext cx="219443" cy="207383"/>
+          </a:xfrm>
+          <a:prstGeom prst="roundRect">
+            <a:avLst/>
+          </a:prstGeom>
+        </p:spPr>
+        <p:style>
+          <a:lnRef idx="2">
+            <a:schemeClr val="accent4">
+              <a:shade val="15000"/>
+            </a:schemeClr>
+          </a:lnRef>
+          <a:fillRef idx="1">
+            <a:schemeClr val="accent4"/>
+          </a:fillRef>
+          <a:effectRef idx="0">
+            <a:schemeClr val="accent4"/>
+          </a:effectRef>
+          <a:fontRef idx="minor">
+            <a:schemeClr val="lt1"/>
+          </a:fontRef>
+        </p:style>
+        <p:txBody>
+          <a:bodyPr rtlCol="0" anchor="ctr"/>
+          <a:lstStyle/>
+          <a:p>
+            <a:pPr algn="ctr"/>
+            <a:endParaRPr lang="de-DE"/>
+          </a:p>
+        </p:txBody>
+      </p:sp>
+      <p:sp>
+        <p:nvSpPr>
+          <p:cNvPr id="22" name="Abgerundetes Rechteck 21">
+            <a:extLst>
+              <a:ext uri="{FF2B5EF4-FFF2-40B4-BE49-F238E27FC236}">
+                <a16:creationId xmlns:a16="http://schemas.microsoft.com/office/drawing/2014/main" id="{5B2D5E35-14E6-C5D4-A4C6-5C7C15FEC671}"/>
+              </a:ext>
+            </a:extLst>
+          </p:cNvPr>
+          <p:cNvSpPr/>
+          <p:nvPr/>
+        </p:nvSpPr>
+        <p:spPr>
+          <a:xfrm>
+            <a:off x="2130692" y="3939126"/>
+            <a:ext cx="844021" cy="207383"/>
+          </a:xfrm>
+          <a:prstGeom prst="roundRect">
+            <a:avLst/>
+          </a:prstGeom>
+        </p:spPr>
+        <p:style>
+          <a:lnRef idx="2">
+            <a:schemeClr val="accent4">
+              <a:shade val="15000"/>
+            </a:schemeClr>
+          </a:lnRef>
+          <a:fillRef idx="1">
+            <a:schemeClr val="accent4"/>
+          </a:fillRef>
+          <a:effectRef idx="0">
+            <a:schemeClr val="accent4"/>
+          </a:effectRef>
+          <a:fontRef idx="minor">
+            <a:schemeClr val="lt1"/>
+          </a:fontRef>
+        </p:style>
+        <p:txBody>
+          <a:bodyPr rtlCol="0" anchor="ctr"/>
+          <a:lstStyle/>
+          <a:p>
+            <a:pPr algn="ctr"/>
+            <a:endParaRPr lang="de-DE"/>
+          </a:p>
+        </p:txBody>
+      </p:sp>
+      <p:pic>
+        <p:nvPicPr>
+          <p:cNvPr id="24" name="Grafik 23" descr="Ein Bild, das Text, Origami enthält.&#10;&#10;KI-generierte Inhalte können fehlerhaft sein.">
+            <a:extLst>
+              <a:ext uri="{FF2B5EF4-FFF2-40B4-BE49-F238E27FC236}">
+                <a16:creationId xmlns:a16="http://schemas.microsoft.com/office/drawing/2014/main" id="{CC976162-BFC8-A7B2-904D-8291B4C5F750}"/>
+              </a:ext>
+            </a:extLst>
+          </p:cNvPr>
+          <p:cNvPicPr>
+            <a:picLocks noChangeAspect="1"/>
+          </p:cNvPicPr>
+          <p:nvPr/>
+        </p:nvPicPr>
+        <p:blipFill>
+          <a:blip r:embed="rId4"/>
+          <a:srcRect l="20022" b="56020"/>
+          <a:stretch>
+            <a:fillRect/>
+          </a:stretch>
+        </p:blipFill>
+        <p:spPr>
+          <a:xfrm>
+            <a:off x="3641768" y="4877854"/>
+            <a:ext cx="3161775" cy="1338602"/>
+          </a:xfrm>
+          <a:prstGeom prst="rect">
+            <a:avLst/>
+          </a:prstGeom>
+          <a:ln>
+            <a:solidFill>
+              <a:schemeClr val="tx1"/>
+            </a:solidFill>
+          </a:ln>
+        </p:spPr>
+      </p:pic>
+      <p:pic>
+        <p:nvPicPr>
+          <p:cNvPr id="25" name="Grafik 24" descr="Ein Bild, das Text, Origami enthält.&#10;&#10;KI-generierte Inhalte können fehlerhaft sein.">
+            <a:extLst>
+              <a:ext uri="{FF2B5EF4-FFF2-40B4-BE49-F238E27FC236}">
+                <a16:creationId xmlns:a16="http://schemas.microsoft.com/office/drawing/2014/main" id="{F20FCD64-9804-FC14-B941-93512B1632DC}"/>
+              </a:ext>
+            </a:extLst>
+          </p:cNvPr>
+          <p:cNvPicPr>
+            <a:picLocks noChangeAspect="1"/>
+          </p:cNvPicPr>
+          <p:nvPr/>
+        </p:nvPicPr>
+        <p:blipFill>
+          <a:blip r:embed="rId4"/>
+          <a:srcRect t="45828"/>
+          <a:stretch>
+            <a:fillRect/>
+          </a:stretch>
+        </p:blipFill>
+        <p:spPr>
+          <a:xfrm>
+            <a:off x="6997967" y="4877854"/>
+            <a:ext cx="4235358" cy="1766485"/>
+          </a:xfrm>
+          <a:prstGeom prst="rect">
+            <a:avLst/>
+          </a:prstGeom>
+          <a:ln>
+            <a:solidFill>
+              <a:schemeClr val="tx1"/>
+            </a:solidFill>
+          </a:ln>
+        </p:spPr>
+      </p:pic>
     </p:spTree>
     <p:extLst>
       <p:ext uri="{BB962C8B-B14F-4D97-AF65-F5344CB8AC3E}">
-        <p14:creationId xmlns:p14="http://schemas.microsoft.com/office/powerpoint/2010/main" val="2406126268"/>
+        <p14:creationId xmlns:p14="http://schemas.microsoft.com/office/powerpoint/2010/main" val="3162902525"/>
+      </p:ext>
+    </p:extLst>
+  </p:cSld>
+  <p:clrMapOvr>
+    <a:masterClrMapping/>
+  </p:clrMapOvr>
+</p:sld>
+</file>
+
+<file path=ppt/slides/slide7.xml><?xml version="1.0" encoding="utf-8"?>
+<p:sld xmlns:a="http://schemas.openxmlformats.org/drawingml/2006/main" xmlns:r="http://schemas.openxmlformats.org/officeDocument/2006/relationships" xmlns:p="http://schemas.openxmlformats.org/presentationml/2006/main">
+  <p:cSld>
+    <p:spTree>
+      <p:nvGrpSpPr>
+        <p:cNvPr id="1" name=""/>
+        <p:cNvGrpSpPr/>
+        <p:nvPr/>
+      </p:nvGrpSpPr>
+      <p:grpSpPr>
+        <a:xfrm>
+          <a:off x="0" y="0"/>
+          <a:ext cx="0" cy="0"/>
+          <a:chOff x="0" y="0"/>
+          <a:chExt cx="0" cy="0"/>
+        </a:xfrm>
+      </p:grpSpPr>
+    </p:spTree>
+    <p:extLst>
+      <p:ext uri="{BB962C8B-B14F-4D97-AF65-F5344CB8AC3E}">
+        <p14:creationId xmlns:p14="http://schemas.microsoft.com/office/powerpoint/2010/main" val="3393627787"/>
       </p:ext>
     </p:extLst>
   </p:cSld>
@@ -6720,7 +6743,7 @@
         <p:cNvPr id="1" name="">
           <a:extLst>
             <a:ext uri="{FF2B5EF4-FFF2-40B4-BE49-F238E27FC236}">
-              <a16:creationId xmlns:a16="http://schemas.microsoft.com/office/drawing/2014/main" id="{11C59FFA-CB53-2E41-B295-6995E33AED7C}"/>
+              <a16:creationId xmlns:a16="http://schemas.microsoft.com/office/drawing/2014/main" id="{031D9A79-4F64-6AF1-CEBD-0A216DEAF88B}"/>
             </a:ext>
           </a:extLst>
         </p:cNvPr>
@@ -6740,7 +6763,7 @@
           <p:cNvPr id="3" name="Titel 1">
             <a:extLst>
               <a:ext uri="{FF2B5EF4-FFF2-40B4-BE49-F238E27FC236}">
-                <a16:creationId xmlns:a16="http://schemas.microsoft.com/office/drawing/2014/main" id="{E5C95B1E-543F-86D6-A505-7DAC962D4EE4}"/>
+                <a16:creationId xmlns:a16="http://schemas.microsoft.com/office/drawing/2014/main" id="{FE22BE25-984B-7AF3-4C01-F0B3633F00DC}"/>
               </a:ext>
             </a:extLst>
           </p:cNvPr>
@@ -6751,7 +6774,7 @@
         </p:nvSpPr>
         <p:spPr>
           <a:xfrm>
-            <a:off x="193623" y="425086"/>
+            <a:off x="211736" y="141622"/>
             <a:ext cx="11768528" cy="549275"/>
           </a:xfrm>
           <a:prstGeom prst="rect">
@@ -6796,65 +6819,21 @@
       </p:sp>
       <p:sp>
         <p:nvSpPr>
-          <p:cNvPr id="6" name="Abgerundetes Rechteck 5">
-            <a:extLst>
-              <a:ext uri="{FF2B5EF4-FFF2-40B4-BE49-F238E27FC236}">
-                <a16:creationId xmlns:a16="http://schemas.microsoft.com/office/drawing/2014/main" id="{21030813-6EB7-A10E-6DF4-C20A6368813F}"/>
-              </a:ext>
-            </a:extLst>
-          </p:cNvPr>
-          <p:cNvSpPr/>
+          <p:cNvPr id="2" name="Inhaltsplatzhalter 2">
+            <a:extLst>
+              <a:ext uri="{FF2B5EF4-FFF2-40B4-BE49-F238E27FC236}">
+                <a16:creationId xmlns:a16="http://schemas.microsoft.com/office/drawing/2014/main" id="{B605FC50-ADA1-0E6A-2CC3-4E7AF5CBAD91}"/>
+              </a:ext>
+            </a:extLst>
+          </p:cNvPr>
+          <p:cNvSpPr txBox="1">
+            <a:spLocks/>
+          </p:cNvSpPr>
           <p:nvPr/>
         </p:nvSpPr>
         <p:spPr>
           <a:xfrm>
-            <a:off x="193623" y="1240970"/>
-            <a:ext cx="11768527" cy="5382251"/>
-          </a:xfrm>
-          <a:prstGeom prst="roundRect">
-            <a:avLst/>
-          </a:prstGeom>
-        </p:spPr>
-        <p:style>
-          <a:lnRef idx="2">
-            <a:schemeClr val="accent3"/>
-          </a:lnRef>
-          <a:fillRef idx="1">
-            <a:schemeClr val="lt1"/>
-          </a:fillRef>
-          <a:effectRef idx="0">
-            <a:schemeClr val="accent3"/>
-          </a:effectRef>
-          <a:fontRef idx="minor">
-            <a:schemeClr val="dk1"/>
-          </a:fontRef>
-        </p:style>
-        <p:txBody>
-          <a:bodyPr rtlCol="0" anchor="ctr"/>
-          <a:lstStyle/>
-          <a:p>
-            <a:pPr algn="ctr"/>
-            <a:endParaRPr lang="de-DE" b="1" dirty="0"/>
-          </a:p>
-        </p:txBody>
-      </p:sp>
-      <p:sp>
-        <p:nvSpPr>
-          <p:cNvPr id="8" name="Inhaltsplatzhalter 2">
-            <a:extLst>
-              <a:ext uri="{FF2B5EF4-FFF2-40B4-BE49-F238E27FC236}">
-                <a16:creationId xmlns:a16="http://schemas.microsoft.com/office/drawing/2014/main" id="{51CD4DA6-533A-1C11-CF38-30C2128D053A}"/>
-              </a:ext>
-            </a:extLst>
-          </p:cNvPr>
-          <p:cNvSpPr txBox="1">
-            <a:spLocks/>
-          </p:cNvSpPr>
-          <p:nvPr/>
-        </p:nvSpPr>
-        <p:spPr>
-          <a:xfrm>
-            <a:off x="423472" y="1559658"/>
+            <a:off x="148465" y="690897"/>
             <a:ext cx="11327804" cy="4396299"/>
           </a:xfrm>
           <a:prstGeom prst="rect">
@@ -7033,50 +7012,17 @@
             </a:pPr>
             <a:r>
               <a:rPr lang="de-DE" sz="2000" b="1" dirty="0"/>
-              <a:t>Übungsaufgaben &amp; HA </a:t>
-            </a:r>
-          </a:p>
-          <a:p>
-            <a:pPr algn="just"/>
-            <a:r>
-              <a:rPr lang="de-DE" sz="2000" dirty="0"/>
-              <a:t>Buch S.97, Nr. 3</a:t>
-            </a:r>
-          </a:p>
-          <a:p>
-            <a:pPr algn="just"/>
-            <a:r>
-              <a:rPr lang="de-DE" sz="2000" dirty="0"/>
-              <a:t>Arbeitsheft S.30</a:t>
-            </a:r>
-          </a:p>
-          <a:p>
-            <a:pPr algn="just"/>
-            <a:r>
-              <a:rPr lang="de-DE" sz="2000" b="1" dirty="0"/>
-              <a:t>Bonus</a:t>
-            </a:r>
-            <a:r>
-              <a:rPr lang="de-DE" sz="2000" dirty="0"/>
-              <a:t>: Nr. 4</a:t>
-            </a:r>
-          </a:p>
-          <a:p>
-            <a:pPr algn="just"/>
-            <a:endParaRPr lang="de-DE" sz="2000" b="1" dirty="0"/>
-          </a:p>
-          <a:p>
-            <a:pPr algn="just"/>
-            <a:endParaRPr lang="de-DE" sz="2000" b="1" dirty="0"/>
+              <a:t>Aufgabe </a:t>
+            </a:r>
           </a:p>
         </p:txBody>
       </p:sp>
       <p:pic>
         <p:nvPicPr>
-          <p:cNvPr id="10" name="Grafik 9" descr="Ein Bild, das Text, Screenshot enthält.&#10;&#10;KI-generierte Inhalte können fehlerhaft sein.">
-            <a:extLst>
-              <a:ext uri="{FF2B5EF4-FFF2-40B4-BE49-F238E27FC236}">
-                <a16:creationId xmlns:a16="http://schemas.microsoft.com/office/drawing/2014/main" id="{5EEBACB8-7346-AD53-4754-4D335152D411}"/>
+          <p:cNvPr id="4" name="Grafik 3" descr="Ein Bild, das Text, Screenshot, Cartoon enthält.&#10;&#10;KI-generierte Inhalte können fehlerhaft sein.">
+            <a:extLst>
+              <a:ext uri="{FF2B5EF4-FFF2-40B4-BE49-F238E27FC236}">
+                <a16:creationId xmlns:a16="http://schemas.microsoft.com/office/drawing/2014/main" id="{E39361E8-78AB-BC2C-08DB-E072014FB428}"/>
               </a:ext>
             </a:extLst>
           </p:cNvPr>
@@ -7086,30 +7032,25 @@
           <p:nvPr/>
         </p:nvPicPr>
         <p:blipFill>
-          <a:blip r:embed="rId2"/>
+          <a:blip r:embed="rId3"/>
           <a:stretch>
             <a:fillRect/>
           </a:stretch>
         </p:blipFill>
         <p:spPr>
           <a:xfrm>
-            <a:off x="4549485" y="1559658"/>
-            <a:ext cx="6972300" cy="3606800"/>
+            <a:off x="588371" y="1187812"/>
+            <a:ext cx="10887898" cy="3402468"/>
           </a:xfrm>
           <a:prstGeom prst="rect">
             <a:avLst/>
           </a:prstGeom>
-          <a:ln>
-            <a:solidFill>
-              <a:schemeClr val="tx1"/>
-            </a:solidFill>
-          </a:ln>
         </p:spPr>
       </p:pic>
     </p:spTree>
     <p:extLst>
       <p:ext uri="{BB962C8B-B14F-4D97-AF65-F5344CB8AC3E}">
-        <p14:creationId xmlns:p14="http://schemas.microsoft.com/office/powerpoint/2010/main" val="3172547515"/>
+        <p14:creationId xmlns:p14="http://schemas.microsoft.com/office/powerpoint/2010/main" val="2406126268"/>
       </p:ext>
     </p:extLst>
   </p:cSld>
@@ -7127,7 +7068,7 @@
         <p:cNvPr id="1" name="">
           <a:extLst>
             <a:ext uri="{FF2B5EF4-FFF2-40B4-BE49-F238E27FC236}">
-              <a16:creationId xmlns:a16="http://schemas.microsoft.com/office/drawing/2014/main" id="{D6F9E721-EB3B-BCB5-BE3B-CA6255C50FF9}"/>
+              <a16:creationId xmlns:a16="http://schemas.microsoft.com/office/drawing/2014/main" id="{11C59FFA-CB53-2E41-B295-6995E33AED7C}"/>
             </a:ext>
           </a:extLst>
         </p:cNvPr>
@@ -7147,7 +7088,7 @@
           <p:cNvPr id="3" name="Titel 1">
             <a:extLst>
               <a:ext uri="{FF2B5EF4-FFF2-40B4-BE49-F238E27FC236}">
-                <a16:creationId xmlns:a16="http://schemas.microsoft.com/office/drawing/2014/main" id="{68D2655B-9794-C641-BFA5-6367C8865A9C}"/>
+                <a16:creationId xmlns:a16="http://schemas.microsoft.com/office/drawing/2014/main" id="{E5C95B1E-543F-86D6-A505-7DAC962D4EE4}"/>
               </a:ext>
             </a:extLst>
           </p:cNvPr>
@@ -7196,17 +7137,61 @@
                 <a:ea typeface="ADLaM Display" panose="02010000000000000000" pitchFamily="2" charset="77"/>
                 <a:cs typeface="ADLaM Display" panose="02010000000000000000" pitchFamily="2" charset="77"/>
               </a:rPr>
-              <a:t>Wiederholung: Zirkel &amp; Punkspiegelung</a:t>
-            </a:r>
-          </a:p>
-        </p:txBody>
-      </p:sp>
-      <p:sp>
-        <p:nvSpPr>
-          <p:cNvPr id="2" name="Inhaltsplatzhalter 2">
-            <a:extLst>
-              <a:ext uri="{FF2B5EF4-FFF2-40B4-BE49-F238E27FC236}">
-                <a16:creationId xmlns:a16="http://schemas.microsoft.com/office/drawing/2014/main" id="{42FC0499-C856-06B5-5E9F-6DB0ABE3E14F}"/>
+              <a:t>Wiederholung: Achsenspiegelung</a:t>
+            </a:r>
+          </a:p>
+        </p:txBody>
+      </p:sp>
+      <p:sp>
+        <p:nvSpPr>
+          <p:cNvPr id="6" name="Abgerundetes Rechteck 5">
+            <a:extLst>
+              <a:ext uri="{FF2B5EF4-FFF2-40B4-BE49-F238E27FC236}">
+                <a16:creationId xmlns:a16="http://schemas.microsoft.com/office/drawing/2014/main" id="{21030813-6EB7-A10E-6DF4-C20A6368813F}"/>
+              </a:ext>
+            </a:extLst>
+          </p:cNvPr>
+          <p:cNvSpPr/>
+          <p:nvPr/>
+        </p:nvSpPr>
+        <p:spPr>
+          <a:xfrm>
+            <a:off x="193623" y="1240970"/>
+            <a:ext cx="11768527" cy="5382251"/>
+          </a:xfrm>
+          <a:prstGeom prst="roundRect">
+            <a:avLst/>
+          </a:prstGeom>
+        </p:spPr>
+        <p:style>
+          <a:lnRef idx="2">
+            <a:schemeClr val="accent3"/>
+          </a:lnRef>
+          <a:fillRef idx="1">
+            <a:schemeClr val="lt1"/>
+          </a:fillRef>
+          <a:effectRef idx="0">
+            <a:schemeClr val="accent3"/>
+          </a:effectRef>
+          <a:fontRef idx="minor">
+            <a:schemeClr val="dk1"/>
+          </a:fontRef>
+        </p:style>
+        <p:txBody>
+          <a:bodyPr rtlCol="0" anchor="ctr"/>
+          <a:lstStyle/>
+          <a:p>
+            <a:pPr algn="ctr"/>
+            <a:endParaRPr lang="de-DE" b="1" dirty="0"/>
+          </a:p>
+        </p:txBody>
+      </p:sp>
+      <p:sp>
+        <p:nvSpPr>
+          <p:cNvPr id="8" name="Inhaltsplatzhalter 2">
+            <a:extLst>
+              <a:ext uri="{FF2B5EF4-FFF2-40B4-BE49-F238E27FC236}">
+                <a16:creationId xmlns:a16="http://schemas.microsoft.com/office/drawing/2014/main" id="{51CD4DA6-533A-1C11-CF38-30C2128D053A}"/>
               </a:ext>
             </a:extLst>
           </p:cNvPr>
@@ -7217,8 +7202,8 @@
         </p:nvSpPr>
         <p:spPr>
           <a:xfrm>
-            <a:off x="193623" y="5078627"/>
-            <a:ext cx="11768528" cy="1534168"/>
+            <a:off x="423472" y="1559658"/>
+            <a:ext cx="11327804" cy="4396299"/>
           </a:xfrm>
           <a:prstGeom prst="rect">
             <a:avLst/>
@@ -7391,42 +7376,88 @@
             </a:lvl9pPr>
           </a:lstStyle>
           <a:p>
-            <a:pPr marL="0" indent="0">
+            <a:pPr marL="0" indent="0" algn="just">
               <a:buNone/>
             </a:pPr>
             <a:r>
-              <a:rPr lang="de-DE" b="1" dirty="0"/>
-              <a:t>HA</a:t>
-            </a:r>
-            <a:r>
-              <a:rPr lang="de-DE" dirty="0"/>
-              <a:t> - Arbeitsheft</a:t>
-            </a:r>
-          </a:p>
-          <a:p>
-            <a:r>
-              <a:rPr lang="de-DE" dirty="0"/>
-              <a:t>S. 31 – Zirkel				-- WDH</a:t>
-            </a:r>
-          </a:p>
-          <a:p>
-            <a:r>
-              <a:rPr lang="de-DE" dirty="0"/>
-              <a:t>S. 32 – Punktspiegelung		-- WDH</a:t>
-            </a:r>
-          </a:p>
-          <a:p>
-            <a:pPr marL="0" indent="0">
-              <a:buNone/>
-            </a:pPr>
-            <a:endParaRPr lang="de-DE" dirty="0"/>
-          </a:p>
-        </p:txBody>
-      </p:sp>
+              <a:rPr lang="de-DE" sz="2000" b="1" dirty="0"/>
+              <a:t>Übungsaufgaben &amp; HA </a:t>
+            </a:r>
+          </a:p>
+          <a:p>
+            <a:pPr algn="just"/>
+            <a:r>
+              <a:rPr lang="de-DE" sz="2000" dirty="0"/>
+              <a:t>Buch S.97, Nr. 3</a:t>
+            </a:r>
+          </a:p>
+          <a:p>
+            <a:pPr algn="just"/>
+            <a:r>
+              <a:rPr lang="de-DE" sz="2000" dirty="0"/>
+              <a:t>Arbeitsheft S.30</a:t>
+            </a:r>
+          </a:p>
+          <a:p>
+            <a:pPr algn="just"/>
+            <a:r>
+              <a:rPr lang="de-DE" sz="2000" b="1" dirty="0"/>
+              <a:t>Bonus</a:t>
+            </a:r>
+            <a:r>
+              <a:rPr lang="de-DE" sz="2000" dirty="0"/>
+              <a:t>: Nr. 4</a:t>
+            </a:r>
+          </a:p>
+          <a:p>
+            <a:pPr algn="just"/>
+            <a:endParaRPr lang="de-DE" sz="2000" b="1" dirty="0"/>
+          </a:p>
+          <a:p>
+            <a:pPr algn="just"/>
+            <a:endParaRPr lang="de-DE" sz="2000" b="1" dirty="0"/>
+          </a:p>
+        </p:txBody>
+      </p:sp>
+      <p:pic>
+        <p:nvPicPr>
+          <p:cNvPr id="10" name="Grafik 9" descr="Ein Bild, das Text, Screenshot enthält.&#10;&#10;KI-generierte Inhalte können fehlerhaft sein.">
+            <a:extLst>
+              <a:ext uri="{FF2B5EF4-FFF2-40B4-BE49-F238E27FC236}">
+                <a16:creationId xmlns:a16="http://schemas.microsoft.com/office/drawing/2014/main" id="{5EEBACB8-7346-AD53-4754-4D335152D411}"/>
+              </a:ext>
+            </a:extLst>
+          </p:cNvPr>
+          <p:cNvPicPr>
+            <a:picLocks noChangeAspect="1"/>
+          </p:cNvPicPr>
+          <p:nvPr/>
+        </p:nvPicPr>
+        <p:blipFill>
+          <a:blip r:embed="rId2"/>
+          <a:stretch>
+            <a:fillRect/>
+          </a:stretch>
+        </p:blipFill>
+        <p:spPr>
+          <a:xfrm>
+            <a:off x="4549485" y="1559658"/>
+            <a:ext cx="6972300" cy="3606800"/>
+          </a:xfrm>
+          <a:prstGeom prst="rect">
+            <a:avLst/>
+          </a:prstGeom>
+          <a:ln>
+            <a:solidFill>
+              <a:schemeClr val="tx1"/>
+            </a:solidFill>
+          </a:ln>
+        </p:spPr>
+      </p:pic>
     </p:spTree>
     <p:extLst>
       <p:ext uri="{BB962C8B-B14F-4D97-AF65-F5344CB8AC3E}">
-        <p14:creationId xmlns:p14="http://schemas.microsoft.com/office/powerpoint/2010/main" val="3519360287"/>
+        <p14:creationId xmlns:p14="http://schemas.microsoft.com/office/powerpoint/2010/main" val="3172547515"/>
       </p:ext>
     </p:extLst>
   </p:cSld>

</xml_diff>